<commit_message>
Turn the poster frame into an advertising layout with real figures
The frame now carries screenshots of the running app, a five-layer
diagram labelled as AI-made, two charts labelled as simulated data,
and three verified numbers. Every text slot stays empty and coded
(H1-H3, T1-T3, G1-G2, S1-S3, P1-P6) for the student to write.

DU_LIEU_POSTER.md maps each slot to guiding questions, a length
limit and the verified numbers with their source files, plus the
phrasings to avoid and a pre-print checklist.

Co-Authored-By: Claude Opus 5.5 <noreply@anthropic.com>
Claude-Session: https://claude.ai/code/session_01NkYGd36L1Tpym32yxKyitD
</commit_message>
<xml_diff>
--- a/poster/poster_khung_1-2.pptx
+++ b/poster/poster_khung_1-2.pptx
@@ -512,7 +512,12 @@
           </a:p>
           <a:p>
             <a:r>
-              <a:t>Không đặt: Logo nhà trường, Tên trường, Mã dự án, Tên giáo viên hướng dẫn, Tên học sinh tham gia.</a:t>
+              <a:t>Mã ô (H1, T1, G1, S1, P1…) khớp bảng tra poster/DU_LIEU_POSTER.md.</a:t>
+            </a:r>
+          </a:p>
+          <a:p>
+            <a:r>
+              <a:t>Không đặt: Logo nhà trường, Tên trường (kể cả viết tắt), Mã dự án, Tên giáo viên hướng dẫn, Tên học sinh tham gia.</a:t>
             </a:r>
           </a:p>
         </p:txBody>
@@ -3702,111 +3707,6 @@
         </p:nvSpPr>
         <p:spPr>
           <a:xfrm>
-            <a:off x="9450000" y="540000"/>
-            <a:ext cx="17100000" cy="4860000"/>
-          </a:xfrm>
-          <a:prstGeom prst="roundRect">
-            <a:avLst>
-              <a:gd name="adj" fmla="val 2222"/>
-            </a:avLst>
-          </a:prstGeom>
-          <a:solidFill>
-            <a:srgbClr val="1C2321"/>
-          </a:solidFill>
-          <a:ln>
-            <a:noFill/>
-          </a:ln>
-          <a:effectLst/>
-        </p:spPr>
-        <p:style>
-          <a:lnRef idx="1">
-            <a:schemeClr val="accent1"/>
-          </a:lnRef>
-          <a:fillRef idx="3">
-            <a:schemeClr val="accent1"/>
-          </a:fillRef>
-          <a:effectRef idx="2">
-            <a:schemeClr val="accent1"/>
-          </a:effectRef>
-          <a:fontRef idx="minor">
-            <a:schemeClr val="lt1"/>
-          </a:fontRef>
-        </p:style>
-        <p:txBody>
-          <a:bodyPr rtlCol="0" anchor="ctr"/>
-          <a:lstStyle/>
-          <a:p>
-            <a:pPr algn="ctr"/>
-          </a:p>
-        </p:txBody>
-      </p:sp>
-      <p:sp>
-        <p:nvSpPr>
-          <p:cNvPr id="7" name="TextBox 6"/>
-          <p:cNvSpPr txBox="1"/>
-          <p:nvPr/>
-        </p:nvSpPr>
-        <p:spPr>
-          <a:xfrm>
-            <a:off x="9990000" y="936000"/>
-            <a:ext cx="16020000" cy="4068000"/>
-          </a:xfrm>
-          <a:prstGeom prst="rect">
-            <a:avLst/>
-          </a:prstGeom>
-          <a:noFill/>
-        </p:spPr>
-        <p:txBody>
-          <a:bodyPr wrap="square" anchor="ctr" lIns="0" rIns="0" tIns="0" bIns="0">
-            <a:spAutoFit/>
-          </a:bodyPr>
-          <a:lstStyle/>
-          <a:p>
-            <a:pPr algn="l"/>
-            <a:r>
-              <a:rPr sz="2000" b="1" i="0">
-                <a:solidFill>
-                  <a:srgbClr val="C98A1F"/>
-                </a:solidFill>
-                <a:latin typeface="IBM Plex Sans"/>
-              </a:rPr>
-              <a:t>[ LĨNH VỰC DỰ THI ]</a:t>
-            </a:r>
-          </a:p>
-          <a:p>
-            <a:pPr algn="l"/>
-            <a:r>
-              <a:rPr sz="7000" b="1" i="0">
-                <a:solidFill>
-                  <a:srgbClr val="F3F4F1"/>
-                </a:solidFill>
-                <a:latin typeface="Be Vietnam Pro"/>
-              </a:rPr>
-              <a:t>[ TÊN ĐỀ TÀI — VIẾT HOA, TỐI ĐA HAI DÒNG ]</a:t>
-            </a:r>
-          </a:p>
-          <a:p>
-            <a:pPr algn="l"/>
-            <a:r>
-              <a:rPr sz="2200" b="0" i="0">
-                <a:solidFill>
-                  <a:srgbClr val="DBDCD5"/>
-                </a:solidFill>
-                <a:latin typeface="IBM Plex Sans"/>
-              </a:rPr>
-              <a:t>[ Một câu nói sản phẩm giải quyết việc gì ]</a:t>
-            </a:r>
-          </a:p>
-        </p:txBody>
-      </p:sp>
-      <p:sp>
-        <p:nvSpPr>
-          <p:cNvPr id="8" name="Rounded Rectangle 7"/>
-          <p:cNvSpPr/>
-          <p:nvPr/>
-        </p:nvSpPr>
-        <p:spPr>
-          <a:xfrm>
             <a:off x="540000" y="540000"/>
             <a:ext cx="8010000" cy="7920000"/>
           </a:xfrm>
@@ -3849,7 +3749,7 @@
       </p:sp>
       <p:sp>
         <p:nvSpPr>
-          <p:cNvPr id="9" name="Oval 8"/>
+          <p:cNvPr id="7" name="Oval 6"/>
           <p:cNvSpPr/>
           <p:nvPr/>
         </p:nvSpPr>
@@ -3884,12 +3784,12 @@
           </a:fontRef>
         </p:style>
         <p:txBody>
-          <a:bodyPr rtlCol="0" anchor="ctr" lIns="0" rIns="0" tIns="0" bIns="0"/>
+          <a:bodyPr rtlCol="0" anchor="ctr" wrap="square" lIns="0" rIns="0" tIns="0" bIns="0"/>
           <a:lstStyle/>
           <a:p>
             <a:pPr algn="ctr"/>
             <a:r>
-              <a:rPr sz="1860" b="1">
+              <a:rPr sz="1860" b="1" i="0">
                 <a:solidFill>
                   <a:srgbClr val="FFFFFF"/>
                 </a:solidFill>
@@ -3902,14 +3802,14 @@
       </p:sp>
       <p:sp>
         <p:nvSpPr>
-          <p:cNvPr id="10" name="TextBox 9"/>
+          <p:cNvPr id="8" name="TextBox 7"/>
           <p:cNvSpPr txBox="1"/>
           <p:nvPr/>
         </p:nvSpPr>
         <p:spPr>
           <a:xfrm>
             <a:off x="1530000" y="827999"/>
-            <a:ext cx="6696000" cy="522000"/>
+            <a:ext cx="6695999" cy="522000"/>
           </a:xfrm>
           <a:prstGeom prst="rect">
             <a:avLst/>
@@ -3930,21 +3830,68 @@
                 </a:solidFill>
                 <a:latin typeface="Be Vietnam Pro"/>
               </a:rPr>
-              <a:t>Đặt vấn đề</a:t>
-            </a:r>
-          </a:p>
-        </p:txBody>
-      </p:sp>
-      <p:sp>
-        <p:nvSpPr>
-          <p:cNvPr id="11" name="TextBox 10"/>
+              <a:t>Vấn đề</a:t>
+            </a:r>
+          </a:p>
+        </p:txBody>
+      </p:sp>
+      <p:sp>
+        <p:nvSpPr>
+          <p:cNvPr id="9" name="Rounded Rectangle 8"/>
+          <p:cNvSpPr/>
+          <p:nvPr/>
+        </p:nvSpPr>
+        <p:spPr>
+          <a:xfrm>
+            <a:off x="864000" y="1530000"/>
+            <a:ext cx="7362000" cy="6606000"/>
+          </a:xfrm>
+          <a:prstGeom prst="roundRect">
+            <a:avLst>
+              <a:gd name="adj" fmla="val 1634"/>
+            </a:avLst>
+          </a:prstGeom>
+          <a:noFill/>
+          <a:ln w="18000">
+            <a:solidFill>
+              <a:srgbClr val="DBDCD5"/>
+            </a:solidFill>
+            <a:prstDash val="dash"/>
+          </a:ln>
+          <a:effectLst/>
+        </p:spPr>
+        <p:style>
+          <a:lnRef idx="1">
+            <a:schemeClr val="accent1"/>
+          </a:lnRef>
+          <a:fillRef idx="3">
+            <a:schemeClr val="accent1"/>
+          </a:fillRef>
+          <a:effectRef idx="2">
+            <a:schemeClr val="accent1"/>
+          </a:effectRef>
+          <a:fontRef idx="minor">
+            <a:schemeClr val="lt1"/>
+          </a:fontRef>
+        </p:style>
+        <p:txBody>
+          <a:bodyPr rtlCol="0" anchor="ctr"/>
+          <a:lstStyle/>
+          <a:p>
+            <a:pPr algn="ctr"/>
+          </a:p>
+        </p:txBody>
+      </p:sp>
+      <p:sp>
+        <p:nvSpPr>
+          <p:cNvPr id="10" name="TextBox 9"/>
           <p:cNvSpPr txBox="1"/>
           <p:nvPr/>
         </p:nvSpPr>
         <p:spPr>
           <a:xfrm>
-            <a:off x="864000" y="1530000"/>
-            <a:ext cx="7362000" cy="6642000"/>
+            <a:off x="1044000" y="1674000"/>
+            <a:ext cx="7002000" cy="6318000"/>
           </a:xfrm>
           <a:prstGeom prst="rect">
             <a:avLst/>
@@ -3965,25 +3912,25 @@
                 </a:solidFill>
                 <a:latin typeface="IBM Plex Sans"/>
               </a:rPr>
-              <a:t>Vấn đề thực tế là gì? Ai gặp phải, ở đâu, mức độ ra sao? Vì sao cách làm hiện tại chưa ổn?</a:t>
-            </a:r>
-          </a:p>
-        </p:txBody>
-      </p:sp>
-      <p:sp>
-        <p:nvSpPr>
-          <p:cNvPr id="12" name="Rounded Rectangle 11"/>
+              <a:t>[ T1 — em viết 2–3 câu. Hiện nay xếp học sinh vào CLB thế nào? Ai thiệt, thiệt ra sao? ]</a:t>
+            </a:r>
+          </a:p>
+        </p:txBody>
+      </p:sp>
+      <p:sp>
+        <p:nvSpPr>
+          <p:cNvPr id="11" name="Rounded Rectangle 10"/>
           <p:cNvSpPr/>
           <p:nvPr/>
         </p:nvSpPr>
         <p:spPr>
           <a:xfrm>
             <a:off x="540000" y="8910000"/>
-            <a:ext cx="8010000" cy="6840000"/>
+            <a:ext cx="8010000" cy="9720000"/>
           </a:xfrm>
           <a:prstGeom prst="roundRect">
             <a:avLst>
-              <a:gd name="adj" fmla="val 1578"/>
+              <a:gd name="adj" fmla="val 1348"/>
             </a:avLst>
           </a:prstGeom>
           <a:solidFill>
@@ -4020,7 +3967,7 @@
       </p:sp>
       <p:sp>
         <p:nvSpPr>
-          <p:cNvPr id="13" name="Oval 12"/>
+          <p:cNvPr id="12" name="Oval 11"/>
           <p:cNvSpPr/>
           <p:nvPr/>
         </p:nvSpPr>
@@ -4055,12 +4002,12 @@
           </a:fontRef>
         </p:style>
         <p:txBody>
-          <a:bodyPr rtlCol="0" anchor="ctr" lIns="0" rIns="0" tIns="0" bIns="0"/>
+          <a:bodyPr rtlCol="0" anchor="ctr" wrap="square" lIns="0" rIns="0" tIns="0" bIns="0"/>
           <a:lstStyle/>
           <a:p>
             <a:pPr algn="ctr"/>
             <a:r>
-              <a:rPr sz="1860" b="1">
+              <a:rPr sz="1860" b="1" i="0">
                 <a:solidFill>
                   <a:srgbClr val="FFFFFF"/>
                 </a:solidFill>
@@ -4073,14 +4020,14 @@
       </p:sp>
       <p:sp>
         <p:nvSpPr>
-          <p:cNvPr id="14" name="TextBox 13"/>
+          <p:cNvPr id="13" name="TextBox 12"/>
           <p:cNvSpPr txBox="1"/>
           <p:nvPr/>
         </p:nvSpPr>
         <p:spPr>
           <a:xfrm>
             <a:off x="1530000" y="9198000"/>
-            <a:ext cx="6696000" cy="522000"/>
+            <a:ext cx="6695999" cy="522000"/>
           </a:xfrm>
           <a:prstGeom prst="rect">
             <a:avLst/>
@@ -4101,11 +4048,35 @@
                 </a:solidFill>
                 <a:latin typeface="Be Vietnam Pro"/>
               </a:rPr>
-              <a:t>Mục tiêu &amp; câu hỏi nghiên cứu</a:t>
-            </a:r>
-          </a:p>
-        </p:txBody>
-      </p:sp>
+              <a:t>Dùng thế nào</a:t>
+            </a:r>
+          </a:p>
+        </p:txBody>
+      </p:sp>
+      <p:pic>
+        <p:nvPicPr>
+          <p:cNvPr id="14" name="Picture 13" descr="giao_dien_van_hanh.png"/>
+          <p:cNvPicPr>
+            <a:picLocks noChangeAspect="1"/>
+          </p:cNvPicPr>
+          <p:nvPr/>
+        </p:nvPicPr>
+        <p:blipFill>
+          <a:blip r:embed="rId2"/>
+          <a:stretch>
+            <a:fillRect/>
+          </a:stretch>
+        </p:blipFill>
+        <p:spPr>
+          <a:xfrm>
+            <a:off x="864000" y="9900000"/>
+            <a:ext cx="7362000" cy="4601250"/>
+          </a:xfrm>
+          <a:prstGeom prst="rect">
+            <a:avLst/>
+          </a:prstGeom>
+        </p:spPr>
+      </p:pic>
       <p:sp>
         <p:nvSpPr>
           <p:cNvPr id="15" name="TextBox 14"/>
@@ -4114,8 +4085,90 @@
         </p:nvSpPr>
         <p:spPr>
           <a:xfrm>
-            <a:off x="864000" y="9900000"/>
-            <a:ext cx="7362000" cy="5562000"/>
+            <a:off x="864000" y="14573250"/>
+            <a:ext cx="7362000" cy="288000"/>
+          </a:xfrm>
+          <a:prstGeom prst="rect">
+            <a:avLst/>
+          </a:prstGeom>
+          <a:noFill/>
+        </p:spPr>
+        <p:txBody>
+          <a:bodyPr wrap="square" anchor="t" lIns="0" rIns="0" tIns="0" bIns="0">
+            <a:spAutoFit/>
+          </a:bodyPr>
+          <a:lstStyle/>
+          <a:p>
+            <a:pPr algn="l"/>
+            <a:r>
+              <a:rPr sz="1200" b="0" i="0">
+                <a:solidFill>
+                  <a:srgbClr val="5B6570"/>
+                </a:solidFill>
+                <a:latin typeface="IBM Plex Sans"/>
+              </a:rPr>
+              <a:t>Ảnh chụp giao diện thật · dữ liệu mô phỏng</a:t>
+            </a:r>
+          </a:p>
+        </p:txBody>
+      </p:sp>
+      <p:sp>
+        <p:nvSpPr>
+          <p:cNvPr id="16" name="Rounded Rectangle 15"/>
+          <p:cNvSpPr/>
+          <p:nvPr/>
+        </p:nvSpPr>
+        <p:spPr>
+          <a:xfrm>
+            <a:off x="864000" y="14933250"/>
+            <a:ext cx="7362000" cy="3372750"/>
+          </a:xfrm>
+          <a:prstGeom prst="roundRect">
+            <a:avLst>
+              <a:gd name="adj" fmla="val 3202"/>
+            </a:avLst>
+          </a:prstGeom>
+          <a:noFill/>
+          <a:ln w="18000">
+            <a:solidFill>
+              <a:srgbClr val="DBDCD5"/>
+            </a:solidFill>
+            <a:prstDash val="dash"/>
+          </a:ln>
+          <a:effectLst/>
+        </p:spPr>
+        <p:style>
+          <a:lnRef idx="1">
+            <a:schemeClr val="accent1"/>
+          </a:lnRef>
+          <a:fillRef idx="3">
+            <a:schemeClr val="accent1"/>
+          </a:fillRef>
+          <a:effectRef idx="2">
+            <a:schemeClr val="accent1"/>
+          </a:effectRef>
+          <a:fontRef idx="minor">
+            <a:schemeClr val="lt1"/>
+          </a:fontRef>
+        </p:style>
+        <p:txBody>
+          <a:bodyPr rtlCol="0" anchor="ctr"/>
+          <a:lstStyle/>
+          <a:p>
+            <a:pPr algn="ctr"/>
+          </a:p>
+        </p:txBody>
+      </p:sp>
+      <p:sp>
+        <p:nvSpPr>
+          <p:cNvPr id="17" name="TextBox 16"/>
+          <p:cNvSpPr txBox="1"/>
+          <p:nvPr/>
+        </p:nvSpPr>
+        <p:spPr>
+          <a:xfrm>
+            <a:off x="1044000" y="15077250"/>
+            <a:ext cx="7002000" cy="3084750"/>
           </a:xfrm>
           <a:prstGeom prst="rect">
             <a:avLst/>
@@ -4136,25 +4189,25 @@
                 </a:solidFill>
                 <a:latin typeface="IBM Plex Sans"/>
               </a:rPr>
-              <a:t>Mục tiêu chính và 2–3 câu hỏi nghiên cứu, mỗi câu một dòng.</a:t>
-            </a:r>
-          </a:p>
-        </p:txBody>
-      </p:sp>
-      <p:sp>
-        <p:nvSpPr>
-          <p:cNvPr id="16" name="Rounded Rectangle 15"/>
+              <a:t>[ T2 — em viết: người dùng làm mấy bước? Mỗi bước một dòng. ]</a:t>
+            </a:r>
+          </a:p>
+        </p:txBody>
+      </p:sp>
+      <p:sp>
+        <p:nvSpPr>
+          <p:cNvPr id="18" name="Rounded Rectangle 17"/>
           <p:cNvSpPr/>
           <p:nvPr/>
         </p:nvSpPr>
         <p:spPr>
           <a:xfrm>
-            <a:off x="540000" y="16200000"/>
-            <a:ext cx="8010000" cy="10080000"/>
+            <a:off x="540000" y="19080000"/>
+            <a:ext cx="8010000" cy="7200000"/>
           </a:xfrm>
           <a:prstGeom prst="roundRect">
             <a:avLst>
-              <a:gd name="adj" fmla="val 1348"/>
+              <a:gd name="adj" fmla="val 1500"/>
             </a:avLst>
           </a:prstGeom>
           <a:solidFill>
@@ -4191,13 +4244,13 @@
       </p:sp>
       <p:sp>
         <p:nvSpPr>
-          <p:cNvPr id="17" name="Oval 16"/>
+          <p:cNvPr id="19" name="Oval 18"/>
           <p:cNvSpPr/>
           <p:nvPr/>
         </p:nvSpPr>
         <p:spPr>
           <a:xfrm>
-            <a:off x="864000" y="16487999"/>
+            <a:off x="864000" y="19368000"/>
             <a:ext cx="522000" cy="522000"/>
           </a:xfrm>
           <a:prstGeom prst="ellipse">
@@ -4226,12 +4279,12 @@
           </a:fontRef>
         </p:style>
         <p:txBody>
-          <a:bodyPr rtlCol="0" anchor="ctr" lIns="0" rIns="0" tIns="0" bIns="0"/>
+          <a:bodyPr rtlCol="0" anchor="ctr" wrap="square" lIns="0" rIns="0" tIns="0" bIns="0"/>
           <a:lstStyle/>
           <a:p>
             <a:pPr algn="ctr"/>
             <a:r>
-              <a:rPr sz="1860" b="1">
+              <a:rPr sz="1860" b="1" i="0">
                 <a:solidFill>
                   <a:srgbClr val="FFFFFF"/>
                 </a:solidFill>
@@ -4244,14 +4297,14 @@
       </p:sp>
       <p:sp>
         <p:nvSpPr>
-          <p:cNvPr id="18" name="TextBox 17"/>
+          <p:cNvPr id="20" name="TextBox 19"/>
           <p:cNvSpPr txBox="1"/>
           <p:nvPr/>
         </p:nvSpPr>
         <p:spPr>
           <a:xfrm>
-            <a:off x="1530000" y="16487999"/>
-            <a:ext cx="6696000" cy="522000"/>
+            <a:off x="1530000" y="19368000"/>
+            <a:ext cx="6695999" cy="522000"/>
           </a:xfrm>
           <a:prstGeom prst="rect">
             <a:avLst/>
@@ -4272,21 +4325,126 @@
                 </a:solidFill>
                 <a:latin typeface="Be Vietnam Pro"/>
               </a:rPr>
-              <a:t>Cơ sở lý thuyết</a:t>
-            </a:r>
-          </a:p>
-        </p:txBody>
-      </p:sp>
-      <p:sp>
-        <p:nvSpPr>
-          <p:cNvPr id="19" name="TextBox 18"/>
+              <a:t>Xem thử</a:t>
+            </a:r>
+          </a:p>
+        </p:txBody>
+      </p:sp>
+      <p:sp>
+        <p:nvSpPr>
+          <p:cNvPr id="21" name="Rounded Rectangle 20"/>
+          <p:cNvSpPr/>
+          <p:nvPr/>
+        </p:nvSpPr>
+        <p:spPr>
+          <a:xfrm>
+            <a:off x="864000" y="20070000"/>
+            <a:ext cx="3600000" cy="3600000"/>
+          </a:xfrm>
+          <a:prstGeom prst="roundRect">
+            <a:avLst>
+              <a:gd name="adj" fmla="val 3000"/>
+            </a:avLst>
+          </a:prstGeom>
+          <a:solidFill>
+            <a:srgbClr val="F3F4F1"/>
+          </a:solidFill>
+          <a:ln w="25200">
+            <a:solidFill>
+              <a:srgbClr val="5B6570"/>
+            </a:solidFill>
+            <a:prstDash val="dash"/>
+          </a:ln>
+          <a:effectLst/>
+        </p:spPr>
+        <p:style>
+          <a:lnRef idx="1">
+            <a:schemeClr val="accent1"/>
+          </a:lnRef>
+          <a:fillRef idx="3">
+            <a:schemeClr val="accent1"/>
+          </a:fillRef>
+          <a:effectRef idx="2">
+            <a:schemeClr val="accent1"/>
+          </a:effectRef>
+          <a:fontRef idx="minor">
+            <a:schemeClr val="lt1"/>
+          </a:fontRef>
+        </p:style>
+        <p:txBody>
+          <a:bodyPr rtlCol="0" anchor="ctr" wrap="square" lIns="0" rIns="0" tIns="0" bIns="0"/>
+          <a:lstStyle/>
+          <a:p>
+            <a:pPr algn="ctr"/>
+            <a:r>
+              <a:rPr sz="1200" b="0" i="0">
+                <a:solidFill>
+                  <a:srgbClr val="5B6570"/>
+                </a:solidFill>
+                <a:latin typeface="IBM Plex Sans"/>
+              </a:rPr>
+              <a:t>[ QR tới video demo — KHÔNG trỏ tới GitHub ]</a:t>
+            </a:r>
+          </a:p>
+        </p:txBody>
+      </p:sp>
+      <p:sp>
+        <p:nvSpPr>
+          <p:cNvPr id="22" name="Rounded Rectangle 21"/>
+          <p:cNvSpPr/>
+          <p:nvPr/>
+        </p:nvSpPr>
+        <p:spPr>
+          <a:xfrm>
+            <a:off x="4734000" y="20070000"/>
+            <a:ext cx="3491999" cy="3600000"/>
+          </a:xfrm>
+          <a:prstGeom prst="roundRect">
+            <a:avLst>
+              <a:gd name="adj" fmla="val 3092"/>
+            </a:avLst>
+          </a:prstGeom>
+          <a:noFill/>
+          <a:ln w="18000">
+            <a:solidFill>
+              <a:srgbClr val="DBDCD5"/>
+            </a:solidFill>
+            <a:prstDash val="dash"/>
+          </a:ln>
+          <a:effectLst/>
+        </p:spPr>
+        <p:style>
+          <a:lnRef idx="1">
+            <a:schemeClr val="accent1"/>
+          </a:lnRef>
+          <a:fillRef idx="3">
+            <a:schemeClr val="accent1"/>
+          </a:fillRef>
+          <a:effectRef idx="2">
+            <a:schemeClr val="accent1"/>
+          </a:effectRef>
+          <a:fontRef idx="minor">
+            <a:schemeClr val="lt1"/>
+          </a:fontRef>
+        </p:style>
+        <p:txBody>
+          <a:bodyPr rtlCol="0" anchor="ctr"/>
+          <a:lstStyle/>
+          <a:p>
+            <a:pPr algn="ctr"/>
+          </a:p>
+        </p:txBody>
+      </p:sp>
+      <p:sp>
+        <p:nvSpPr>
+          <p:cNvPr id="23" name="TextBox 22"/>
           <p:cNvSpPr txBox="1"/>
           <p:nvPr/>
         </p:nvSpPr>
         <p:spPr>
           <a:xfrm>
-            <a:off x="864000" y="17190000"/>
-            <a:ext cx="7362000" cy="1980000"/>
+            <a:off x="4914000" y="20214000"/>
+            <a:ext cx="3131999" cy="3311999"/>
           </a:xfrm>
           <a:prstGeom prst="rect">
             <a:avLst/>
@@ -4307,35 +4465,32 @@
                 </a:solidFill>
                 <a:latin typeface="IBM Plex Sans"/>
               </a:rPr>
-              <a:t>Khái niệm và tài liệu nền tảng đề tài dựa vào.</a:t>
-            </a:r>
-          </a:p>
-        </p:txBody>
-      </p:sp>
-      <p:sp>
-        <p:nvSpPr>
-          <p:cNvPr id="20" name="Rounded Rectangle 19"/>
+              <a:t>[ T3 — em viết 1 câu mời xem demo / dùng thử tại gian ]</a:t>
+            </a:r>
+          </a:p>
+        </p:txBody>
+      </p:sp>
+      <p:sp>
+        <p:nvSpPr>
+          <p:cNvPr id="24" name="Rounded Rectangle 23"/>
           <p:cNvSpPr/>
           <p:nvPr/>
         </p:nvSpPr>
         <p:spPr>
           <a:xfrm>
-            <a:off x="864000" y="19350000"/>
-            <a:ext cx="7362000" cy="6642000"/>
+            <a:off x="9450000" y="540000"/>
+            <a:ext cx="17100000" cy="4860000"/>
           </a:xfrm>
           <a:prstGeom prst="roundRect">
             <a:avLst>
-              <a:gd name="adj" fmla="val 1626"/>
+              <a:gd name="adj" fmla="val 2222"/>
             </a:avLst>
           </a:prstGeom>
           <a:solidFill>
-            <a:srgbClr val="F3F4F1"/>
+            <a:srgbClr val="1C2321"/>
           </a:solidFill>
-          <a:ln w="21600">
-            <a:solidFill>
-              <a:srgbClr val="5B6570"/>
-            </a:solidFill>
-            <a:prstDash val="dash"/>
+          <a:ln>
+            <a:noFill/>
           </a:ln>
           <a:effectLst/>
         </p:spPr>
@@ -4358,32 +4513,82 @@
           <a:lstStyle/>
           <a:p>
             <a:pPr algn="ctr"/>
-            <a:r>
-              <a:rPr sz="1300">
+          </a:p>
+        </p:txBody>
+      </p:sp>
+      <p:sp>
+        <p:nvSpPr>
+          <p:cNvPr id="25" name="TextBox 24"/>
+          <p:cNvSpPr txBox="1"/>
+          <p:nvPr/>
+        </p:nvSpPr>
+        <p:spPr>
+          <a:xfrm>
+            <a:off x="9990000" y="936000"/>
+            <a:ext cx="16020000" cy="4068000"/>
+          </a:xfrm>
+          <a:prstGeom prst="rect">
+            <a:avLst/>
+          </a:prstGeom>
+          <a:noFill/>
+        </p:spPr>
+        <p:txBody>
+          <a:bodyPr wrap="square" anchor="ctr" lIns="0" rIns="0" tIns="0" bIns="0">
+            <a:spAutoFit/>
+          </a:bodyPr>
+          <a:lstStyle/>
+          <a:p>
+            <a:pPr algn="l"/>
+            <a:r>
+              <a:rPr sz="2000" b="1" i="0">
                 <a:solidFill>
-                  <a:srgbClr val="5B6570"/>
+                  <a:srgbClr val="C98A1F"/>
                 </a:solidFill>
                 <a:latin typeface="IBM Plex Sans"/>
               </a:rPr>
-              <a:t>[ Sơ đồ khái niệm (nếu có) ]</a:t>
-            </a:r>
-          </a:p>
-        </p:txBody>
-      </p:sp>
-      <p:sp>
-        <p:nvSpPr>
-          <p:cNvPr id="21" name="Rounded Rectangle 20"/>
+              <a:t>[ H1 — LĨNH VỰC DỰ THI ]</a:t>
+            </a:r>
+          </a:p>
+          <a:p>
+            <a:pPr algn="l"/>
+            <a:r>
+              <a:rPr sz="7000" b="1" i="0">
+                <a:solidFill>
+                  <a:srgbClr val="F3F4F1"/>
+                </a:solidFill>
+                <a:latin typeface="Be Vietnam Pro"/>
+              </a:rPr>
+              <a:t>[ H2 — THÔNG ĐIỆP CHÍNH, MỘT CÂU, TỐI ĐA HAI DÒNG ]</a:t>
+            </a:r>
+          </a:p>
+          <a:p>
+            <a:pPr algn="l"/>
+            <a:r>
+              <a:rPr sz="2400" b="0" i="0">
+                <a:solidFill>
+                  <a:srgbClr val="DBDCD5"/>
+                </a:solidFill>
+                <a:latin typeface="IBM Plex Sans"/>
+              </a:rPr>
+              <a:t>[ H3 — tên đề tài đầy đủ ]</a:t>
+            </a:r>
+          </a:p>
+        </p:txBody>
+      </p:sp>
+      <p:sp>
+        <p:nvSpPr>
+          <p:cNvPr id="26" name="Rounded Rectangle 25"/>
           <p:cNvSpPr/>
           <p:nvPr/>
         </p:nvSpPr>
         <p:spPr>
           <a:xfrm>
             <a:off x="9450000" y="5850000"/>
-            <a:ext cx="17100000" cy="7560000"/>
+            <a:ext cx="10980000" cy="10260000"/>
           </a:xfrm>
           <a:prstGeom prst="roundRect">
             <a:avLst>
-              <a:gd name="adj" fmla="val 1428"/>
+              <a:gd name="adj" fmla="val 1052"/>
             </a:avLst>
           </a:prstGeom>
           <a:solidFill>
@@ -4418,25 +4623,87 @@
           </a:p>
         </p:txBody>
       </p:sp>
-      <p:sp>
-        <p:nvSpPr>
-          <p:cNvPr id="22" name="Oval 21"/>
+      <p:pic>
+        <p:nvPicPr>
+          <p:cNvPr id="27" name="Picture 26" descr="giao_dien_ket_qua.png"/>
+          <p:cNvPicPr>
+            <a:picLocks noChangeAspect="1"/>
+          </p:cNvPicPr>
+          <p:nvPr/>
+        </p:nvPicPr>
+        <p:blipFill>
+          <a:blip r:embed="rId3"/>
+          <a:stretch>
+            <a:fillRect/>
+          </a:stretch>
+        </p:blipFill>
+        <p:spPr>
+          <a:xfrm>
+            <a:off x="9774000" y="6173999"/>
+            <a:ext cx="10332000" cy="6457500"/>
+          </a:xfrm>
+          <a:prstGeom prst="rect">
+            <a:avLst/>
+          </a:prstGeom>
+        </p:spPr>
+      </p:pic>
+      <p:sp>
+        <p:nvSpPr>
+          <p:cNvPr id="28" name="TextBox 27"/>
+          <p:cNvSpPr txBox="1"/>
+          <p:nvPr/>
+        </p:nvSpPr>
+        <p:spPr>
+          <a:xfrm>
+            <a:off x="9774000" y="12703500"/>
+            <a:ext cx="10332000" cy="288000"/>
+          </a:xfrm>
+          <a:prstGeom prst="rect">
+            <a:avLst/>
+          </a:prstGeom>
+          <a:noFill/>
+        </p:spPr>
+        <p:txBody>
+          <a:bodyPr wrap="square" anchor="t" lIns="0" rIns="0" tIns="0" bIns="0">
+            <a:spAutoFit/>
+          </a:bodyPr>
+          <a:lstStyle/>
+          <a:p>
+            <a:pPr algn="l"/>
+            <a:r>
+              <a:rPr sz="1200" b="0" i="0">
+                <a:solidFill>
+                  <a:srgbClr val="5B6570"/>
+                </a:solidFill>
+                <a:latin typeface="IBM Plex Sans"/>
+              </a:rPr>
+              <a:t>Ảnh chụp giao diện thật · tab Kết quả · dữ liệu mô phỏng (120 học sinh, 10 CLB)</a:t>
+            </a:r>
+          </a:p>
+        </p:txBody>
+      </p:sp>
+      <p:sp>
+        <p:nvSpPr>
+          <p:cNvPr id="29" name="Rounded Rectangle 28"/>
           <p:cNvSpPr/>
           <p:nvPr/>
         </p:nvSpPr>
         <p:spPr>
           <a:xfrm>
-            <a:off x="9774000" y="6138000"/>
-            <a:ext cx="522000" cy="522000"/>
-          </a:xfrm>
-          <a:prstGeom prst="ellipse">
-            <a:avLst/>
-          </a:prstGeom>
-          <a:solidFill>
-            <a:srgbClr val="C98A1F"/>
-          </a:solidFill>
-          <a:ln>
-            <a:noFill/>
+            <a:off x="9774000" y="13063500"/>
+            <a:ext cx="10332000" cy="2722500"/>
+          </a:xfrm>
+          <a:prstGeom prst="roundRect">
+            <a:avLst>
+              <a:gd name="adj" fmla="val 3966"/>
+            </a:avLst>
+          </a:prstGeom>
+          <a:noFill/>
+          <a:ln w="18000">
+            <a:solidFill>
+              <a:srgbClr val="DBDCD5"/>
+            </a:solidFill>
+            <a:prstDash val="dash"/>
           </a:ln>
           <a:effectLst/>
         </p:spPr>
@@ -4455,67 +4722,23 @@
           </a:fontRef>
         </p:style>
         <p:txBody>
-          <a:bodyPr rtlCol="0" anchor="ctr" lIns="0" rIns="0" tIns="0" bIns="0"/>
+          <a:bodyPr rtlCol="0" anchor="ctr"/>
           <a:lstStyle/>
           <a:p>
             <a:pPr algn="ctr"/>
-            <a:r>
-              <a:rPr sz="1860" b="1">
-                <a:solidFill>
-                  <a:srgbClr val="FFFFFF"/>
-                </a:solidFill>
-                <a:latin typeface="Be Vietnam Pro"/>
-              </a:rPr>
-              <a:t>04</a:t>
-            </a:r>
-          </a:p>
-        </p:txBody>
-      </p:sp>
-      <p:sp>
-        <p:nvSpPr>
-          <p:cNvPr id="23" name="TextBox 22"/>
+          </a:p>
+        </p:txBody>
+      </p:sp>
+      <p:sp>
+        <p:nvSpPr>
+          <p:cNvPr id="30" name="TextBox 29"/>
           <p:cNvSpPr txBox="1"/>
           <p:nvPr/>
         </p:nvSpPr>
         <p:spPr>
           <a:xfrm>
-            <a:off x="10439999" y="6138000"/>
-            <a:ext cx="15785999" cy="522000"/>
-          </a:xfrm>
-          <a:prstGeom prst="rect">
-            <a:avLst/>
-          </a:prstGeom>
-          <a:noFill/>
-        </p:spPr>
-        <p:txBody>
-          <a:bodyPr wrap="square" anchor="ctr" lIns="0" rIns="0" tIns="0" bIns="0">
-            <a:spAutoFit/>
-          </a:bodyPr>
-          <a:lstStyle/>
-          <a:p>
-            <a:pPr algn="l"/>
-            <a:r>
-              <a:rPr sz="3000" b="1" i="0">
-                <a:solidFill>
-                  <a:srgbClr val="1C2321"/>
-                </a:solidFill>
-                <a:latin typeface="Be Vietnam Pro"/>
-              </a:rPr>
-              <a:t>Phương pháp &amp; quy trình</a:t>
-            </a:r>
-          </a:p>
-        </p:txBody>
-      </p:sp>
-      <p:sp>
-        <p:nvSpPr>
-          <p:cNvPr id="24" name="TextBox 23"/>
-          <p:cNvSpPr txBox="1"/>
-          <p:nvPr/>
-        </p:nvSpPr>
-        <p:spPr>
-          <a:xfrm>
-            <a:off x="9774000" y="6840000"/>
-            <a:ext cx="16452000" cy="1530000"/>
+            <a:off x="9954000" y="13207500"/>
+            <a:ext cx="9972000" cy="2434500"/>
           </a:xfrm>
           <a:prstGeom prst="rect">
             <a:avLst/>
@@ -4536,83 +4759,25 @@
                 </a:solidFill>
                 <a:latin typeface="IBM Plex Sans"/>
               </a:rPr>
-              <a:t>Các bước thực hiện, từ dữ liệu đầu vào tới kết quả.</a:t>
-            </a:r>
-          </a:p>
-        </p:txBody>
-      </p:sp>
-      <p:sp>
-        <p:nvSpPr>
-          <p:cNvPr id="25" name="Rounded Rectangle 24"/>
+              <a:t>[ G1 — em viết 1–2 câu: ảnh này cho thấy phần mềm làm được gì? ]</a:t>
+            </a:r>
+          </a:p>
+        </p:txBody>
+      </p:sp>
+      <p:sp>
+        <p:nvSpPr>
+          <p:cNvPr id="31" name="Rounded Rectangle 30"/>
           <p:cNvSpPr/>
           <p:nvPr/>
         </p:nvSpPr>
         <p:spPr>
           <a:xfrm>
-            <a:off x="9774000" y="8550000"/>
-            <a:ext cx="16452000" cy="4572000"/>
+            <a:off x="20880000" y="5850000"/>
+            <a:ext cx="5670000" cy="3180000"/>
           </a:xfrm>
           <a:prstGeom prst="roundRect">
             <a:avLst>
-              <a:gd name="adj" fmla="val 2362"/>
-            </a:avLst>
-          </a:prstGeom>
-          <a:solidFill>
-            <a:srgbClr val="F3F4F1"/>
-          </a:solidFill>
-          <a:ln w="21600">
-            <a:solidFill>
-              <a:srgbClr val="5B6570"/>
-            </a:solidFill>
-            <a:prstDash val="dash"/>
-          </a:ln>
-          <a:effectLst/>
-        </p:spPr>
-        <p:style>
-          <a:lnRef idx="1">
-            <a:schemeClr val="accent1"/>
-          </a:lnRef>
-          <a:fillRef idx="3">
-            <a:schemeClr val="accent1"/>
-          </a:fillRef>
-          <a:effectRef idx="2">
-            <a:schemeClr val="accent1"/>
-          </a:effectRef>
-          <a:fontRef idx="minor">
-            <a:schemeClr val="lt1"/>
-          </a:fontRef>
-        </p:style>
-        <p:txBody>
-          <a:bodyPr rtlCol="0" anchor="ctr"/>
-          <a:lstStyle/>
-          <a:p>
-            <a:pPr algn="ctr"/>
-            <a:r>
-              <a:rPr sz="1300">
-                <a:solidFill>
-                  <a:srgbClr val="5B6570"/>
-                </a:solidFill>
-                <a:latin typeface="IBM Plex Sans"/>
-              </a:rPr>
-              <a:t>[ Sơ đồ quy trình — khổ ngang ]</a:t>
-            </a:r>
-          </a:p>
-        </p:txBody>
-      </p:sp>
-      <p:sp>
-        <p:nvSpPr>
-          <p:cNvPr id="26" name="Rounded Rectangle 25"/>
-          <p:cNvSpPr/>
-          <p:nvPr/>
-        </p:nvSpPr>
-        <p:spPr>
-          <a:xfrm>
-            <a:off x="9450000" y="13860000"/>
-            <a:ext cx="8325000" cy="12420000"/>
-          </a:xfrm>
-          <a:prstGeom prst="roundRect">
-            <a:avLst>
-              <a:gd name="adj" fmla="val 1297"/>
+              <a:gd name="adj" fmla="val 3396"/>
             </a:avLst>
           </a:prstGeom>
           <a:solidFill>
@@ -4649,20 +4814,20 @@
       </p:sp>
       <p:sp>
         <p:nvSpPr>
-          <p:cNvPr id="27" name="Oval 26"/>
+          <p:cNvPr id="32" name="Rectangle 31"/>
           <p:cNvSpPr/>
           <p:nvPr/>
         </p:nvSpPr>
         <p:spPr>
           <a:xfrm>
-            <a:off x="9774000" y="14147999"/>
-            <a:ext cx="522000" cy="522000"/>
-          </a:xfrm>
-          <a:prstGeom prst="ellipse">
+            <a:off x="20880000" y="5850000"/>
+            <a:ext cx="108000" cy="3180000"/>
+          </a:xfrm>
+          <a:prstGeom prst="rect">
             <a:avLst/>
           </a:prstGeom>
           <a:solidFill>
-            <a:srgbClr val="C98A1F"/>
+            <a:srgbClr val="27805A"/>
           </a:solidFill>
           <a:ln>
             <a:noFill/>
@@ -4684,199 +4849,86 @@
           </a:fontRef>
         </p:style>
         <p:txBody>
-          <a:bodyPr rtlCol="0" anchor="ctr" lIns="0" rIns="0" tIns="0" bIns="0"/>
+          <a:bodyPr rtlCol="0" anchor="ctr"/>
           <a:lstStyle/>
           <a:p>
             <a:pPr algn="ctr"/>
-            <a:r>
-              <a:rPr sz="1860" b="1">
+          </a:p>
+        </p:txBody>
+      </p:sp>
+      <p:sp>
+        <p:nvSpPr>
+          <p:cNvPr id="33" name="TextBox 32"/>
+          <p:cNvSpPr txBox="1"/>
+          <p:nvPr/>
+        </p:nvSpPr>
+        <p:spPr>
+          <a:xfrm>
+            <a:off x="21168000" y="6066000"/>
+            <a:ext cx="5166000" cy="2748000"/>
+          </a:xfrm>
+          <a:prstGeom prst="rect">
+            <a:avLst/>
+          </a:prstGeom>
+          <a:noFill/>
+        </p:spPr>
+        <p:txBody>
+          <a:bodyPr wrap="square" anchor="t" lIns="0" rIns="0" tIns="0" bIns="0">
+            <a:spAutoFit/>
+          </a:bodyPr>
+          <a:lstStyle/>
+          <a:p>
+            <a:pPr algn="l"/>
+            <a:r>
+              <a:rPr sz="5500" b="1" i="0">
                 <a:solidFill>
-                  <a:srgbClr val="FFFFFF"/>
+                  <a:srgbClr val="27805A"/>
                 </a:solidFill>
                 <a:latin typeface="Be Vietnam Pro"/>
               </a:rPr>
-              <a:t>05</a:t>
-            </a:r>
-          </a:p>
-        </p:txBody>
-      </p:sp>
-      <p:sp>
-        <p:nvSpPr>
-          <p:cNvPr id="28" name="TextBox 27"/>
-          <p:cNvSpPr txBox="1"/>
-          <p:nvPr/>
-        </p:nvSpPr>
-        <p:spPr>
-          <a:xfrm>
-            <a:off x="10439999" y="14147999"/>
-            <a:ext cx="7011000" cy="522000"/>
-          </a:xfrm>
-          <a:prstGeom prst="rect">
-            <a:avLst/>
-          </a:prstGeom>
-          <a:noFill/>
-        </p:spPr>
-        <p:txBody>
-          <a:bodyPr wrap="square" anchor="ctr" lIns="0" rIns="0" tIns="0" bIns="0">
-            <a:spAutoFit/>
-          </a:bodyPr>
-          <a:lstStyle/>
+              <a:t>0</a:t>
+            </a:r>
+          </a:p>
           <a:p>
             <a:pPr algn="l"/>
             <a:r>
-              <a:rPr sz="3000" b="1" i="0">
+              <a:rPr sz="1200" b="1" i="0">
                 <a:solidFill>
                   <a:srgbClr val="1C2321"/>
                 </a:solidFill>
-                <a:latin typeface="Be Vietnam Pro"/>
+                <a:latin typeface="IBM Plex Sans"/>
               </a:rPr>
-              <a:t>Sản phẩm</a:t>
-            </a:r>
-          </a:p>
-        </p:txBody>
-      </p:sp>
-      <p:sp>
-        <p:nvSpPr>
-          <p:cNvPr id="29" name="TextBox 28"/>
-          <p:cNvSpPr txBox="1"/>
-          <p:nvPr/>
-        </p:nvSpPr>
-        <p:spPr>
-          <a:xfrm>
-            <a:off x="9774000" y="14850000"/>
-            <a:ext cx="7677000" cy="1620000"/>
-          </a:xfrm>
-          <a:prstGeom prst="rect">
-            <a:avLst/>
-          </a:prstGeom>
-          <a:noFill/>
-        </p:spPr>
-        <p:txBody>
-          <a:bodyPr wrap="square" anchor="t" lIns="0" rIns="0" tIns="0" bIns="0">
-            <a:spAutoFit/>
-          </a:bodyPr>
-          <a:lstStyle/>
+              <a:t>cặp phá vỡ · mọi seed, mọi bộ dữ liệu mô phỏng</a:t>
+            </a:r>
+          </a:p>
           <a:p>
             <a:pPr algn="l"/>
             <a:r>
-              <a:rPr sz="1600" b="0" i="1">
+              <a:rPr sz="1200" b="0" i="1">
                 <a:solidFill>
                   <a:srgbClr val="5B6570"/>
                 </a:solidFill>
                 <a:latin typeface="IBM Plex Sans"/>
               </a:rPr>
-              <a:t>Sản phẩm làm được gì, dùng thế nào.</a:t>
-            </a:r>
-          </a:p>
-        </p:txBody>
-      </p:sp>
-      <p:sp>
-        <p:nvSpPr>
-          <p:cNvPr id="30" name="Rounded Rectangle 29"/>
+              <a:t>[ S1 — em viết 1 dòng: con số này nghĩa là gì? ]</a:t>
+            </a:r>
+          </a:p>
+        </p:txBody>
+      </p:sp>
+      <p:sp>
+        <p:nvSpPr>
+          <p:cNvPr id="34" name="Rounded Rectangle 33"/>
           <p:cNvSpPr/>
           <p:nvPr/>
         </p:nvSpPr>
         <p:spPr>
           <a:xfrm>
-            <a:off x="9774000" y="16650000"/>
-            <a:ext cx="7677000" cy="6840000"/>
+            <a:off x="20880000" y="9390000"/>
+            <a:ext cx="5670000" cy="3180000"/>
           </a:xfrm>
           <a:prstGeom prst="roundRect">
             <a:avLst>
-              <a:gd name="adj" fmla="val 1578"/>
-            </a:avLst>
-          </a:prstGeom>
-          <a:solidFill>
-            <a:srgbClr val="F3F4F1"/>
-          </a:solidFill>
-          <a:ln w="21600">
-            <a:solidFill>
-              <a:srgbClr val="5B6570"/>
-            </a:solidFill>
-            <a:prstDash val="dash"/>
-          </a:ln>
-          <a:effectLst/>
-        </p:spPr>
-        <p:style>
-          <a:lnRef idx="1">
-            <a:schemeClr val="accent1"/>
-          </a:lnRef>
-          <a:fillRef idx="3">
-            <a:schemeClr val="accent1"/>
-          </a:fillRef>
-          <a:effectRef idx="2">
-            <a:schemeClr val="accent1"/>
-          </a:effectRef>
-          <a:fontRef idx="minor">
-            <a:schemeClr val="lt1"/>
-          </a:fontRef>
-        </p:style>
-        <p:txBody>
-          <a:bodyPr rtlCol="0" anchor="ctr"/>
-          <a:lstStyle/>
-          <a:p>
-            <a:pPr algn="ctr"/>
-            <a:r>
-              <a:rPr sz="1300">
-                <a:solidFill>
-                  <a:srgbClr val="5B6570"/>
-                </a:solidFill>
-                <a:latin typeface="IBM Plex Sans"/>
-              </a:rPr>
-              <a:t>[ Ảnh chụp giao diện / sản phẩm ]</a:t>
-            </a:r>
-          </a:p>
-        </p:txBody>
-      </p:sp>
-      <p:sp>
-        <p:nvSpPr>
-          <p:cNvPr id="31" name="TextBox 30"/>
-          <p:cNvSpPr txBox="1"/>
-          <p:nvPr/>
-        </p:nvSpPr>
-        <p:spPr>
-          <a:xfrm>
-            <a:off x="9774000" y="23670000"/>
-            <a:ext cx="7677000" cy="2322000"/>
-          </a:xfrm>
-          <a:prstGeom prst="rect">
-            <a:avLst/>
-          </a:prstGeom>
-          <a:noFill/>
-        </p:spPr>
-        <p:txBody>
-          <a:bodyPr wrap="square" anchor="t" lIns="0" rIns="0" tIns="0" bIns="0">
-            <a:spAutoFit/>
-          </a:bodyPr>
-          <a:lstStyle/>
-          <a:p>
-            <a:pPr algn="l"/>
-            <a:r>
-              <a:rPr sz="1300" b="0" i="1">
-                <a:solidFill>
-                  <a:srgbClr val="5B6570"/>
-                </a:solidFill>
-                <a:latin typeface="IBM Plex Sans"/>
-              </a:rPr>
-              <a:t>Chú thích ảnh và 3–4 dòng diễn giải.</a:t>
-            </a:r>
-          </a:p>
-        </p:txBody>
-      </p:sp>
-      <p:sp>
-        <p:nvSpPr>
-          <p:cNvPr id="32" name="Rounded Rectangle 31"/>
-          <p:cNvSpPr/>
-          <p:nvPr/>
-        </p:nvSpPr>
-        <p:spPr>
-          <a:xfrm>
-            <a:off x="18225000" y="13860000"/>
-            <a:ext cx="8325000" cy="12420000"/>
-          </a:xfrm>
-          <a:prstGeom prst="roundRect">
-            <a:avLst>
-              <a:gd name="adj" fmla="val 1297"/>
+              <a:gd name="adj" fmla="val 3396"/>
             </a:avLst>
           </a:prstGeom>
           <a:solidFill>
@@ -4913,20 +4965,20 @@
       </p:sp>
       <p:sp>
         <p:nvSpPr>
-          <p:cNvPr id="33" name="Oval 32"/>
+          <p:cNvPr id="35" name="Rectangle 34"/>
           <p:cNvSpPr/>
           <p:nvPr/>
         </p:nvSpPr>
         <p:spPr>
           <a:xfrm>
-            <a:off x="18549000" y="14147999"/>
-            <a:ext cx="522000" cy="522000"/>
-          </a:xfrm>
-          <a:prstGeom prst="ellipse">
+            <a:off x="20880000" y="9390000"/>
+            <a:ext cx="108000" cy="3180000"/>
+          </a:xfrm>
+          <a:prstGeom prst="rect">
             <a:avLst/>
           </a:prstGeom>
           <a:solidFill>
-            <a:srgbClr val="C98A1F"/>
+            <a:srgbClr val="27805A"/>
           </a:solidFill>
           <a:ln>
             <a:noFill/>
@@ -4948,199 +5000,86 @@
           </a:fontRef>
         </p:style>
         <p:txBody>
-          <a:bodyPr rtlCol="0" anchor="ctr" lIns="0" rIns="0" tIns="0" bIns="0"/>
+          <a:bodyPr rtlCol="0" anchor="ctr"/>
           <a:lstStyle/>
           <a:p>
             <a:pPr algn="ctr"/>
-            <a:r>
-              <a:rPr sz="1860" b="1">
+          </a:p>
+        </p:txBody>
+      </p:sp>
+      <p:sp>
+        <p:nvSpPr>
+          <p:cNvPr id="36" name="TextBox 35"/>
+          <p:cNvSpPr txBox="1"/>
+          <p:nvPr/>
+        </p:nvSpPr>
+        <p:spPr>
+          <a:xfrm>
+            <a:off x="21168000" y="9606000"/>
+            <a:ext cx="5166000" cy="2748000"/>
+          </a:xfrm>
+          <a:prstGeom prst="rect">
+            <a:avLst/>
+          </a:prstGeom>
+          <a:noFill/>
+        </p:spPr>
+        <p:txBody>
+          <a:bodyPr wrap="square" anchor="t" lIns="0" rIns="0" tIns="0" bIns="0">
+            <a:spAutoFit/>
+          </a:bodyPr>
+          <a:lstStyle/>
+          <a:p>
+            <a:pPr algn="l"/>
+            <a:r>
+              <a:rPr sz="5500" b="1" i="0">
                 <a:solidFill>
-                  <a:srgbClr val="FFFFFF"/>
+                  <a:srgbClr val="27805A"/>
                 </a:solidFill>
                 <a:latin typeface="Be Vietnam Pro"/>
               </a:rPr>
-              <a:t>06</a:t>
-            </a:r>
-          </a:p>
-        </p:txBody>
-      </p:sp>
-      <p:sp>
-        <p:nvSpPr>
-          <p:cNvPr id="34" name="TextBox 33"/>
-          <p:cNvSpPr txBox="1"/>
-          <p:nvPr/>
-        </p:nvSpPr>
-        <p:spPr>
-          <a:xfrm>
-            <a:off x="19215000" y="14147999"/>
-            <a:ext cx="7010999" cy="522000"/>
-          </a:xfrm>
-          <a:prstGeom prst="rect">
-            <a:avLst/>
-          </a:prstGeom>
-          <a:noFill/>
-        </p:spPr>
-        <p:txBody>
-          <a:bodyPr wrap="square" anchor="ctr" lIns="0" rIns="0" tIns="0" bIns="0">
-            <a:spAutoFit/>
-          </a:bodyPr>
-          <a:lstStyle/>
+              <a:t>0,14 giây</a:t>
+            </a:r>
+          </a:p>
           <a:p>
             <a:pPr algn="l"/>
             <a:r>
-              <a:rPr sz="3000" b="1" i="0">
+              <a:rPr sz="1200" b="1" i="0">
                 <a:solidFill>
                   <a:srgbClr val="1C2321"/>
                 </a:solidFill>
-                <a:latin typeface="Be Vietnam Pro"/>
+                <a:latin typeface="IBM Plex Sans"/>
               </a:rPr>
-              <a:t>Kết quả</a:t>
-            </a:r>
-          </a:p>
-        </p:txBody>
-      </p:sp>
-      <p:sp>
-        <p:nvSpPr>
-          <p:cNvPr id="35" name="TextBox 34"/>
-          <p:cNvSpPr txBox="1"/>
-          <p:nvPr/>
-        </p:nvSpPr>
-        <p:spPr>
-          <a:xfrm>
-            <a:off x="18549000" y="14850000"/>
-            <a:ext cx="7677000" cy="1620000"/>
-          </a:xfrm>
-          <a:prstGeom prst="rect">
-            <a:avLst/>
-          </a:prstGeom>
-          <a:noFill/>
-        </p:spPr>
-        <p:txBody>
-          <a:bodyPr wrap="square" anchor="t" lIns="0" rIns="0" tIns="0" bIns="0">
-            <a:spAutoFit/>
-          </a:bodyPr>
-          <a:lstStyle/>
+              <a:t>xếp 2 000 học sinh · 40 CLB · dữ liệu mô phỏng</a:t>
+            </a:r>
+          </a:p>
           <a:p>
             <a:pPr algn="l"/>
             <a:r>
-              <a:rPr sz="1600" b="0" i="1">
+              <a:rPr sz="1200" b="0" i="1">
                 <a:solidFill>
                   <a:srgbClr val="5B6570"/>
                 </a:solidFill>
                 <a:latin typeface="IBM Plex Sans"/>
               </a:rPr>
-              <a:t>Số đo chính. Dữ liệu mô phỏng thì ghi rõ là mô phỏng.</a:t>
-            </a:r>
-          </a:p>
-        </p:txBody>
-      </p:sp>
-      <p:sp>
-        <p:nvSpPr>
-          <p:cNvPr id="36" name="Rounded Rectangle 35"/>
+              <a:t>[ S2 — em viết 1 dòng: con số này nghĩa là gì? ]</a:t>
+            </a:r>
+          </a:p>
+        </p:txBody>
+      </p:sp>
+      <p:sp>
+        <p:nvSpPr>
+          <p:cNvPr id="37" name="Rounded Rectangle 36"/>
           <p:cNvSpPr/>
           <p:nvPr/>
         </p:nvSpPr>
         <p:spPr>
           <a:xfrm>
-            <a:off x="18549000" y="16650000"/>
-            <a:ext cx="7677000" cy="6840000"/>
+            <a:off x="20880000" y="12930000"/>
+            <a:ext cx="5670000" cy="3180000"/>
           </a:xfrm>
           <a:prstGeom prst="roundRect">
             <a:avLst>
-              <a:gd name="adj" fmla="val 1578"/>
-            </a:avLst>
-          </a:prstGeom>
-          <a:solidFill>
-            <a:srgbClr val="F3F4F1"/>
-          </a:solidFill>
-          <a:ln w="21600">
-            <a:solidFill>
-              <a:srgbClr val="5B6570"/>
-            </a:solidFill>
-            <a:prstDash val="dash"/>
-          </a:ln>
-          <a:effectLst/>
-        </p:spPr>
-        <p:style>
-          <a:lnRef idx="1">
-            <a:schemeClr val="accent1"/>
-          </a:lnRef>
-          <a:fillRef idx="3">
-            <a:schemeClr val="accent1"/>
-          </a:fillRef>
-          <a:effectRef idx="2">
-            <a:schemeClr val="accent1"/>
-          </a:effectRef>
-          <a:fontRef idx="minor">
-            <a:schemeClr val="lt1"/>
-          </a:fontRef>
-        </p:style>
-        <p:txBody>
-          <a:bodyPr rtlCol="0" anchor="ctr"/>
-          <a:lstStyle/>
-          <a:p>
-            <a:pPr algn="ctr"/>
-            <a:r>
-              <a:rPr sz="1300">
-                <a:solidFill>
-                  <a:srgbClr val="5B6570"/>
-                </a:solidFill>
-                <a:latin typeface="IBM Plex Sans"/>
-              </a:rPr>
-              <a:t>[ Biểu đồ / bảng số liệu ]</a:t>
-            </a:r>
-          </a:p>
-        </p:txBody>
-      </p:sp>
-      <p:sp>
-        <p:nvSpPr>
-          <p:cNvPr id="37" name="TextBox 36"/>
-          <p:cNvSpPr txBox="1"/>
-          <p:nvPr/>
-        </p:nvSpPr>
-        <p:spPr>
-          <a:xfrm>
-            <a:off x="18549000" y="23670000"/>
-            <a:ext cx="7677000" cy="2322000"/>
-          </a:xfrm>
-          <a:prstGeom prst="rect">
-            <a:avLst/>
-          </a:prstGeom>
-          <a:noFill/>
-        </p:spPr>
-        <p:txBody>
-          <a:bodyPr wrap="square" anchor="t" lIns="0" rIns="0" tIns="0" bIns="0">
-            <a:spAutoFit/>
-          </a:bodyPr>
-          <a:lstStyle/>
-          <a:p>
-            <a:pPr algn="l"/>
-            <a:r>
-              <a:rPr sz="1300" b="0" i="1">
-                <a:solidFill>
-                  <a:srgbClr val="5B6570"/>
-                </a:solidFill>
-                <a:latin typeface="IBM Plex Sans"/>
-              </a:rPr>
-              <a:t>Chú thích ảnh và 3–4 dòng diễn giải.</a:t>
-            </a:r>
-          </a:p>
-        </p:txBody>
-      </p:sp>
-      <p:sp>
-        <p:nvSpPr>
-          <p:cNvPr id="38" name="Rounded Rectangle 37"/>
-          <p:cNvSpPr/>
-          <p:nvPr/>
-        </p:nvSpPr>
-        <p:spPr>
-          <a:xfrm>
-            <a:off x="27450000" y="540000"/>
-            <a:ext cx="8010000" cy="7200000"/>
-          </a:xfrm>
-          <a:prstGeom prst="roundRect">
-            <a:avLst>
-              <a:gd name="adj" fmla="val 1500"/>
+              <a:gd name="adj" fmla="val 3396"/>
             </a:avLst>
           </a:prstGeom>
           <a:solidFill>
@@ -5177,20 +5116,20 @@
       </p:sp>
       <p:sp>
         <p:nvSpPr>
-          <p:cNvPr id="39" name="Oval 38"/>
+          <p:cNvPr id="38" name="Rectangle 37"/>
           <p:cNvSpPr/>
           <p:nvPr/>
         </p:nvSpPr>
         <p:spPr>
           <a:xfrm>
-            <a:off x="27774000" y="827999"/>
-            <a:ext cx="522000" cy="522000"/>
-          </a:xfrm>
-          <a:prstGeom prst="ellipse">
+            <a:off x="20880000" y="12930000"/>
+            <a:ext cx="108000" cy="3180000"/>
+          </a:xfrm>
+          <a:prstGeom prst="rect">
             <a:avLst/>
           </a:prstGeom>
           <a:solidFill>
-            <a:srgbClr val="C98A1F"/>
+            <a:srgbClr val="27805A"/>
           </a:solidFill>
           <a:ln>
             <a:noFill/>
@@ -5212,277 +5151,86 @@
           </a:fontRef>
         </p:style>
         <p:txBody>
-          <a:bodyPr rtlCol="0" anchor="ctr" lIns="0" rIns="0" tIns="0" bIns="0"/>
+          <a:bodyPr rtlCol="0" anchor="ctr"/>
           <a:lstStyle/>
           <a:p>
             <a:pPr algn="ctr"/>
-            <a:r>
-              <a:rPr sz="1860" b="1">
+          </a:p>
+        </p:txBody>
+      </p:sp>
+      <p:sp>
+        <p:nvSpPr>
+          <p:cNvPr id="39" name="TextBox 38"/>
+          <p:cNvSpPr txBox="1"/>
+          <p:nvPr/>
+        </p:nvSpPr>
+        <p:spPr>
+          <a:xfrm>
+            <a:off x="21168000" y="13146000"/>
+            <a:ext cx="5166000" cy="2748000"/>
+          </a:xfrm>
+          <a:prstGeom prst="rect">
+            <a:avLst/>
+          </a:prstGeom>
+          <a:noFill/>
+        </p:spPr>
+        <p:txBody>
+          <a:bodyPr wrap="square" anchor="t" lIns="0" rIns="0" tIns="0" bIns="0">
+            <a:spAutoFit/>
+          </a:bodyPr>
+          <a:lstStyle/>
+          <a:p>
+            <a:pPr algn="l"/>
+            <a:r>
+              <a:rPr sz="5500" b="1" i="0">
                 <a:solidFill>
-                  <a:srgbClr val="FFFFFF"/>
+                  <a:srgbClr val="27805A"/>
                 </a:solidFill>
                 <a:latin typeface="Be Vietnam Pro"/>
               </a:rPr>
-              <a:t>07</a:t>
-            </a:r>
-          </a:p>
-        </p:txBody>
-      </p:sp>
-      <p:sp>
-        <p:nvSpPr>
-          <p:cNvPr id="40" name="TextBox 39"/>
-          <p:cNvSpPr txBox="1"/>
-          <p:nvPr/>
-        </p:nvSpPr>
-        <p:spPr>
-          <a:xfrm>
-            <a:off x="28440000" y="827999"/>
-            <a:ext cx="6695999" cy="522000"/>
-          </a:xfrm>
-          <a:prstGeom prst="rect">
-            <a:avLst/>
-          </a:prstGeom>
-          <a:noFill/>
-        </p:spPr>
-        <p:txBody>
-          <a:bodyPr wrap="square" anchor="ctr" lIns="0" rIns="0" tIns="0" bIns="0">
-            <a:spAutoFit/>
-          </a:bodyPr>
-          <a:lstStyle/>
+              <a:t>816</a:t>
+            </a:r>
+          </a:p>
           <a:p>
             <a:pPr algn="l"/>
             <a:r>
-              <a:rPr sz="3000" b="1" i="0">
+              <a:rPr sz="1200" b="1" i="0">
                 <a:solidFill>
                   <a:srgbClr val="1C2321"/>
                 </a:solidFill>
-                <a:latin typeface="Be Vietnam Pro"/>
+                <a:latin typeface="IBM Plex Sans"/>
               </a:rPr>
-              <a:t>Thảo luận &amp; đánh giá</a:t>
-            </a:r>
-          </a:p>
-        </p:txBody>
-      </p:sp>
-      <p:sp>
-        <p:nvSpPr>
-          <p:cNvPr id="41" name="TextBox 40"/>
-          <p:cNvSpPr txBox="1"/>
-          <p:nvPr/>
-        </p:nvSpPr>
-        <p:spPr>
-          <a:xfrm>
-            <a:off x="27774000" y="1530000"/>
-            <a:ext cx="7362000" cy="5922000"/>
-          </a:xfrm>
-          <a:prstGeom prst="rect">
-            <a:avLst/>
-          </a:prstGeom>
-          <a:noFill/>
-        </p:spPr>
-        <p:txBody>
-          <a:bodyPr wrap="square" anchor="t" lIns="0" rIns="0" tIns="0" bIns="0">
-            <a:spAutoFit/>
-          </a:bodyPr>
-          <a:lstStyle/>
+              <a:t>bài kiểm thử tự động</a:t>
+            </a:r>
+          </a:p>
           <a:p>
             <a:pPr algn="l"/>
             <a:r>
-              <a:rPr sz="1600" b="0" i="1">
+              <a:rPr sz="1200" b="0" i="1">
                 <a:solidFill>
                   <a:srgbClr val="5B6570"/>
                 </a:solidFill>
                 <a:latin typeface="IBM Plex Sans"/>
               </a:rPr>
-              <a:t>Kết quả nói lên điều gì? Hạn chế của đề tài.</a:t>
-            </a:r>
-          </a:p>
-        </p:txBody>
-      </p:sp>
-      <p:sp>
-        <p:nvSpPr>
-          <p:cNvPr id="42" name="Rounded Rectangle 41"/>
+              <a:t>[ S3 — em viết 1 dòng: con số này nghĩa là gì? ]</a:t>
+            </a:r>
+          </a:p>
+        </p:txBody>
+      </p:sp>
+      <p:sp>
+        <p:nvSpPr>
+          <p:cNvPr id="40" name="Rounded Rectangle 39"/>
           <p:cNvSpPr/>
           <p:nvPr/>
         </p:nvSpPr>
         <p:spPr>
           <a:xfrm>
-            <a:off x="27450000" y="8190000"/>
-            <a:ext cx="8010000" cy="7200000"/>
+            <a:off x="9450000" y="16560000"/>
+            <a:ext cx="17100000" cy="9720000"/>
           </a:xfrm>
           <a:prstGeom prst="roundRect">
             <a:avLst>
-              <a:gd name="adj" fmla="val 1500"/>
-            </a:avLst>
-          </a:prstGeom>
-          <a:solidFill>
-            <a:srgbClr val="F1DFB8"/>
-          </a:solidFill>
-          <a:ln w="25200">
-            <a:solidFill>
-              <a:srgbClr val="C98A1F"/>
-            </a:solidFill>
-          </a:ln>
-          <a:effectLst/>
-        </p:spPr>
-        <p:style>
-          <a:lnRef idx="1">
-            <a:schemeClr val="accent1"/>
-          </a:lnRef>
-          <a:fillRef idx="3">
-            <a:schemeClr val="accent1"/>
-          </a:fillRef>
-          <a:effectRef idx="2">
-            <a:schemeClr val="accent1"/>
-          </a:effectRef>
-          <a:fontRef idx="minor">
-            <a:schemeClr val="lt1"/>
-          </a:fontRef>
-        </p:style>
-        <p:txBody>
-          <a:bodyPr rtlCol="0" anchor="ctr"/>
-          <a:lstStyle/>
-          <a:p>
-            <a:pPr algn="ctr"/>
-          </a:p>
-        </p:txBody>
-      </p:sp>
-      <p:sp>
-        <p:nvSpPr>
-          <p:cNvPr id="43" name="Oval 42"/>
-          <p:cNvSpPr/>
-          <p:nvPr/>
-        </p:nvSpPr>
-        <p:spPr>
-          <a:xfrm>
-            <a:off x="27774000" y="8478000"/>
-            <a:ext cx="522000" cy="522000"/>
-          </a:xfrm>
-          <a:prstGeom prst="ellipse">
-            <a:avLst/>
-          </a:prstGeom>
-          <a:solidFill>
-            <a:srgbClr val="1C2321"/>
-          </a:solidFill>
-          <a:ln>
-            <a:noFill/>
-          </a:ln>
-          <a:effectLst/>
-        </p:spPr>
-        <p:style>
-          <a:lnRef idx="1">
-            <a:schemeClr val="accent1"/>
-          </a:lnRef>
-          <a:fillRef idx="3">
-            <a:schemeClr val="accent1"/>
-          </a:fillRef>
-          <a:effectRef idx="2">
-            <a:schemeClr val="accent1"/>
-          </a:effectRef>
-          <a:fontRef idx="minor">
-            <a:schemeClr val="lt1"/>
-          </a:fontRef>
-        </p:style>
-        <p:txBody>
-          <a:bodyPr rtlCol="0" anchor="ctr" lIns="0" rIns="0" tIns="0" bIns="0"/>
-          <a:lstStyle/>
-          <a:p>
-            <a:pPr algn="ctr"/>
-            <a:r>
-              <a:rPr sz="1860" b="1">
-                <a:solidFill>
-                  <a:srgbClr val="FFFFFF"/>
-                </a:solidFill>
-                <a:latin typeface="Be Vietnam Pro"/>
-              </a:rPr>
-              <a:t>08</a:t>
-            </a:r>
-          </a:p>
-        </p:txBody>
-      </p:sp>
-      <p:sp>
-        <p:nvSpPr>
-          <p:cNvPr id="44" name="TextBox 43"/>
-          <p:cNvSpPr txBox="1"/>
-          <p:nvPr/>
-        </p:nvSpPr>
-        <p:spPr>
-          <a:xfrm>
-            <a:off x="28440000" y="8478000"/>
-            <a:ext cx="6695999" cy="522000"/>
-          </a:xfrm>
-          <a:prstGeom prst="rect">
-            <a:avLst/>
-          </a:prstGeom>
-          <a:noFill/>
-        </p:spPr>
-        <p:txBody>
-          <a:bodyPr wrap="square" anchor="ctr" lIns="0" rIns="0" tIns="0" bIns="0">
-            <a:spAutoFit/>
-          </a:bodyPr>
-          <a:lstStyle/>
-          <a:p>
-            <a:pPr algn="l"/>
-            <a:r>
-              <a:rPr sz="3000" b="1" i="0">
-                <a:solidFill>
-                  <a:srgbClr val="1C2321"/>
-                </a:solidFill>
-                <a:latin typeface="Be Vietnam Pro"/>
-              </a:rPr>
-              <a:t>Kết luận</a:t>
-            </a:r>
-          </a:p>
-        </p:txBody>
-      </p:sp>
-      <p:sp>
-        <p:nvSpPr>
-          <p:cNvPr id="45" name="TextBox 44"/>
-          <p:cNvSpPr txBox="1"/>
-          <p:nvPr/>
-        </p:nvSpPr>
-        <p:spPr>
-          <a:xfrm>
-            <a:off x="27774000" y="9180000"/>
-            <a:ext cx="7362000" cy="5922000"/>
-          </a:xfrm>
-          <a:prstGeom prst="rect">
-            <a:avLst/>
-          </a:prstGeom>
-          <a:noFill/>
-        </p:spPr>
-        <p:txBody>
-          <a:bodyPr wrap="square" anchor="t" lIns="0" rIns="0" tIns="0" bIns="0">
-            <a:spAutoFit/>
-          </a:bodyPr>
-          <a:lstStyle/>
-          <a:p>
-            <a:pPr algn="l"/>
-            <a:r>
-              <a:rPr sz="1600" b="0" i="1">
-                <a:solidFill>
-                  <a:srgbClr val="5B6570"/>
-                </a:solidFill>
-                <a:latin typeface="IBM Plex Sans"/>
-              </a:rPr>
-              <a:t>Trả lời lần lượt từng câu hỏi nghiên cứu ở mục 02.</a:t>
-            </a:r>
-          </a:p>
-        </p:txBody>
-      </p:sp>
-      <p:sp>
-        <p:nvSpPr>
-          <p:cNvPr id="46" name="Rounded Rectangle 45"/>
-          <p:cNvSpPr/>
-          <p:nvPr/>
-        </p:nvSpPr>
-        <p:spPr>
-          <a:xfrm>
-            <a:off x="27450000" y="15840000"/>
-            <a:ext cx="8010000" cy="4320000"/>
-          </a:xfrm>
-          <a:prstGeom prst="roundRect">
-            <a:avLst>
-              <a:gd name="adj" fmla="val 2500"/>
+              <a:gd name="adj" fmla="val 1111"/>
             </a:avLst>
           </a:prstGeom>
           <a:solidFill>
@@ -5519,13 +5267,13 @@
       </p:sp>
       <p:sp>
         <p:nvSpPr>
-          <p:cNvPr id="47" name="Oval 46"/>
+          <p:cNvPr id="41" name="Oval 40"/>
           <p:cNvSpPr/>
           <p:nvPr/>
         </p:nvSpPr>
         <p:spPr>
           <a:xfrm>
-            <a:off x="27774000" y="16127999"/>
+            <a:off x="9774000" y="16848000"/>
             <a:ext cx="522000" cy="522000"/>
           </a:xfrm>
           <a:prstGeom prst="ellipse">
@@ -5554,32 +5302,32 @@
           </a:fontRef>
         </p:style>
         <p:txBody>
-          <a:bodyPr rtlCol="0" anchor="ctr" lIns="0" rIns="0" tIns="0" bIns="0"/>
+          <a:bodyPr rtlCol="0" anchor="ctr" wrap="square" lIns="0" rIns="0" tIns="0" bIns="0"/>
           <a:lstStyle/>
           <a:p>
             <a:pPr algn="ctr"/>
             <a:r>
-              <a:rPr sz="1860" b="1">
+              <a:rPr sz="1860" b="1" i="0">
                 <a:solidFill>
                   <a:srgbClr val="FFFFFF"/>
                 </a:solidFill>
                 <a:latin typeface="Be Vietnam Pro"/>
               </a:rPr>
-              <a:t>09</a:t>
-            </a:r>
-          </a:p>
-        </p:txBody>
-      </p:sp>
-      <p:sp>
-        <p:nvSpPr>
-          <p:cNvPr id="48" name="TextBox 47"/>
+              <a:t>04</a:t>
+            </a:r>
+          </a:p>
+        </p:txBody>
+      </p:sp>
+      <p:sp>
+        <p:nvSpPr>
+          <p:cNvPr id="42" name="TextBox 41"/>
           <p:cNvSpPr txBox="1"/>
           <p:nvPr/>
         </p:nvSpPr>
         <p:spPr>
           <a:xfrm>
-            <a:off x="28440000" y="16127999"/>
-            <a:ext cx="6695999" cy="522000"/>
+            <a:off x="10439999" y="16848000"/>
+            <a:ext cx="15785999" cy="522000"/>
           </a:xfrm>
           <a:prstGeom prst="rect">
             <a:avLst/>
@@ -5600,21 +5348,92 @@
                 </a:solidFill>
                 <a:latin typeface="Be Vietnam Pro"/>
               </a:rPr>
-              <a:t>Hướng phát triển</a:t>
-            </a:r>
-          </a:p>
-        </p:txBody>
-      </p:sp>
-      <p:sp>
-        <p:nvSpPr>
-          <p:cNvPr id="49" name="TextBox 48"/>
+              <a:t>Cách hoạt động</a:t>
+            </a:r>
+          </a:p>
+        </p:txBody>
+      </p:sp>
+      <p:pic>
+        <p:nvPicPr>
+          <p:cNvPr id="43" name="Picture 42" descr="so_do_5_lop.png"/>
+          <p:cNvPicPr>
+            <a:picLocks noChangeAspect="1"/>
+          </p:cNvPicPr>
+          <p:nvPr/>
+        </p:nvPicPr>
+        <p:blipFill>
+          <a:blip r:embed="rId4"/>
+          <a:stretch>
+            <a:fillRect/>
+          </a:stretch>
+        </p:blipFill>
+        <p:spPr>
+          <a:xfrm>
+            <a:off x="9774000" y="17550000"/>
+            <a:ext cx="16452000" cy="6169500"/>
+          </a:xfrm>
+          <a:prstGeom prst="rect">
+            <a:avLst/>
+          </a:prstGeom>
+        </p:spPr>
+      </p:pic>
+      <p:sp>
+        <p:nvSpPr>
+          <p:cNvPr id="44" name="Rounded Rectangle 43"/>
+          <p:cNvSpPr/>
+          <p:nvPr/>
+        </p:nvSpPr>
+        <p:spPr>
+          <a:xfrm>
+            <a:off x="9774000" y="23863500"/>
+            <a:ext cx="16452000" cy="2092499"/>
+          </a:xfrm>
+          <a:prstGeom prst="roundRect">
+            <a:avLst>
+              <a:gd name="adj" fmla="val 5161"/>
+            </a:avLst>
+          </a:prstGeom>
+          <a:noFill/>
+          <a:ln w="18000">
+            <a:solidFill>
+              <a:srgbClr val="DBDCD5"/>
+            </a:solidFill>
+            <a:prstDash val="dash"/>
+          </a:ln>
+          <a:effectLst/>
+        </p:spPr>
+        <p:style>
+          <a:lnRef idx="1">
+            <a:schemeClr val="accent1"/>
+          </a:lnRef>
+          <a:fillRef idx="3">
+            <a:schemeClr val="accent1"/>
+          </a:fillRef>
+          <a:effectRef idx="2">
+            <a:schemeClr val="accent1"/>
+          </a:effectRef>
+          <a:fontRef idx="minor">
+            <a:schemeClr val="lt1"/>
+          </a:fontRef>
+        </p:style>
+        <p:txBody>
+          <a:bodyPr rtlCol="0" anchor="ctr"/>
+          <a:lstStyle/>
+          <a:p>
+            <a:pPr algn="ctr"/>
+          </a:p>
+        </p:txBody>
+      </p:sp>
+      <p:sp>
+        <p:nvSpPr>
+          <p:cNvPr id="45" name="TextBox 44"/>
           <p:cNvSpPr txBox="1"/>
           <p:nvPr/>
         </p:nvSpPr>
         <p:spPr>
           <a:xfrm>
-            <a:off x="27774000" y="16830000"/>
-            <a:ext cx="7362000" cy="3042000"/>
+            <a:off x="9954000" y="24007500"/>
+            <a:ext cx="16092000" cy="1804499"/>
           </a:xfrm>
           <a:prstGeom prst="rect">
             <a:avLst/>
@@ -5635,25 +5454,25 @@
                 </a:solidFill>
                 <a:latin typeface="IBM Plex Sans"/>
               </a:rPr>
-              <a:t>Bước tiếp theo nếu tiếp tục đề tài.</a:t>
-            </a:r>
-          </a:p>
-        </p:txBody>
-      </p:sp>
-      <p:sp>
-        <p:nvSpPr>
-          <p:cNvPr id="50" name="Rounded Rectangle 49"/>
+              <a:t>[ G2 — em viết 1–2 câu tóm tắt sơ đồ. Nhãn "Sơ đồ do AI tạo ra" đã có sẵn trong hình — giữ nguyên. ]</a:t>
+            </a:r>
+          </a:p>
+        </p:txBody>
+      </p:sp>
+      <p:sp>
+        <p:nvSpPr>
+          <p:cNvPr id="46" name="Rounded Rectangle 45"/>
           <p:cNvSpPr/>
           <p:nvPr/>
         </p:nvSpPr>
         <p:spPr>
           <a:xfrm>
-            <a:off x="27450000" y="20610000"/>
-            <a:ext cx="8010000" cy="3060000"/>
+            <a:off x="27450000" y="540000"/>
+            <a:ext cx="8010000" cy="10440000"/>
           </a:xfrm>
           <a:prstGeom prst="roundRect">
             <a:avLst>
-              <a:gd name="adj" fmla="val 3529"/>
+              <a:gd name="adj" fmla="val 1348"/>
             </a:avLst>
           </a:prstGeom>
           <a:solidFill>
@@ -5690,14 +5509,14 @@
       </p:sp>
       <p:sp>
         <p:nvSpPr>
-          <p:cNvPr id="51" name="Oval 50"/>
+          <p:cNvPr id="47" name="Oval 46"/>
           <p:cNvSpPr/>
           <p:nvPr/>
         </p:nvSpPr>
         <p:spPr>
           <a:xfrm>
-            <a:off x="27774000" y="20826000"/>
-            <a:ext cx="396000" cy="396000"/>
+            <a:off x="27774000" y="827999"/>
+            <a:ext cx="522000" cy="522000"/>
           </a:xfrm>
           <a:prstGeom prst="ellipse">
             <a:avLst/>
@@ -5725,32 +5544,32 @@
           </a:fontRef>
         </p:style>
         <p:txBody>
-          <a:bodyPr rtlCol="0" anchor="ctr" lIns="0" rIns="0" tIns="0" bIns="0"/>
+          <a:bodyPr rtlCol="0" anchor="ctr" wrap="square" lIns="0" rIns="0" tIns="0" bIns="0"/>
           <a:lstStyle/>
           <a:p>
             <a:pPr algn="ctr"/>
             <a:r>
-              <a:rPr sz="1350" b="1">
+              <a:rPr sz="1860" b="1" i="0">
                 <a:solidFill>
                   <a:srgbClr val="FFFFFF"/>
                 </a:solidFill>
                 <a:latin typeface="Be Vietnam Pro"/>
               </a:rPr>
-              <a:t>10</a:t>
-            </a:r>
-          </a:p>
-        </p:txBody>
-      </p:sp>
-      <p:sp>
-        <p:nvSpPr>
-          <p:cNvPr id="52" name="TextBox 51"/>
+              <a:t>05</a:t>
+            </a:r>
+          </a:p>
+        </p:txBody>
+      </p:sp>
+      <p:sp>
+        <p:nvSpPr>
+          <p:cNvPr id="48" name="TextBox 47"/>
           <p:cNvSpPr txBox="1"/>
           <p:nvPr/>
         </p:nvSpPr>
         <p:spPr>
           <a:xfrm>
-            <a:off x="28314000" y="20826000"/>
-            <a:ext cx="6821999" cy="396000"/>
+            <a:off x="28440000" y="827999"/>
+            <a:ext cx="6695999" cy="522000"/>
           </a:xfrm>
           <a:prstGeom prst="rect">
             <a:avLst/>
@@ -5765,27 +5584,127 @@
           <a:p>
             <a:pPr algn="l"/>
             <a:r>
-              <a:rPr sz="2100" b="1" i="0">
+              <a:rPr sz="3000" b="1" i="0">
                 <a:solidFill>
                   <a:srgbClr val="1C2321"/>
                 </a:solidFill>
                 <a:latin typeface="Be Vietnam Pro"/>
               </a:rPr>
-              <a:t>Tài liệu tham khảo</a:t>
-            </a:r>
-          </a:p>
-        </p:txBody>
-      </p:sp>
-      <p:sp>
-        <p:nvSpPr>
-          <p:cNvPr id="53" name="TextBox 52"/>
+              <a:t>Lợi ích</a:t>
+            </a:r>
+          </a:p>
+        </p:txBody>
+      </p:sp>
+      <p:sp>
+        <p:nvSpPr>
+          <p:cNvPr id="49" name="Oval 48"/>
+          <p:cNvSpPr/>
+          <p:nvPr/>
+        </p:nvSpPr>
+        <p:spPr>
+          <a:xfrm>
+            <a:off x="27774000" y="1548000"/>
+            <a:ext cx="432000" cy="432000"/>
+          </a:xfrm>
+          <a:prstGeom prst="ellipse">
+            <a:avLst/>
+          </a:prstGeom>
+          <a:solidFill>
+            <a:srgbClr val="27805A"/>
+          </a:solidFill>
+          <a:ln>
+            <a:noFill/>
+          </a:ln>
+          <a:effectLst/>
+        </p:spPr>
+        <p:style>
+          <a:lnRef idx="1">
+            <a:schemeClr val="accent1"/>
+          </a:lnRef>
+          <a:fillRef idx="3">
+            <a:schemeClr val="accent1"/>
+          </a:fillRef>
+          <a:effectRef idx="2">
+            <a:schemeClr val="accent1"/>
+          </a:effectRef>
+          <a:fontRef idx="minor">
+            <a:schemeClr val="lt1"/>
+          </a:fontRef>
+        </p:style>
+        <p:txBody>
+          <a:bodyPr rtlCol="0" anchor="ctr" wrap="square" lIns="0" rIns="0" tIns="0" bIns="0"/>
+          <a:lstStyle/>
+          <a:p>
+            <a:pPr algn="ctr"/>
+            <a:r>
+              <a:rPr sz="1500" b="1" i="0">
+                <a:solidFill>
+                  <a:srgbClr val="FFFFFF"/>
+                </a:solidFill>
+                <a:latin typeface="Be Vietnam Pro"/>
+              </a:rPr>
+              <a:t>1</a:t>
+            </a:r>
+          </a:p>
+        </p:txBody>
+      </p:sp>
+      <p:sp>
+        <p:nvSpPr>
+          <p:cNvPr id="50" name="Rounded Rectangle 49"/>
+          <p:cNvSpPr/>
+          <p:nvPr/>
+        </p:nvSpPr>
+        <p:spPr>
+          <a:xfrm>
+            <a:off x="28350000" y="1530000"/>
+            <a:ext cx="6785999" cy="2137500"/>
+          </a:xfrm>
+          <a:prstGeom prst="roundRect">
+            <a:avLst>
+              <a:gd name="adj" fmla="val 5052"/>
+            </a:avLst>
+          </a:prstGeom>
+          <a:noFill/>
+          <a:ln w="18000">
+            <a:solidFill>
+              <a:srgbClr val="DBDCD5"/>
+            </a:solidFill>
+            <a:prstDash val="dash"/>
+          </a:ln>
+          <a:effectLst/>
+        </p:spPr>
+        <p:style>
+          <a:lnRef idx="1">
+            <a:schemeClr val="accent1"/>
+          </a:lnRef>
+          <a:fillRef idx="3">
+            <a:schemeClr val="accent1"/>
+          </a:fillRef>
+          <a:effectRef idx="2">
+            <a:schemeClr val="accent1"/>
+          </a:effectRef>
+          <a:fontRef idx="minor">
+            <a:schemeClr val="lt1"/>
+          </a:fontRef>
+        </p:style>
+        <p:txBody>
+          <a:bodyPr rtlCol="0" anchor="ctr"/>
+          <a:lstStyle/>
+          <a:p>
+            <a:pPr algn="ctr"/>
+          </a:p>
+        </p:txBody>
+      </p:sp>
+      <p:sp>
+        <p:nvSpPr>
+          <p:cNvPr id="51" name="TextBox 50"/>
           <p:cNvSpPr txBox="1"/>
           <p:nvPr/>
         </p:nvSpPr>
         <p:spPr>
           <a:xfrm>
-            <a:off x="27774000" y="21330000"/>
-            <a:ext cx="7362000" cy="2124000"/>
+            <a:off x="28530000" y="1674000"/>
+            <a:ext cx="6425999" cy="1849500"/>
           </a:xfrm>
           <a:prstGeom prst="rect">
             <a:avLst/>
@@ -5800,31 +5719,702 @@
           <a:p>
             <a:pPr algn="l"/>
             <a:r>
-              <a:rPr sz="1300" b="0" i="1">
+              <a:rPr sz="1600" b="0" i="1">
                 <a:solidFill>
                   <a:srgbClr val="5B6570"/>
                 </a:solidFill>
                 <a:latin typeface="IBM Plex Sans"/>
               </a:rPr>
-              <a:t>Theo một chuẩn trích dẫn thống nhất.</a:t>
-            </a:r>
-          </a:p>
-        </p:txBody>
-      </p:sp>
-      <p:sp>
-        <p:nvSpPr>
-          <p:cNvPr id="54" name="Rounded Rectangle 53"/>
+              <a:t>[ P1 — một lợi ích, tối đa 2 dòng ]</a:t>
+            </a:r>
+          </a:p>
+        </p:txBody>
+      </p:sp>
+      <p:sp>
+        <p:nvSpPr>
+          <p:cNvPr id="52" name="Oval 51"/>
           <p:cNvSpPr/>
           <p:nvPr/>
         </p:nvSpPr>
         <p:spPr>
           <a:xfrm>
-            <a:off x="27450000" y="24120000"/>
-            <a:ext cx="8010000" cy="2160000"/>
+            <a:off x="27774000" y="3829500"/>
+            <a:ext cx="432000" cy="432000"/>
+          </a:xfrm>
+          <a:prstGeom prst="ellipse">
+            <a:avLst/>
+          </a:prstGeom>
+          <a:solidFill>
+            <a:srgbClr val="27805A"/>
+          </a:solidFill>
+          <a:ln>
+            <a:noFill/>
+          </a:ln>
+          <a:effectLst/>
+        </p:spPr>
+        <p:style>
+          <a:lnRef idx="1">
+            <a:schemeClr val="accent1"/>
+          </a:lnRef>
+          <a:fillRef idx="3">
+            <a:schemeClr val="accent1"/>
+          </a:fillRef>
+          <a:effectRef idx="2">
+            <a:schemeClr val="accent1"/>
+          </a:effectRef>
+          <a:fontRef idx="minor">
+            <a:schemeClr val="lt1"/>
+          </a:fontRef>
+        </p:style>
+        <p:txBody>
+          <a:bodyPr rtlCol="0" anchor="ctr" wrap="square" lIns="0" rIns="0" tIns="0" bIns="0"/>
+          <a:lstStyle/>
+          <a:p>
+            <a:pPr algn="ctr"/>
+            <a:r>
+              <a:rPr sz="1500" b="1" i="0">
+                <a:solidFill>
+                  <a:srgbClr val="FFFFFF"/>
+                </a:solidFill>
+                <a:latin typeface="Be Vietnam Pro"/>
+              </a:rPr>
+              <a:t>2</a:t>
+            </a:r>
+          </a:p>
+        </p:txBody>
+      </p:sp>
+      <p:sp>
+        <p:nvSpPr>
+          <p:cNvPr id="53" name="Rounded Rectangle 52"/>
+          <p:cNvSpPr/>
+          <p:nvPr/>
+        </p:nvSpPr>
+        <p:spPr>
+          <a:xfrm>
+            <a:off x="28350000" y="3811500"/>
+            <a:ext cx="6785999" cy="2137500"/>
           </a:xfrm>
           <a:prstGeom prst="roundRect">
             <a:avLst>
-              <a:gd name="adj" fmla="val 5000"/>
+              <a:gd name="adj" fmla="val 5052"/>
+            </a:avLst>
+          </a:prstGeom>
+          <a:noFill/>
+          <a:ln w="18000">
+            <a:solidFill>
+              <a:srgbClr val="DBDCD5"/>
+            </a:solidFill>
+            <a:prstDash val="dash"/>
+          </a:ln>
+          <a:effectLst/>
+        </p:spPr>
+        <p:style>
+          <a:lnRef idx="1">
+            <a:schemeClr val="accent1"/>
+          </a:lnRef>
+          <a:fillRef idx="3">
+            <a:schemeClr val="accent1"/>
+          </a:fillRef>
+          <a:effectRef idx="2">
+            <a:schemeClr val="accent1"/>
+          </a:effectRef>
+          <a:fontRef idx="minor">
+            <a:schemeClr val="lt1"/>
+          </a:fontRef>
+        </p:style>
+        <p:txBody>
+          <a:bodyPr rtlCol="0" anchor="ctr"/>
+          <a:lstStyle/>
+          <a:p>
+            <a:pPr algn="ctr"/>
+          </a:p>
+        </p:txBody>
+      </p:sp>
+      <p:sp>
+        <p:nvSpPr>
+          <p:cNvPr id="54" name="TextBox 53"/>
+          <p:cNvSpPr txBox="1"/>
+          <p:nvPr/>
+        </p:nvSpPr>
+        <p:spPr>
+          <a:xfrm>
+            <a:off x="28530000" y="3955500"/>
+            <a:ext cx="6425999" cy="1849500"/>
+          </a:xfrm>
+          <a:prstGeom prst="rect">
+            <a:avLst/>
+          </a:prstGeom>
+          <a:noFill/>
+        </p:spPr>
+        <p:txBody>
+          <a:bodyPr wrap="square" anchor="t" lIns="0" rIns="0" tIns="0" bIns="0">
+            <a:spAutoFit/>
+          </a:bodyPr>
+          <a:lstStyle/>
+          <a:p>
+            <a:pPr algn="l"/>
+            <a:r>
+              <a:rPr sz="1600" b="0" i="1">
+                <a:solidFill>
+                  <a:srgbClr val="5B6570"/>
+                </a:solidFill>
+                <a:latin typeface="IBM Plex Sans"/>
+              </a:rPr>
+              <a:t>[ P2 — một lợi ích, tối đa 2 dòng ]</a:t>
+            </a:r>
+          </a:p>
+        </p:txBody>
+      </p:sp>
+      <p:sp>
+        <p:nvSpPr>
+          <p:cNvPr id="55" name="Oval 54"/>
+          <p:cNvSpPr/>
+          <p:nvPr/>
+        </p:nvSpPr>
+        <p:spPr>
+          <a:xfrm>
+            <a:off x="27774000" y="6111000"/>
+            <a:ext cx="432000" cy="432000"/>
+          </a:xfrm>
+          <a:prstGeom prst="ellipse">
+            <a:avLst/>
+          </a:prstGeom>
+          <a:solidFill>
+            <a:srgbClr val="27805A"/>
+          </a:solidFill>
+          <a:ln>
+            <a:noFill/>
+          </a:ln>
+          <a:effectLst/>
+        </p:spPr>
+        <p:style>
+          <a:lnRef idx="1">
+            <a:schemeClr val="accent1"/>
+          </a:lnRef>
+          <a:fillRef idx="3">
+            <a:schemeClr val="accent1"/>
+          </a:fillRef>
+          <a:effectRef idx="2">
+            <a:schemeClr val="accent1"/>
+          </a:effectRef>
+          <a:fontRef idx="minor">
+            <a:schemeClr val="lt1"/>
+          </a:fontRef>
+        </p:style>
+        <p:txBody>
+          <a:bodyPr rtlCol="0" anchor="ctr" wrap="square" lIns="0" rIns="0" tIns="0" bIns="0"/>
+          <a:lstStyle/>
+          <a:p>
+            <a:pPr algn="ctr"/>
+            <a:r>
+              <a:rPr sz="1500" b="1" i="0">
+                <a:solidFill>
+                  <a:srgbClr val="FFFFFF"/>
+                </a:solidFill>
+                <a:latin typeface="Be Vietnam Pro"/>
+              </a:rPr>
+              <a:t>3</a:t>
+            </a:r>
+          </a:p>
+        </p:txBody>
+      </p:sp>
+      <p:sp>
+        <p:nvSpPr>
+          <p:cNvPr id="56" name="Rounded Rectangle 55"/>
+          <p:cNvSpPr/>
+          <p:nvPr/>
+        </p:nvSpPr>
+        <p:spPr>
+          <a:xfrm>
+            <a:off x="28350000" y="6093000"/>
+            <a:ext cx="6785999" cy="2137500"/>
+          </a:xfrm>
+          <a:prstGeom prst="roundRect">
+            <a:avLst>
+              <a:gd name="adj" fmla="val 5052"/>
+            </a:avLst>
+          </a:prstGeom>
+          <a:noFill/>
+          <a:ln w="18000">
+            <a:solidFill>
+              <a:srgbClr val="DBDCD5"/>
+            </a:solidFill>
+            <a:prstDash val="dash"/>
+          </a:ln>
+          <a:effectLst/>
+        </p:spPr>
+        <p:style>
+          <a:lnRef idx="1">
+            <a:schemeClr val="accent1"/>
+          </a:lnRef>
+          <a:fillRef idx="3">
+            <a:schemeClr val="accent1"/>
+          </a:fillRef>
+          <a:effectRef idx="2">
+            <a:schemeClr val="accent1"/>
+          </a:effectRef>
+          <a:fontRef idx="minor">
+            <a:schemeClr val="lt1"/>
+          </a:fontRef>
+        </p:style>
+        <p:txBody>
+          <a:bodyPr rtlCol="0" anchor="ctr"/>
+          <a:lstStyle/>
+          <a:p>
+            <a:pPr algn="ctr"/>
+          </a:p>
+        </p:txBody>
+      </p:sp>
+      <p:sp>
+        <p:nvSpPr>
+          <p:cNvPr id="57" name="TextBox 56"/>
+          <p:cNvSpPr txBox="1"/>
+          <p:nvPr/>
+        </p:nvSpPr>
+        <p:spPr>
+          <a:xfrm>
+            <a:off x="28530000" y="6237000"/>
+            <a:ext cx="6425999" cy="1849500"/>
+          </a:xfrm>
+          <a:prstGeom prst="rect">
+            <a:avLst/>
+          </a:prstGeom>
+          <a:noFill/>
+        </p:spPr>
+        <p:txBody>
+          <a:bodyPr wrap="square" anchor="t" lIns="0" rIns="0" tIns="0" bIns="0">
+            <a:spAutoFit/>
+          </a:bodyPr>
+          <a:lstStyle/>
+          <a:p>
+            <a:pPr algn="l"/>
+            <a:r>
+              <a:rPr sz="1600" b="0" i="1">
+                <a:solidFill>
+                  <a:srgbClr val="5B6570"/>
+                </a:solidFill>
+                <a:latin typeface="IBM Plex Sans"/>
+              </a:rPr>
+              <a:t>[ P3 — một lợi ích, tối đa 2 dòng ]</a:t>
+            </a:r>
+          </a:p>
+        </p:txBody>
+      </p:sp>
+      <p:sp>
+        <p:nvSpPr>
+          <p:cNvPr id="58" name="Oval 57"/>
+          <p:cNvSpPr/>
+          <p:nvPr/>
+        </p:nvSpPr>
+        <p:spPr>
+          <a:xfrm>
+            <a:off x="27774000" y="8392500"/>
+            <a:ext cx="432000" cy="432000"/>
+          </a:xfrm>
+          <a:prstGeom prst="ellipse">
+            <a:avLst/>
+          </a:prstGeom>
+          <a:solidFill>
+            <a:srgbClr val="27805A"/>
+          </a:solidFill>
+          <a:ln>
+            <a:noFill/>
+          </a:ln>
+          <a:effectLst/>
+        </p:spPr>
+        <p:style>
+          <a:lnRef idx="1">
+            <a:schemeClr val="accent1"/>
+          </a:lnRef>
+          <a:fillRef idx="3">
+            <a:schemeClr val="accent1"/>
+          </a:fillRef>
+          <a:effectRef idx="2">
+            <a:schemeClr val="accent1"/>
+          </a:effectRef>
+          <a:fontRef idx="minor">
+            <a:schemeClr val="lt1"/>
+          </a:fontRef>
+        </p:style>
+        <p:txBody>
+          <a:bodyPr rtlCol="0" anchor="ctr" wrap="square" lIns="0" rIns="0" tIns="0" bIns="0"/>
+          <a:lstStyle/>
+          <a:p>
+            <a:pPr algn="ctr"/>
+            <a:r>
+              <a:rPr sz="1500" b="1" i="0">
+                <a:solidFill>
+                  <a:srgbClr val="FFFFFF"/>
+                </a:solidFill>
+                <a:latin typeface="Be Vietnam Pro"/>
+              </a:rPr>
+              <a:t>4</a:t>
+            </a:r>
+          </a:p>
+        </p:txBody>
+      </p:sp>
+      <p:sp>
+        <p:nvSpPr>
+          <p:cNvPr id="59" name="Rounded Rectangle 58"/>
+          <p:cNvSpPr/>
+          <p:nvPr/>
+        </p:nvSpPr>
+        <p:spPr>
+          <a:xfrm>
+            <a:off x="28350000" y="8374500"/>
+            <a:ext cx="6785999" cy="2137500"/>
+          </a:xfrm>
+          <a:prstGeom prst="roundRect">
+            <a:avLst>
+              <a:gd name="adj" fmla="val 5052"/>
+            </a:avLst>
+          </a:prstGeom>
+          <a:noFill/>
+          <a:ln w="18000">
+            <a:solidFill>
+              <a:srgbClr val="DBDCD5"/>
+            </a:solidFill>
+            <a:prstDash val="dash"/>
+          </a:ln>
+          <a:effectLst/>
+        </p:spPr>
+        <p:style>
+          <a:lnRef idx="1">
+            <a:schemeClr val="accent1"/>
+          </a:lnRef>
+          <a:fillRef idx="3">
+            <a:schemeClr val="accent1"/>
+          </a:fillRef>
+          <a:effectRef idx="2">
+            <a:schemeClr val="accent1"/>
+          </a:effectRef>
+          <a:fontRef idx="minor">
+            <a:schemeClr val="lt1"/>
+          </a:fontRef>
+        </p:style>
+        <p:txBody>
+          <a:bodyPr rtlCol="0" anchor="ctr"/>
+          <a:lstStyle/>
+          <a:p>
+            <a:pPr algn="ctr"/>
+          </a:p>
+        </p:txBody>
+      </p:sp>
+      <p:sp>
+        <p:nvSpPr>
+          <p:cNvPr id="60" name="TextBox 59"/>
+          <p:cNvSpPr txBox="1"/>
+          <p:nvPr/>
+        </p:nvSpPr>
+        <p:spPr>
+          <a:xfrm>
+            <a:off x="28530000" y="8518500"/>
+            <a:ext cx="6425999" cy="1849500"/>
+          </a:xfrm>
+          <a:prstGeom prst="rect">
+            <a:avLst/>
+          </a:prstGeom>
+          <a:noFill/>
+        </p:spPr>
+        <p:txBody>
+          <a:bodyPr wrap="square" anchor="t" lIns="0" rIns="0" tIns="0" bIns="0">
+            <a:spAutoFit/>
+          </a:bodyPr>
+          <a:lstStyle/>
+          <a:p>
+            <a:pPr algn="l"/>
+            <a:r>
+              <a:rPr sz="1600" b="0" i="1">
+                <a:solidFill>
+                  <a:srgbClr val="5B6570"/>
+                </a:solidFill>
+                <a:latin typeface="IBM Plex Sans"/>
+              </a:rPr>
+              <a:t>[ P4 — một lợi ích, tối đa 2 dòng ]</a:t>
+            </a:r>
+          </a:p>
+        </p:txBody>
+      </p:sp>
+      <p:sp>
+        <p:nvSpPr>
+          <p:cNvPr id="61" name="Rounded Rectangle 60"/>
+          <p:cNvSpPr/>
+          <p:nvPr/>
+        </p:nvSpPr>
+        <p:spPr>
+          <a:xfrm>
+            <a:off x="27450000" y="11430000"/>
+            <a:ext cx="8010000" cy="11880000"/>
+          </a:xfrm>
+          <a:prstGeom prst="roundRect">
+            <a:avLst>
+              <a:gd name="adj" fmla="val 1348"/>
+            </a:avLst>
+          </a:prstGeom>
+          <a:solidFill>
+            <a:srgbClr val="FFFFFF"/>
+          </a:solidFill>
+          <a:ln w="14400">
+            <a:solidFill>
+              <a:srgbClr val="DBDCD5"/>
+            </a:solidFill>
+          </a:ln>
+          <a:effectLst/>
+        </p:spPr>
+        <p:style>
+          <a:lnRef idx="1">
+            <a:schemeClr val="accent1"/>
+          </a:lnRef>
+          <a:fillRef idx="3">
+            <a:schemeClr val="accent1"/>
+          </a:fillRef>
+          <a:effectRef idx="2">
+            <a:schemeClr val="accent1"/>
+          </a:effectRef>
+          <a:fontRef idx="minor">
+            <a:schemeClr val="lt1"/>
+          </a:fontRef>
+        </p:style>
+        <p:txBody>
+          <a:bodyPr rtlCol="0" anchor="ctr"/>
+          <a:lstStyle/>
+          <a:p>
+            <a:pPr algn="ctr"/>
+          </a:p>
+        </p:txBody>
+      </p:sp>
+      <p:sp>
+        <p:nvSpPr>
+          <p:cNvPr id="62" name="Oval 61"/>
+          <p:cNvSpPr/>
+          <p:nvPr/>
+        </p:nvSpPr>
+        <p:spPr>
+          <a:xfrm>
+            <a:off x="27774000" y="11717999"/>
+            <a:ext cx="522000" cy="522000"/>
+          </a:xfrm>
+          <a:prstGeom prst="ellipse">
+            <a:avLst/>
+          </a:prstGeom>
+          <a:solidFill>
+            <a:srgbClr val="C98A1F"/>
+          </a:solidFill>
+          <a:ln>
+            <a:noFill/>
+          </a:ln>
+          <a:effectLst/>
+        </p:spPr>
+        <p:style>
+          <a:lnRef idx="1">
+            <a:schemeClr val="accent1"/>
+          </a:lnRef>
+          <a:fillRef idx="3">
+            <a:schemeClr val="accent1"/>
+          </a:fillRef>
+          <a:effectRef idx="2">
+            <a:schemeClr val="accent1"/>
+          </a:effectRef>
+          <a:fontRef idx="minor">
+            <a:schemeClr val="lt1"/>
+          </a:fontRef>
+        </p:style>
+        <p:txBody>
+          <a:bodyPr rtlCol="0" anchor="ctr" wrap="square" lIns="0" rIns="0" tIns="0" bIns="0"/>
+          <a:lstStyle/>
+          <a:p>
+            <a:pPr algn="ctr"/>
+            <a:r>
+              <a:rPr sz="1860" b="1" i="0">
+                <a:solidFill>
+                  <a:srgbClr val="FFFFFF"/>
+                </a:solidFill>
+                <a:latin typeface="Be Vietnam Pro"/>
+              </a:rPr>
+              <a:t>06</a:t>
+            </a:r>
+          </a:p>
+        </p:txBody>
+      </p:sp>
+      <p:sp>
+        <p:nvSpPr>
+          <p:cNvPr id="63" name="TextBox 62"/>
+          <p:cNvSpPr txBox="1"/>
+          <p:nvPr/>
+        </p:nvSpPr>
+        <p:spPr>
+          <a:xfrm>
+            <a:off x="28440000" y="11717999"/>
+            <a:ext cx="6695999" cy="522000"/>
+          </a:xfrm>
+          <a:prstGeom prst="rect">
+            <a:avLst/>
+          </a:prstGeom>
+          <a:noFill/>
+        </p:spPr>
+        <p:txBody>
+          <a:bodyPr wrap="square" anchor="ctr" lIns="0" rIns="0" tIns="0" bIns="0">
+            <a:spAutoFit/>
+          </a:bodyPr>
+          <a:lstStyle/>
+          <a:p>
+            <a:pPr algn="l"/>
+            <a:r>
+              <a:rPr sz="3000" b="1" i="0">
+                <a:solidFill>
+                  <a:srgbClr val="1C2321"/>
+                </a:solidFill>
+                <a:latin typeface="Be Vietnam Pro"/>
+              </a:rPr>
+              <a:t>Đã kiểm chứng</a:t>
+            </a:r>
+          </a:p>
+        </p:txBody>
+      </p:sp>
+      <p:pic>
+        <p:nvPicPr>
+          <p:cNvPr id="64" name="Picture 63" descr="bieu_do_khai_gian.png"/>
+          <p:cNvPicPr>
+            <a:picLocks noChangeAspect="1"/>
+          </p:cNvPicPr>
+          <p:nvPr/>
+        </p:nvPicPr>
+        <p:blipFill>
+          <a:blip r:embed="rId5"/>
+          <a:stretch>
+            <a:fillRect/>
+          </a:stretch>
+        </p:blipFill>
+        <p:spPr>
+          <a:xfrm>
+            <a:off x="27774000" y="12420000"/>
+            <a:ext cx="7362000" cy="3496949"/>
+          </a:xfrm>
+          <a:prstGeom prst="rect">
+            <a:avLst/>
+          </a:prstGeom>
+        </p:spPr>
+      </p:pic>
+      <p:pic>
+        <p:nvPicPr>
+          <p:cNvPr id="65" name="Picture 64" descr="bieu_do_nguyen_vong.png"/>
+          <p:cNvPicPr>
+            <a:picLocks noChangeAspect="1"/>
+          </p:cNvPicPr>
+          <p:nvPr/>
+        </p:nvPicPr>
+        <p:blipFill>
+          <a:blip r:embed="rId6"/>
+          <a:stretch>
+            <a:fillRect/>
+          </a:stretch>
+        </p:blipFill>
+        <p:spPr>
+          <a:xfrm>
+            <a:off x="27774000" y="16060949"/>
+            <a:ext cx="7362000" cy="4601250"/>
+          </a:xfrm>
+          <a:prstGeom prst="rect">
+            <a:avLst/>
+          </a:prstGeom>
+        </p:spPr>
+      </p:pic>
+      <p:sp>
+        <p:nvSpPr>
+          <p:cNvPr id="66" name="Rounded Rectangle 65"/>
+          <p:cNvSpPr/>
+          <p:nvPr/>
+        </p:nvSpPr>
+        <p:spPr>
+          <a:xfrm>
+            <a:off x="27774000" y="20806199"/>
+            <a:ext cx="7362000" cy="2179800"/>
+          </a:xfrm>
+          <a:prstGeom prst="roundRect">
+            <a:avLst>
+              <a:gd name="adj" fmla="val 4954"/>
+            </a:avLst>
+          </a:prstGeom>
+          <a:noFill/>
+          <a:ln w="18000">
+            <a:solidFill>
+              <a:srgbClr val="DBDCD5"/>
+            </a:solidFill>
+            <a:prstDash val="dash"/>
+          </a:ln>
+          <a:effectLst/>
+        </p:spPr>
+        <p:style>
+          <a:lnRef idx="1">
+            <a:schemeClr val="accent1"/>
+          </a:lnRef>
+          <a:fillRef idx="3">
+            <a:schemeClr val="accent1"/>
+          </a:fillRef>
+          <a:effectRef idx="2">
+            <a:schemeClr val="accent1"/>
+          </a:effectRef>
+          <a:fontRef idx="minor">
+            <a:schemeClr val="lt1"/>
+          </a:fontRef>
+        </p:style>
+        <p:txBody>
+          <a:bodyPr rtlCol="0" anchor="ctr"/>
+          <a:lstStyle/>
+          <a:p>
+            <a:pPr algn="ctr"/>
+          </a:p>
+        </p:txBody>
+      </p:sp>
+      <p:sp>
+        <p:nvSpPr>
+          <p:cNvPr id="67" name="TextBox 66"/>
+          <p:cNvSpPr txBox="1"/>
+          <p:nvPr/>
+        </p:nvSpPr>
+        <p:spPr>
+          <a:xfrm>
+            <a:off x="27954000" y="20950199"/>
+            <a:ext cx="7002000" cy="1891800"/>
+          </a:xfrm>
+          <a:prstGeom prst="rect">
+            <a:avLst/>
+          </a:prstGeom>
+          <a:noFill/>
+        </p:spPr>
+        <p:txBody>
+          <a:bodyPr wrap="square" anchor="t" lIns="0" rIns="0" tIns="0" bIns="0">
+            <a:spAutoFit/>
+          </a:bodyPr>
+          <a:lstStyle/>
+          <a:p>
+            <a:pPr algn="l"/>
+            <a:r>
+              <a:rPr sz="1600" b="0" i="1">
+                <a:solidFill>
+                  <a:srgbClr val="5B6570"/>
+                </a:solidFill>
+                <a:latin typeface="IBM Plex Sans"/>
+              </a:rPr>
+              <a:t>[ P5 — em viết 1–2 câu: hai biểu đồ này nói gì với học sinh? ]</a:t>
+            </a:r>
+          </a:p>
+        </p:txBody>
+      </p:sp>
+      <p:sp>
+        <p:nvSpPr>
+          <p:cNvPr id="68" name="Rounded Rectangle 67"/>
+          <p:cNvSpPr/>
+          <p:nvPr/>
+        </p:nvSpPr>
+        <p:spPr>
+          <a:xfrm>
+            <a:off x="27450000" y="23760000"/>
+            <a:ext cx="8010000" cy="2520000"/>
+          </a:xfrm>
+          <a:prstGeom prst="roundRect">
+            <a:avLst>
+              <a:gd name="adj" fmla="val 4285"/>
             </a:avLst>
           </a:prstGeom>
           <a:solidFill>
@@ -5861,14 +6451,14 @@
       </p:sp>
       <p:sp>
         <p:nvSpPr>
-          <p:cNvPr id="55" name="TextBox 54"/>
+          <p:cNvPr id="69" name="TextBox 68"/>
           <p:cNvSpPr txBox="1"/>
           <p:nvPr/>
         </p:nvSpPr>
         <p:spPr>
           <a:xfrm>
-            <a:off x="27774000" y="24335999"/>
-            <a:ext cx="7361999" cy="396000"/>
+            <a:off x="27774000" y="23975999"/>
+            <a:ext cx="7362000" cy="360000"/>
           </a:xfrm>
           <a:prstGeom prst="rect">
             <a:avLst/>
@@ -5883,7 +6473,7 @@
           <a:p>
             <a:pPr algn="l"/>
             <a:r>
-              <a:rPr sz="2100" b="1" i="0">
+              <a:rPr sz="1800" b="1" i="0">
                 <a:solidFill>
                   <a:srgbClr val="3F6B52"/>
                 </a:solidFill>
@@ -5896,14 +6486,61 @@
       </p:sp>
       <p:sp>
         <p:nvSpPr>
-          <p:cNvPr id="56" name="TextBox 55"/>
+          <p:cNvPr id="70" name="Rounded Rectangle 69"/>
+          <p:cNvSpPr/>
+          <p:nvPr/>
+        </p:nvSpPr>
+        <p:spPr>
+          <a:xfrm>
+            <a:off x="27774000" y="24443999"/>
+            <a:ext cx="7362000" cy="1656000"/>
+          </a:xfrm>
+          <a:prstGeom prst="roundRect">
+            <a:avLst>
+              <a:gd name="adj" fmla="val 6521"/>
+            </a:avLst>
+          </a:prstGeom>
+          <a:noFill/>
+          <a:ln w="18000">
+            <a:solidFill>
+              <a:srgbClr val="DBDCD5"/>
+            </a:solidFill>
+            <a:prstDash val="dash"/>
+          </a:ln>
+          <a:effectLst/>
+        </p:spPr>
+        <p:style>
+          <a:lnRef idx="1">
+            <a:schemeClr val="accent1"/>
+          </a:lnRef>
+          <a:fillRef idx="3">
+            <a:schemeClr val="accent1"/>
+          </a:fillRef>
+          <a:effectRef idx="2">
+            <a:schemeClr val="accent1"/>
+          </a:effectRef>
+          <a:fontRef idx="minor">
+            <a:schemeClr val="lt1"/>
+          </a:fontRef>
+        </p:style>
+        <p:txBody>
+          <a:bodyPr rtlCol="0" anchor="ctr"/>
+          <a:lstStyle/>
+          <a:p>
+            <a:pPr algn="ctr"/>
+          </a:p>
+        </p:txBody>
+      </p:sp>
+      <p:sp>
+        <p:nvSpPr>
+          <p:cNvPr id="71" name="TextBox 70"/>
           <p:cNvSpPr txBox="1"/>
           <p:nvPr/>
         </p:nvSpPr>
         <p:spPr>
           <a:xfrm>
-            <a:off x="27774000" y="24839999"/>
-            <a:ext cx="7362000" cy="1224000"/>
+            <a:off x="27954000" y="24588000"/>
+            <a:ext cx="7002000" cy="1368000"/>
           </a:xfrm>
           <a:prstGeom prst="rect">
             <a:avLst/>
@@ -5918,13 +6555,13 @@
           <a:p>
             <a:pPr algn="l"/>
             <a:r>
-              <a:rPr sz="1300" b="0" i="1">
+              <a:rPr sz="1200" b="0" i="1">
                 <a:solidFill>
                   <a:srgbClr val="5B6570"/>
                 </a:solidFill>
                 <a:latin typeface="IBM Plex Sans"/>
               </a:rPr>
-              <a:t>Phần nào có AI hỗ trợ, theo Phụ lục 1.</a:t>
+              <a:t>[ P6 — theo Phụ lục 1: phần nào có AI hỗ trợ ]</a:t>
             </a:r>
           </a:p>
         </p:txBody>

</xml_diff>

<commit_message>
Make the diagram and charts editable in the PowerPoint frame
The five-layer diagram is now grouped shapes and text drawn from the
same spec as the SVG, and the two charts are native PowerPoint charts
fed by the same numbers as the PNGs. Only the two app screenshots
remain pictures. The PDF and preview still use the rendered images.

Co-Authored-By: Claude Opus 5.5 <noreply@anthropic.com>
Claude-Session: https://claude.ai/code/session_01NkYGd36L1Tpym32yxKyitD
</commit_message>
<xml_diff>
--- a/poster/poster_khung_1-2.pptx
+++ b/poster/poster_khung_1-2.pptx
@@ -105,6 +105,552 @@
     </a:lvl9pPr>
   </p:defaultTextStyle>
 </p:presentation>
+</file>
+
+<file path=ppt/charts/chart1.xml><?xml version="1.0" encoding="utf-8"?>
+<c:chartSpace xmlns:c="http://schemas.openxmlformats.org/drawingml/2006/chart" xmlns:a="http://schemas.openxmlformats.org/drawingml/2006/main" xmlns:r="http://schemas.openxmlformats.org/officeDocument/2006/relationships">
+  <c:date1904 val="0"/>
+  <c:chart>
+    <c:autoTitleDeleted val="1"/>
+    <c:plotArea>
+      <c:barChart>
+        <c:barDir val="bar"/>
+        <c:grouping val="clustered"/>
+        <c:ser>
+          <c:idx val="0"/>
+          <c:order val="0"/>
+          <c:tx>
+            <c:strRef>
+              <c:f>Sheet1!$B$1</c:f>
+              <c:strCache>
+                <c:ptCount val="1"/>
+                <c:pt idx="0">
+                  <c:v>Số em</c:v>
+                </c:pt>
+              </c:strCache>
+            </c:strRef>
+          </c:tx>
+          <c:dPt>
+            <c:idx val="0"/>
+            <c:spPr>
+              <a:solidFill>
+                <a:srgbClr val="27805A"/>
+              </a:solidFill>
+            </c:spPr>
+          </c:dPt>
+          <c:dPt>
+            <c:idx val="1"/>
+            <c:spPr>
+              <a:solidFill>
+                <a:srgbClr val="B9BEC3"/>
+              </a:solidFill>
+            </c:spPr>
+          </c:dPt>
+          <c:dLbls>
+            <c:dLbl>
+              <c:idx val="0"/>
+              <c:tx>
+                <c:rich>
+                  <a:bodyPr/>
+                  <a:lstStyle/>
+                  <a:p>
+                    <a:r>
+                      <a:rPr sz="1231" b="1">
+                        <a:solidFill>
+                          <a:srgbClr val="1C2321"/>
+                        </a:solidFill>
+                      </a:rPr>
+                      <a:t>0 / 1 400 em</a:t>
+                    </a:r>
+                  </a:p>
+                </c:rich>
+              </c:tx>
+              <c:dLblPos val="outEnd"/>
+              <c:showLegendKey val="0"/>
+              <c:showVal val="1"/>
+              <c:showCatName val="0"/>
+              <c:showSerName val="0"/>
+              <c:showPercent val="0"/>
+              <c:showBubbleSize val="0"/>
+            </c:dLbl>
+            <c:dLbl>
+              <c:idx val="1"/>
+              <c:tx>
+                <c:rich>
+                  <a:bodyPr/>
+                  <a:lstStyle/>
+                  <a:p>
+                    <a:r>
+                      <a:rPr sz="1231" b="1">
+                        <a:solidFill>
+                          <a:srgbClr val="1C2321"/>
+                        </a:solidFill>
+                      </a:rPr>
+                      <a:t>258 / 1 400 em (18,43%)</a:t>
+                    </a:r>
+                  </a:p>
+                </c:rich>
+              </c:tx>
+              <c:dLblPos val="outEnd"/>
+              <c:showLegendKey val="0"/>
+              <c:showVal val="1"/>
+              <c:showCatName val="0"/>
+              <c:showSerName val="0"/>
+              <c:showPercent val="0"/>
+              <c:showBubbleSize val="0"/>
+            </c:dLbl>
+            <c:showLegendKey val="0"/>
+            <c:showVal val="0"/>
+            <c:showCatName val="0"/>
+            <c:showSerName val="0"/>
+            <c:showPercent val="0"/>
+            <c:showBubbleSize val="0"/>
+            <c:showLeaderLines val="1"/>
+          </c:dLbls>
+          <c:cat>
+            <c:strRef>
+              <c:f>Sheet1!$A$2:$A$3</c:f>
+              <c:strCache>
+                <c:ptCount val="2"/>
+                <c:pt idx="0">
+                  <c:v>Phần mềm (RB-DA)</c:v>
+                </c:pt>
+                <c:pt idx="1">
+                  <c:v>Cơ chế Boston</c:v>
+                </c:pt>
+              </c:strCache>
+            </c:strRef>
+          </c:cat>
+          <c:val>
+            <c:numRef>
+              <c:f>Sheet1!$B$2:$B$3</c:f>
+              <c:numCache>
+                <c:formatCode>General</c:formatCode>
+                <c:ptCount val="2"/>
+                <c:pt idx="0">
+                  <c:v>0</c:v>
+                </c:pt>
+                <c:pt idx="1">
+                  <c:v>258</c:v>
+                </c:pt>
+              </c:numCache>
+            </c:numRef>
+          </c:val>
+        </c:ser>
+        <c:gapWidth val="70"/>
+        <c:axId val="-2068027336"/>
+        <c:axId val="-2113994440"/>
+      </c:barChart>
+      <c:catAx>
+        <c:axId val="-2068027336"/>
+        <c:scaling>
+          <c:orientation val="maxMin"/>
+        </c:scaling>
+        <c:delete val="0"/>
+        <c:axPos val="l"/>
+        <c:majorTickMark val="out"/>
+        <c:minorTickMark val="none"/>
+        <c:tickLblPos val="nextTo"/>
+        <c:spPr>
+          <a:ln>
+            <a:solidFill>
+              <a:srgbClr val="5B6570"/>
+            </a:solidFill>
+          </a:ln>
+        </c:spPr>
+        <c:txPr>
+          <a:bodyPr/>
+          <a:lstStyle/>
+          <a:p>
+            <a:pPr>
+              <a:defRPr b="1" sz="1159"/>
+            </a:pPr>
+          </a:p>
+        </c:txPr>
+        <c:crossAx val="-2113994440"/>
+        <c:crosses val="autoZero"/>
+        <c:auto val="1"/>
+        <c:lblAlgn val="ctr"/>
+        <c:lblOffset val="100"/>
+        <c:noMultiLvlLbl val="0"/>
+      </c:catAx>
+      <c:valAx>
+        <c:axId val="-2113994440"/>
+        <c:scaling>
+          <c:max val="400.0"/>
+          <c:min val="0.0"/>
+        </c:scaling>
+        <c:delete val="0"/>
+        <c:axPos val="b"/>
+        <c:majorGridlines>
+          <c:spPr>
+            <a:ln>
+              <a:solidFill>
+                <a:srgbClr val="DBDCD5"/>
+              </a:solidFill>
+            </a:ln>
+          </c:spPr>
+        </c:majorGridlines>
+        <c:majorTickMark val="out"/>
+        <c:minorTickMark val="none"/>
+        <c:tickLblPos val="nextTo"/>
+        <c:spPr>
+          <a:ln>
+            <a:noFill/>
+          </a:ln>
+        </c:spPr>
+        <c:txPr>
+          <a:bodyPr/>
+          <a:lstStyle/>
+          <a:p>
+            <a:pPr>
+              <a:defRPr>
+                <a:solidFill>
+                  <a:srgbClr val="8A929A"/>
+                </a:solidFill>
+              </a:defRPr>
+            </a:pPr>
+          </a:p>
+        </c:txPr>
+        <c:crossAx val="-2068027336"/>
+        <c:crosses val="autoZero"/>
+        <c:majorUnit val="100.0"/>
+      </c:valAx>
+    </c:plotArea>
+    <c:dispBlanksAs val="gap"/>
+  </c:chart>
+  <c:txPr>
+    <a:bodyPr/>
+    <a:lstStyle/>
+    <a:p>
+      <a:pPr>
+        <a:defRPr sz="941">
+          <a:solidFill>
+            <a:srgbClr val="1C2321"/>
+          </a:solidFill>
+          <a:latin typeface="IBM Plex Sans"/>
+        </a:defRPr>
+      </a:pPr>
+      <a:endParaRPr lang="en-US"/>
+    </a:p>
+  </c:txPr>
+  <c:externalData r:id="rId1">
+    <c:autoUpdate val="0"/>
+  </c:externalData>
+</c:chartSpace>
+</file>
+
+<file path=ppt/charts/chart2.xml><?xml version="1.0" encoding="utf-8"?>
+<c:chartSpace xmlns:c="http://schemas.openxmlformats.org/drawingml/2006/chart" xmlns:a="http://schemas.openxmlformats.org/drawingml/2006/main" xmlns:r="http://schemas.openxmlformats.org/officeDocument/2006/relationships">
+  <c:date1904 val="0"/>
+  <c:chart>
+    <c:autoTitleDeleted val="1"/>
+    <c:plotArea>
+      <c:barChart>
+        <c:barDir val="col"/>
+        <c:grouping val="clustered"/>
+        <c:ser>
+          <c:idx val="0"/>
+          <c:order val="0"/>
+          <c:tx>
+            <c:strRef>
+              <c:f>Sheet1!$B$1</c:f>
+              <c:strCache>
+                <c:ptCount val="1"/>
+                <c:pt idx="0">
+                  <c:v>Số em</c:v>
+                </c:pt>
+              </c:strCache>
+            </c:strRef>
+          </c:tx>
+          <c:dPt>
+            <c:idx val="0"/>
+            <c:spPr>
+              <a:solidFill>
+                <a:srgbClr val="27805A"/>
+              </a:solidFill>
+            </c:spPr>
+          </c:dPt>
+          <c:dPt>
+            <c:idx val="1"/>
+            <c:spPr>
+              <a:solidFill>
+                <a:srgbClr val="7FAE95"/>
+              </a:solidFill>
+            </c:spPr>
+          </c:dPt>
+          <c:dPt>
+            <c:idx val="2"/>
+            <c:spPr>
+              <a:solidFill>
+                <a:srgbClr val="7FAE95"/>
+              </a:solidFill>
+            </c:spPr>
+          </c:dPt>
+          <c:dPt>
+            <c:idx val="3"/>
+            <c:spPr>
+              <a:solidFill>
+                <a:srgbClr val="7FAE95"/>
+              </a:solidFill>
+            </c:spPr>
+          </c:dPt>
+          <c:dLbls>
+            <c:dLbl>
+              <c:idx val="0"/>
+              <c:tx>
+                <c:rich>
+                  <a:bodyPr/>
+                  <a:lstStyle/>
+                  <a:p>
+                    <a:r>
+                      <a:rPr sz="1231" b="1">
+                        <a:solidFill>
+                          <a:srgbClr val="1C2321"/>
+                        </a:solidFill>
+                      </a:rPr>
+                      <a:t>64 em · 59%</a:t>
+                    </a:r>
+                  </a:p>
+                </c:rich>
+              </c:tx>
+              <c:dLblPos val="outEnd"/>
+              <c:showLegendKey val="0"/>
+              <c:showVal val="1"/>
+              <c:showCatName val="0"/>
+              <c:showSerName val="0"/>
+              <c:showPercent val="0"/>
+              <c:showBubbleSize val="0"/>
+            </c:dLbl>
+            <c:dLbl>
+              <c:idx val="1"/>
+              <c:tx>
+                <c:rich>
+                  <a:bodyPr/>
+                  <a:lstStyle/>
+                  <a:p>
+                    <a:r>
+                      <a:rPr sz="1231" b="1">
+                        <a:solidFill>
+                          <a:srgbClr val="1C2321"/>
+                        </a:solidFill>
+                      </a:rPr>
+                      <a:t>28 em · 26%</a:t>
+                    </a:r>
+                  </a:p>
+                </c:rich>
+              </c:tx>
+              <c:dLblPos val="outEnd"/>
+              <c:showLegendKey val="0"/>
+              <c:showVal val="1"/>
+              <c:showCatName val="0"/>
+              <c:showSerName val="0"/>
+              <c:showPercent val="0"/>
+              <c:showBubbleSize val="0"/>
+            </c:dLbl>
+            <c:dLbl>
+              <c:idx val="2"/>
+              <c:tx>
+                <c:rich>
+                  <a:bodyPr/>
+                  <a:lstStyle/>
+                  <a:p>
+                    <a:r>
+                      <a:rPr sz="1231" b="1">
+                        <a:solidFill>
+                          <a:srgbClr val="1C2321"/>
+                        </a:solidFill>
+                      </a:rPr>
+                      <a:t>10 em · 9%</a:t>
+                    </a:r>
+                  </a:p>
+                </c:rich>
+              </c:tx>
+              <c:dLblPos val="outEnd"/>
+              <c:showLegendKey val="0"/>
+              <c:showVal val="1"/>
+              <c:showCatName val="0"/>
+              <c:showSerName val="0"/>
+              <c:showPercent val="0"/>
+              <c:showBubbleSize val="0"/>
+            </c:dLbl>
+            <c:dLbl>
+              <c:idx val="3"/>
+              <c:tx>
+                <c:rich>
+                  <a:bodyPr/>
+                  <a:lstStyle/>
+                  <a:p>
+                    <a:r>
+                      <a:rPr sz="1231" b="1">
+                        <a:solidFill>
+                          <a:srgbClr val="1C2321"/>
+                        </a:solidFill>
+                      </a:rPr>
+                      <a:t>6 em · 6%</a:t>
+                    </a:r>
+                  </a:p>
+                </c:rich>
+              </c:tx>
+              <c:dLblPos val="outEnd"/>
+              <c:showLegendKey val="0"/>
+              <c:showVal val="1"/>
+              <c:showCatName val="0"/>
+              <c:showSerName val="0"/>
+              <c:showPercent val="0"/>
+              <c:showBubbleSize val="0"/>
+            </c:dLbl>
+            <c:showLegendKey val="0"/>
+            <c:showVal val="0"/>
+            <c:showCatName val="0"/>
+            <c:showSerName val="0"/>
+            <c:showPercent val="0"/>
+            <c:showBubbleSize val="0"/>
+            <c:showLeaderLines val="1"/>
+          </c:dLbls>
+          <c:cat>
+            <c:strRef>
+              <c:f>Sheet1!$A$2:$A$5</c:f>
+              <c:strCache>
+                <c:ptCount val="4"/>
+                <c:pt idx="0">
+                  <c:v>NV 1</c:v>
+                </c:pt>
+                <c:pt idx="1">
+                  <c:v>NV 2</c:v>
+                </c:pt>
+                <c:pt idx="2">
+                  <c:v>NV 3</c:v>
+                </c:pt>
+                <c:pt idx="3">
+                  <c:v>NV 4</c:v>
+                </c:pt>
+              </c:strCache>
+            </c:strRef>
+          </c:cat>
+          <c:val>
+            <c:numRef>
+              <c:f>Sheet1!$B$2:$B$5</c:f>
+              <c:numCache>
+                <c:formatCode>General</c:formatCode>
+                <c:ptCount val="4"/>
+                <c:pt idx="0">
+                  <c:v>64</c:v>
+                </c:pt>
+                <c:pt idx="1">
+                  <c:v>28</c:v>
+                </c:pt>
+                <c:pt idx="2">
+                  <c:v>10</c:v>
+                </c:pt>
+                <c:pt idx="3">
+                  <c:v>6</c:v>
+                </c:pt>
+              </c:numCache>
+            </c:numRef>
+          </c:val>
+        </c:ser>
+        <c:gapWidth val="70"/>
+        <c:axId val="-2068027336"/>
+        <c:axId val="-2113994440"/>
+      </c:barChart>
+      <c:catAx>
+        <c:axId val="-2068027336"/>
+        <c:scaling>
+          <c:orientation val="minMax"/>
+        </c:scaling>
+        <c:delete val="0"/>
+        <c:axPos val="b"/>
+        <c:majorTickMark val="out"/>
+        <c:minorTickMark val="none"/>
+        <c:tickLblPos val="nextTo"/>
+        <c:spPr>
+          <a:ln>
+            <a:solidFill>
+              <a:srgbClr val="5B6570"/>
+            </a:solidFill>
+          </a:ln>
+        </c:spPr>
+        <c:txPr>
+          <a:bodyPr/>
+          <a:lstStyle/>
+          <a:p>
+            <a:pPr>
+              <a:defRPr b="1" sz="1159"/>
+            </a:pPr>
+          </a:p>
+        </c:txPr>
+        <c:crossAx val="-2113994440"/>
+        <c:crosses val="autoZero"/>
+        <c:auto val="1"/>
+        <c:lblAlgn val="ctr"/>
+        <c:lblOffset val="100"/>
+        <c:noMultiLvlLbl val="0"/>
+      </c:catAx>
+      <c:valAx>
+        <c:axId val="-2113994440"/>
+        <c:scaling>
+          <c:max val="70.0"/>
+          <c:min val="0.0"/>
+        </c:scaling>
+        <c:delete val="0"/>
+        <c:axPos val="l"/>
+        <c:majorGridlines>
+          <c:spPr>
+            <a:ln>
+              <a:solidFill>
+                <a:srgbClr val="DBDCD5"/>
+              </a:solidFill>
+            </a:ln>
+          </c:spPr>
+        </c:majorGridlines>
+        <c:majorTickMark val="out"/>
+        <c:minorTickMark val="none"/>
+        <c:tickLblPos val="nextTo"/>
+        <c:spPr>
+          <a:ln>
+            <a:noFill/>
+          </a:ln>
+        </c:spPr>
+        <c:txPr>
+          <a:bodyPr/>
+          <a:lstStyle/>
+          <a:p>
+            <a:pPr>
+              <a:defRPr>
+                <a:solidFill>
+                  <a:srgbClr val="8A929A"/>
+                </a:solidFill>
+              </a:defRPr>
+            </a:pPr>
+          </a:p>
+        </c:txPr>
+        <c:crossAx val="-2068027336"/>
+        <c:crosses val="autoZero"/>
+        <c:majorUnit val="20.0"/>
+      </c:valAx>
+    </c:plotArea>
+    <c:dispBlanksAs val="gap"/>
+  </c:chart>
+  <c:txPr>
+    <a:bodyPr/>
+    <a:lstStyle/>
+    <a:p>
+      <a:pPr>
+        <a:defRPr sz="941">
+          <a:solidFill>
+            <a:srgbClr val="1C2321"/>
+          </a:solidFill>
+          <a:latin typeface="IBM Plex Sans"/>
+        </a:defRPr>
+      </a:pPr>
+      <a:endParaRPr lang="en-US"/>
+    </a:p>
+  </c:txPr>
+  <c:externalData r:id="rId1">
+    <c:autoUpdate val="0"/>
+  </c:externalData>
+</c:chartSpace>
 </file>
 
 <file path=ppt/notesMasters/notesMaster1.xml><?xml version="1.0" encoding="utf-8"?>
@@ -5353,33 +5899,1921 @@
           </a:p>
         </p:txBody>
       </p:sp>
-      <p:pic>
-        <p:nvPicPr>
-          <p:cNvPr id="43" name="Picture 42" descr="so_do_5_lop.png"/>
-          <p:cNvPicPr>
-            <a:picLocks noChangeAspect="1"/>
-          </p:cNvPicPr>
-          <p:nvPr/>
-        </p:nvPicPr>
-        <p:blipFill>
-          <a:blip r:embed="rId4"/>
-          <a:stretch>
-            <a:fillRect/>
-          </a:stretch>
-        </p:blipFill>
-        <p:spPr>
-          <a:xfrm>
-            <a:off x="9774000" y="17550000"/>
-            <a:ext cx="16452000" cy="6169500"/>
+      <p:grpSp>
+        <p:nvGrpSpPr>
+          <p:cNvPr id="43" name="So do 5 lop"/>
+          <p:cNvGrpSpPr/>
+          <p:nvPr/>
+        </p:nvGrpSpPr>
+        <p:grpSpPr>
+          <a:xfrm>
+            <a:off x="0" y="0"/>
+            <a:ext cx="0" cy="0"/>
+            <a:chOff x="0" y="0"/>
+            <a:chExt cx="0" cy="0"/>
+          </a:xfrm>
+        </p:grpSpPr>
+      </p:grpSp>
+      <p:sp>
+        <p:nvSpPr>
+          <p:cNvPr id="44" name="Rounded Rectangle 43"/>
+          <p:cNvSpPr/>
+          <p:nvPr/>
+        </p:nvSpPr>
+        <p:spPr>
+          <a:xfrm>
+            <a:off x="10048200" y="18715350"/>
+            <a:ext cx="2742000" cy="3838800"/>
+          </a:xfrm>
+          <a:prstGeom prst="roundRect">
+            <a:avLst>
+              <a:gd name="adj" fmla="val 4500"/>
+            </a:avLst>
+          </a:prstGeom>
+          <a:solidFill>
+            <a:srgbClr val="F3F4F1"/>
+          </a:solidFill>
+          <a:ln w="20565">
+            <a:solidFill>
+              <a:srgbClr val="DBDCD5"/>
+            </a:solidFill>
+          </a:ln>
+          <a:effectLst/>
+        </p:spPr>
+        <p:style>
+          <a:lnRef idx="1">
+            <a:schemeClr val="accent1"/>
+          </a:lnRef>
+          <a:fillRef idx="3">
+            <a:schemeClr val="accent1"/>
+          </a:fillRef>
+          <a:effectRef idx="2">
+            <a:schemeClr val="accent1"/>
+          </a:effectRef>
+          <a:fontRef idx="minor">
+            <a:schemeClr val="lt1"/>
+          </a:fontRef>
+        </p:style>
+        <p:txBody>
+          <a:bodyPr rtlCol="0" anchor="ctr"/>
+          <a:lstStyle/>
+          <a:p>
+            <a:pPr algn="ctr"/>
+          </a:p>
+        </p:txBody>
+      </p:sp>
+      <p:sp>
+        <p:nvSpPr>
+          <p:cNvPr id="45" name="TextBox 44"/>
+          <p:cNvSpPr txBox="1"/>
+          <p:nvPr/>
+        </p:nvSpPr>
+        <p:spPr>
+          <a:xfrm>
+            <a:off x="10267559" y="18959388"/>
+            <a:ext cx="180000" cy="320814"/>
           </a:xfrm>
           <a:prstGeom prst="rect">
             <a:avLst/>
           </a:prstGeom>
-        </p:spPr>
-      </p:pic>
-      <p:sp>
-        <p:nvSpPr>
-          <p:cNvPr id="44" name="Rounded Rectangle 43"/>
+          <a:noFill/>
+        </p:spPr>
+        <p:txBody>
+          <a:bodyPr wrap="none" anchor="t" lIns="0" rIns="0" tIns="0" bIns="0">
+            <a:spAutoFit/>
+          </a:bodyPr>
+          <a:lstStyle/>
+          <a:p>
+            <a:pPr algn="l"/>
+            <a:r>
+              <a:rPr sz="1943" b="1" i="0">
+                <a:solidFill>
+                  <a:srgbClr val="1C2321"/>
+                </a:solidFill>
+                <a:latin typeface="Be Vietnam Pro"/>
+              </a:rPr>
+              <a:t>Đầu vào</a:t>
+            </a:r>
+          </a:p>
+        </p:txBody>
+      </p:sp>
+      <p:sp>
+        <p:nvSpPr>
+          <p:cNvPr id="46" name="TextBox 45"/>
+          <p:cNvSpPr txBox="1"/>
+          <p:nvPr/>
+        </p:nvSpPr>
+        <p:spPr>
+          <a:xfrm>
+            <a:off x="10267559" y="19433754"/>
+            <a:ext cx="180000" cy="249522"/>
+          </a:xfrm>
+          <a:prstGeom prst="rect">
+            <a:avLst/>
+          </a:prstGeom>
+          <a:noFill/>
+        </p:spPr>
+        <p:txBody>
+          <a:bodyPr wrap="none" anchor="t" lIns="0" rIns="0" tIns="0" bIns="0">
+            <a:spAutoFit/>
+          </a:bodyPr>
+          <a:lstStyle/>
+          <a:p>
+            <a:pPr algn="l"/>
+            <a:r>
+              <a:rPr sz="1511" b="0" i="0">
+                <a:solidFill>
+                  <a:srgbClr val="5B6570"/>
+                </a:solidFill>
+                <a:latin typeface="IBM Plex Sans"/>
+              </a:rPr>
+              <a:t>Danh sách CLB</a:t>
+            </a:r>
+          </a:p>
+        </p:txBody>
+      </p:sp>
+      <p:sp>
+        <p:nvSpPr>
+          <p:cNvPr id="47" name="TextBox 46"/>
+          <p:cNvSpPr txBox="1"/>
+          <p:nvPr/>
+        </p:nvSpPr>
+        <p:spPr>
+          <a:xfrm>
+            <a:off x="10267559" y="19735374"/>
+            <a:ext cx="180000" cy="249522"/>
+          </a:xfrm>
+          <a:prstGeom prst="rect">
+            <a:avLst/>
+          </a:prstGeom>
+          <a:noFill/>
+        </p:spPr>
+        <p:txBody>
+          <a:bodyPr wrap="none" anchor="t" lIns="0" rIns="0" tIns="0" bIns="0">
+            <a:spAutoFit/>
+          </a:bodyPr>
+          <a:lstStyle/>
+          <a:p>
+            <a:pPr algn="l"/>
+            <a:r>
+              <a:rPr sz="1511" b="0" i="0">
+                <a:solidFill>
+                  <a:srgbClr val="5B6570"/>
+                </a:solidFill>
+                <a:latin typeface="IBM Plex Sans"/>
+              </a:rPr>
+              <a:t>· sức chứa</a:t>
+            </a:r>
+          </a:p>
+        </p:txBody>
+      </p:sp>
+      <p:sp>
+        <p:nvSpPr>
+          <p:cNvPr id="48" name="TextBox 47"/>
+          <p:cNvSpPr txBox="1"/>
+          <p:nvPr/>
+        </p:nvSpPr>
+        <p:spPr>
+          <a:xfrm>
+            <a:off x="10267559" y="20036994"/>
+            <a:ext cx="180000" cy="249522"/>
+          </a:xfrm>
+          <a:prstGeom prst="rect">
+            <a:avLst/>
+          </a:prstGeom>
+          <a:noFill/>
+        </p:spPr>
+        <p:txBody>
+          <a:bodyPr wrap="none" anchor="t" lIns="0" rIns="0" tIns="0" bIns="0">
+            <a:spAutoFit/>
+          </a:bodyPr>
+          <a:lstStyle/>
+          <a:p>
+            <a:pPr algn="l"/>
+            <a:r>
+              <a:rPr sz="1511" b="0" i="0">
+                <a:solidFill>
+                  <a:srgbClr val="5B6570"/>
+                </a:solidFill>
+                <a:latin typeface="IBM Plex Sans"/>
+              </a:rPr>
+              <a:t>· suất dự trữ</a:t>
+            </a:r>
+          </a:p>
+        </p:txBody>
+      </p:sp>
+      <p:sp>
+        <p:nvSpPr>
+          <p:cNvPr id="49" name="TextBox 48"/>
+          <p:cNvSpPr txBox="1"/>
+          <p:nvPr/>
+        </p:nvSpPr>
+        <p:spPr>
+          <a:xfrm>
+            <a:off x="10267559" y="20338614"/>
+            <a:ext cx="180000" cy="249522"/>
+          </a:xfrm>
+          <a:prstGeom prst="rect">
+            <a:avLst/>
+          </a:prstGeom>
+          <a:noFill/>
+        </p:spPr>
+        <p:txBody>
+          <a:bodyPr wrap="none" anchor="t" lIns="0" rIns="0" tIns="0" bIns="0">
+            <a:spAutoFit/>
+          </a:bodyPr>
+          <a:lstStyle/>
+          <a:p>
+            <a:pPr algn="l"/>
+            <a:r>
+              <a:rPr sz="1511" b="0" i="0">
+                <a:solidFill>
+                  <a:srgbClr val="5B6570"/>
+                </a:solidFill>
+                <a:latin typeface="IBM Plex Sans"/>
+              </a:rPr>
+              <a:t/>
+            </a:r>
+          </a:p>
+        </p:txBody>
+      </p:sp>
+      <p:sp>
+        <p:nvSpPr>
+          <p:cNvPr id="50" name="TextBox 49"/>
+          <p:cNvSpPr txBox="1"/>
+          <p:nvPr/>
+        </p:nvSpPr>
+        <p:spPr>
+          <a:xfrm>
+            <a:off x="10267559" y="20640234"/>
+            <a:ext cx="180000" cy="249522"/>
+          </a:xfrm>
+          <a:prstGeom prst="rect">
+            <a:avLst/>
+          </a:prstGeom>
+          <a:noFill/>
+        </p:spPr>
+        <p:txBody>
+          <a:bodyPr wrap="none" anchor="t" lIns="0" rIns="0" tIns="0" bIns="0">
+            <a:spAutoFit/>
+          </a:bodyPr>
+          <a:lstStyle/>
+          <a:p>
+            <a:pPr algn="l"/>
+            <a:r>
+              <a:rPr sz="1511" b="0" i="0">
+                <a:solidFill>
+                  <a:srgbClr val="5B6570"/>
+                </a:solidFill>
+                <a:latin typeface="IBM Plex Sans"/>
+              </a:rPr>
+              <a:t>CLB muốn thi</a:t>
+            </a:r>
+          </a:p>
+        </p:txBody>
+      </p:sp>
+      <p:sp>
+        <p:nvSpPr>
+          <p:cNvPr id="51" name="TextBox 50"/>
+          <p:cNvSpPr txBox="1"/>
+          <p:nvPr/>
+        </p:nvSpPr>
+        <p:spPr>
+          <a:xfrm>
+            <a:off x="10267559" y="20941854"/>
+            <a:ext cx="180000" cy="249522"/>
+          </a:xfrm>
+          <a:prstGeom prst="rect">
+            <a:avLst/>
+          </a:prstGeom>
+          <a:noFill/>
+        </p:spPr>
+        <p:txBody>
+          <a:bodyPr wrap="none" anchor="t" lIns="0" rIns="0" tIns="0" bIns="0">
+            <a:spAutoFit/>
+          </a:bodyPr>
+          <a:lstStyle/>
+          <a:p>
+            <a:pPr algn="l"/>
+            <a:r>
+              <a:rPr sz="1511" b="0" i="0">
+                <a:solidFill>
+                  <a:srgbClr val="5B6570"/>
+                </a:solidFill>
+                <a:latin typeface="IBM Plex Sans"/>
+              </a:rPr>
+              <a:t>· điểm chấm mù</a:t>
+            </a:r>
+          </a:p>
+        </p:txBody>
+      </p:sp>
+      <p:sp>
+        <p:nvSpPr>
+          <p:cNvPr id="52" name="TextBox 51"/>
+          <p:cNvSpPr txBox="1"/>
+          <p:nvPr/>
+        </p:nvSpPr>
+        <p:spPr>
+          <a:xfrm>
+            <a:off x="10267559" y="21243474"/>
+            <a:ext cx="180000" cy="249522"/>
+          </a:xfrm>
+          <a:prstGeom prst="rect">
+            <a:avLst/>
+          </a:prstGeom>
+          <a:noFill/>
+        </p:spPr>
+        <p:txBody>
+          <a:bodyPr wrap="none" anchor="t" lIns="0" rIns="0" tIns="0" bIns="0">
+            <a:spAutoFit/>
+          </a:bodyPr>
+          <a:lstStyle/>
+          <a:p>
+            <a:pPr algn="l"/>
+            <a:r>
+              <a:rPr sz="1511" b="0" i="0">
+                <a:solidFill>
+                  <a:srgbClr val="5B6570"/>
+                </a:solidFill>
+                <a:latin typeface="IBM Plex Sans"/>
+              </a:rPr>
+              <a:t/>
+            </a:r>
+          </a:p>
+        </p:txBody>
+      </p:sp>
+      <p:sp>
+        <p:nvSpPr>
+          <p:cNvPr id="53" name="TextBox 52"/>
+          <p:cNvSpPr txBox="1"/>
+          <p:nvPr/>
+        </p:nvSpPr>
+        <p:spPr>
+          <a:xfrm>
+            <a:off x="10267559" y="21545094"/>
+            <a:ext cx="180000" cy="249522"/>
+          </a:xfrm>
+          <a:prstGeom prst="rect">
+            <a:avLst/>
+          </a:prstGeom>
+          <a:noFill/>
+        </p:spPr>
+        <p:txBody>
+          <a:bodyPr wrap="none" anchor="t" lIns="0" rIns="0" tIns="0" bIns="0">
+            <a:spAutoFit/>
+          </a:bodyPr>
+          <a:lstStyle/>
+          <a:p>
+            <a:pPr algn="l"/>
+            <a:r>
+              <a:rPr sz="1511" b="0" i="0">
+                <a:solidFill>
+                  <a:srgbClr val="5B6570"/>
+                </a:solidFill>
+                <a:latin typeface="IBM Plex Sans"/>
+              </a:rPr>
+              <a:t>Nguyện vọng</a:t>
+            </a:r>
+          </a:p>
+        </p:txBody>
+      </p:sp>
+      <p:sp>
+        <p:nvSpPr>
+          <p:cNvPr id="54" name="TextBox 53"/>
+          <p:cNvSpPr txBox="1"/>
+          <p:nvPr/>
+        </p:nvSpPr>
+        <p:spPr>
+          <a:xfrm>
+            <a:off x="10267559" y="21846714"/>
+            <a:ext cx="180000" cy="249522"/>
+          </a:xfrm>
+          <a:prstGeom prst="rect">
+            <a:avLst/>
+          </a:prstGeom>
+          <a:noFill/>
+        </p:spPr>
+        <p:txBody>
+          <a:bodyPr wrap="none" anchor="t" lIns="0" rIns="0" tIns="0" bIns="0">
+            <a:spAutoFit/>
+          </a:bodyPr>
+          <a:lstStyle/>
+          <a:p>
+            <a:pPr algn="l"/>
+            <a:r>
+              <a:rPr sz="1511" b="0" i="0">
+                <a:solidFill>
+                  <a:srgbClr val="5B6570"/>
+                </a:solidFill>
+                <a:latin typeface="IBM Plex Sans"/>
+              </a:rPr>
+              <a:t>· xếp hạng CLB</a:t>
+            </a:r>
+          </a:p>
+        </p:txBody>
+      </p:sp>
+      <p:sp>
+        <p:nvSpPr>
+          <p:cNvPr id="55" name="Right Arrow 54"/>
+          <p:cNvSpPr/>
+          <p:nvPr/>
+        </p:nvSpPr>
+        <p:spPr>
+          <a:xfrm>
+            <a:off x="12790200" y="20525070"/>
+            <a:ext cx="616950" cy="219360"/>
+          </a:xfrm>
+          <a:prstGeom prst="rightArrow">
+            <a:avLst/>
+          </a:prstGeom>
+          <a:solidFill>
+            <a:srgbClr val="5B6570"/>
+          </a:solidFill>
+          <a:ln>
+            <a:noFill/>
+          </a:ln>
+          <a:effectLst/>
+        </p:spPr>
+        <p:style>
+          <a:lnRef idx="1">
+            <a:schemeClr val="accent1"/>
+          </a:lnRef>
+          <a:fillRef idx="3">
+            <a:schemeClr val="accent1"/>
+          </a:fillRef>
+          <a:effectRef idx="2">
+            <a:schemeClr val="accent1"/>
+          </a:effectRef>
+          <a:fontRef idx="minor">
+            <a:schemeClr val="lt1"/>
+          </a:fontRef>
+        </p:style>
+        <p:txBody>
+          <a:bodyPr rtlCol="0" anchor="ctr"/>
+          <a:lstStyle/>
+          <a:p>
+            <a:pPr algn="ctr"/>
+          </a:p>
+        </p:txBody>
+      </p:sp>
+      <p:sp>
+        <p:nvSpPr>
+          <p:cNvPr id="56" name="Rounded Rectangle 55"/>
+          <p:cNvSpPr/>
+          <p:nvPr/>
+        </p:nvSpPr>
+        <p:spPr>
+          <a:xfrm>
+            <a:off x="13407150" y="18715350"/>
+            <a:ext cx="3564600" cy="1816575"/>
+          </a:xfrm>
+          <a:prstGeom prst="roundRect">
+            <a:avLst>
+              <a:gd name="adj" fmla="val 6792"/>
+            </a:avLst>
+          </a:prstGeom>
+          <a:solidFill>
+            <a:srgbClr val="FFFFFF"/>
+          </a:solidFill>
+          <a:ln w="20565">
+            <a:solidFill>
+              <a:srgbClr val="27805A"/>
+            </a:solidFill>
+          </a:ln>
+          <a:effectLst/>
+        </p:spPr>
+        <p:style>
+          <a:lnRef idx="1">
+            <a:schemeClr val="accent1"/>
+          </a:lnRef>
+          <a:fillRef idx="3">
+            <a:schemeClr val="accent1"/>
+          </a:fillRef>
+          <a:effectRef idx="2">
+            <a:schemeClr val="accent1"/>
+          </a:effectRef>
+          <a:fontRef idx="minor">
+            <a:schemeClr val="lt1"/>
+          </a:fontRef>
+        </p:style>
+        <p:txBody>
+          <a:bodyPr rtlCol="0" anchor="ctr"/>
+          <a:lstStyle/>
+          <a:p>
+            <a:pPr algn="ctr"/>
+          </a:p>
+        </p:txBody>
+      </p:sp>
+      <p:sp>
+        <p:nvSpPr>
+          <p:cNvPr id="57" name="Oval 56"/>
+          <p:cNvSpPr/>
+          <p:nvPr/>
+        </p:nvSpPr>
+        <p:spPr>
+          <a:xfrm>
+            <a:off x="13557960" y="18893580"/>
+            <a:ext cx="411300" cy="411300"/>
+          </a:xfrm>
+          <a:prstGeom prst="ellipse">
+            <a:avLst/>
+          </a:prstGeom>
+          <a:solidFill>
+            <a:srgbClr val="B8781A"/>
+          </a:solidFill>
+          <a:ln>
+            <a:noFill/>
+          </a:ln>
+          <a:effectLst/>
+        </p:spPr>
+        <p:style>
+          <a:lnRef idx="1">
+            <a:schemeClr val="accent1"/>
+          </a:lnRef>
+          <a:fillRef idx="3">
+            <a:schemeClr val="accent1"/>
+          </a:fillRef>
+          <a:effectRef idx="2">
+            <a:schemeClr val="accent1"/>
+          </a:effectRef>
+          <a:fontRef idx="minor">
+            <a:schemeClr val="lt1"/>
+          </a:fontRef>
+        </p:style>
+        <p:txBody>
+          <a:bodyPr rtlCol="0" anchor="ctr" wrap="square" lIns="0" rIns="0" tIns="0" bIns="0"/>
+          <a:lstStyle/>
+          <a:p>
+            <a:pPr algn="ctr"/>
+            <a:r>
+              <a:rPr sz="1619" b="1" i="0">
+                <a:solidFill>
+                  <a:srgbClr val="FFFFFF"/>
+                </a:solidFill>
+                <a:latin typeface="Be Vietnam Pro"/>
+              </a:rPr>
+              <a:t>4</a:t>
+            </a:r>
+          </a:p>
+        </p:txBody>
+      </p:sp>
+      <p:sp>
+        <p:nvSpPr>
+          <p:cNvPr id="58" name="TextBox 57"/>
+          <p:cNvSpPr txBox="1"/>
+          <p:nvPr/>
+        </p:nvSpPr>
+        <p:spPr>
+          <a:xfrm>
+            <a:off x="14092650" y="18959388"/>
+            <a:ext cx="180000" cy="320814"/>
+          </a:xfrm>
+          <a:prstGeom prst="rect">
+            <a:avLst/>
+          </a:prstGeom>
+          <a:noFill/>
+        </p:spPr>
+        <p:txBody>
+          <a:bodyPr wrap="none" anchor="t" lIns="0" rIns="0" tIns="0" bIns="0">
+            <a:spAutoFit/>
+          </a:bodyPr>
+          <a:lstStyle/>
+          <a:p>
+            <a:pPr algn="l"/>
+            <a:r>
+              <a:rPr sz="1943" b="1" i="0">
+                <a:solidFill>
+                  <a:srgbClr val="1C2321"/>
+                </a:solidFill>
+                <a:latin typeface="Be Vietnam Pro"/>
+              </a:rPr>
+              <a:t>Ưu tiên hai tầng</a:t>
+            </a:r>
+          </a:p>
+        </p:txBody>
+      </p:sp>
+      <p:sp>
+        <p:nvSpPr>
+          <p:cNvPr id="59" name="TextBox 58"/>
+          <p:cNvSpPr txBox="1"/>
+          <p:nvPr/>
+        </p:nvSpPr>
+        <p:spPr>
+          <a:xfrm>
+            <a:off x="13626510" y="19433754"/>
+            <a:ext cx="180000" cy="249522"/>
+          </a:xfrm>
+          <a:prstGeom prst="rect">
+            <a:avLst/>
+          </a:prstGeom>
+          <a:noFill/>
+        </p:spPr>
+        <p:txBody>
+          <a:bodyPr wrap="none" anchor="t" lIns="0" rIns="0" tIns="0" bIns="0">
+            <a:spAutoFit/>
+          </a:bodyPr>
+          <a:lstStyle/>
+          <a:p>
+            <a:pPr algn="l"/>
+            <a:r>
+              <a:rPr sz="1511" b="0" i="0">
+                <a:solidFill>
+                  <a:srgbClr val="5B6570"/>
+                </a:solidFill>
+                <a:latin typeface="IBM Plex Sans"/>
+              </a:rPr>
+              <a:t>Tầng 1: đã thi → theo điểm</a:t>
+            </a:r>
+          </a:p>
+        </p:txBody>
+      </p:sp>
+      <p:sp>
+        <p:nvSpPr>
+          <p:cNvPr id="60" name="TextBox 59"/>
+          <p:cNvSpPr txBox="1"/>
+          <p:nvPr/>
+        </p:nvSpPr>
+        <p:spPr>
+          <a:xfrm>
+            <a:off x="13626510" y="19735374"/>
+            <a:ext cx="180000" cy="249522"/>
+          </a:xfrm>
+          <a:prstGeom prst="rect">
+            <a:avLst/>
+          </a:prstGeom>
+          <a:noFill/>
+        </p:spPr>
+        <p:txBody>
+          <a:bodyPr wrap="none" anchor="t" lIns="0" rIns="0" tIns="0" bIns="0">
+            <a:spAutoFit/>
+          </a:bodyPr>
+          <a:lstStyle/>
+          <a:p>
+            <a:pPr algn="l"/>
+            <a:r>
+              <a:rPr sz="1511" b="0" i="0">
+                <a:solidFill>
+                  <a:srgbClr val="5B6570"/>
+                </a:solidFill>
+                <a:latin typeface="IBM Plex Sans"/>
+              </a:rPr>
+              <a:t>Tầng 2: không thi</a:t>
+            </a:r>
+          </a:p>
+        </p:txBody>
+      </p:sp>
+      <p:sp>
+        <p:nvSpPr>
+          <p:cNvPr id="61" name="Rounded Rectangle 60"/>
+          <p:cNvSpPr/>
+          <p:nvPr/>
+        </p:nvSpPr>
+        <p:spPr>
+          <a:xfrm>
+            <a:off x="13407150" y="20737575"/>
+            <a:ext cx="3564600" cy="1816575"/>
+          </a:xfrm>
+          <a:prstGeom prst="roundRect">
+            <a:avLst>
+              <a:gd name="adj" fmla="val 6792"/>
+            </a:avLst>
+          </a:prstGeom>
+          <a:solidFill>
+            <a:srgbClr val="FFFFFF"/>
+          </a:solidFill>
+          <a:ln w="20565">
+            <a:solidFill>
+              <a:srgbClr val="27805A"/>
+            </a:solidFill>
+          </a:ln>
+          <a:effectLst/>
+        </p:spPr>
+        <p:style>
+          <a:lnRef idx="1">
+            <a:schemeClr val="accent1"/>
+          </a:lnRef>
+          <a:fillRef idx="3">
+            <a:schemeClr val="accent1"/>
+          </a:fillRef>
+          <a:effectRef idx="2">
+            <a:schemeClr val="accent1"/>
+          </a:effectRef>
+          <a:fontRef idx="minor">
+            <a:schemeClr val="lt1"/>
+          </a:fontRef>
+        </p:style>
+        <p:txBody>
+          <a:bodyPr rtlCol="0" anchor="ctr"/>
+          <a:lstStyle/>
+          <a:p>
+            <a:pPr algn="ctr"/>
+          </a:p>
+        </p:txBody>
+      </p:sp>
+      <p:sp>
+        <p:nvSpPr>
+          <p:cNvPr id="62" name="Oval 61"/>
+          <p:cNvSpPr/>
+          <p:nvPr/>
+        </p:nvSpPr>
+        <p:spPr>
+          <a:xfrm>
+            <a:off x="13557960" y="20915805"/>
+            <a:ext cx="411300" cy="411300"/>
+          </a:xfrm>
+          <a:prstGeom prst="ellipse">
+            <a:avLst/>
+          </a:prstGeom>
+          <a:solidFill>
+            <a:srgbClr val="B8781A"/>
+          </a:solidFill>
+          <a:ln>
+            <a:noFill/>
+          </a:ln>
+          <a:effectLst/>
+        </p:spPr>
+        <p:style>
+          <a:lnRef idx="1">
+            <a:schemeClr val="accent1"/>
+          </a:lnRef>
+          <a:fillRef idx="3">
+            <a:schemeClr val="accent1"/>
+          </a:fillRef>
+          <a:effectRef idx="2">
+            <a:schemeClr val="accent1"/>
+          </a:effectRef>
+          <a:fontRef idx="minor">
+            <a:schemeClr val="lt1"/>
+          </a:fontRef>
+        </p:style>
+        <p:txBody>
+          <a:bodyPr rtlCol="0" anchor="ctr" wrap="square" lIns="0" rIns="0" tIns="0" bIns="0"/>
+          <a:lstStyle/>
+          <a:p>
+            <a:pPr algn="ctr"/>
+            <a:r>
+              <a:rPr sz="1619" b="1" i="0">
+                <a:solidFill>
+                  <a:srgbClr val="FFFFFF"/>
+                </a:solidFill>
+                <a:latin typeface="Be Vietnam Pro"/>
+              </a:rPr>
+              <a:t>3</a:t>
+            </a:r>
+          </a:p>
+        </p:txBody>
+      </p:sp>
+      <p:sp>
+        <p:nvSpPr>
+          <p:cNvPr id="63" name="TextBox 62"/>
+          <p:cNvSpPr txBox="1"/>
+          <p:nvPr/>
+        </p:nvSpPr>
+        <p:spPr>
+          <a:xfrm>
+            <a:off x="14092650" y="20981613"/>
+            <a:ext cx="180000" cy="320814"/>
+          </a:xfrm>
+          <a:prstGeom prst="rect">
+            <a:avLst/>
+          </a:prstGeom>
+          <a:noFill/>
+        </p:spPr>
+        <p:txBody>
+          <a:bodyPr wrap="none" anchor="t" lIns="0" rIns="0" tIns="0" bIns="0">
+            <a:spAutoFit/>
+          </a:bodyPr>
+          <a:lstStyle/>
+          <a:p>
+            <a:pPr algn="l"/>
+            <a:r>
+              <a:rPr sz="1943" b="1" i="0">
+                <a:solidFill>
+                  <a:srgbClr val="1C2321"/>
+                </a:solidFill>
+                <a:latin typeface="Be Vietnam Pro"/>
+              </a:rPr>
+              <a:t>Bốc thăm dùng chung</a:t>
+            </a:r>
+          </a:p>
+        </p:txBody>
+      </p:sp>
+      <p:sp>
+        <p:nvSpPr>
+          <p:cNvPr id="64" name="TextBox 63"/>
+          <p:cNvSpPr txBox="1"/>
+          <p:nvPr/>
+        </p:nvSpPr>
+        <p:spPr>
+          <a:xfrm>
+            <a:off x="13626510" y="21455979"/>
+            <a:ext cx="180000" cy="249522"/>
+          </a:xfrm>
+          <a:prstGeom prst="rect">
+            <a:avLst/>
+          </a:prstGeom>
+          <a:noFill/>
+        </p:spPr>
+        <p:txBody>
+          <a:bodyPr wrap="none" anchor="t" lIns="0" rIns="0" tIns="0" bIns="0">
+            <a:spAutoFit/>
+          </a:bodyPr>
+          <a:lstStyle/>
+          <a:p>
+            <a:pPr algn="l"/>
+            <a:r>
+              <a:rPr sz="1511" b="0" i="0">
+                <a:solidFill>
+                  <a:srgbClr val="5B6570"/>
+                </a:solidFill>
+                <a:latin typeface="IBM Plex Sans"/>
+              </a:rPr>
+              <a:t>Một số cho mỗi em, mọi CLB</a:t>
+            </a:r>
+          </a:p>
+        </p:txBody>
+      </p:sp>
+      <p:sp>
+        <p:nvSpPr>
+          <p:cNvPr id="65" name="TextBox 64"/>
+          <p:cNvSpPr txBox="1"/>
+          <p:nvPr/>
+        </p:nvSpPr>
+        <p:spPr>
+          <a:xfrm>
+            <a:off x="13626510" y="21757599"/>
+            <a:ext cx="180000" cy="249522"/>
+          </a:xfrm>
+          <a:prstGeom prst="rect">
+            <a:avLst/>
+          </a:prstGeom>
+          <a:noFill/>
+        </p:spPr>
+        <p:txBody>
+          <a:bodyPr wrap="none" anchor="t" lIns="0" rIns="0" tIns="0" bIns="0">
+            <a:spAutoFit/>
+          </a:bodyPr>
+          <a:lstStyle/>
+          <a:p>
+            <a:pPr algn="l"/>
+            <a:r>
+              <a:rPr sz="1511" b="0" i="0">
+                <a:solidFill>
+                  <a:srgbClr val="5B6570"/>
+                </a:solidFill>
+                <a:latin typeface="IBM Plex Sans"/>
+              </a:rPr>
+              <a:t>Chỉ phá hoà · khoá theo seed</a:t>
+            </a:r>
+          </a:p>
+        </p:txBody>
+      </p:sp>
+      <p:sp>
+        <p:nvSpPr>
+          <p:cNvPr id="66" name="Right Arrow 65"/>
+          <p:cNvSpPr/>
+          <p:nvPr/>
+        </p:nvSpPr>
+        <p:spPr>
+          <a:xfrm>
+            <a:off x="16971750" y="20525070"/>
+            <a:ext cx="616950" cy="219360"/>
+          </a:xfrm>
+          <a:prstGeom prst="rightArrow">
+            <a:avLst/>
+          </a:prstGeom>
+          <a:solidFill>
+            <a:srgbClr val="5B6570"/>
+          </a:solidFill>
+          <a:ln>
+            <a:noFill/>
+          </a:ln>
+          <a:effectLst/>
+        </p:spPr>
+        <p:style>
+          <a:lnRef idx="1">
+            <a:schemeClr val="accent1"/>
+          </a:lnRef>
+          <a:fillRef idx="3">
+            <a:schemeClr val="accent1"/>
+          </a:fillRef>
+          <a:effectRef idx="2">
+            <a:schemeClr val="accent1"/>
+          </a:effectRef>
+          <a:fontRef idx="minor">
+            <a:schemeClr val="lt1"/>
+          </a:fontRef>
+        </p:style>
+        <p:txBody>
+          <a:bodyPr rtlCol="0" anchor="ctr"/>
+          <a:lstStyle/>
+          <a:p>
+            <a:pPr algn="ctr"/>
+          </a:p>
+        </p:txBody>
+      </p:sp>
+      <p:sp>
+        <p:nvSpPr>
+          <p:cNvPr id="67" name="Rounded Rectangle 66"/>
+          <p:cNvSpPr/>
+          <p:nvPr/>
+        </p:nvSpPr>
+        <p:spPr>
+          <a:xfrm>
+            <a:off x="17588700" y="18441150"/>
+            <a:ext cx="4387200" cy="4387200"/>
+          </a:xfrm>
+          <a:prstGeom prst="roundRect">
+            <a:avLst>
+              <a:gd name="adj" fmla="val 2812"/>
+            </a:avLst>
+          </a:prstGeom>
+          <a:solidFill>
+            <a:srgbClr val="DCE9E0"/>
+          </a:solidFill>
+          <a:ln w="27420">
+            <a:solidFill>
+              <a:srgbClr val="27805A"/>
+            </a:solidFill>
+          </a:ln>
+          <a:effectLst/>
+        </p:spPr>
+        <p:style>
+          <a:lnRef idx="1">
+            <a:schemeClr val="accent1"/>
+          </a:lnRef>
+          <a:fillRef idx="3">
+            <a:schemeClr val="accent1"/>
+          </a:fillRef>
+          <a:effectRef idx="2">
+            <a:schemeClr val="accent1"/>
+          </a:effectRef>
+          <a:fontRef idx="minor">
+            <a:schemeClr val="lt1"/>
+          </a:fontRef>
+        </p:style>
+        <p:txBody>
+          <a:bodyPr rtlCol="0" anchor="ctr"/>
+          <a:lstStyle/>
+          <a:p>
+            <a:pPr algn="ctr"/>
+          </a:p>
+        </p:txBody>
+      </p:sp>
+      <p:sp>
+        <p:nvSpPr>
+          <p:cNvPr id="68" name="Oval 67"/>
+          <p:cNvSpPr/>
+          <p:nvPr/>
+        </p:nvSpPr>
+        <p:spPr>
+          <a:xfrm>
+            <a:off x="17739510" y="18619380"/>
+            <a:ext cx="411300" cy="411300"/>
+          </a:xfrm>
+          <a:prstGeom prst="ellipse">
+            <a:avLst/>
+          </a:prstGeom>
+          <a:solidFill>
+            <a:srgbClr val="B8781A"/>
+          </a:solidFill>
+          <a:ln>
+            <a:noFill/>
+          </a:ln>
+          <a:effectLst/>
+        </p:spPr>
+        <p:style>
+          <a:lnRef idx="1">
+            <a:schemeClr val="accent1"/>
+          </a:lnRef>
+          <a:fillRef idx="3">
+            <a:schemeClr val="accent1"/>
+          </a:fillRef>
+          <a:effectRef idx="2">
+            <a:schemeClr val="accent1"/>
+          </a:effectRef>
+          <a:fontRef idx="minor">
+            <a:schemeClr val="lt1"/>
+          </a:fontRef>
+        </p:style>
+        <p:txBody>
+          <a:bodyPr rtlCol="0" anchor="ctr" wrap="square" lIns="0" rIns="0" tIns="0" bIns="0"/>
+          <a:lstStyle/>
+          <a:p>
+            <a:pPr algn="ctr"/>
+            <a:r>
+              <a:rPr sz="1619" b="1" i="0">
+                <a:solidFill>
+                  <a:srgbClr val="FFFFFF"/>
+                </a:solidFill>
+                <a:latin typeface="Be Vietnam Pro"/>
+              </a:rPr>
+              <a:t>1</a:t>
+            </a:r>
+          </a:p>
+        </p:txBody>
+      </p:sp>
+      <p:sp>
+        <p:nvSpPr>
+          <p:cNvPr id="69" name="TextBox 68"/>
+          <p:cNvSpPr txBox="1"/>
+          <p:nvPr/>
+        </p:nvSpPr>
+        <p:spPr>
+          <a:xfrm>
+            <a:off x="18274200" y="18672849"/>
+            <a:ext cx="180000" cy="338637"/>
+          </a:xfrm>
+          <a:prstGeom prst="rect">
+            <a:avLst/>
+          </a:prstGeom>
+          <a:noFill/>
+        </p:spPr>
+        <p:txBody>
+          <a:bodyPr wrap="none" anchor="t" lIns="0" rIns="0" tIns="0" bIns="0">
+            <a:spAutoFit/>
+          </a:bodyPr>
+          <a:lstStyle/>
+          <a:p>
+            <a:pPr algn="l"/>
+            <a:r>
+              <a:rPr sz="2051" b="1" i="0">
+                <a:solidFill>
+                  <a:srgbClr val="1C2321"/>
+                </a:solidFill>
+                <a:latin typeface="Be Vietnam Pro"/>
+              </a:rPr>
+              <a:t>Deferred Acceptance</a:t>
+            </a:r>
+          </a:p>
+        </p:txBody>
+      </p:sp>
+      <p:sp>
+        <p:nvSpPr>
+          <p:cNvPr id="70" name="TextBox 69"/>
+          <p:cNvSpPr txBox="1"/>
+          <p:nvPr/>
+        </p:nvSpPr>
+        <p:spPr>
+          <a:xfrm>
+            <a:off x="17808060" y="19132134"/>
+            <a:ext cx="180000" cy="249522"/>
+          </a:xfrm>
+          <a:prstGeom prst="rect">
+            <a:avLst/>
+          </a:prstGeom>
+          <a:noFill/>
+        </p:spPr>
+        <p:txBody>
+          <a:bodyPr wrap="none" anchor="t" lIns="0" rIns="0" tIns="0" bIns="0">
+            <a:spAutoFit/>
+          </a:bodyPr>
+          <a:lstStyle/>
+          <a:p>
+            <a:pPr algn="l"/>
+            <a:r>
+              <a:rPr sz="1511" b="0" i="0">
+                <a:solidFill>
+                  <a:srgbClr val="5B6570"/>
+                </a:solidFill>
+                <a:latin typeface="IBM Plex Sans"/>
+              </a:rPr>
+              <a:t>Học sinh đề xuất theo nguyện vọng</a:t>
+            </a:r>
+          </a:p>
+        </p:txBody>
+      </p:sp>
+      <p:sp>
+        <p:nvSpPr>
+          <p:cNvPr id="71" name="TextBox 70"/>
+          <p:cNvSpPr txBox="1"/>
+          <p:nvPr/>
+        </p:nvSpPr>
+        <p:spPr>
+          <a:xfrm>
+            <a:off x="17808060" y="19433754"/>
+            <a:ext cx="180000" cy="249522"/>
+          </a:xfrm>
+          <a:prstGeom prst="rect">
+            <a:avLst/>
+          </a:prstGeom>
+          <a:noFill/>
+        </p:spPr>
+        <p:txBody>
+          <a:bodyPr wrap="none" anchor="t" lIns="0" rIns="0" tIns="0" bIns="0">
+            <a:spAutoFit/>
+          </a:bodyPr>
+          <a:lstStyle/>
+          <a:p>
+            <a:pPr algn="l"/>
+            <a:r>
+              <a:rPr sz="1511" b="0" i="0">
+                <a:solidFill>
+                  <a:srgbClr val="5B6570"/>
+                </a:solidFill>
+                <a:latin typeface="IBM Plex Sans"/>
+              </a:rPr>
+              <a:t>CLB giữ tạm, từ chối phần còn lại</a:t>
+            </a:r>
+          </a:p>
+        </p:txBody>
+      </p:sp>
+      <p:sp>
+        <p:nvSpPr>
+          <p:cNvPr id="72" name="TextBox 71"/>
+          <p:cNvSpPr txBox="1"/>
+          <p:nvPr/>
+        </p:nvSpPr>
+        <p:spPr>
+          <a:xfrm>
+            <a:off x="17808060" y="19735374"/>
+            <a:ext cx="180000" cy="249522"/>
+          </a:xfrm>
+          <a:prstGeom prst="rect">
+            <a:avLst/>
+          </a:prstGeom>
+          <a:noFill/>
+        </p:spPr>
+        <p:txBody>
+          <a:bodyPr wrap="none" anchor="t" lIns="0" rIns="0" tIns="0" bIns="0">
+            <a:spAutoFit/>
+          </a:bodyPr>
+          <a:lstStyle/>
+          <a:p>
+            <a:pPr algn="l"/>
+            <a:r>
+              <a:rPr sz="1511" b="0" i="0">
+                <a:solidFill>
+                  <a:srgbClr val="5B6570"/>
+                </a:solidFill>
+                <a:latin typeface="IBM Plex Sans"/>
+              </a:rPr>
+              <a:t>Lặp tới khi không còn đề xuất</a:t>
+            </a:r>
+          </a:p>
+        </p:txBody>
+      </p:sp>
+      <p:sp>
+        <p:nvSpPr>
+          <p:cNvPr id="73" name="Rounded Rectangle 72"/>
+          <p:cNvSpPr/>
+          <p:nvPr/>
+        </p:nvSpPr>
+        <p:spPr>
+          <a:xfrm>
+            <a:off x="17862900" y="20292000"/>
+            <a:ext cx="3838800" cy="2262150"/>
+          </a:xfrm>
+          <a:prstGeom prst="roundRect">
+            <a:avLst>
+              <a:gd name="adj" fmla="val 5454"/>
+            </a:avLst>
+          </a:prstGeom>
+          <a:solidFill>
+            <a:srgbClr val="FFFFFF"/>
+          </a:solidFill>
+          <a:ln w="20565">
+            <a:solidFill>
+              <a:srgbClr val="B8781A"/>
+            </a:solidFill>
+          </a:ln>
+          <a:effectLst/>
+        </p:spPr>
+        <p:style>
+          <a:lnRef idx="1">
+            <a:schemeClr val="accent1"/>
+          </a:lnRef>
+          <a:fillRef idx="3">
+            <a:schemeClr val="accent1"/>
+          </a:fillRef>
+          <a:effectRef idx="2">
+            <a:schemeClr val="accent1"/>
+          </a:effectRef>
+          <a:fontRef idx="minor">
+            <a:schemeClr val="lt1"/>
+          </a:fontRef>
+        </p:style>
+        <p:txBody>
+          <a:bodyPr rtlCol="0" anchor="ctr"/>
+          <a:lstStyle/>
+          <a:p>
+            <a:pPr algn="ctr"/>
+          </a:p>
+        </p:txBody>
+      </p:sp>
+      <p:sp>
+        <p:nvSpPr>
+          <p:cNvPr id="74" name="Oval 73"/>
+          <p:cNvSpPr/>
+          <p:nvPr/>
+        </p:nvSpPr>
+        <p:spPr>
+          <a:xfrm>
+            <a:off x="18013710" y="20470230"/>
+            <a:ext cx="411300" cy="411300"/>
+          </a:xfrm>
+          <a:prstGeom prst="ellipse">
+            <a:avLst/>
+          </a:prstGeom>
+          <a:solidFill>
+            <a:srgbClr val="B8781A"/>
+          </a:solidFill>
+          <a:ln>
+            <a:noFill/>
+          </a:ln>
+          <a:effectLst/>
+        </p:spPr>
+        <p:style>
+          <a:lnRef idx="1">
+            <a:schemeClr val="accent1"/>
+          </a:lnRef>
+          <a:fillRef idx="3">
+            <a:schemeClr val="accent1"/>
+          </a:fillRef>
+          <a:effectRef idx="2">
+            <a:schemeClr val="accent1"/>
+          </a:effectRef>
+          <a:fontRef idx="minor">
+            <a:schemeClr val="lt1"/>
+          </a:fontRef>
+        </p:style>
+        <p:txBody>
+          <a:bodyPr rtlCol="0" anchor="ctr" wrap="square" lIns="0" rIns="0" tIns="0" bIns="0"/>
+          <a:lstStyle/>
+          <a:p>
+            <a:pPr algn="ctr"/>
+            <a:r>
+              <a:rPr sz="1619" b="1" i="0">
+                <a:solidFill>
+                  <a:srgbClr val="FFFFFF"/>
+                </a:solidFill>
+                <a:latin typeface="Be Vietnam Pro"/>
+              </a:rPr>
+              <a:t>2</a:t>
+            </a:r>
+          </a:p>
+        </p:txBody>
+      </p:sp>
+      <p:sp>
+        <p:nvSpPr>
+          <p:cNvPr id="75" name="TextBox 74"/>
+          <p:cNvSpPr txBox="1"/>
+          <p:nvPr/>
+        </p:nvSpPr>
+        <p:spPr>
+          <a:xfrm>
+            <a:off x="18548400" y="20536038"/>
+            <a:ext cx="180000" cy="320814"/>
+          </a:xfrm>
+          <a:prstGeom prst="rect">
+            <a:avLst/>
+          </a:prstGeom>
+          <a:noFill/>
+        </p:spPr>
+        <p:txBody>
+          <a:bodyPr wrap="none" anchor="t" lIns="0" rIns="0" tIns="0" bIns="0">
+            <a:spAutoFit/>
+          </a:bodyPr>
+          <a:lstStyle/>
+          <a:p>
+            <a:pPr algn="l"/>
+            <a:r>
+              <a:rPr sz="1943" b="1" i="0">
+                <a:solidFill>
+                  <a:srgbClr val="1C2321"/>
+                </a:solidFill>
+                <a:latin typeface="Be Vietnam Pro"/>
+              </a:rPr>
+              <a:t>Dự trữ mềm, hai lượt</a:t>
+            </a:r>
+          </a:p>
+        </p:txBody>
+      </p:sp>
+      <p:sp>
+        <p:nvSpPr>
+          <p:cNvPr id="76" name="TextBox 75"/>
+          <p:cNvSpPr txBox="1"/>
+          <p:nvPr/>
+        </p:nvSpPr>
+        <p:spPr>
+          <a:xfrm>
+            <a:off x="18082260" y="21010404"/>
+            <a:ext cx="180000" cy="249522"/>
+          </a:xfrm>
+          <a:prstGeom prst="rect">
+            <a:avLst/>
+          </a:prstGeom>
+          <a:noFill/>
+        </p:spPr>
+        <p:txBody>
+          <a:bodyPr wrap="none" anchor="t" lIns="0" rIns="0" tIns="0" bIns="0">
+            <a:spAutoFit/>
+          </a:bodyPr>
+          <a:lstStyle/>
+          <a:p>
+            <a:pPr algn="l"/>
+            <a:r>
+              <a:rPr sz="1511" b="0" i="0">
+                <a:solidFill>
+                  <a:srgbClr val="5B6570"/>
+                </a:solidFill>
+                <a:latin typeface="IBM Plex Sans"/>
+              </a:rPr>
+              <a:t>Lượt 1: suất dự trữ</a:t>
+            </a:r>
+          </a:p>
+        </p:txBody>
+      </p:sp>
+      <p:sp>
+        <p:nvSpPr>
+          <p:cNvPr id="77" name="TextBox 76"/>
+          <p:cNvSpPr txBox="1"/>
+          <p:nvPr/>
+        </p:nvSpPr>
+        <p:spPr>
+          <a:xfrm>
+            <a:off x="18082260" y="21312024"/>
+            <a:ext cx="180000" cy="249522"/>
+          </a:xfrm>
+          <a:prstGeom prst="rect">
+            <a:avLst/>
+          </a:prstGeom>
+          <a:noFill/>
+        </p:spPr>
+        <p:txBody>
+          <a:bodyPr wrap="none" anchor="t" lIns="0" rIns="0" tIns="0" bIns="0">
+            <a:spAutoFit/>
+          </a:bodyPr>
+          <a:lstStyle/>
+          <a:p>
+            <a:pPr algn="l"/>
+            <a:r>
+              <a:rPr sz="1511" b="0" i="0">
+                <a:solidFill>
+                  <a:srgbClr val="5B6570"/>
+                </a:solidFill>
+                <a:latin typeface="IBM Plex Sans"/>
+              </a:rPr>
+              <a:t>  → chỉ em thuộc diện</a:t>
+            </a:r>
+          </a:p>
+        </p:txBody>
+      </p:sp>
+      <p:sp>
+        <p:nvSpPr>
+          <p:cNvPr id="78" name="TextBox 77"/>
+          <p:cNvSpPr txBox="1"/>
+          <p:nvPr/>
+        </p:nvSpPr>
+        <p:spPr>
+          <a:xfrm>
+            <a:off x="18082260" y="21613644"/>
+            <a:ext cx="180000" cy="249522"/>
+          </a:xfrm>
+          <a:prstGeom prst="rect">
+            <a:avLst/>
+          </a:prstGeom>
+          <a:noFill/>
+        </p:spPr>
+        <p:txBody>
+          <a:bodyPr wrap="none" anchor="t" lIns="0" rIns="0" tIns="0" bIns="0">
+            <a:spAutoFit/>
+          </a:bodyPr>
+          <a:lstStyle/>
+          <a:p>
+            <a:pPr algn="l"/>
+            <a:r>
+              <a:rPr sz="1511" b="0" i="0">
+                <a:solidFill>
+                  <a:srgbClr val="5B6570"/>
+                </a:solidFill>
+                <a:latin typeface="IBM Plex Sans"/>
+              </a:rPr>
+              <a:t>Lượt 2: lượt chung</a:t>
+            </a:r>
+          </a:p>
+        </p:txBody>
+      </p:sp>
+      <p:sp>
+        <p:nvSpPr>
+          <p:cNvPr id="79" name="TextBox 78"/>
+          <p:cNvSpPr txBox="1"/>
+          <p:nvPr/>
+        </p:nvSpPr>
+        <p:spPr>
+          <a:xfrm>
+            <a:off x="18082260" y="21915264"/>
+            <a:ext cx="180000" cy="249522"/>
+          </a:xfrm>
+          <a:prstGeom prst="rect">
+            <a:avLst/>
+          </a:prstGeom>
+          <a:noFill/>
+        </p:spPr>
+        <p:txBody>
+          <a:bodyPr wrap="none" anchor="t" lIns="0" rIns="0" tIns="0" bIns="0">
+            <a:spAutoFit/>
+          </a:bodyPr>
+          <a:lstStyle/>
+          <a:p>
+            <a:pPr algn="l"/>
+            <a:r>
+              <a:rPr sz="1511" b="0" i="0">
+                <a:solidFill>
+                  <a:srgbClr val="5B6570"/>
+                </a:solidFill>
+                <a:latin typeface="IBM Plex Sans"/>
+              </a:rPr>
+              <a:t>  → suất thừa tự chuyển sang</a:t>
+            </a:r>
+          </a:p>
+        </p:txBody>
+      </p:sp>
+      <p:sp>
+        <p:nvSpPr>
+          <p:cNvPr id="80" name="Right Arrow 79"/>
+          <p:cNvSpPr/>
+          <p:nvPr/>
+        </p:nvSpPr>
+        <p:spPr>
+          <a:xfrm>
+            <a:off x="21975900" y="20525070"/>
+            <a:ext cx="616950" cy="219360"/>
+          </a:xfrm>
+          <a:prstGeom prst="rightArrow">
+            <a:avLst/>
+          </a:prstGeom>
+          <a:solidFill>
+            <a:srgbClr val="5B6570"/>
+          </a:solidFill>
+          <a:ln>
+            <a:noFill/>
+          </a:ln>
+          <a:effectLst/>
+        </p:spPr>
+        <p:style>
+          <a:lnRef idx="1">
+            <a:schemeClr val="accent1"/>
+          </a:lnRef>
+          <a:fillRef idx="3">
+            <a:schemeClr val="accent1"/>
+          </a:fillRef>
+          <a:effectRef idx="2">
+            <a:schemeClr val="accent1"/>
+          </a:effectRef>
+          <a:fontRef idx="minor">
+            <a:schemeClr val="lt1"/>
+          </a:fontRef>
+        </p:style>
+        <p:txBody>
+          <a:bodyPr rtlCol="0" anchor="ctr"/>
+          <a:lstStyle/>
+          <a:p>
+            <a:pPr algn="ctr"/>
+          </a:p>
+        </p:txBody>
+      </p:sp>
+      <p:sp>
+        <p:nvSpPr>
+          <p:cNvPr id="81" name="Rounded Rectangle 80"/>
+          <p:cNvSpPr/>
+          <p:nvPr/>
+        </p:nvSpPr>
+        <p:spPr>
+          <a:xfrm>
+            <a:off x="22592850" y="18715350"/>
+            <a:ext cx="3358950" cy="1816575"/>
+          </a:xfrm>
+          <a:prstGeom prst="roundRect">
+            <a:avLst>
+              <a:gd name="adj" fmla="val 6792"/>
+            </a:avLst>
+          </a:prstGeom>
+          <a:solidFill>
+            <a:srgbClr val="FFFFFF"/>
+          </a:solidFill>
+          <a:ln w="20565">
+            <a:solidFill>
+              <a:srgbClr val="27805A"/>
+            </a:solidFill>
+          </a:ln>
+          <a:effectLst/>
+        </p:spPr>
+        <p:style>
+          <a:lnRef idx="1">
+            <a:schemeClr val="accent1"/>
+          </a:lnRef>
+          <a:fillRef idx="3">
+            <a:schemeClr val="accent1"/>
+          </a:fillRef>
+          <a:effectRef idx="2">
+            <a:schemeClr val="accent1"/>
+          </a:effectRef>
+          <a:fontRef idx="minor">
+            <a:schemeClr val="lt1"/>
+          </a:fontRef>
+        </p:style>
+        <p:txBody>
+          <a:bodyPr rtlCol="0" anchor="ctr"/>
+          <a:lstStyle/>
+          <a:p>
+            <a:pPr algn="ctr"/>
+          </a:p>
+        </p:txBody>
+      </p:sp>
+      <p:sp>
+        <p:nvSpPr>
+          <p:cNvPr id="82" name="Oval 81"/>
+          <p:cNvSpPr/>
+          <p:nvPr/>
+        </p:nvSpPr>
+        <p:spPr>
+          <a:xfrm>
+            <a:off x="22743660" y="18893580"/>
+            <a:ext cx="411300" cy="411300"/>
+          </a:xfrm>
+          <a:prstGeom prst="ellipse">
+            <a:avLst/>
+          </a:prstGeom>
+          <a:solidFill>
+            <a:srgbClr val="B8781A"/>
+          </a:solidFill>
+          <a:ln>
+            <a:noFill/>
+          </a:ln>
+          <a:effectLst/>
+        </p:spPr>
+        <p:style>
+          <a:lnRef idx="1">
+            <a:schemeClr val="accent1"/>
+          </a:lnRef>
+          <a:fillRef idx="3">
+            <a:schemeClr val="accent1"/>
+          </a:fillRef>
+          <a:effectRef idx="2">
+            <a:schemeClr val="accent1"/>
+          </a:effectRef>
+          <a:fontRef idx="minor">
+            <a:schemeClr val="lt1"/>
+          </a:fontRef>
+        </p:style>
+        <p:txBody>
+          <a:bodyPr rtlCol="0" anchor="ctr" wrap="square" lIns="0" rIns="0" tIns="0" bIns="0"/>
+          <a:lstStyle/>
+          <a:p>
+            <a:pPr algn="ctr"/>
+            <a:r>
+              <a:rPr sz="1619" b="1" i="0">
+                <a:solidFill>
+                  <a:srgbClr val="FFFFFF"/>
+                </a:solidFill>
+                <a:latin typeface="Be Vietnam Pro"/>
+              </a:rPr>
+              <a:t>5</a:t>
+            </a:r>
+          </a:p>
+        </p:txBody>
+      </p:sp>
+      <p:sp>
+        <p:nvSpPr>
+          <p:cNvPr id="83" name="TextBox 82"/>
+          <p:cNvSpPr txBox="1"/>
+          <p:nvPr/>
+        </p:nvSpPr>
+        <p:spPr>
+          <a:xfrm>
+            <a:off x="23278349" y="18959388"/>
+            <a:ext cx="180000" cy="320814"/>
+          </a:xfrm>
+          <a:prstGeom prst="rect">
+            <a:avLst/>
+          </a:prstGeom>
+          <a:noFill/>
+        </p:spPr>
+        <p:txBody>
+          <a:bodyPr wrap="none" anchor="t" lIns="0" rIns="0" tIns="0" bIns="0">
+            <a:spAutoFit/>
+          </a:bodyPr>
+          <a:lstStyle/>
+          <a:p>
+            <a:pPr algn="l"/>
+            <a:r>
+              <a:rPr sz="1943" b="1" i="0">
+                <a:solidFill>
+                  <a:srgbClr val="1C2321"/>
+                </a:solidFill>
+                <a:latin typeface="Be Vietnam Pro"/>
+              </a:rPr>
+              <a:t>Kiểm tra ổn định</a:t>
+            </a:r>
+          </a:p>
+        </p:txBody>
+      </p:sp>
+      <p:sp>
+        <p:nvSpPr>
+          <p:cNvPr id="84" name="TextBox 83"/>
+          <p:cNvSpPr txBox="1"/>
+          <p:nvPr/>
+        </p:nvSpPr>
+        <p:spPr>
+          <a:xfrm>
+            <a:off x="22812210" y="19433754"/>
+            <a:ext cx="180000" cy="249522"/>
+          </a:xfrm>
+          <a:prstGeom prst="rect">
+            <a:avLst/>
+          </a:prstGeom>
+          <a:noFill/>
+        </p:spPr>
+        <p:txBody>
+          <a:bodyPr wrap="none" anchor="t" lIns="0" rIns="0" tIns="0" bIns="0">
+            <a:spAutoFit/>
+          </a:bodyPr>
+          <a:lstStyle/>
+          <a:p>
+            <a:pPr algn="l"/>
+            <a:r>
+              <a:rPr sz="1511" b="0" i="0">
+                <a:solidFill>
+                  <a:srgbClr val="5B6570"/>
+                </a:solidFill>
+                <a:latin typeface="IBM Plex Sans"/>
+              </a:rPr>
+              <a:t>Tìm cặp phá vỡ bằng</a:t>
+            </a:r>
+          </a:p>
+        </p:txBody>
+      </p:sp>
+      <p:sp>
+        <p:nvSpPr>
+          <p:cNvPr id="85" name="TextBox 84"/>
+          <p:cNvSpPr txBox="1"/>
+          <p:nvPr/>
+        </p:nvSpPr>
+        <p:spPr>
+          <a:xfrm>
+            <a:off x="22812210" y="19735374"/>
+            <a:ext cx="180000" cy="249522"/>
+          </a:xfrm>
+          <a:prstGeom prst="rect">
+            <a:avLst/>
+          </a:prstGeom>
+          <a:noFill/>
+        </p:spPr>
+        <p:txBody>
+          <a:bodyPr wrap="none" anchor="t" lIns="0" rIns="0" tIns="0" bIns="0">
+            <a:spAutoFit/>
+          </a:bodyPr>
+          <a:lstStyle/>
+          <a:p>
+            <a:pPr algn="l"/>
+            <a:r>
+              <a:rPr sz="1511" b="0" i="0">
+                <a:solidFill>
+                  <a:srgbClr val="5B6570"/>
+                </a:solidFill>
+                <a:latin typeface="IBM Plex Sans"/>
+              </a:rPr>
+              <a:t>chính hàm lựa chọn</a:t>
+            </a:r>
+          </a:p>
+        </p:txBody>
+      </p:sp>
+      <p:sp>
+        <p:nvSpPr>
+          <p:cNvPr id="86" name="Down Arrow 85"/>
+          <p:cNvSpPr/>
+          <p:nvPr/>
+        </p:nvSpPr>
+        <p:spPr>
+          <a:xfrm>
+            <a:off x="24162645" y="20531925"/>
+            <a:ext cx="219360" cy="205650"/>
+          </a:xfrm>
+          <a:prstGeom prst="downArrow">
+            <a:avLst/>
+          </a:prstGeom>
+          <a:solidFill>
+            <a:srgbClr val="5B6570"/>
+          </a:solidFill>
+          <a:ln>
+            <a:noFill/>
+          </a:ln>
+          <a:effectLst/>
+        </p:spPr>
+        <p:style>
+          <a:lnRef idx="1">
+            <a:schemeClr val="accent1"/>
+          </a:lnRef>
+          <a:fillRef idx="3">
+            <a:schemeClr val="accent1"/>
+          </a:fillRef>
+          <a:effectRef idx="2">
+            <a:schemeClr val="accent1"/>
+          </a:effectRef>
+          <a:fontRef idx="minor">
+            <a:schemeClr val="lt1"/>
+          </a:fontRef>
+        </p:style>
+        <p:txBody>
+          <a:bodyPr rtlCol="0" anchor="ctr"/>
+          <a:lstStyle/>
+          <a:p>
+            <a:pPr algn="ctr"/>
+          </a:p>
+        </p:txBody>
+      </p:sp>
+      <p:sp>
+        <p:nvSpPr>
+          <p:cNvPr id="87" name="Rounded Rectangle 86"/>
+          <p:cNvSpPr/>
+          <p:nvPr/>
+        </p:nvSpPr>
+        <p:spPr>
+          <a:xfrm>
+            <a:off x="22592850" y="20737575"/>
+            <a:ext cx="3358950" cy="1816575"/>
+          </a:xfrm>
+          <a:prstGeom prst="roundRect">
+            <a:avLst>
+              <a:gd name="adj" fmla="val 6792"/>
+            </a:avLst>
+          </a:prstGeom>
+          <a:solidFill>
+            <a:srgbClr val="F3F4F1"/>
+          </a:solidFill>
+          <a:ln w="20565">
+            <a:solidFill>
+              <a:srgbClr val="DBDCD5"/>
+            </a:solidFill>
+          </a:ln>
+          <a:effectLst/>
+        </p:spPr>
+        <p:style>
+          <a:lnRef idx="1">
+            <a:schemeClr val="accent1"/>
+          </a:lnRef>
+          <a:fillRef idx="3">
+            <a:schemeClr val="accent1"/>
+          </a:fillRef>
+          <a:effectRef idx="2">
+            <a:schemeClr val="accent1"/>
+          </a:effectRef>
+          <a:fontRef idx="minor">
+            <a:schemeClr val="lt1"/>
+          </a:fontRef>
+        </p:style>
+        <p:txBody>
+          <a:bodyPr rtlCol="0" anchor="ctr"/>
+          <a:lstStyle/>
+          <a:p>
+            <a:pPr algn="ctr"/>
+          </a:p>
+        </p:txBody>
+      </p:sp>
+      <p:sp>
+        <p:nvSpPr>
+          <p:cNvPr id="88" name="TextBox 87"/>
+          <p:cNvSpPr txBox="1"/>
+          <p:nvPr/>
+        </p:nvSpPr>
+        <p:spPr>
+          <a:xfrm>
+            <a:off x="22812210" y="20981613"/>
+            <a:ext cx="180000" cy="320814"/>
+          </a:xfrm>
+          <a:prstGeom prst="rect">
+            <a:avLst/>
+          </a:prstGeom>
+          <a:noFill/>
+        </p:spPr>
+        <p:txBody>
+          <a:bodyPr wrap="none" anchor="t" lIns="0" rIns="0" tIns="0" bIns="0">
+            <a:spAutoFit/>
+          </a:bodyPr>
+          <a:lstStyle/>
+          <a:p>
+            <a:pPr algn="l"/>
+            <a:r>
+              <a:rPr sz="1943" b="1" i="0">
+                <a:solidFill>
+                  <a:srgbClr val="1C2321"/>
+                </a:solidFill>
+                <a:latin typeface="Be Vietnam Pro"/>
+              </a:rPr>
+              <a:t>Kết quả</a:t>
+            </a:r>
+          </a:p>
+        </p:txBody>
+      </p:sp>
+      <p:sp>
+        <p:nvSpPr>
+          <p:cNvPr id="89" name="TextBox 88"/>
+          <p:cNvSpPr txBox="1"/>
+          <p:nvPr/>
+        </p:nvSpPr>
+        <p:spPr>
+          <a:xfrm>
+            <a:off x="22812210" y="21455979"/>
+            <a:ext cx="180000" cy="249522"/>
+          </a:xfrm>
+          <a:prstGeom prst="rect">
+            <a:avLst/>
+          </a:prstGeom>
+          <a:noFill/>
+        </p:spPr>
+        <p:txBody>
+          <a:bodyPr wrap="none" anchor="t" lIns="0" rIns="0" tIns="0" bIns="0">
+            <a:spAutoFit/>
+          </a:bodyPr>
+          <a:lstStyle/>
+          <a:p>
+            <a:pPr algn="l"/>
+            <a:r>
+              <a:rPr sz="1511" b="0" i="0">
+                <a:solidFill>
+                  <a:srgbClr val="5B6570"/>
+                </a:solidFill>
+                <a:latin typeface="IBM Plex Sans"/>
+              </a:rPr>
+              <a:t>Mỗi em một CLB</a:t>
+            </a:r>
+          </a:p>
+        </p:txBody>
+      </p:sp>
+      <p:sp>
+        <p:nvSpPr>
+          <p:cNvPr id="90" name="TextBox 89"/>
+          <p:cNvSpPr txBox="1"/>
+          <p:nvPr/>
+        </p:nvSpPr>
+        <p:spPr>
+          <a:xfrm>
+            <a:off x="22812210" y="21757599"/>
+            <a:ext cx="180000" cy="249522"/>
+          </a:xfrm>
+          <a:prstGeom prst="rect">
+            <a:avLst/>
+          </a:prstGeom>
+          <a:noFill/>
+        </p:spPr>
+        <p:txBody>
+          <a:bodyPr wrap="none" anchor="t" lIns="0" rIns="0" tIns="0" bIns="0">
+            <a:spAutoFit/>
+          </a:bodyPr>
+          <a:lstStyle/>
+          <a:p>
+            <a:pPr algn="l"/>
+            <a:r>
+              <a:rPr sz="1511" b="0" i="0">
+                <a:solidFill>
+                  <a:srgbClr val="5B6570"/>
+                </a:solidFill>
+                <a:latin typeface="IBM Plex Sans"/>
+              </a:rPr>
+              <a:t>Xuất Excel / CSV theo CLB</a:t>
+            </a:r>
+          </a:p>
+        </p:txBody>
+      </p:sp>
+      <p:sp>
+        <p:nvSpPr>
+          <p:cNvPr id="91" name="TextBox 90"/>
+          <p:cNvSpPr txBox="1"/>
+          <p:nvPr/>
+        </p:nvSpPr>
+        <p:spPr>
+          <a:xfrm>
+            <a:off x="10048200" y="23216343"/>
+            <a:ext cx="180000" cy="231699"/>
+          </a:xfrm>
+          <a:prstGeom prst="rect">
+            <a:avLst/>
+          </a:prstGeom>
+          <a:noFill/>
+        </p:spPr>
+        <p:txBody>
+          <a:bodyPr wrap="none" anchor="t" lIns="0" rIns="0" tIns="0" bIns="0">
+            <a:spAutoFit/>
+          </a:bodyPr>
+          <a:lstStyle/>
+          <a:p>
+            <a:pPr algn="l"/>
+            <a:r>
+              <a:rPr sz="1403" b="0" i="0">
+                <a:solidFill>
+                  <a:srgbClr val="8A929A"/>
+                </a:solidFill>
+                <a:latin typeface="IBM Plex Sans"/>
+              </a:rPr>
+              <a:t>Sơ đồ do AI tạo ra — theo CO_CHE_THUAT_TOAN.md (năm lớp cơ chế của phần mềm)</a:t>
+            </a:r>
+          </a:p>
+        </p:txBody>
+      </p:sp>
+      <p:sp>
+        <p:nvSpPr>
+          <p:cNvPr id="92" name="Rounded Rectangle 91"/>
           <p:cNvSpPr/>
           <p:nvPr/>
         </p:nvSpPr>
@@ -5426,7 +7860,7 @@
       </p:sp>
       <p:sp>
         <p:nvSpPr>
-          <p:cNvPr id="45" name="TextBox 44"/>
+          <p:cNvPr id="93" name="TextBox 92"/>
           <p:cNvSpPr txBox="1"/>
           <p:nvPr/>
         </p:nvSpPr>
@@ -5461,7 +7895,7 @@
       </p:sp>
       <p:sp>
         <p:nvSpPr>
-          <p:cNvPr id="46" name="Rounded Rectangle 45"/>
+          <p:cNvPr id="94" name="Rounded Rectangle 93"/>
           <p:cNvSpPr/>
           <p:nvPr/>
         </p:nvSpPr>
@@ -5509,7 +7943,7 @@
       </p:sp>
       <p:sp>
         <p:nvSpPr>
-          <p:cNvPr id="47" name="Oval 46"/>
+          <p:cNvPr id="95" name="Oval 94"/>
           <p:cNvSpPr/>
           <p:nvPr/>
         </p:nvSpPr>
@@ -5562,7 +7996,7 @@
       </p:sp>
       <p:sp>
         <p:nvSpPr>
-          <p:cNvPr id="48" name="TextBox 47"/>
+          <p:cNvPr id="96" name="TextBox 95"/>
           <p:cNvSpPr txBox="1"/>
           <p:nvPr/>
         </p:nvSpPr>
@@ -5597,7 +8031,7 @@
       </p:sp>
       <p:sp>
         <p:nvSpPr>
-          <p:cNvPr id="49" name="Oval 48"/>
+          <p:cNvPr id="97" name="Oval 96"/>
           <p:cNvSpPr/>
           <p:nvPr/>
         </p:nvSpPr>
@@ -5650,7 +8084,7 @@
       </p:sp>
       <p:sp>
         <p:nvSpPr>
-          <p:cNvPr id="50" name="Rounded Rectangle 49"/>
+          <p:cNvPr id="98" name="Rounded Rectangle 97"/>
           <p:cNvSpPr/>
           <p:nvPr/>
         </p:nvSpPr>
@@ -5697,7 +8131,7 @@
       </p:sp>
       <p:sp>
         <p:nvSpPr>
-          <p:cNvPr id="51" name="TextBox 50"/>
+          <p:cNvPr id="99" name="TextBox 98"/>
           <p:cNvSpPr txBox="1"/>
           <p:nvPr/>
         </p:nvSpPr>
@@ -5732,7 +8166,7 @@
       </p:sp>
       <p:sp>
         <p:nvSpPr>
-          <p:cNvPr id="52" name="Oval 51"/>
+          <p:cNvPr id="100" name="Oval 99"/>
           <p:cNvSpPr/>
           <p:nvPr/>
         </p:nvSpPr>
@@ -5785,7 +8219,7 @@
       </p:sp>
       <p:sp>
         <p:nvSpPr>
-          <p:cNvPr id="53" name="Rounded Rectangle 52"/>
+          <p:cNvPr id="101" name="Rounded Rectangle 100"/>
           <p:cNvSpPr/>
           <p:nvPr/>
         </p:nvSpPr>
@@ -5832,7 +8266,7 @@
       </p:sp>
       <p:sp>
         <p:nvSpPr>
-          <p:cNvPr id="54" name="TextBox 53"/>
+          <p:cNvPr id="102" name="TextBox 101"/>
           <p:cNvSpPr txBox="1"/>
           <p:nvPr/>
         </p:nvSpPr>
@@ -5867,7 +8301,7 @@
       </p:sp>
       <p:sp>
         <p:nvSpPr>
-          <p:cNvPr id="55" name="Oval 54"/>
+          <p:cNvPr id="103" name="Oval 102"/>
           <p:cNvSpPr/>
           <p:nvPr/>
         </p:nvSpPr>
@@ -5920,7 +8354,7 @@
       </p:sp>
       <p:sp>
         <p:nvSpPr>
-          <p:cNvPr id="56" name="Rounded Rectangle 55"/>
+          <p:cNvPr id="104" name="Rounded Rectangle 103"/>
           <p:cNvSpPr/>
           <p:nvPr/>
         </p:nvSpPr>
@@ -5967,7 +8401,7 @@
       </p:sp>
       <p:sp>
         <p:nvSpPr>
-          <p:cNvPr id="57" name="TextBox 56"/>
+          <p:cNvPr id="105" name="TextBox 104"/>
           <p:cNvSpPr txBox="1"/>
           <p:nvPr/>
         </p:nvSpPr>
@@ -6002,7 +8436,7 @@
       </p:sp>
       <p:sp>
         <p:nvSpPr>
-          <p:cNvPr id="58" name="Oval 57"/>
+          <p:cNvPr id="106" name="Oval 105"/>
           <p:cNvSpPr/>
           <p:nvPr/>
         </p:nvSpPr>
@@ -6055,7 +8489,7 @@
       </p:sp>
       <p:sp>
         <p:nvSpPr>
-          <p:cNvPr id="59" name="Rounded Rectangle 58"/>
+          <p:cNvPr id="107" name="Rounded Rectangle 106"/>
           <p:cNvSpPr/>
           <p:nvPr/>
         </p:nvSpPr>
@@ -6102,7 +8536,7 @@
       </p:sp>
       <p:sp>
         <p:nvSpPr>
-          <p:cNvPr id="60" name="TextBox 59"/>
+          <p:cNvPr id="108" name="TextBox 107"/>
           <p:cNvSpPr txBox="1"/>
           <p:nvPr/>
         </p:nvSpPr>
@@ -6137,7 +8571,7 @@
       </p:sp>
       <p:sp>
         <p:nvSpPr>
-          <p:cNvPr id="61" name="Rounded Rectangle 60"/>
+          <p:cNvPr id="109" name="Rounded Rectangle 108"/>
           <p:cNvSpPr/>
           <p:nvPr/>
         </p:nvSpPr>
@@ -6185,7 +8619,7 @@
       </p:sp>
       <p:sp>
         <p:nvSpPr>
-          <p:cNvPr id="62" name="Oval 61"/>
+          <p:cNvPr id="110" name="Oval 109"/>
           <p:cNvSpPr/>
           <p:nvPr/>
         </p:nvSpPr>
@@ -6238,7 +8672,7 @@
       </p:sp>
       <p:sp>
         <p:nvSpPr>
-          <p:cNvPr id="63" name="TextBox 62"/>
+          <p:cNvPr id="111" name="TextBox 110"/>
           <p:cNvSpPr txBox="1"/>
           <p:nvPr/>
         </p:nvSpPr>
@@ -6271,57 +8705,285 @@
           </a:p>
         </p:txBody>
       </p:sp>
-      <p:pic>
-        <p:nvPicPr>
-          <p:cNvPr id="64" name="Picture 63" descr="bieu_do_khai_gian.png"/>
-          <p:cNvPicPr>
-            <a:picLocks noChangeAspect="1"/>
-          </p:cNvPicPr>
-          <p:nvPr/>
-        </p:nvPicPr>
-        <p:blipFill>
-          <a:blip r:embed="rId5"/>
-          <a:stretch>
-            <a:fillRect/>
-          </a:stretch>
-        </p:blipFill>
-        <p:spPr>
-          <a:xfrm>
-            <a:off x="27774000" y="12420000"/>
-            <a:ext cx="7362000" cy="3496949"/>
+      <p:grpSp>
+        <p:nvGrpSpPr>
+          <p:cNvPr id="112" name="Bieu do khai gian"/>
+          <p:cNvGrpSpPr/>
+          <p:nvPr/>
+        </p:nvGrpSpPr>
+        <p:grpSpPr>
+          <a:xfrm>
+            <a:off x="27958050" y="13202212"/>
+            <a:ext cx="6993899" cy="2208600"/>
+            <a:chOff x="27958050" y="13202212"/>
+            <a:chExt cx="6993899" cy="2208600"/>
+          </a:xfrm>
+        </p:grpSpPr>
+        <p:graphicFrame>
+          <p:nvGraphicFramePr>
+            <p:cNvPr id="116" name="Chart 115"/>
+            <p:cNvGraphicFramePr>
+              <a:graphicFrameLocks noGrp="1"/>
+            </p:cNvGraphicFramePr>
+            <p:nvPr/>
+          </p:nvGraphicFramePr>
+          <p:xfrm>
+            <a:off x="27958050" y="13202212"/>
+            <a:ext cx="6993899" cy="2208600"/>
+          </p:xfrm>
+          <a:graphic>
+            <a:graphicData uri="http://schemas.openxmlformats.org/drawingml/2006/chart">
+              <c:chart xmlns:c="http://schemas.openxmlformats.org/drawingml/2006/chart" r:id="rId4"/>
+            </a:graphicData>
+          </a:graphic>
+        </p:graphicFrame>
+      </p:grpSp>
+      <p:sp>
+        <p:nvSpPr>
+          <p:cNvPr id="113" name="TextBox 112"/>
+          <p:cNvSpPr txBox="1"/>
+          <p:nvPr/>
+        </p:nvSpPr>
+        <p:spPr>
+          <a:xfrm>
+            <a:off x="28050075" y="12605890"/>
+            <a:ext cx="180000" cy="263191"/>
           </a:xfrm>
           <a:prstGeom prst="rect">
             <a:avLst/>
           </a:prstGeom>
-        </p:spPr>
-      </p:pic>
-      <p:pic>
-        <p:nvPicPr>
-          <p:cNvPr id="65" name="Picture 64" descr="bieu_do_nguyen_vong.png"/>
-          <p:cNvPicPr>
-            <a:picLocks noChangeAspect="1"/>
-          </p:cNvPicPr>
-          <p:nvPr/>
-        </p:nvPicPr>
-        <p:blipFill>
-          <a:blip r:embed="rId6"/>
-          <a:stretch>
-            <a:fillRect/>
-          </a:stretch>
-        </p:blipFill>
-        <p:spPr>
-          <a:xfrm>
-            <a:off x="27774000" y="16060949"/>
-            <a:ext cx="7362000" cy="4601250"/>
+          <a:noFill/>
+        </p:spPr>
+        <p:txBody>
+          <a:bodyPr wrap="none" anchor="t" lIns="0" rIns="0" tIns="0" bIns="0">
+            <a:spAutoFit/>
+          </a:bodyPr>
+          <a:lstStyle/>
+          <a:p>
+            <a:pPr algn="l"/>
+            <a:r>
+              <a:rPr sz="1594" b="1" i="0">
+                <a:solidFill>
+                  <a:srgbClr val="1C2321"/>
+                </a:solidFill>
+                <a:latin typeface="Be Vietnam Pro"/>
+              </a:rPr>
+              <a:t>Số em khai sai nguyện vọng mà được lợi</a:t>
+            </a:r>
+          </a:p>
+        </p:txBody>
+      </p:sp>
+      <p:sp>
+        <p:nvSpPr>
+          <p:cNvPr id="114" name="TextBox 113"/>
+          <p:cNvSpPr txBox="1"/>
+          <p:nvPr/>
+        </p:nvSpPr>
+        <p:spPr>
+          <a:xfrm>
+            <a:off x="28050075" y="12893008"/>
+            <a:ext cx="180000" cy="167485"/>
           </a:xfrm>
           <a:prstGeom prst="rect">
             <a:avLst/>
           </a:prstGeom>
-        </p:spPr>
-      </p:pic>
-      <p:sp>
-        <p:nvSpPr>
-          <p:cNvPr id="66" name="Rounded Rectangle 65"/>
+          <a:noFill/>
+        </p:spPr>
+        <p:txBody>
+          <a:bodyPr wrap="none" anchor="t" lIns="0" rIns="0" tIns="0" bIns="0">
+            <a:spAutoFit/>
+          </a:bodyPr>
+          <a:lstStyle/>
+          <a:p>
+            <a:pPr algn="l"/>
+            <a:r>
+              <a:rPr sz="1014" b="0" i="0">
+                <a:solidFill>
+                  <a:srgbClr val="5B6570"/>
+                </a:solidFill>
+                <a:latin typeface="IBM Plex Sans"/>
+              </a:rPr>
+              <a:t>Vét cạn mọi cách khai của từng em · 200 thể hiện, 1 400 lượt học sinh</a:t>
+            </a:r>
+          </a:p>
+        </p:txBody>
+      </p:sp>
+      <p:sp>
+        <p:nvSpPr>
+          <p:cNvPr id="115" name="TextBox 114"/>
+          <p:cNvSpPr txBox="1"/>
+          <p:nvPr/>
+        </p:nvSpPr>
+        <p:spPr>
+          <a:xfrm>
+            <a:off x="28050075" y="15541488"/>
+            <a:ext cx="180000" cy="143559"/>
+          </a:xfrm>
+          <a:prstGeom prst="rect">
+            <a:avLst/>
+          </a:prstGeom>
+          <a:noFill/>
+        </p:spPr>
+        <p:txBody>
+          <a:bodyPr wrap="none" anchor="t" lIns="0" rIns="0" tIns="0" bIns="0">
+            <a:spAutoFit/>
+          </a:bodyPr>
+          <a:lstStyle/>
+          <a:p>
+            <a:pPr algn="l"/>
+            <a:r>
+              <a:rPr sz="869" b="0" i="0">
+                <a:solidFill>
+                  <a:srgbClr val="8A929A"/>
+                </a:solidFill>
+                <a:latin typeface="IBM Plex Sans"/>
+              </a:rPr>
+              <a:t>Dữ liệu mô phỏng — nguồn: NGHIEN_CUU_TOI_UU.md, TN3</a:t>
+            </a:r>
+          </a:p>
+        </p:txBody>
+      </p:sp>
+      <p:grpSp>
+        <p:nvGrpSpPr>
+          <p:cNvPr id="117" name="Bieu do nguyen vong"/>
+          <p:cNvGrpSpPr/>
+          <p:nvPr/>
+        </p:nvGrpSpPr>
+        <p:grpSpPr>
+          <a:xfrm>
+            <a:off x="27958050" y="16797150"/>
+            <a:ext cx="6993899" cy="3404924"/>
+            <a:chOff x="27958050" y="16797150"/>
+            <a:chExt cx="6993899" cy="3404924"/>
+          </a:xfrm>
+        </p:grpSpPr>
+        <p:graphicFrame>
+          <p:nvGraphicFramePr>
+            <p:cNvPr id="121" name="Chart 120"/>
+            <p:cNvGraphicFramePr>
+              <a:graphicFrameLocks noGrp="1"/>
+            </p:cNvGraphicFramePr>
+            <p:nvPr/>
+          </p:nvGraphicFramePr>
+          <p:xfrm>
+            <a:off x="27958050" y="16797150"/>
+            <a:ext cx="6993899" cy="3404924"/>
+          </p:xfrm>
+          <a:graphic>
+            <a:graphicData uri="http://schemas.openxmlformats.org/drawingml/2006/chart">
+              <c:chart xmlns:c="http://schemas.openxmlformats.org/drawingml/2006/chart" r:id="rId5"/>
+            </a:graphicData>
+          </a:graphic>
+        </p:graphicFrame>
+      </p:grpSp>
+      <p:sp>
+        <p:nvSpPr>
+          <p:cNvPr id="118" name="TextBox 117"/>
+          <p:cNvSpPr txBox="1"/>
+          <p:nvPr/>
+        </p:nvSpPr>
+        <p:spPr>
+          <a:xfrm>
+            <a:off x="28050075" y="16246840"/>
+            <a:ext cx="180000" cy="263191"/>
+          </a:xfrm>
+          <a:prstGeom prst="rect">
+            <a:avLst/>
+          </a:prstGeom>
+          <a:noFill/>
+        </p:spPr>
+        <p:txBody>
+          <a:bodyPr wrap="none" anchor="t" lIns="0" rIns="0" tIns="0" bIns="0">
+            <a:spAutoFit/>
+          </a:bodyPr>
+          <a:lstStyle/>
+          <a:p>
+            <a:pPr algn="l"/>
+            <a:r>
+              <a:rPr sz="1594" b="1" i="0">
+                <a:solidFill>
+                  <a:srgbClr val="1C2321"/>
+                </a:solidFill>
+                <a:latin typeface="Be Vietnam Pro"/>
+              </a:rPr>
+              <a:t>Được xếp vào nguyện vọng thứ mấy</a:t>
+            </a:r>
+          </a:p>
+        </p:txBody>
+      </p:sp>
+      <p:sp>
+        <p:nvSpPr>
+          <p:cNvPr id="119" name="TextBox 118"/>
+          <p:cNvSpPr txBox="1"/>
+          <p:nvPr/>
+        </p:nvSpPr>
+        <p:spPr>
+          <a:xfrm>
+            <a:off x="28050075" y="16533958"/>
+            <a:ext cx="180000" cy="167485"/>
+          </a:xfrm>
+          <a:prstGeom prst="rect">
+            <a:avLst/>
+          </a:prstGeom>
+          <a:noFill/>
+        </p:spPr>
+        <p:txBody>
+          <a:bodyPr wrap="none" anchor="t" lIns="0" rIns="0" tIns="0" bIns="0">
+            <a:spAutoFit/>
+          </a:bodyPr>
+          <a:lstStyle/>
+          <a:p>
+            <a:pPr algn="l"/>
+            <a:r>
+              <a:rPr sz="1014" b="0" i="0">
+                <a:solidFill>
+                  <a:srgbClr val="5B6570"/>
+                </a:solidFill>
+                <a:latin typeface="IBM Plex Sans"/>
+              </a:rPr>
+              <a:t>108 em được xếp · bộ 120 học sinh, 10 CLB · seed 42</a:t>
+            </a:r>
+          </a:p>
+        </p:txBody>
+      </p:sp>
+      <p:sp>
+        <p:nvSpPr>
+          <p:cNvPr id="120" name="TextBox 119"/>
+          <p:cNvSpPr txBox="1"/>
+          <p:nvPr/>
+        </p:nvSpPr>
+        <p:spPr>
+          <a:xfrm>
+            <a:off x="28050075" y="20378762"/>
+            <a:ext cx="180000" cy="143559"/>
+          </a:xfrm>
+          <a:prstGeom prst="rect">
+            <a:avLst/>
+          </a:prstGeom>
+          <a:noFill/>
+        </p:spPr>
+        <p:txBody>
+          <a:bodyPr wrap="none" anchor="t" lIns="0" rIns="0" tIns="0" bIns="0">
+            <a:spAutoFit/>
+          </a:bodyPr>
+          <a:lstStyle/>
+          <a:p>
+            <a:pPr algn="l"/>
+            <a:r>
+              <a:rPr sz="869" b="0" i="0">
+                <a:solidFill>
+                  <a:srgbClr val="8A929A"/>
+                </a:solidFill>
+                <a:latin typeface="IBM Plex Sans"/>
+              </a:rPr>
+              <a:t>Dữ liệu mô phỏng — nguồn: du_lieu_test/SO_LIEU_DA_KIEM_CHUNG.md, mục 2</a:t>
+            </a:r>
+          </a:p>
+        </p:txBody>
+      </p:sp>
+      <p:sp>
+        <p:nvSpPr>
+          <p:cNvPr id="122" name="Rounded Rectangle 121"/>
           <p:cNvSpPr/>
           <p:nvPr/>
         </p:nvSpPr>
@@ -6368,7 +9030,7 @@
       </p:sp>
       <p:sp>
         <p:nvSpPr>
-          <p:cNvPr id="67" name="TextBox 66"/>
+          <p:cNvPr id="123" name="TextBox 122"/>
           <p:cNvSpPr txBox="1"/>
           <p:nvPr/>
         </p:nvSpPr>
@@ -6403,7 +9065,7 @@
       </p:sp>
       <p:sp>
         <p:nvSpPr>
-          <p:cNvPr id="68" name="Rounded Rectangle 67"/>
+          <p:cNvPr id="124" name="Rounded Rectangle 123"/>
           <p:cNvSpPr/>
           <p:nvPr/>
         </p:nvSpPr>
@@ -6451,7 +9113,7 @@
       </p:sp>
       <p:sp>
         <p:nvSpPr>
-          <p:cNvPr id="69" name="TextBox 68"/>
+          <p:cNvPr id="125" name="TextBox 124"/>
           <p:cNvSpPr txBox="1"/>
           <p:nvPr/>
         </p:nvSpPr>
@@ -6486,7 +9148,7 @@
       </p:sp>
       <p:sp>
         <p:nvSpPr>
-          <p:cNvPr id="70" name="Rounded Rectangle 69"/>
+          <p:cNvPr id="126" name="Rounded Rectangle 125"/>
           <p:cNvSpPr/>
           <p:nvPr/>
         </p:nvSpPr>
@@ -6533,7 +9195,7 @@
       </p:sp>
       <p:sp>
         <p:nvSpPr>
-          <p:cNvPr id="71" name="TextBox 70"/>
+          <p:cNvPr id="127" name="TextBox 126"/>
           <p:cNvSpPr txBox="1"/>
           <p:nvPr/>
         </p:nvSpPr>

</xml_diff>

<commit_message>
Redraw the process diagram in Vietnamese with only the key steps
Four steps in run order (input, priority, multi-round review with
reserved seats, check) instead of five layers numbered out of order.
No English labels. The PNG and the editable PowerPoint shapes both
come from the same spec.

Co-Authored-By: Claude Opus 5.5 <noreply@anthropic.com>
Claude-Session: https://claude.ai/code/session_01NkYGd36L1Tpym32yxKyitD
</commit_message>
<xml_diff>
--- a/poster/poster_khung_1-2.pptx
+++ b/poster/poster_khung_1-2.pptx
@@ -5922,12 +5922,12 @@
         </p:nvSpPr>
         <p:spPr>
           <a:xfrm>
-            <a:off x="10048200" y="18715350"/>
-            <a:ext cx="2742000" cy="3838800"/>
+            <a:off x="10048200" y="19537950"/>
+            <a:ext cx="2604900" cy="2056500"/>
           </a:xfrm>
           <a:prstGeom prst="roundRect">
             <a:avLst>
-              <a:gd name="adj" fmla="val 4500"/>
+              <a:gd name="adj" fmla="val 6000"/>
             </a:avLst>
           </a:prstGeom>
           <a:solidFill>
@@ -5970,8 +5970,8 @@
         </p:nvSpPr>
         <p:spPr>
           <a:xfrm>
-            <a:off x="10267559" y="18959388"/>
-            <a:ext cx="180000" cy="320814"/>
+            <a:off x="10294980" y="19801182"/>
+            <a:ext cx="180000" cy="392106"/>
           </a:xfrm>
           <a:prstGeom prst="rect">
             <a:avLst/>
@@ -5986,7 +5986,7 @@
           <a:p>
             <a:pPr algn="l"/>
             <a:r>
-              <a:rPr sz="1943" b="1" i="0">
+              <a:rPr sz="2374" b="1" i="0">
                 <a:solidFill>
                   <a:srgbClr val="1C2321"/>
                 </a:solidFill>
@@ -6005,8 +6005,8 @@
         </p:nvSpPr>
         <p:spPr>
           <a:xfrm>
-            <a:off x="10267559" y="19433754"/>
-            <a:ext cx="180000" cy="249522"/>
+            <a:off x="10294980" y="20356437"/>
+            <a:ext cx="180000" cy="302991"/>
           </a:xfrm>
           <a:prstGeom prst="rect">
             <a:avLst/>
@@ -6021,7 +6021,7 @@
           <a:p>
             <a:pPr algn="l"/>
             <a:r>
-              <a:rPr sz="1511" b="0" i="0">
+              <a:rPr sz="1835" b="0" i="0">
                 <a:solidFill>
                   <a:srgbClr val="5B6570"/>
                 </a:solidFill>
@@ -6040,8 +6040,8 @@
         </p:nvSpPr>
         <p:spPr>
           <a:xfrm>
-            <a:off x="10267559" y="19735374"/>
-            <a:ext cx="180000" cy="249522"/>
+            <a:off x="10294980" y="20726607"/>
+            <a:ext cx="180000" cy="302991"/>
           </a:xfrm>
           <a:prstGeom prst="rect">
             <a:avLst/>
@@ -6056,13 +6056,13 @@
           <a:p>
             <a:pPr algn="l"/>
             <a:r>
-              <a:rPr sz="1511" b="0" i="0">
+              <a:rPr sz="1835" b="0" i="0">
                 <a:solidFill>
                   <a:srgbClr val="5B6570"/>
                 </a:solidFill>
                 <a:latin typeface="IBM Plex Sans"/>
               </a:rPr>
-              <a:t>· sức chứa</a:t>
+              <a:t>Điểm thi</a:t>
             </a:r>
           </a:p>
         </p:txBody>
@@ -6075,8 +6075,8 @@
         </p:nvSpPr>
         <p:spPr>
           <a:xfrm>
-            <a:off x="10267559" y="20036994"/>
-            <a:ext cx="180000" cy="249522"/>
+            <a:off x="10294980" y="21096777"/>
+            <a:ext cx="180000" cy="302991"/>
           </a:xfrm>
           <a:prstGeom prst="rect">
             <a:avLst/>
@@ -6091,182 +6091,7 @@
           <a:p>
             <a:pPr algn="l"/>
             <a:r>
-              <a:rPr sz="1511" b="0" i="0">
-                <a:solidFill>
-                  <a:srgbClr val="5B6570"/>
-                </a:solidFill>
-                <a:latin typeface="IBM Plex Sans"/>
-              </a:rPr>
-              <a:t>· suất dự trữ</a:t>
-            </a:r>
-          </a:p>
-        </p:txBody>
-      </p:sp>
-      <p:sp>
-        <p:nvSpPr>
-          <p:cNvPr id="49" name="TextBox 48"/>
-          <p:cNvSpPr txBox="1"/>
-          <p:nvPr/>
-        </p:nvSpPr>
-        <p:spPr>
-          <a:xfrm>
-            <a:off x="10267559" y="20338614"/>
-            <a:ext cx="180000" cy="249522"/>
-          </a:xfrm>
-          <a:prstGeom prst="rect">
-            <a:avLst/>
-          </a:prstGeom>
-          <a:noFill/>
-        </p:spPr>
-        <p:txBody>
-          <a:bodyPr wrap="none" anchor="t" lIns="0" rIns="0" tIns="0" bIns="0">
-            <a:spAutoFit/>
-          </a:bodyPr>
-          <a:lstStyle/>
-          <a:p>
-            <a:pPr algn="l"/>
-            <a:r>
-              <a:rPr sz="1511" b="0" i="0">
-                <a:solidFill>
-                  <a:srgbClr val="5B6570"/>
-                </a:solidFill>
-                <a:latin typeface="IBM Plex Sans"/>
-              </a:rPr>
-              <a:t/>
-            </a:r>
-          </a:p>
-        </p:txBody>
-      </p:sp>
-      <p:sp>
-        <p:nvSpPr>
-          <p:cNvPr id="50" name="TextBox 49"/>
-          <p:cNvSpPr txBox="1"/>
-          <p:nvPr/>
-        </p:nvSpPr>
-        <p:spPr>
-          <a:xfrm>
-            <a:off x="10267559" y="20640234"/>
-            <a:ext cx="180000" cy="249522"/>
-          </a:xfrm>
-          <a:prstGeom prst="rect">
-            <a:avLst/>
-          </a:prstGeom>
-          <a:noFill/>
-        </p:spPr>
-        <p:txBody>
-          <a:bodyPr wrap="none" anchor="t" lIns="0" rIns="0" tIns="0" bIns="0">
-            <a:spAutoFit/>
-          </a:bodyPr>
-          <a:lstStyle/>
-          <a:p>
-            <a:pPr algn="l"/>
-            <a:r>
-              <a:rPr sz="1511" b="0" i="0">
-                <a:solidFill>
-                  <a:srgbClr val="5B6570"/>
-                </a:solidFill>
-                <a:latin typeface="IBM Plex Sans"/>
-              </a:rPr>
-              <a:t>CLB muốn thi</a:t>
-            </a:r>
-          </a:p>
-        </p:txBody>
-      </p:sp>
-      <p:sp>
-        <p:nvSpPr>
-          <p:cNvPr id="51" name="TextBox 50"/>
-          <p:cNvSpPr txBox="1"/>
-          <p:nvPr/>
-        </p:nvSpPr>
-        <p:spPr>
-          <a:xfrm>
-            <a:off x="10267559" y="20941854"/>
-            <a:ext cx="180000" cy="249522"/>
-          </a:xfrm>
-          <a:prstGeom prst="rect">
-            <a:avLst/>
-          </a:prstGeom>
-          <a:noFill/>
-        </p:spPr>
-        <p:txBody>
-          <a:bodyPr wrap="none" anchor="t" lIns="0" rIns="0" tIns="0" bIns="0">
-            <a:spAutoFit/>
-          </a:bodyPr>
-          <a:lstStyle/>
-          <a:p>
-            <a:pPr algn="l"/>
-            <a:r>
-              <a:rPr sz="1511" b="0" i="0">
-                <a:solidFill>
-                  <a:srgbClr val="5B6570"/>
-                </a:solidFill>
-                <a:latin typeface="IBM Plex Sans"/>
-              </a:rPr>
-              <a:t>· điểm chấm mù</a:t>
-            </a:r>
-          </a:p>
-        </p:txBody>
-      </p:sp>
-      <p:sp>
-        <p:nvSpPr>
-          <p:cNvPr id="52" name="TextBox 51"/>
-          <p:cNvSpPr txBox="1"/>
-          <p:nvPr/>
-        </p:nvSpPr>
-        <p:spPr>
-          <a:xfrm>
-            <a:off x="10267559" y="21243474"/>
-            <a:ext cx="180000" cy="249522"/>
-          </a:xfrm>
-          <a:prstGeom prst="rect">
-            <a:avLst/>
-          </a:prstGeom>
-          <a:noFill/>
-        </p:spPr>
-        <p:txBody>
-          <a:bodyPr wrap="none" anchor="t" lIns="0" rIns="0" tIns="0" bIns="0">
-            <a:spAutoFit/>
-          </a:bodyPr>
-          <a:lstStyle/>
-          <a:p>
-            <a:pPr algn="l"/>
-            <a:r>
-              <a:rPr sz="1511" b="0" i="0">
-                <a:solidFill>
-                  <a:srgbClr val="5B6570"/>
-                </a:solidFill>
-                <a:latin typeface="IBM Plex Sans"/>
-              </a:rPr>
-              <a:t/>
-            </a:r>
-          </a:p>
-        </p:txBody>
-      </p:sp>
-      <p:sp>
-        <p:nvSpPr>
-          <p:cNvPr id="53" name="TextBox 52"/>
-          <p:cNvSpPr txBox="1"/>
-          <p:nvPr/>
-        </p:nvSpPr>
-        <p:spPr>
-          <a:xfrm>
-            <a:off x="10267559" y="21545094"/>
-            <a:ext cx="180000" cy="249522"/>
-          </a:xfrm>
-          <a:prstGeom prst="rect">
-            <a:avLst/>
-          </a:prstGeom>
-          <a:noFill/>
-        </p:spPr>
-        <p:txBody>
-          <a:bodyPr wrap="none" anchor="t" lIns="0" rIns="0" tIns="0" bIns="0">
-            <a:spAutoFit/>
-          </a:bodyPr>
-          <a:lstStyle/>
-          <a:p>
-            <a:pPr algn="l"/>
-            <a:r>
-              <a:rPr sz="1511" b="0" i="0">
+              <a:rPr sz="1835" b="0" i="0">
                 <a:solidFill>
                   <a:srgbClr val="5B6570"/>
                 </a:solidFill>
@@ -6279,49 +6104,14 @@
       </p:sp>
       <p:sp>
         <p:nvSpPr>
-          <p:cNvPr id="54" name="TextBox 53"/>
-          <p:cNvSpPr txBox="1"/>
-          <p:nvPr/>
-        </p:nvSpPr>
-        <p:spPr>
-          <a:xfrm>
-            <a:off x="10267559" y="21846714"/>
-            <a:ext cx="180000" cy="249522"/>
-          </a:xfrm>
-          <a:prstGeom prst="rect">
-            <a:avLst/>
-          </a:prstGeom>
-          <a:noFill/>
-        </p:spPr>
-        <p:txBody>
-          <a:bodyPr wrap="none" anchor="t" lIns="0" rIns="0" tIns="0" bIns="0">
-            <a:spAutoFit/>
-          </a:bodyPr>
-          <a:lstStyle/>
-          <a:p>
-            <a:pPr algn="l"/>
-            <a:r>
-              <a:rPr sz="1511" b="0" i="0">
-                <a:solidFill>
-                  <a:srgbClr val="5B6570"/>
-                </a:solidFill>
-                <a:latin typeface="IBM Plex Sans"/>
-              </a:rPr>
-              <a:t>· xếp hạng CLB</a:t>
-            </a:r>
-          </a:p>
-        </p:txBody>
-      </p:sp>
-      <p:sp>
-        <p:nvSpPr>
-          <p:cNvPr id="55" name="Right Arrow 54"/>
+          <p:cNvPr id="49" name="Right Arrow 48"/>
           <p:cNvSpPr/>
           <p:nvPr/>
         </p:nvSpPr>
         <p:spPr>
           <a:xfrm>
-            <a:off x="12790200" y="20525070"/>
-            <a:ext cx="616950" cy="219360"/>
+            <a:off x="12653100" y="20456520"/>
+            <a:ext cx="479850" cy="219360"/>
           </a:xfrm>
           <a:prstGeom prst="rightArrow">
             <a:avLst/>
@@ -6358,18 +6148,18 @@
       </p:sp>
       <p:sp>
         <p:nvSpPr>
-          <p:cNvPr id="56" name="Rounded Rectangle 55"/>
+          <p:cNvPr id="50" name="Rounded Rectangle 49"/>
           <p:cNvSpPr/>
           <p:nvPr/>
         </p:nvSpPr>
         <p:spPr>
           <a:xfrm>
-            <a:off x="13407150" y="18715350"/>
-            <a:ext cx="3564600" cy="1816575"/>
+            <a:off x="13132950" y="19537950"/>
+            <a:ext cx="3290400" cy="2056500"/>
           </a:xfrm>
           <a:prstGeom prst="roundRect">
             <a:avLst>
-              <a:gd name="adj" fmla="val 6792"/>
+              <a:gd name="adj" fmla="val 6000"/>
             </a:avLst>
           </a:prstGeom>
           <a:solidFill>
@@ -6406,14 +6196,14 @@
       </p:sp>
       <p:sp>
         <p:nvSpPr>
-          <p:cNvPr id="57" name="Oval 56"/>
+          <p:cNvPr id="51" name="Oval 50"/>
           <p:cNvSpPr/>
           <p:nvPr/>
         </p:nvSpPr>
         <p:spPr>
           <a:xfrm>
-            <a:off x="13557960" y="18893580"/>
-            <a:ext cx="411300" cy="411300"/>
+            <a:off x="13324889" y="19743600"/>
+            <a:ext cx="438720" cy="438720"/>
           </a:xfrm>
           <a:prstGeom prst="ellipse">
             <a:avLst/>
@@ -6452,21 +6242,21 @@
                 </a:solidFill>
                 <a:latin typeface="Be Vietnam Pro"/>
               </a:rPr>
-              <a:t>4</a:t>
-            </a:r>
-          </a:p>
-        </p:txBody>
-      </p:sp>
-      <p:sp>
-        <p:nvSpPr>
-          <p:cNvPr id="58" name="TextBox 57"/>
+              <a:t>1</a:t>
+            </a:r>
+          </a:p>
+        </p:txBody>
+      </p:sp>
+      <p:sp>
+        <p:nvSpPr>
+          <p:cNvPr id="52" name="TextBox 51"/>
           <p:cNvSpPr txBox="1"/>
           <p:nvPr/>
         </p:nvSpPr>
         <p:spPr>
           <a:xfrm>
-            <a:off x="14092650" y="18959388"/>
-            <a:ext cx="180000" cy="320814"/>
+            <a:off x="13900710" y="19801182"/>
+            <a:ext cx="180000" cy="392106"/>
           </a:xfrm>
           <a:prstGeom prst="rect">
             <a:avLst/>
@@ -6481,27 +6271,27 @@
           <a:p>
             <a:pPr algn="l"/>
             <a:r>
-              <a:rPr sz="1943" b="1" i="0">
+              <a:rPr sz="2374" b="1" i="0">
                 <a:solidFill>
                   <a:srgbClr val="1C2321"/>
                 </a:solidFill>
                 <a:latin typeface="Be Vietnam Pro"/>
               </a:rPr>
-              <a:t>Ưu tiên hai tầng</a:t>
-            </a:r>
-          </a:p>
-        </p:txBody>
-      </p:sp>
-      <p:sp>
-        <p:nvSpPr>
-          <p:cNvPr id="59" name="TextBox 58"/>
+              <a:t>Xếp ưu tiên</a:t>
+            </a:r>
+          </a:p>
+        </p:txBody>
+      </p:sp>
+      <p:sp>
+        <p:nvSpPr>
+          <p:cNvPr id="53" name="TextBox 52"/>
           <p:cNvSpPr txBox="1"/>
           <p:nvPr/>
         </p:nvSpPr>
         <p:spPr>
           <a:xfrm>
-            <a:off x="13626510" y="19433754"/>
-            <a:ext cx="180000" cy="249522"/>
+            <a:off x="13379730" y="20356437"/>
+            <a:ext cx="180000" cy="302991"/>
           </a:xfrm>
           <a:prstGeom prst="rect">
             <a:avLst/>
@@ -6516,27 +6306,27 @@
           <a:p>
             <a:pPr algn="l"/>
             <a:r>
-              <a:rPr sz="1511" b="0" i="0">
+              <a:rPr sz="1835" b="0" i="0">
                 <a:solidFill>
                   <a:srgbClr val="5B6570"/>
                 </a:solidFill>
                 <a:latin typeface="IBM Plex Sans"/>
               </a:rPr>
-              <a:t>Tầng 1: đã thi → theo điểm</a:t>
-            </a:r>
-          </a:p>
-        </p:txBody>
-      </p:sp>
-      <p:sp>
-        <p:nvSpPr>
-          <p:cNvPr id="60" name="TextBox 59"/>
+              <a:t>Đã thi → theo điểm</a:t>
+            </a:r>
+          </a:p>
+        </p:txBody>
+      </p:sp>
+      <p:sp>
+        <p:nvSpPr>
+          <p:cNvPr id="54" name="TextBox 53"/>
           <p:cNvSpPr txBox="1"/>
           <p:nvPr/>
         </p:nvSpPr>
         <p:spPr>
           <a:xfrm>
-            <a:off x="13626510" y="19735374"/>
-            <a:ext cx="180000" cy="249522"/>
+            <a:off x="13379730" y="20726607"/>
+            <a:ext cx="180000" cy="302991"/>
           </a:xfrm>
           <a:prstGeom prst="rect">
             <a:avLst/>
@@ -6551,31 +6341,548 @@
           <a:p>
             <a:pPr algn="l"/>
             <a:r>
-              <a:rPr sz="1511" b="0" i="0">
+              <a:rPr sz="1835" b="0" i="0">
                 <a:solidFill>
                   <a:srgbClr val="5B6570"/>
                 </a:solidFill>
                 <a:latin typeface="IBM Plex Sans"/>
               </a:rPr>
-              <a:t>Tầng 2: không thi</a:t>
-            </a:r>
-          </a:p>
-        </p:txBody>
-      </p:sp>
-      <p:sp>
-        <p:nvSpPr>
-          <p:cNvPr id="61" name="Rounded Rectangle 60"/>
+              <a:t>Bằng điểm → bốc thăm</a:t>
+            </a:r>
+          </a:p>
+        </p:txBody>
+      </p:sp>
+      <p:sp>
+        <p:nvSpPr>
+          <p:cNvPr id="55" name="TextBox 54"/>
+          <p:cNvSpPr txBox="1"/>
+          <p:nvPr/>
+        </p:nvSpPr>
+        <p:spPr>
+          <a:xfrm>
+            <a:off x="13379730" y="21096777"/>
+            <a:ext cx="180000" cy="302991"/>
+          </a:xfrm>
+          <a:prstGeom prst="rect">
+            <a:avLst/>
+          </a:prstGeom>
+          <a:noFill/>
+        </p:spPr>
+        <p:txBody>
+          <a:bodyPr wrap="none" anchor="t" lIns="0" rIns="0" tIns="0" bIns="0">
+            <a:spAutoFit/>
+          </a:bodyPr>
+          <a:lstStyle/>
+          <a:p>
+            <a:pPr algn="l"/>
+            <a:r>
+              <a:rPr sz="1835" b="0" i="0">
+                <a:solidFill>
+                  <a:srgbClr val="5B6570"/>
+                </a:solidFill>
+                <a:latin typeface="IBM Plex Sans"/>
+              </a:rPr>
+              <a:t>Không thi → bốc thăm</a:t>
+            </a:r>
+          </a:p>
+        </p:txBody>
+      </p:sp>
+      <p:sp>
+        <p:nvSpPr>
+          <p:cNvPr id="56" name="Right Arrow 55"/>
           <p:cNvSpPr/>
           <p:nvPr/>
         </p:nvSpPr>
         <p:spPr>
           <a:xfrm>
-            <a:off x="13407150" y="20737575"/>
-            <a:ext cx="3564600" cy="1816575"/>
+            <a:off x="16423350" y="20456520"/>
+            <a:ext cx="479850" cy="219360"/>
+          </a:xfrm>
+          <a:prstGeom prst="rightArrow">
+            <a:avLst/>
+          </a:prstGeom>
+          <a:solidFill>
+            <a:srgbClr val="5B6570"/>
+          </a:solidFill>
+          <a:ln>
+            <a:noFill/>
+          </a:ln>
+          <a:effectLst/>
+        </p:spPr>
+        <p:style>
+          <a:lnRef idx="1">
+            <a:schemeClr val="accent1"/>
+          </a:lnRef>
+          <a:fillRef idx="3">
+            <a:schemeClr val="accent1"/>
+          </a:fillRef>
+          <a:effectRef idx="2">
+            <a:schemeClr val="accent1"/>
+          </a:effectRef>
+          <a:fontRef idx="minor">
+            <a:schemeClr val="lt1"/>
+          </a:fontRef>
+        </p:style>
+        <p:txBody>
+          <a:bodyPr rtlCol="0" anchor="ctr"/>
+          <a:lstStyle/>
+          <a:p>
+            <a:pPr algn="ctr"/>
+          </a:p>
+        </p:txBody>
+      </p:sp>
+      <p:sp>
+        <p:nvSpPr>
+          <p:cNvPr id="57" name="Rounded Rectangle 56"/>
+          <p:cNvSpPr/>
+          <p:nvPr/>
+        </p:nvSpPr>
+        <p:spPr>
+          <a:xfrm>
+            <a:off x="16903200" y="18372600"/>
+            <a:ext cx="5346900" cy="4387200"/>
           </a:xfrm>
           <a:prstGeom prst="roundRect">
             <a:avLst>
-              <a:gd name="adj" fmla="val 6792"/>
+              <a:gd name="adj" fmla="val 2812"/>
+            </a:avLst>
+          </a:prstGeom>
+          <a:solidFill>
+            <a:srgbClr val="DCE9E0"/>
+          </a:solidFill>
+          <a:ln w="27420">
+            <a:solidFill>
+              <a:srgbClr val="27805A"/>
+            </a:solidFill>
+          </a:ln>
+          <a:effectLst/>
+        </p:spPr>
+        <p:style>
+          <a:lnRef idx="1">
+            <a:schemeClr val="accent1"/>
+          </a:lnRef>
+          <a:fillRef idx="3">
+            <a:schemeClr val="accent1"/>
+          </a:fillRef>
+          <a:effectRef idx="2">
+            <a:schemeClr val="accent1"/>
+          </a:effectRef>
+          <a:fontRef idx="minor">
+            <a:schemeClr val="lt1"/>
+          </a:fontRef>
+        </p:style>
+        <p:txBody>
+          <a:bodyPr rtlCol="0" anchor="ctr"/>
+          <a:lstStyle/>
+          <a:p>
+            <a:pPr algn="ctr"/>
+          </a:p>
+        </p:txBody>
+      </p:sp>
+      <p:sp>
+        <p:nvSpPr>
+          <p:cNvPr id="58" name="Oval 57"/>
+          <p:cNvSpPr/>
+          <p:nvPr/>
+        </p:nvSpPr>
+        <p:spPr>
+          <a:xfrm>
+            <a:off x="17095140" y="18578250"/>
+            <a:ext cx="438720" cy="438720"/>
+          </a:xfrm>
+          <a:prstGeom prst="ellipse">
+            <a:avLst/>
+          </a:prstGeom>
+          <a:solidFill>
+            <a:srgbClr val="B8781A"/>
+          </a:solidFill>
+          <a:ln>
+            <a:noFill/>
+          </a:ln>
+          <a:effectLst/>
+        </p:spPr>
+        <p:style>
+          <a:lnRef idx="1">
+            <a:schemeClr val="accent1"/>
+          </a:lnRef>
+          <a:fillRef idx="3">
+            <a:schemeClr val="accent1"/>
+          </a:fillRef>
+          <a:effectRef idx="2">
+            <a:schemeClr val="accent1"/>
+          </a:effectRef>
+          <a:fontRef idx="minor">
+            <a:schemeClr val="lt1"/>
+          </a:fontRef>
+        </p:style>
+        <p:txBody>
+          <a:bodyPr rtlCol="0" anchor="ctr" wrap="square" lIns="0" rIns="0" tIns="0" bIns="0"/>
+          <a:lstStyle/>
+          <a:p>
+            <a:pPr algn="ctr"/>
+            <a:r>
+              <a:rPr sz="1619" b="1" i="0">
+                <a:solidFill>
+                  <a:srgbClr val="FFFFFF"/>
+                </a:solidFill>
+                <a:latin typeface="Be Vietnam Pro"/>
+              </a:rPr>
+              <a:t>2</a:t>
+            </a:r>
+          </a:p>
+        </p:txBody>
+      </p:sp>
+      <p:sp>
+        <p:nvSpPr>
+          <p:cNvPr id="59" name="TextBox 58"/>
+          <p:cNvSpPr txBox="1"/>
+          <p:nvPr/>
+        </p:nvSpPr>
+        <p:spPr>
+          <a:xfrm>
+            <a:off x="17670960" y="18635832"/>
+            <a:ext cx="180000" cy="392106"/>
+          </a:xfrm>
+          <a:prstGeom prst="rect">
+            <a:avLst/>
+          </a:prstGeom>
+          <a:noFill/>
+        </p:spPr>
+        <p:txBody>
+          <a:bodyPr wrap="none" anchor="t" lIns="0" rIns="0" tIns="0" bIns="0">
+            <a:spAutoFit/>
+          </a:bodyPr>
+          <a:lstStyle/>
+          <a:p>
+            <a:pPr algn="l"/>
+            <a:r>
+              <a:rPr sz="2374" b="1" i="0">
+                <a:solidFill>
+                  <a:srgbClr val="1C2321"/>
+                </a:solidFill>
+                <a:latin typeface="Be Vietnam Pro"/>
+              </a:rPr>
+              <a:t>Xét duyệt nhiều vòng</a:t>
+            </a:r>
+          </a:p>
+        </p:txBody>
+      </p:sp>
+      <p:sp>
+        <p:nvSpPr>
+          <p:cNvPr id="60" name="TextBox 59"/>
+          <p:cNvSpPr txBox="1"/>
+          <p:nvPr/>
+        </p:nvSpPr>
+        <p:spPr>
+          <a:xfrm>
+            <a:off x="17149980" y="19191087"/>
+            <a:ext cx="180000" cy="302991"/>
+          </a:xfrm>
+          <a:prstGeom prst="rect">
+            <a:avLst/>
+          </a:prstGeom>
+          <a:noFill/>
+        </p:spPr>
+        <p:txBody>
+          <a:bodyPr wrap="none" anchor="t" lIns="0" rIns="0" tIns="0" bIns="0">
+            <a:spAutoFit/>
+          </a:bodyPr>
+          <a:lstStyle/>
+          <a:p>
+            <a:pPr algn="l"/>
+            <a:r>
+              <a:rPr sz="1835" b="0" i="0">
+                <a:solidFill>
+                  <a:srgbClr val="5B6570"/>
+                </a:solidFill>
+                <a:latin typeface="IBM Plex Sans"/>
+              </a:rPr>
+              <a:t>Học sinh nộp theo nguyện vọng</a:t>
+            </a:r>
+          </a:p>
+        </p:txBody>
+      </p:sp>
+      <p:sp>
+        <p:nvSpPr>
+          <p:cNvPr id="61" name="TextBox 60"/>
+          <p:cNvSpPr txBox="1"/>
+          <p:nvPr/>
+        </p:nvSpPr>
+        <p:spPr>
+          <a:xfrm>
+            <a:off x="17149980" y="19561257"/>
+            <a:ext cx="180000" cy="302991"/>
+          </a:xfrm>
+          <a:prstGeom prst="rect">
+            <a:avLst/>
+          </a:prstGeom>
+          <a:noFill/>
+        </p:spPr>
+        <p:txBody>
+          <a:bodyPr wrap="none" anchor="t" lIns="0" rIns="0" tIns="0" bIns="0">
+            <a:spAutoFit/>
+          </a:bodyPr>
+          <a:lstStyle/>
+          <a:p>
+            <a:pPr algn="l"/>
+            <a:r>
+              <a:rPr sz="1835" b="0" i="0">
+                <a:solidFill>
+                  <a:srgbClr val="5B6570"/>
+                </a:solidFill>
+                <a:latin typeface="IBM Plex Sans"/>
+              </a:rPr>
+              <a:t>CLB giữ tạm các em ưu tiên cao nhất</a:t>
+            </a:r>
+          </a:p>
+        </p:txBody>
+      </p:sp>
+      <p:sp>
+        <p:nvSpPr>
+          <p:cNvPr id="62" name="TextBox 61"/>
+          <p:cNvSpPr txBox="1"/>
+          <p:nvPr/>
+        </p:nvSpPr>
+        <p:spPr>
+          <a:xfrm>
+            <a:off x="17149980" y="19931427"/>
+            <a:ext cx="180000" cy="302991"/>
+          </a:xfrm>
+          <a:prstGeom prst="rect">
+            <a:avLst/>
+          </a:prstGeom>
+          <a:noFill/>
+        </p:spPr>
+        <p:txBody>
+          <a:bodyPr wrap="none" anchor="t" lIns="0" rIns="0" tIns="0" bIns="0">
+            <a:spAutoFit/>
+          </a:bodyPr>
+          <a:lstStyle/>
+          <a:p>
+            <a:pPr algn="l"/>
+            <a:r>
+              <a:rPr sz="1835" b="0" i="0">
+                <a:solidFill>
+                  <a:srgbClr val="5B6570"/>
+                </a:solidFill>
+                <a:latin typeface="IBM Plex Sans"/>
+              </a:rPr>
+              <a:t>Em bị trả lại nộp nguyện vọng kế tiếp</a:t>
+            </a:r>
+          </a:p>
+        </p:txBody>
+      </p:sp>
+      <p:sp>
+        <p:nvSpPr>
+          <p:cNvPr id="63" name="Rounded Rectangle 62"/>
+          <p:cNvSpPr/>
+          <p:nvPr/>
+        </p:nvSpPr>
+        <p:spPr>
+          <a:xfrm>
+            <a:off x="17149980" y="20771850"/>
+            <a:ext cx="4853340" cy="1713750"/>
+          </a:xfrm>
+          <a:prstGeom prst="roundRect">
+            <a:avLst>
+              <a:gd name="adj" fmla="val 7200"/>
+            </a:avLst>
+          </a:prstGeom>
+          <a:solidFill>
+            <a:srgbClr val="FFFFFF"/>
+          </a:solidFill>
+          <a:ln w="20565">
+            <a:solidFill>
+              <a:srgbClr val="B8781A"/>
+            </a:solidFill>
+          </a:ln>
+          <a:effectLst/>
+        </p:spPr>
+        <p:style>
+          <a:lnRef idx="1">
+            <a:schemeClr val="accent1"/>
+          </a:lnRef>
+          <a:fillRef idx="3">
+            <a:schemeClr val="accent1"/>
+          </a:fillRef>
+          <a:effectRef idx="2">
+            <a:schemeClr val="accent1"/>
+          </a:effectRef>
+          <a:fontRef idx="minor">
+            <a:schemeClr val="lt1"/>
+          </a:fontRef>
+        </p:style>
+        <p:txBody>
+          <a:bodyPr rtlCol="0" anchor="ctr"/>
+          <a:lstStyle/>
+          <a:p>
+            <a:pPr algn="ctr"/>
+          </a:p>
+        </p:txBody>
+      </p:sp>
+      <p:sp>
+        <p:nvSpPr>
+          <p:cNvPr id="64" name="TextBox 63"/>
+          <p:cNvSpPr txBox="1"/>
+          <p:nvPr/>
+        </p:nvSpPr>
+        <p:spPr>
+          <a:xfrm>
+            <a:off x="17396760" y="21035082"/>
+            <a:ext cx="180000" cy="392106"/>
+          </a:xfrm>
+          <a:prstGeom prst="rect">
+            <a:avLst/>
+          </a:prstGeom>
+          <a:noFill/>
+        </p:spPr>
+        <p:txBody>
+          <a:bodyPr wrap="none" anchor="t" lIns="0" rIns="0" tIns="0" bIns="0">
+            <a:spAutoFit/>
+          </a:bodyPr>
+          <a:lstStyle/>
+          <a:p>
+            <a:pPr algn="l"/>
+            <a:r>
+              <a:rPr sz="2374" b="1" i="0">
+                <a:solidFill>
+                  <a:srgbClr val="1C2321"/>
+                </a:solidFill>
+                <a:latin typeface="Be Vietnam Pro"/>
+              </a:rPr>
+              <a:t>Suất dự trữ</a:t>
+            </a:r>
+          </a:p>
+        </p:txBody>
+      </p:sp>
+      <p:sp>
+        <p:nvSpPr>
+          <p:cNvPr id="65" name="TextBox 64"/>
+          <p:cNvSpPr txBox="1"/>
+          <p:nvPr/>
+        </p:nvSpPr>
+        <p:spPr>
+          <a:xfrm>
+            <a:off x="17396760" y="21590337"/>
+            <a:ext cx="180000" cy="302991"/>
+          </a:xfrm>
+          <a:prstGeom prst="rect">
+            <a:avLst/>
+          </a:prstGeom>
+          <a:noFill/>
+        </p:spPr>
+        <p:txBody>
+          <a:bodyPr wrap="none" anchor="t" lIns="0" rIns="0" tIns="0" bIns="0">
+            <a:spAutoFit/>
+          </a:bodyPr>
+          <a:lstStyle/>
+          <a:p>
+            <a:pPr algn="l"/>
+            <a:r>
+              <a:rPr sz="1835" b="0" i="0">
+                <a:solidFill>
+                  <a:srgbClr val="5B6570"/>
+                </a:solidFill>
+                <a:latin typeface="IBM Plex Sans"/>
+              </a:rPr>
+              <a:t>Giữ chỗ cho nhóm ưu tiên</a:t>
+            </a:r>
+          </a:p>
+        </p:txBody>
+      </p:sp>
+      <p:sp>
+        <p:nvSpPr>
+          <p:cNvPr id="66" name="TextBox 65"/>
+          <p:cNvSpPr txBox="1"/>
+          <p:nvPr/>
+        </p:nvSpPr>
+        <p:spPr>
+          <a:xfrm>
+            <a:off x="17396760" y="21960507"/>
+            <a:ext cx="180000" cy="302991"/>
+          </a:xfrm>
+          <a:prstGeom prst="rect">
+            <a:avLst/>
+          </a:prstGeom>
+          <a:noFill/>
+        </p:spPr>
+        <p:txBody>
+          <a:bodyPr wrap="none" anchor="t" lIns="0" rIns="0" tIns="0" bIns="0">
+            <a:spAutoFit/>
+          </a:bodyPr>
+          <a:lstStyle/>
+          <a:p>
+            <a:pPr algn="l"/>
+            <a:r>
+              <a:rPr sz="1835" b="0" i="0">
+                <a:solidFill>
+                  <a:srgbClr val="5B6570"/>
+                </a:solidFill>
+                <a:latin typeface="IBM Plex Sans"/>
+              </a:rPr>
+              <a:t>Không đủ người → trả về xét chung</a:t>
+            </a:r>
+          </a:p>
+        </p:txBody>
+      </p:sp>
+      <p:sp>
+        <p:nvSpPr>
+          <p:cNvPr id="67" name="Right Arrow 66"/>
+          <p:cNvSpPr/>
+          <p:nvPr/>
+        </p:nvSpPr>
+        <p:spPr>
+          <a:xfrm>
+            <a:off x="22250100" y="20456520"/>
+            <a:ext cx="479850" cy="219360"/>
+          </a:xfrm>
+          <a:prstGeom prst="rightArrow">
+            <a:avLst/>
+          </a:prstGeom>
+          <a:solidFill>
+            <a:srgbClr val="5B6570"/>
+          </a:solidFill>
+          <a:ln>
+            <a:noFill/>
+          </a:ln>
+          <a:effectLst/>
+        </p:spPr>
+        <p:style>
+          <a:lnRef idx="1">
+            <a:schemeClr val="accent1"/>
+          </a:lnRef>
+          <a:fillRef idx="3">
+            <a:schemeClr val="accent1"/>
+          </a:fillRef>
+          <a:effectRef idx="2">
+            <a:schemeClr val="accent1"/>
+          </a:effectRef>
+          <a:fontRef idx="minor">
+            <a:schemeClr val="lt1"/>
+          </a:fontRef>
+        </p:style>
+        <p:txBody>
+          <a:bodyPr rtlCol="0" anchor="ctr"/>
+          <a:lstStyle/>
+          <a:p>
+            <a:pPr algn="ctr"/>
+          </a:p>
+        </p:txBody>
+      </p:sp>
+      <p:sp>
+        <p:nvSpPr>
+          <p:cNvPr id="68" name="Rounded Rectangle 67"/>
+          <p:cNvSpPr/>
+          <p:nvPr/>
+        </p:nvSpPr>
+        <p:spPr>
+          <a:xfrm>
+            <a:off x="22729950" y="18921000"/>
+            <a:ext cx="3290400" cy="1371000"/>
+          </a:xfrm>
+          <a:prstGeom prst="roundRect">
+            <a:avLst>
+              <a:gd name="adj" fmla="val 9000"/>
             </a:avLst>
           </a:prstGeom>
           <a:solidFill>
@@ -6612,14 +6919,14 @@
       </p:sp>
       <p:sp>
         <p:nvSpPr>
-          <p:cNvPr id="62" name="Oval 61"/>
+          <p:cNvPr id="69" name="Oval 68"/>
           <p:cNvSpPr/>
           <p:nvPr/>
         </p:nvSpPr>
         <p:spPr>
           <a:xfrm>
-            <a:off x="13557960" y="20915805"/>
-            <a:ext cx="411300" cy="411300"/>
+            <a:off x="22921890" y="19126650"/>
+            <a:ext cx="438720" cy="438720"/>
           </a:xfrm>
           <a:prstGeom prst="ellipse">
             <a:avLst/>
@@ -6665,14 +6972,14 @@
       </p:sp>
       <p:sp>
         <p:nvSpPr>
-          <p:cNvPr id="63" name="TextBox 62"/>
+          <p:cNvPr id="70" name="TextBox 69"/>
           <p:cNvSpPr txBox="1"/>
           <p:nvPr/>
         </p:nvSpPr>
         <p:spPr>
           <a:xfrm>
-            <a:off x="14092650" y="20981613"/>
-            <a:ext cx="180000" cy="320814"/>
+            <a:off x="23497710" y="19184232"/>
+            <a:ext cx="180000" cy="392106"/>
           </a:xfrm>
           <a:prstGeom prst="rect">
             <a:avLst/>
@@ -6687,27 +6994,27 @@
           <a:p>
             <a:pPr algn="l"/>
             <a:r>
-              <a:rPr sz="1943" b="1" i="0">
+              <a:rPr sz="2374" b="1" i="0">
                 <a:solidFill>
                   <a:srgbClr val="1C2321"/>
                 </a:solidFill>
                 <a:latin typeface="Be Vietnam Pro"/>
               </a:rPr>
-              <a:t>Bốc thăm dùng chung</a:t>
-            </a:r>
-          </a:p>
-        </p:txBody>
-      </p:sp>
-      <p:sp>
-        <p:nvSpPr>
-          <p:cNvPr id="64" name="TextBox 63"/>
+              <a:t>Kiểm tra</a:t>
+            </a:r>
+          </a:p>
+        </p:txBody>
+      </p:sp>
+      <p:sp>
+        <p:nvSpPr>
+          <p:cNvPr id="71" name="TextBox 70"/>
           <p:cNvSpPr txBox="1"/>
           <p:nvPr/>
         </p:nvSpPr>
         <p:spPr>
           <a:xfrm>
-            <a:off x="13626510" y="21455979"/>
-            <a:ext cx="180000" cy="249522"/>
+            <a:off x="22976730" y="19739487"/>
+            <a:ext cx="180000" cy="302991"/>
           </a:xfrm>
           <a:prstGeom prst="rect">
             <a:avLst/>
@@ -6722,64 +7029,29 @@
           <a:p>
             <a:pPr algn="l"/>
             <a:r>
-              <a:rPr sz="1511" b="0" i="0">
+              <a:rPr sz="1835" b="0" i="0">
                 <a:solidFill>
                   <a:srgbClr val="5B6570"/>
                 </a:solidFill>
                 <a:latin typeface="IBM Plex Sans"/>
               </a:rPr>
-              <a:t>Một số cho mỗi em, mọi CLB</a:t>
-            </a:r>
-          </a:p>
-        </p:txBody>
-      </p:sp>
-      <p:sp>
-        <p:nvSpPr>
-          <p:cNvPr id="65" name="TextBox 64"/>
-          <p:cNvSpPr txBox="1"/>
-          <p:nvPr/>
-        </p:nvSpPr>
-        <p:spPr>
-          <a:xfrm>
-            <a:off x="13626510" y="21757599"/>
-            <a:ext cx="180000" cy="249522"/>
-          </a:xfrm>
-          <a:prstGeom prst="rect">
-            <a:avLst/>
-          </a:prstGeom>
-          <a:noFill/>
-        </p:spPr>
-        <p:txBody>
-          <a:bodyPr wrap="none" anchor="t" lIns="0" rIns="0" tIns="0" bIns="0">
-            <a:spAutoFit/>
-          </a:bodyPr>
-          <a:lstStyle/>
-          <a:p>
-            <a:pPr algn="l"/>
-            <a:r>
-              <a:rPr sz="1511" b="0" i="0">
-                <a:solidFill>
-                  <a:srgbClr val="5B6570"/>
-                </a:solidFill>
-                <a:latin typeface="IBM Plex Sans"/>
-              </a:rPr>
-              <a:t>Chỉ phá hoà · khoá theo seed</a:t>
-            </a:r>
-          </a:p>
-        </p:txBody>
-      </p:sp>
-      <p:sp>
-        <p:nvSpPr>
-          <p:cNvPr id="66" name="Right Arrow 65"/>
+              <a:t>Không còn cặp phá vỡ</a:t>
+            </a:r>
+          </a:p>
+        </p:txBody>
+      </p:sp>
+      <p:sp>
+        <p:nvSpPr>
+          <p:cNvPr id="72" name="Down Arrow 71"/>
           <p:cNvSpPr/>
           <p:nvPr/>
         </p:nvSpPr>
         <p:spPr>
           <a:xfrm>
-            <a:off x="16971750" y="20525070"/>
-            <a:ext cx="616950" cy="219360"/>
-          </a:xfrm>
-          <a:prstGeom prst="rightArrow">
+            <a:off x="24265470" y="20292000"/>
+            <a:ext cx="219360" cy="479850"/>
+          </a:xfrm>
+          <a:prstGeom prst="downArrow">
             <a:avLst/>
           </a:prstGeom>
           <a:solidFill>
@@ -6814,829 +7086,18 @@
       </p:sp>
       <p:sp>
         <p:nvSpPr>
-          <p:cNvPr id="67" name="Rounded Rectangle 66"/>
+          <p:cNvPr id="73" name="Rounded Rectangle 72"/>
           <p:cNvSpPr/>
           <p:nvPr/>
         </p:nvSpPr>
         <p:spPr>
           <a:xfrm>
-            <a:off x="17588700" y="18441150"/>
-            <a:ext cx="4387200" cy="4387200"/>
+            <a:off x="22729950" y="20771850"/>
+            <a:ext cx="3290400" cy="1713750"/>
           </a:xfrm>
           <a:prstGeom prst="roundRect">
             <a:avLst>
-              <a:gd name="adj" fmla="val 2812"/>
-            </a:avLst>
-          </a:prstGeom>
-          <a:solidFill>
-            <a:srgbClr val="DCE9E0"/>
-          </a:solidFill>
-          <a:ln w="27420">
-            <a:solidFill>
-              <a:srgbClr val="27805A"/>
-            </a:solidFill>
-          </a:ln>
-          <a:effectLst/>
-        </p:spPr>
-        <p:style>
-          <a:lnRef idx="1">
-            <a:schemeClr val="accent1"/>
-          </a:lnRef>
-          <a:fillRef idx="3">
-            <a:schemeClr val="accent1"/>
-          </a:fillRef>
-          <a:effectRef idx="2">
-            <a:schemeClr val="accent1"/>
-          </a:effectRef>
-          <a:fontRef idx="minor">
-            <a:schemeClr val="lt1"/>
-          </a:fontRef>
-        </p:style>
-        <p:txBody>
-          <a:bodyPr rtlCol="0" anchor="ctr"/>
-          <a:lstStyle/>
-          <a:p>
-            <a:pPr algn="ctr"/>
-          </a:p>
-        </p:txBody>
-      </p:sp>
-      <p:sp>
-        <p:nvSpPr>
-          <p:cNvPr id="68" name="Oval 67"/>
-          <p:cNvSpPr/>
-          <p:nvPr/>
-        </p:nvSpPr>
-        <p:spPr>
-          <a:xfrm>
-            <a:off x="17739510" y="18619380"/>
-            <a:ext cx="411300" cy="411300"/>
-          </a:xfrm>
-          <a:prstGeom prst="ellipse">
-            <a:avLst/>
-          </a:prstGeom>
-          <a:solidFill>
-            <a:srgbClr val="B8781A"/>
-          </a:solidFill>
-          <a:ln>
-            <a:noFill/>
-          </a:ln>
-          <a:effectLst/>
-        </p:spPr>
-        <p:style>
-          <a:lnRef idx="1">
-            <a:schemeClr val="accent1"/>
-          </a:lnRef>
-          <a:fillRef idx="3">
-            <a:schemeClr val="accent1"/>
-          </a:fillRef>
-          <a:effectRef idx="2">
-            <a:schemeClr val="accent1"/>
-          </a:effectRef>
-          <a:fontRef idx="minor">
-            <a:schemeClr val="lt1"/>
-          </a:fontRef>
-        </p:style>
-        <p:txBody>
-          <a:bodyPr rtlCol="0" anchor="ctr" wrap="square" lIns="0" rIns="0" tIns="0" bIns="0"/>
-          <a:lstStyle/>
-          <a:p>
-            <a:pPr algn="ctr"/>
-            <a:r>
-              <a:rPr sz="1619" b="1" i="0">
-                <a:solidFill>
-                  <a:srgbClr val="FFFFFF"/>
-                </a:solidFill>
-                <a:latin typeface="Be Vietnam Pro"/>
-              </a:rPr>
-              <a:t>1</a:t>
-            </a:r>
-          </a:p>
-        </p:txBody>
-      </p:sp>
-      <p:sp>
-        <p:nvSpPr>
-          <p:cNvPr id="69" name="TextBox 68"/>
-          <p:cNvSpPr txBox="1"/>
-          <p:nvPr/>
-        </p:nvSpPr>
-        <p:spPr>
-          <a:xfrm>
-            <a:off x="18274200" y="18672849"/>
-            <a:ext cx="180000" cy="338637"/>
-          </a:xfrm>
-          <a:prstGeom prst="rect">
-            <a:avLst/>
-          </a:prstGeom>
-          <a:noFill/>
-        </p:spPr>
-        <p:txBody>
-          <a:bodyPr wrap="none" anchor="t" lIns="0" rIns="0" tIns="0" bIns="0">
-            <a:spAutoFit/>
-          </a:bodyPr>
-          <a:lstStyle/>
-          <a:p>
-            <a:pPr algn="l"/>
-            <a:r>
-              <a:rPr sz="2051" b="1" i="0">
-                <a:solidFill>
-                  <a:srgbClr val="1C2321"/>
-                </a:solidFill>
-                <a:latin typeface="Be Vietnam Pro"/>
-              </a:rPr>
-              <a:t>Deferred Acceptance</a:t>
-            </a:r>
-          </a:p>
-        </p:txBody>
-      </p:sp>
-      <p:sp>
-        <p:nvSpPr>
-          <p:cNvPr id="70" name="TextBox 69"/>
-          <p:cNvSpPr txBox="1"/>
-          <p:nvPr/>
-        </p:nvSpPr>
-        <p:spPr>
-          <a:xfrm>
-            <a:off x="17808060" y="19132134"/>
-            <a:ext cx="180000" cy="249522"/>
-          </a:xfrm>
-          <a:prstGeom prst="rect">
-            <a:avLst/>
-          </a:prstGeom>
-          <a:noFill/>
-        </p:spPr>
-        <p:txBody>
-          <a:bodyPr wrap="none" anchor="t" lIns="0" rIns="0" tIns="0" bIns="0">
-            <a:spAutoFit/>
-          </a:bodyPr>
-          <a:lstStyle/>
-          <a:p>
-            <a:pPr algn="l"/>
-            <a:r>
-              <a:rPr sz="1511" b="0" i="0">
-                <a:solidFill>
-                  <a:srgbClr val="5B6570"/>
-                </a:solidFill>
-                <a:latin typeface="IBM Plex Sans"/>
-              </a:rPr>
-              <a:t>Học sinh đề xuất theo nguyện vọng</a:t>
-            </a:r>
-          </a:p>
-        </p:txBody>
-      </p:sp>
-      <p:sp>
-        <p:nvSpPr>
-          <p:cNvPr id="71" name="TextBox 70"/>
-          <p:cNvSpPr txBox="1"/>
-          <p:nvPr/>
-        </p:nvSpPr>
-        <p:spPr>
-          <a:xfrm>
-            <a:off x="17808060" y="19433754"/>
-            <a:ext cx="180000" cy="249522"/>
-          </a:xfrm>
-          <a:prstGeom prst="rect">
-            <a:avLst/>
-          </a:prstGeom>
-          <a:noFill/>
-        </p:spPr>
-        <p:txBody>
-          <a:bodyPr wrap="none" anchor="t" lIns="0" rIns="0" tIns="0" bIns="0">
-            <a:spAutoFit/>
-          </a:bodyPr>
-          <a:lstStyle/>
-          <a:p>
-            <a:pPr algn="l"/>
-            <a:r>
-              <a:rPr sz="1511" b="0" i="0">
-                <a:solidFill>
-                  <a:srgbClr val="5B6570"/>
-                </a:solidFill>
-                <a:latin typeface="IBM Plex Sans"/>
-              </a:rPr>
-              <a:t>CLB giữ tạm, từ chối phần còn lại</a:t>
-            </a:r>
-          </a:p>
-        </p:txBody>
-      </p:sp>
-      <p:sp>
-        <p:nvSpPr>
-          <p:cNvPr id="72" name="TextBox 71"/>
-          <p:cNvSpPr txBox="1"/>
-          <p:nvPr/>
-        </p:nvSpPr>
-        <p:spPr>
-          <a:xfrm>
-            <a:off x="17808060" y="19735374"/>
-            <a:ext cx="180000" cy="249522"/>
-          </a:xfrm>
-          <a:prstGeom prst="rect">
-            <a:avLst/>
-          </a:prstGeom>
-          <a:noFill/>
-        </p:spPr>
-        <p:txBody>
-          <a:bodyPr wrap="none" anchor="t" lIns="0" rIns="0" tIns="0" bIns="0">
-            <a:spAutoFit/>
-          </a:bodyPr>
-          <a:lstStyle/>
-          <a:p>
-            <a:pPr algn="l"/>
-            <a:r>
-              <a:rPr sz="1511" b="0" i="0">
-                <a:solidFill>
-                  <a:srgbClr val="5B6570"/>
-                </a:solidFill>
-                <a:latin typeface="IBM Plex Sans"/>
-              </a:rPr>
-              <a:t>Lặp tới khi không còn đề xuất</a:t>
-            </a:r>
-          </a:p>
-        </p:txBody>
-      </p:sp>
-      <p:sp>
-        <p:nvSpPr>
-          <p:cNvPr id="73" name="Rounded Rectangle 72"/>
-          <p:cNvSpPr/>
-          <p:nvPr/>
-        </p:nvSpPr>
-        <p:spPr>
-          <a:xfrm>
-            <a:off x="17862900" y="20292000"/>
-            <a:ext cx="3838800" cy="2262150"/>
-          </a:xfrm>
-          <a:prstGeom prst="roundRect">
-            <a:avLst>
-              <a:gd name="adj" fmla="val 5454"/>
-            </a:avLst>
-          </a:prstGeom>
-          <a:solidFill>
-            <a:srgbClr val="FFFFFF"/>
-          </a:solidFill>
-          <a:ln w="20565">
-            <a:solidFill>
-              <a:srgbClr val="B8781A"/>
-            </a:solidFill>
-          </a:ln>
-          <a:effectLst/>
-        </p:spPr>
-        <p:style>
-          <a:lnRef idx="1">
-            <a:schemeClr val="accent1"/>
-          </a:lnRef>
-          <a:fillRef idx="3">
-            <a:schemeClr val="accent1"/>
-          </a:fillRef>
-          <a:effectRef idx="2">
-            <a:schemeClr val="accent1"/>
-          </a:effectRef>
-          <a:fontRef idx="minor">
-            <a:schemeClr val="lt1"/>
-          </a:fontRef>
-        </p:style>
-        <p:txBody>
-          <a:bodyPr rtlCol="0" anchor="ctr"/>
-          <a:lstStyle/>
-          <a:p>
-            <a:pPr algn="ctr"/>
-          </a:p>
-        </p:txBody>
-      </p:sp>
-      <p:sp>
-        <p:nvSpPr>
-          <p:cNvPr id="74" name="Oval 73"/>
-          <p:cNvSpPr/>
-          <p:nvPr/>
-        </p:nvSpPr>
-        <p:spPr>
-          <a:xfrm>
-            <a:off x="18013710" y="20470230"/>
-            <a:ext cx="411300" cy="411300"/>
-          </a:xfrm>
-          <a:prstGeom prst="ellipse">
-            <a:avLst/>
-          </a:prstGeom>
-          <a:solidFill>
-            <a:srgbClr val="B8781A"/>
-          </a:solidFill>
-          <a:ln>
-            <a:noFill/>
-          </a:ln>
-          <a:effectLst/>
-        </p:spPr>
-        <p:style>
-          <a:lnRef idx="1">
-            <a:schemeClr val="accent1"/>
-          </a:lnRef>
-          <a:fillRef idx="3">
-            <a:schemeClr val="accent1"/>
-          </a:fillRef>
-          <a:effectRef idx="2">
-            <a:schemeClr val="accent1"/>
-          </a:effectRef>
-          <a:fontRef idx="minor">
-            <a:schemeClr val="lt1"/>
-          </a:fontRef>
-        </p:style>
-        <p:txBody>
-          <a:bodyPr rtlCol="0" anchor="ctr" wrap="square" lIns="0" rIns="0" tIns="0" bIns="0"/>
-          <a:lstStyle/>
-          <a:p>
-            <a:pPr algn="ctr"/>
-            <a:r>
-              <a:rPr sz="1619" b="1" i="0">
-                <a:solidFill>
-                  <a:srgbClr val="FFFFFF"/>
-                </a:solidFill>
-                <a:latin typeface="Be Vietnam Pro"/>
-              </a:rPr>
-              <a:t>2</a:t>
-            </a:r>
-          </a:p>
-        </p:txBody>
-      </p:sp>
-      <p:sp>
-        <p:nvSpPr>
-          <p:cNvPr id="75" name="TextBox 74"/>
-          <p:cNvSpPr txBox="1"/>
-          <p:nvPr/>
-        </p:nvSpPr>
-        <p:spPr>
-          <a:xfrm>
-            <a:off x="18548400" y="20536038"/>
-            <a:ext cx="180000" cy="320814"/>
-          </a:xfrm>
-          <a:prstGeom prst="rect">
-            <a:avLst/>
-          </a:prstGeom>
-          <a:noFill/>
-        </p:spPr>
-        <p:txBody>
-          <a:bodyPr wrap="none" anchor="t" lIns="0" rIns="0" tIns="0" bIns="0">
-            <a:spAutoFit/>
-          </a:bodyPr>
-          <a:lstStyle/>
-          <a:p>
-            <a:pPr algn="l"/>
-            <a:r>
-              <a:rPr sz="1943" b="1" i="0">
-                <a:solidFill>
-                  <a:srgbClr val="1C2321"/>
-                </a:solidFill>
-                <a:latin typeface="Be Vietnam Pro"/>
-              </a:rPr>
-              <a:t>Dự trữ mềm, hai lượt</a:t>
-            </a:r>
-          </a:p>
-        </p:txBody>
-      </p:sp>
-      <p:sp>
-        <p:nvSpPr>
-          <p:cNvPr id="76" name="TextBox 75"/>
-          <p:cNvSpPr txBox="1"/>
-          <p:nvPr/>
-        </p:nvSpPr>
-        <p:spPr>
-          <a:xfrm>
-            <a:off x="18082260" y="21010404"/>
-            <a:ext cx="180000" cy="249522"/>
-          </a:xfrm>
-          <a:prstGeom prst="rect">
-            <a:avLst/>
-          </a:prstGeom>
-          <a:noFill/>
-        </p:spPr>
-        <p:txBody>
-          <a:bodyPr wrap="none" anchor="t" lIns="0" rIns="0" tIns="0" bIns="0">
-            <a:spAutoFit/>
-          </a:bodyPr>
-          <a:lstStyle/>
-          <a:p>
-            <a:pPr algn="l"/>
-            <a:r>
-              <a:rPr sz="1511" b="0" i="0">
-                <a:solidFill>
-                  <a:srgbClr val="5B6570"/>
-                </a:solidFill>
-                <a:latin typeface="IBM Plex Sans"/>
-              </a:rPr>
-              <a:t>Lượt 1: suất dự trữ</a:t>
-            </a:r>
-          </a:p>
-        </p:txBody>
-      </p:sp>
-      <p:sp>
-        <p:nvSpPr>
-          <p:cNvPr id="77" name="TextBox 76"/>
-          <p:cNvSpPr txBox="1"/>
-          <p:nvPr/>
-        </p:nvSpPr>
-        <p:spPr>
-          <a:xfrm>
-            <a:off x="18082260" y="21312024"/>
-            <a:ext cx="180000" cy="249522"/>
-          </a:xfrm>
-          <a:prstGeom prst="rect">
-            <a:avLst/>
-          </a:prstGeom>
-          <a:noFill/>
-        </p:spPr>
-        <p:txBody>
-          <a:bodyPr wrap="none" anchor="t" lIns="0" rIns="0" tIns="0" bIns="0">
-            <a:spAutoFit/>
-          </a:bodyPr>
-          <a:lstStyle/>
-          <a:p>
-            <a:pPr algn="l"/>
-            <a:r>
-              <a:rPr sz="1511" b="0" i="0">
-                <a:solidFill>
-                  <a:srgbClr val="5B6570"/>
-                </a:solidFill>
-                <a:latin typeface="IBM Plex Sans"/>
-              </a:rPr>
-              <a:t>  → chỉ em thuộc diện</a:t>
-            </a:r>
-          </a:p>
-        </p:txBody>
-      </p:sp>
-      <p:sp>
-        <p:nvSpPr>
-          <p:cNvPr id="78" name="TextBox 77"/>
-          <p:cNvSpPr txBox="1"/>
-          <p:nvPr/>
-        </p:nvSpPr>
-        <p:spPr>
-          <a:xfrm>
-            <a:off x="18082260" y="21613644"/>
-            <a:ext cx="180000" cy="249522"/>
-          </a:xfrm>
-          <a:prstGeom prst="rect">
-            <a:avLst/>
-          </a:prstGeom>
-          <a:noFill/>
-        </p:spPr>
-        <p:txBody>
-          <a:bodyPr wrap="none" anchor="t" lIns="0" rIns="0" tIns="0" bIns="0">
-            <a:spAutoFit/>
-          </a:bodyPr>
-          <a:lstStyle/>
-          <a:p>
-            <a:pPr algn="l"/>
-            <a:r>
-              <a:rPr sz="1511" b="0" i="0">
-                <a:solidFill>
-                  <a:srgbClr val="5B6570"/>
-                </a:solidFill>
-                <a:latin typeface="IBM Plex Sans"/>
-              </a:rPr>
-              <a:t>Lượt 2: lượt chung</a:t>
-            </a:r>
-          </a:p>
-        </p:txBody>
-      </p:sp>
-      <p:sp>
-        <p:nvSpPr>
-          <p:cNvPr id="79" name="TextBox 78"/>
-          <p:cNvSpPr txBox="1"/>
-          <p:nvPr/>
-        </p:nvSpPr>
-        <p:spPr>
-          <a:xfrm>
-            <a:off x="18082260" y="21915264"/>
-            <a:ext cx="180000" cy="249522"/>
-          </a:xfrm>
-          <a:prstGeom prst="rect">
-            <a:avLst/>
-          </a:prstGeom>
-          <a:noFill/>
-        </p:spPr>
-        <p:txBody>
-          <a:bodyPr wrap="none" anchor="t" lIns="0" rIns="0" tIns="0" bIns="0">
-            <a:spAutoFit/>
-          </a:bodyPr>
-          <a:lstStyle/>
-          <a:p>
-            <a:pPr algn="l"/>
-            <a:r>
-              <a:rPr sz="1511" b="0" i="0">
-                <a:solidFill>
-                  <a:srgbClr val="5B6570"/>
-                </a:solidFill>
-                <a:latin typeface="IBM Plex Sans"/>
-              </a:rPr>
-              <a:t>  → suất thừa tự chuyển sang</a:t>
-            </a:r>
-          </a:p>
-        </p:txBody>
-      </p:sp>
-      <p:sp>
-        <p:nvSpPr>
-          <p:cNvPr id="80" name="Right Arrow 79"/>
-          <p:cNvSpPr/>
-          <p:nvPr/>
-        </p:nvSpPr>
-        <p:spPr>
-          <a:xfrm>
-            <a:off x="21975900" y="20525070"/>
-            <a:ext cx="616950" cy="219360"/>
-          </a:xfrm>
-          <a:prstGeom prst="rightArrow">
-            <a:avLst/>
-          </a:prstGeom>
-          <a:solidFill>
-            <a:srgbClr val="5B6570"/>
-          </a:solidFill>
-          <a:ln>
-            <a:noFill/>
-          </a:ln>
-          <a:effectLst/>
-        </p:spPr>
-        <p:style>
-          <a:lnRef idx="1">
-            <a:schemeClr val="accent1"/>
-          </a:lnRef>
-          <a:fillRef idx="3">
-            <a:schemeClr val="accent1"/>
-          </a:fillRef>
-          <a:effectRef idx="2">
-            <a:schemeClr val="accent1"/>
-          </a:effectRef>
-          <a:fontRef idx="minor">
-            <a:schemeClr val="lt1"/>
-          </a:fontRef>
-        </p:style>
-        <p:txBody>
-          <a:bodyPr rtlCol="0" anchor="ctr"/>
-          <a:lstStyle/>
-          <a:p>
-            <a:pPr algn="ctr"/>
-          </a:p>
-        </p:txBody>
-      </p:sp>
-      <p:sp>
-        <p:nvSpPr>
-          <p:cNvPr id="81" name="Rounded Rectangle 80"/>
-          <p:cNvSpPr/>
-          <p:nvPr/>
-        </p:nvSpPr>
-        <p:spPr>
-          <a:xfrm>
-            <a:off x="22592850" y="18715350"/>
-            <a:ext cx="3358950" cy="1816575"/>
-          </a:xfrm>
-          <a:prstGeom prst="roundRect">
-            <a:avLst>
-              <a:gd name="adj" fmla="val 6792"/>
-            </a:avLst>
-          </a:prstGeom>
-          <a:solidFill>
-            <a:srgbClr val="FFFFFF"/>
-          </a:solidFill>
-          <a:ln w="20565">
-            <a:solidFill>
-              <a:srgbClr val="27805A"/>
-            </a:solidFill>
-          </a:ln>
-          <a:effectLst/>
-        </p:spPr>
-        <p:style>
-          <a:lnRef idx="1">
-            <a:schemeClr val="accent1"/>
-          </a:lnRef>
-          <a:fillRef idx="3">
-            <a:schemeClr val="accent1"/>
-          </a:fillRef>
-          <a:effectRef idx="2">
-            <a:schemeClr val="accent1"/>
-          </a:effectRef>
-          <a:fontRef idx="minor">
-            <a:schemeClr val="lt1"/>
-          </a:fontRef>
-        </p:style>
-        <p:txBody>
-          <a:bodyPr rtlCol="0" anchor="ctr"/>
-          <a:lstStyle/>
-          <a:p>
-            <a:pPr algn="ctr"/>
-          </a:p>
-        </p:txBody>
-      </p:sp>
-      <p:sp>
-        <p:nvSpPr>
-          <p:cNvPr id="82" name="Oval 81"/>
-          <p:cNvSpPr/>
-          <p:nvPr/>
-        </p:nvSpPr>
-        <p:spPr>
-          <a:xfrm>
-            <a:off x="22743660" y="18893580"/>
-            <a:ext cx="411300" cy="411300"/>
-          </a:xfrm>
-          <a:prstGeom prst="ellipse">
-            <a:avLst/>
-          </a:prstGeom>
-          <a:solidFill>
-            <a:srgbClr val="B8781A"/>
-          </a:solidFill>
-          <a:ln>
-            <a:noFill/>
-          </a:ln>
-          <a:effectLst/>
-        </p:spPr>
-        <p:style>
-          <a:lnRef idx="1">
-            <a:schemeClr val="accent1"/>
-          </a:lnRef>
-          <a:fillRef idx="3">
-            <a:schemeClr val="accent1"/>
-          </a:fillRef>
-          <a:effectRef idx="2">
-            <a:schemeClr val="accent1"/>
-          </a:effectRef>
-          <a:fontRef idx="minor">
-            <a:schemeClr val="lt1"/>
-          </a:fontRef>
-        </p:style>
-        <p:txBody>
-          <a:bodyPr rtlCol="0" anchor="ctr" wrap="square" lIns="0" rIns="0" tIns="0" bIns="0"/>
-          <a:lstStyle/>
-          <a:p>
-            <a:pPr algn="ctr"/>
-            <a:r>
-              <a:rPr sz="1619" b="1" i="0">
-                <a:solidFill>
-                  <a:srgbClr val="FFFFFF"/>
-                </a:solidFill>
-                <a:latin typeface="Be Vietnam Pro"/>
-              </a:rPr>
-              <a:t>5</a:t>
-            </a:r>
-          </a:p>
-        </p:txBody>
-      </p:sp>
-      <p:sp>
-        <p:nvSpPr>
-          <p:cNvPr id="83" name="TextBox 82"/>
-          <p:cNvSpPr txBox="1"/>
-          <p:nvPr/>
-        </p:nvSpPr>
-        <p:spPr>
-          <a:xfrm>
-            <a:off x="23278349" y="18959388"/>
-            <a:ext cx="180000" cy="320814"/>
-          </a:xfrm>
-          <a:prstGeom prst="rect">
-            <a:avLst/>
-          </a:prstGeom>
-          <a:noFill/>
-        </p:spPr>
-        <p:txBody>
-          <a:bodyPr wrap="none" anchor="t" lIns="0" rIns="0" tIns="0" bIns="0">
-            <a:spAutoFit/>
-          </a:bodyPr>
-          <a:lstStyle/>
-          <a:p>
-            <a:pPr algn="l"/>
-            <a:r>
-              <a:rPr sz="1943" b="1" i="0">
-                <a:solidFill>
-                  <a:srgbClr val="1C2321"/>
-                </a:solidFill>
-                <a:latin typeface="Be Vietnam Pro"/>
-              </a:rPr>
-              <a:t>Kiểm tra ổn định</a:t>
-            </a:r>
-          </a:p>
-        </p:txBody>
-      </p:sp>
-      <p:sp>
-        <p:nvSpPr>
-          <p:cNvPr id="84" name="TextBox 83"/>
-          <p:cNvSpPr txBox="1"/>
-          <p:nvPr/>
-        </p:nvSpPr>
-        <p:spPr>
-          <a:xfrm>
-            <a:off x="22812210" y="19433754"/>
-            <a:ext cx="180000" cy="249522"/>
-          </a:xfrm>
-          <a:prstGeom prst="rect">
-            <a:avLst/>
-          </a:prstGeom>
-          <a:noFill/>
-        </p:spPr>
-        <p:txBody>
-          <a:bodyPr wrap="none" anchor="t" lIns="0" rIns="0" tIns="0" bIns="0">
-            <a:spAutoFit/>
-          </a:bodyPr>
-          <a:lstStyle/>
-          <a:p>
-            <a:pPr algn="l"/>
-            <a:r>
-              <a:rPr sz="1511" b="0" i="0">
-                <a:solidFill>
-                  <a:srgbClr val="5B6570"/>
-                </a:solidFill>
-                <a:latin typeface="IBM Plex Sans"/>
-              </a:rPr>
-              <a:t>Tìm cặp phá vỡ bằng</a:t>
-            </a:r>
-          </a:p>
-        </p:txBody>
-      </p:sp>
-      <p:sp>
-        <p:nvSpPr>
-          <p:cNvPr id="85" name="TextBox 84"/>
-          <p:cNvSpPr txBox="1"/>
-          <p:nvPr/>
-        </p:nvSpPr>
-        <p:spPr>
-          <a:xfrm>
-            <a:off x="22812210" y="19735374"/>
-            <a:ext cx="180000" cy="249522"/>
-          </a:xfrm>
-          <a:prstGeom prst="rect">
-            <a:avLst/>
-          </a:prstGeom>
-          <a:noFill/>
-        </p:spPr>
-        <p:txBody>
-          <a:bodyPr wrap="none" anchor="t" lIns="0" rIns="0" tIns="0" bIns="0">
-            <a:spAutoFit/>
-          </a:bodyPr>
-          <a:lstStyle/>
-          <a:p>
-            <a:pPr algn="l"/>
-            <a:r>
-              <a:rPr sz="1511" b="0" i="0">
-                <a:solidFill>
-                  <a:srgbClr val="5B6570"/>
-                </a:solidFill>
-                <a:latin typeface="IBM Plex Sans"/>
-              </a:rPr>
-              <a:t>chính hàm lựa chọn</a:t>
-            </a:r>
-          </a:p>
-        </p:txBody>
-      </p:sp>
-      <p:sp>
-        <p:nvSpPr>
-          <p:cNvPr id="86" name="Down Arrow 85"/>
-          <p:cNvSpPr/>
-          <p:nvPr/>
-        </p:nvSpPr>
-        <p:spPr>
-          <a:xfrm>
-            <a:off x="24162645" y="20531925"/>
-            <a:ext cx="219360" cy="205650"/>
-          </a:xfrm>
-          <a:prstGeom prst="downArrow">
-            <a:avLst/>
-          </a:prstGeom>
-          <a:solidFill>
-            <a:srgbClr val="5B6570"/>
-          </a:solidFill>
-          <a:ln>
-            <a:noFill/>
-          </a:ln>
-          <a:effectLst/>
-        </p:spPr>
-        <p:style>
-          <a:lnRef idx="1">
-            <a:schemeClr val="accent1"/>
-          </a:lnRef>
-          <a:fillRef idx="3">
-            <a:schemeClr val="accent1"/>
-          </a:fillRef>
-          <a:effectRef idx="2">
-            <a:schemeClr val="accent1"/>
-          </a:effectRef>
-          <a:fontRef idx="minor">
-            <a:schemeClr val="lt1"/>
-          </a:fontRef>
-        </p:style>
-        <p:txBody>
-          <a:bodyPr rtlCol="0" anchor="ctr"/>
-          <a:lstStyle/>
-          <a:p>
-            <a:pPr algn="ctr"/>
-          </a:p>
-        </p:txBody>
-      </p:sp>
-      <p:sp>
-        <p:nvSpPr>
-          <p:cNvPr id="87" name="Rounded Rectangle 86"/>
-          <p:cNvSpPr/>
-          <p:nvPr/>
-        </p:nvSpPr>
-        <p:spPr>
-          <a:xfrm>
-            <a:off x="22592850" y="20737575"/>
-            <a:ext cx="3358950" cy="1816575"/>
-          </a:xfrm>
-          <a:prstGeom prst="roundRect">
-            <a:avLst>
-              <a:gd name="adj" fmla="val 6792"/>
+              <a:gd name="adj" fmla="val 7200"/>
             </a:avLst>
           </a:prstGeom>
           <a:solidFill>
@@ -7673,14 +7134,14 @@
       </p:sp>
       <p:sp>
         <p:nvSpPr>
-          <p:cNvPr id="88" name="TextBox 87"/>
+          <p:cNvPr id="74" name="TextBox 73"/>
           <p:cNvSpPr txBox="1"/>
           <p:nvPr/>
         </p:nvSpPr>
         <p:spPr>
           <a:xfrm>
-            <a:off x="22812210" y="20981613"/>
-            <a:ext cx="180000" cy="320814"/>
+            <a:off x="22976730" y="21035082"/>
+            <a:ext cx="180000" cy="392106"/>
           </a:xfrm>
           <a:prstGeom prst="rect">
             <a:avLst/>
@@ -7695,7 +7156,7 @@
           <a:p>
             <a:pPr algn="l"/>
             <a:r>
-              <a:rPr sz="1943" b="1" i="0">
+              <a:rPr sz="2374" b="1" i="0">
                 <a:solidFill>
                   <a:srgbClr val="1C2321"/>
                 </a:solidFill>
@@ -7708,14 +7169,14 @@
       </p:sp>
       <p:sp>
         <p:nvSpPr>
-          <p:cNvPr id="89" name="TextBox 88"/>
+          <p:cNvPr id="75" name="TextBox 74"/>
           <p:cNvSpPr txBox="1"/>
           <p:nvPr/>
         </p:nvSpPr>
         <p:spPr>
           <a:xfrm>
-            <a:off x="22812210" y="21455979"/>
-            <a:ext cx="180000" cy="249522"/>
+            <a:off x="22976730" y="21590337"/>
+            <a:ext cx="180000" cy="302991"/>
           </a:xfrm>
           <a:prstGeom prst="rect">
             <a:avLst/>
@@ -7730,7 +7191,7 @@
           <a:p>
             <a:pPr algn="l"/>
             <a:r>
-              <a:rPr sz="1511" b="0" i="0">
+              <a:rPr sz="1835" b="0" i="0">
                 <a:solidFill>
                   <a:srgbClr val="5B6570"/>
                 </a:solidFill>
@@ -7743,14 +7204,14 @@
       </p:sp>
       <p:sp>
         <p:nvSpPr>
-          <p:cNvPr id="90" name="TextBox 89"/>
+          <p:cNvPr id="76" name="TextBox 75"/>
           <p:cNvSpPr txBox="1"/>
           <p:nvPr/>
         </p:nvSpPr>
         <p:spPr>
           <a:xfrm>
-            <a:off x="22812210" y="21757599"/>
-            <a:ext cx="180000" cy="249522"/>
+            <a:off x="22976730" y="21960507"/>
+            <a:ext cx="180000" cy="302991"/>
           </a:xfrm>
           <a:prstGeom prst="rect">
             <a:avLst/>
@@ -7765,20 +7226,20 @@
           <a:p>
             <a:pPr algn="l"/>
             <a:r>
-              <a:rPr sz="1511" b="0" i="0">
+              <a:rPr sz="1835" b="0" i="0">
                 <a:solidFill>
                   <a:srgbClr val="5B6570"/>
                 </a:solidFill>
                 <a:latin typeface="IBM Plex Sans"/>
               </a:rPr>
-              <a:t>Xuất Excel / CSV theo CLB</a:t>
-            </a:r>
-          </a:p>
-        </p:txBody>
-      </p:sp>
-      <p:sp>
-        <p:nvSpPr>
-          <p:cNvPr id="91" name="TextBox 90"/>
+              <a:t>Danh sách từng CLB</a:t>
+            </a:r>
+          </a:p>
+        </p:txBody>
+      </p:sp>
+      <p:sp>
+        <p:nvSpPr>
+          <p:cNvPr id="77" name="TextBox 76"/>
           <p:cNvSpPr txBox="1"/>
           <p:nvPr/>
         </p:nvSpPr>
@@ -7806,14 +7267,14 @@
                 </a:solidFill>
                 <a:latin typeface="IBM Plex Sans"/>
               </a:rPr>
-              <a:t>Sơ đồ do AI tạo ra — theo CO_CHE_THUAT_TOAN.md (năm lớp cơ chế của phần mềm)</a:t>
-            </a:r>
-          </a:p>
-        </p:txBody>
-      </p:sp>
-      <p:sp>
-        <p:nvSpPr>
-          <p:cNvPr id="92" name="Rounded Rectangle 91"/>
+              <a:t>Sơ đồ do AI tạo ra</a:t>
+            </a:r>
+          </a:p>
+        </p:txBody>
+      </p:sp>
+      <p:sp>
+        <p:nvSpPr>
+          <p:cNvPr id="78" name="Rounded Rectangle 77"/>
           <p:cNvSpPr/>
           <p:nvPr/>
         </p:nvSpPr>
@@ -7860,7 +7321,7 @@
       </p:sp>
       <p:sp>
         <p:nvSpPr>
-          <p:cNvPr id="93" name="TextBox 92"/>
+          <p:cNvPr id="79" name="TextBox 78"/>
           <p:cNvSpPr txBox="1"/>
           <p:nvPr/>
         </p:nvSpPr>
@@ -7895,7 +7356,7 @@
       </p:sp>
       <p:sp>
         <p:nvSpPr>
-          <p:cNvPr id="94" name="Rounded Rectangle 93"/>
+          <p:cNvPr id="80" name="Rounded Rectangle 79"/>
           <p:cNvSpPr/>
           <p:nvPr/>
         </p:nvSpPr>
@@ -7943,7 +7404,7 @@
       </p:sp>
       <p:sp>
         <p:nvSpPr>
-          <p:cNvPr id="95" name="Oval 94"/>
+          <p:cNvPr id="81" name="Oval 80"/>
           <p:cNvSpPr/>
           <p:nvPr/>
         </p:nvSpPr>
@@ -7996,7 +7457,7 @@
       </p:sp>
       <p:sp>
         <p:nvSpPr>
-          <p:cNvPr id="96" name="TextBox 95"/>
+          <p:cNvPr id="82" name="TextBox 81"/>
           <p:cNvSpPr txBox="1"/>
           <p:nvPr/>
         </p:nvSpPr>
@@ -8031,7 +7492,7 @@
       </p:sp>
       <p:sp>
         <p:nvSpPr>
-          <p:cNvPr id="97" name="Oval 96"/>
+          <p:cNvPr id="83" name="Oval 82"/>
           <p:cNvSpPr/>
           <p:nvPr/>
         </p:nvSpPr>
@@ -8084,7 +7545,7 @@
       </p:sp>
       <p:sp>
         <p:nvSpPr>
-          <p:cNvPr id="98" name="Rounded Rectangle 97"/>
+          <p:cNvPr id="84" name="Rounded Rectangle 83"/>
           <p:cNvSpPr/>
           <p:nvPr/>
         </p:nvSpPr>
@@ -8131,7 +7592,7 @@
       </p:sp>
       <p:sp>
         <p:nvSpPr>
-          <p:cNvPr id="99" name="TextBox 98"/>
+          <p:cNvPr id="85" name="TextBox 84"/>
           <p:cNvSpPr txBox="1"/>
           <p:nvPr/>
         </p:nvSpPr>
@@ -8166,7 +7627,7 @@
       </p:sp>
       <p:sp>
         <p:nvSpPr>
-          <p:cNvPr id="100" name="Oval 99"/>
+          <p:cNvPr id="86" name="Oval 85"/>
           <p:cNvSpPr/>
           <p:nvPr/>
         </p:nvSpPr>
@@ -8219,7 +7680,7 @@
       </p:sp>
       <p:sp>
         <p:nvSpPr>
-          <p:cNvPr id="101" name="Rounded Rectangle 100"/>
+          <p:cNvPr id="87" name="Rounded Rectangle 86"/>
           <p:cNvSpPr/>
           <p:nvPr/>
         </p:nvSpPr>
@@ -8266,7 +7727,7 @@
       </p:sp>
       <p:sp>
         <p:nvSpPr>
-          <p:cNvPr id="102" name="TextBox 101"/>
+          <p:cNvPr id="88" name="TextBox 87"/>
           <p:cNvSpPr txBox="1"/>
           <p:nvPr/>
         </p:nvSpPr>
@@ -8301,7 +7762,7 @@
       </p:sp>
       <p:sp>
         <p:nvSpPr>
-          <p:cNvPr id="103" name="Oval 102"/>
+          <p:cNvPr id="89" name="Oval 88"/>
           <p:cNvSpPr/>
           <p:nvPr/>
         </p:nvSpPr>
@@ -8354,7 +7815,7 @@
       </p:sp>
       <p:sp>
         <p:nvSpPr>
-          <p:cNvPr id="104" name="Rounded Rectangle 103"/>
+          <p:cNvPr id="90" name="Rounded Rectangle 89"/>
           <p:cNvSpPr/>
           <p:nvPr/>
         </p:nvSpPr>
@@ -8401,7 +7862,7 @@
       </p:sp>
       <p:sp>
         <p:nvSpPr>
-          <p:cNvPr id="105" name="TextBox 104"/>
+          <p:cNvPr id="91" name="TextBox 90"/>
           <p:cNvSpPr txBox="1"/>
           <p:nvPr/>
         </p:nvSpPr>
@@ -8436,7 +7897,7 @@
       </p:sp>
       <p:sp>
         <p:nvSpPr>
-          <p:cNvPr id="106" name="Oval 105"/>
+          <p:cNvPr id="92" name="Oval 91"/>
           <p:cNvSpPr/>
           <p:nvPr/>
         </p:nvSpPr>
@@ -8489,7 +7950,7 @@
       </p:sp>
       <p:sp>
         <p:nvSpPr>
-          <p:cNvPr id="107" name="Rounded Rectangle 106"/>
+          <p:cNvPr id="93" name="Rounded Rectangle 92"/>
           <p:cNvSpPr/>
           <p:nvPr/>
         </p:nvSpPr>
@@ -8536,7 +7997,7 @@
       </p:sp>
       <p:sp>
         <p:nvSpPr>
-          <p:cNvPr id="108" name="TextBox 107"/>
+          <p:cNvPr id="94" name="TextBox 93"/>
           <p:cNvSpPr txBox="1"/>
           <p:nvPr/>
         </p:nvSpPr>
@@ -8571,7 +8032,7 @@
       </p:sp>
       <p:sp>
         <p:nvSpPr>
-          <p:cNvPr id="109" name="Rounded Rectangle 108"/>
+          <p:cNvPr id="95" name="Rounded Rectangle 94"/>
           <p:cNvSpPr/>
           <p:nvPr/>
         </p:nvSpPr>
@@ -8619,7 +8080,7 @@
       </p:sp>
       <p:sp>
         <p:nvSpPr>
-          <p:cNvPr id="110" name="Oval 109"/>
+          <p:cNvPr id="96" name="Oval 95"/>
           <p:cNvSpPr/>
           <p:nvPr/>
         </p:nvSpPr>
@@ -8672,7 +8133,7 @@
       </p:sp>
       <p:sp>
         <p:nvSpPr>
-          <p:cNvPr id="111" name="TextBox 110"/>
+          <p:cNvPr id="97" name="TextBox 96"/>
           <p:cNvSpPr txBox="1"/>
           <p:nvPr/>
         </p:nvSpPr>
@@ -8707,7 +8168,7 @@
       </p:sp>
       <p:grpSp>
         <p:nvGrpSpPr>
-          <p:cNvPr id="112" name="Bieu do khai gian"/>
+          <p:cNvPr id="98" name="Bieu do khai gian"/>
           <p:cNvGrpSpPr/>
           <p:nvPr/>
         </p:nvGrpSpPr>
@@ -8721,7 +8182,7 @@
         </p:grpSpPr>
         <p:graphicFrame>
           <p:nvGraphicFramePr>
-            <p:cNvPr id="116" name="Chart 115"/>
+            <p:cNvPr id="102" name="Chart 101"/>
             <p:cNvGraphicFramePr>
               <a:graphicFrameLocks noGrp="1"/>
             </p:cNvGraphicFramePr>
@@ -8740,7 +8201,7 @@
       </p:grpSp>
       <p:sp>
         <p:nvSpPr>
-          <p:cNvPr id="113" name="TextBox 112"/>
+          <p:cNvPr id="99" name="TextBox 98"/>
           <p:cNvSpPr txBox="1"/>
           <p:nvPr/>
         </p:nvSpPr>
@@ -8775,7 +8236,7 @@
       </p:sp>
       <p:sp>
         <p:nvSpPr>
-          <p:cNvPr id="114" name="TextBox 113"/>
+          <p:cNvPr id="100" name="TextBox 99"/>
           <p:cNvSpPr txBox="1"/>
           <p:nvPr/>
         </p:nvSpPr>
@@ -8810,7 +8271,7 @@
       </p:sp>
       <p:sp>
         <p:nvSpPr>
-          <p:cNvPr id="115" name="TextBox 114"/>
+          <p:cNvPr id="101" name="TextBox 100"/>
           <p:cNvSpPr txBox="1"/>
           <p:nvPr/>
         </p:nvSpPr>
@@ -8845,7 +8306,7 @@
       </p:sp>
       <p:grpSp>
         <p:nvGrpSpPr>
-          <p:cNvPr id="117" name="Bieu do nguyen vong"/>
+          <p:cNvPr id="103" name="Bieu do nguyen vong"/>
           <p:cNvGrpSpPr/>
           <p:nvPr/>
         </p:nvGrpSpPr>
@@ -8859,7 +8320,7 @@
         </p:grpSpPr>
         <p:graphicFrame>
           <p:nvGraphicFramePr>
-            <p:cNvPr id="121" name="Chart 120"/>
+            <p:cNvPr id="107" name="Chart 106"/>
             <p:cNvGraphicFramePr>
               <a:graphicFrameLocks noGrp="1"/>
             </p:cNvGraphicFramePr>
@@ -8878,7 +8339,7 @@
       </p:grpSp>
       <p:sp>
         <p:nvSpPr>
-          <p:cNvPr id="118" name="TextBox 117"/>
+          <p:cNvPr id="104" name="TextBox 103"/>
           <p:cNvSpPr txBox="1"/>
           <p:nvPr/>
         </p:nvSpPr>
@@ -8913,7 +8374,7 @@
       </p:sp>
       <p:sp>
         <p:nvSpPr>
-          <p:cNvPr id="119" name="TextBox 118"/>
+          <p:cNvPr id="105" name="TextBox 104"/>
           <p:cNvSpPr txBox="1"/>
           <p:nvPr/>
         </p:nvSpPr>
@@ -8948,7 +8409,7 @@
       </p:sp>
       <p:sp>
         <p:nvSpPr>
-          <p:cNvPr id="120" name="TextBox 119"/>
+          <p:cNvPr id="106" name="TextBox 105"/>
           <p:cNvSpPr txBox="1"/>
           <p:nvPr/>
         </p:nvSpPr>
@@ -8983,7 +8444,7 @@
       </p:sp>
       <p:sp>
         <p:nvSpPr>
-          <p:cNvPr id="122" name="Rounded Rectangle 121"/>
+          <p:cNvPr id="108" name="Rounded Rectangle 107"/>
           <p:cNvSpPr/>
           <p:nvPr/>
         </p:nvSpPr>
@@ -9030,7 +8491,7 @@
       </p:sp>
       <p:sp>
         <p:nvSpPr>
-          <p:cNvPr id="123" name="TextBox 122"/>
+          <p:cNvPr id="109" name="TextBox 108"/>
           <p:cNvSpPr txBox="1"/>
           <p:nvPr/>
         </p:nvSpPr>
@@ -9065,7 +8526,7 @@
       </p:sp>
       <p:sp>
         <p:nvSpPr>
-          <p:cNvPr id="124" name="Rounded Rectangle 123"/>
+          <p:cNvPr id="110" name="Rounded Rectangle 109"/>
           <p:cNvSpPr/>
           <p:nvPr/>
         </p:nvSpPr>
@@ -9113,7 +8574,7 @@
       </p:sp>
       <p:sp>
         <p:nvSpPr>
-          <p:cNvPr id="125" name="TextBox 124"/>
+          <p:cNvPr id="111" name="TextBox 110"/>
           <p:cNvSpPr txBox="1"/>
           <p:nvPr/>
         </p:nvSpPr>
@@ -9148,7 +8609,7 @@
       </p:sp>
       <p:sp>
         <p:nvSpPr>
-          <p:cNvPr id="126" name="Rounded Rectangle 125"/>
+          <p:cNvPr id="112" name="Rounded Rectangle 111"/>
           <p:cNvSpPr/>
           <p:nvPr/>
         </p:nvSpPr>
@@ -9195,7 +8656,7 @@
       </p:sp>
       <p:sp>
         <p:nvSpPr>
-          <p:cNvPr id="127" name="TextBox 126"/>
+          <p:cNvPr id="113" name="TextBox 112"/>
           <p:cNvSpPr txBox="1"/>
           <p:nvPr/>
         </p:nvSpPr>

</xml_diff>

<commit_message>
Replace the remaining English 'seed' labels on the poster
Co-Authored-By: Claude Opus 5.5 <noreply@anthropic.com>
Claude-Session: https://claude.ai/code/session_01NkYGd36L1Tpym32yxKyitD
</commit_message>
<xml_diff>
--- a/poster/poster_khung_1-2.pptx
+++ b/poster/poster_khung_1-2.pptx
@@ -5444,7 +5444,7 @@
                 </a:solidFill>
                 <a:latin typeface="IBM Plex Sans"/>
               </a:rPr>
-              <a:t>cặp phá vỡ · mọi seed, mọi bộ dữ liệu mô phỏng</a:t>
+              <a:t>cặp phá vỡ · mọi lần bốc thăm, mọi bộ dữ liệu mô phỏng</a:t>
             </a:r>
           </a:p>
           <a:p>
@@ -8402,7 +8402,7 @@
                 </a:solidFill>
                 <a:latin typeface="IBM Plex Sans"/>
               </a:rPr>
-              <a:t>108 em được xếp · bộ 120 học sinh, 10 CLB · seed 42</a:t>
+              <a:t>108 em được xếp · bộ 120 học sinh, 10 CLB · hạt giống bốc thăm 42</a:t>
             </a:r>
           </a:p>
         </p:txBody>

</xml_diff>

<commit_message>
Detail the process diagram and explain the lottery on the poster
The top row now spells out each step (two priority tiers, the four
rounds of review, the two reserved-seat passes, the stability check)
and a new bottom band explains the lottery in four cards: one number
per student shared by all clubs, used only to break ties or for
students who did not sit the club's test, reproducible from the same
seed, and locked once drawn. All labels are Vietnamese.

Co-Authored-By: Claude Opus 5.5 <noreply@anthropic.com>
Claude-Session: https://claude.ai/code/session_01NkYGd36L1Tpym32yxKyitD
</commit_message>
<xml_diff>
--- a/poster/poster_khung_1-2.pptx
+++ b/poster/poster_khung_1-2.pptx
@@ -5922,8 +5922,8 @@
         </p:nvSpPr>
         <p:spPr>
           <a:xfrm>
-            <a:off x="10048200" y="19537950"/>
-            <a:ext cx="2604900" cy="2056500"/>
+            <a:off x="9979650" y="17755650"/>
+            <a:ext cx="2056500" cy="3838800"/>
           </a:xfrm>
           <a:prstGeom prst="roundRect">
             <a:avLst>
@@ -5970,8 +5970,8 @@
         </p:nvSpPr>
         <p:spPr>
           <a:xfrm>
-            <a:off x="10294980" y="19801182"/>
-            <a:ext cx="180000" cy="392106"/>
+            <a:off x="10199010" y="17988720"/>
+            <a:ext cx="180000" cy="356460"/>
           </a:xfrm>
           <a:prstGeom prst="rect">
             <a:avLst/>
@@ -5986,7 +5986,7 @@
           <a:p>
             <a:pPr algn="l"/>
             <a:r>
-              <a:rPr sz="2374" b="1" i="0">
+              <a:rPr sz="2159" b="1" i="0">
                 <a:solidFill>
                   <a:srgbClr val="1C2321"/>
                 </a:solidFill>
@@ -6005,8 +6005,8 @@
         </p:nvSpPr>
         <p:spPr>
           <a:xfrm>
-            <a:off x="10294980" y="20356437"/>
-            <a:ext cx="180000" cy="302991"/>
+            <a:off x="10199010" y="18487764"/>
+            <a:ext cx="180000" cy="249522"/>
           </a:xfrm>
           <a:prstGeom prst="rect">
             <a:avLst/>
@@ -6021,7 +6021,7 @@
           <a:p>
             <a:pPr algn="l"/>
             <a:r>
-              <a:rPr sz="1835" b="0" i="0">
+              <a:rPr sz="1511" b="0" i="0">
                 <a:solidFill>
                   <a:srgbClr val="5B6570"/>
                 </a:solidFill>
@@ -6040,8 +6040,8 @@
         </p:nvSpPr>
         <p:spPr>
           <a:xfrm>
-            <a:off x="10294980" y="20726607"/>
-            <a:ext cx="180000" cy="302991"/>
+            <a:off x="10199010" y="18775674"/>
+            <a:ext cx="180000" cy="249522"/>
           </a:xfrm>
           <a:prstGeom prst="rect">
             <a:avLst/>
@@ -6056,7 +6056,112 @@
           <a:p>
             <a:pPr algn="l"/>
             <a:r>
-              <a:rPr sz="1835" b="0" i="0">
+              <a:rPr sz="1511" b="0" i="0">
+                <a:solidFill>
+                  <a:srgbClr val="5B6570"/>
+                </a:solidFill>
+                <a:latin typeface="IBM Plex Sans"/>
+              </a:rPr>
+              <a:t>· số chỗ</a:t>
+            </a:r>
+          </a:p>
+        </p:txBody>
+      </p:sp>
+      <p:sp>
+        <p:nvSpPr>
+          <p:cNvPr id="48" name="TextBox 47"/>
+          <p:cNvSpPr txBox="1"/>
+          <p:nvPr/>
+        </p:nvSpPr>
+        <p:spPr>
+          <a:xfrm>
+            <a:off x="10199010" y="19063584"/>
+            <a:ext cx="180000" cy="249522"/>
+          </a:xfrm>
+          <a:prstGeom prst="rect">
+            <a:avLst/>
+          </a:prstGeom>
+          <a:noFill/>
+        </p:spPr>
+        <p:txBody>
+          <a:bodyPr wrap="none" anchor="t" lIns="0" rIns="0" tIns="0" bIns="0">
+            <a:spAutoFit/>
+          </a:bodyPr>
+          <a:lstStyle/>
+          <a:p>
+            <a:pPr algn="l"/>
+            <a:r>
+              <a:rPr sz="1511" b="0" i="0">
+                <a:solidFill>
+                  <a:srgbClr val="5B6570"/>
+                </a:solidFill>
+                <a:latin typeface="IBM Plex Sans"/>
+              </a:rPr>
+              <a:t>· suất dự trữ</a:t>
+            </a:r>
+          </a:p>
+        </p:txBody>
+      </p:sp>
+      <p:sp>
+        <p:nvSpPr>
+          <p:cNvPr id="49" name="TextBox 48"/>
+          <p:cNvSpPr txBox="1"/>
+          <p:nvPr/>
+        </p:nvSpPr>
+        <p:spPr>
+          <a:xfrm>
+            <a:off x="10199010" y="19351494"/>
+            <a:ext cx="180000" cy="249522"/>
+          </a:xfrm>
+          <a:prstGeom prst="rect">
+            <a:avLst/>
+          </a:prstGeom>
+          <a:noFill/>
+        </p:spPr>
+        <p:txBody>
+          <a:bodyPr wrap="none" anchor="t" lIns="0" rIns="0" tIns="0" bIns="0">
+            <a:spAutoFit/>
+          </a:bodyPr>
+          <a:lstStyle/>
+          <a:p>
+            <a:pPr algn="l"/>
+            <a:r>
+              <a:rPr sz="1511" b="0" i="0">
+                <a:solidFill>
+                  <a:srgbClr val="5B6570"/>
+                </a:solidFill>
+                <a:latin typeface="IBM Plex Sans"/>
+              </a:rPr>
+              <a:t/>
+            </a:r>
+          </a:p>
+        </p:txBody>
+      </p:sp>
+      <p:sp>
+        <p:nvSpPr>
+          <p:cNvPr id="50" name="TextBox 49"/>
+          <p:cNvSpPr txBox="1"/>
+          <p:nvPr/>
+        </p:nvSpPr>
+        <p:spPr>
+          <a:xfrm>
+            <a:off x="10199010" y="19639404"/>
+            <a:ext cx="180000" cy="249522"/>
+          </a:xfrm>
+          <a:prstGeom prst="rect">
+            <a:avLst/>
+          </a:prstGeom>
+          <a:noFill/>
+        </p:spPr>
+        <p:txBody>
+          <a:bodyPr wrap="none" anchor="t" lIns="0" rIns="0" tIns="0" bIns="0">
+            <a:spAutoFit/>
+          </a:bodyPr>
+          <a:lstStyle/>
+          <a:p>
+            <a:pPr algn="l"/>
+            <a:r>
+              <a:rPr sz="1511" b="0" i="0">
                 <a:solidFill>
                   <a:srgbClr val="5B6570"/>
                 </a:solidFill>
@@ -6069,14 +6174,14 @@
       </p:sp>
       <p:sp>
         <p:nvSpPr>
-          <p:cNvPr id="48" name="TextBox 47"/>
+          <p:cNvPr id="51" name="TextBox 50"/>
           <p:cNvSpPr txBox="1"/>
           <p:nvPr/>
         </p:nvSpPr>
         <p:spPr>
           <a:xfrm>
-            <a:off x="10294980" y="21096777"/>
-            <a:ext cx="180000" cy="302991"/>
+            <a:off x="10199010" y="19927314"/>
+            <a:ext cx="180000" cy="249522"/>
           </a:xfrm>
           <a:prstGeom prst="rect">
             <a:avLst/>
@@ -6091,7 +6196,77 @@
           <a:p>
             <a:pPr algn="l"/>
             <a:r>
-              <a:rPr sz="1835" b="0" i="0">
+              <a:rPr sz="1511" b="0" i="0">
+                <a:solidFill>
+                  <a:srgbClr val="5B6570"/>
+                </a:solidFill>
+                <a:latin typeface="IBM Plex Sans"/>
+              </a:rPr>
+              <a:t>· chấm mù</a:t>
+            </a:r>
+          </a:p>
+        </p:txBody>
+      </p:sp>
+      <p:sp>
+        <p:nvSpPr>
+          <p:cNvPr id="52" name="TextBox 51"/>
+          <p:cNvSpPr txBox="1"/>
+          <p:nvPr/>
+        </p:nvSpPr>
+        <p:spPr>
+          <a:xfrm>
+            <a:off x="10199010" y="20215224"/>
+            <a:ext cx="180000" cy="249522"/>
+          </a:xfrm>
+          <a:prstGeom prst="rect">
+            <a:avLst/>
+          </a:prstGeom>
+          <a:noFill/>
+        </p:spPr>
+        <p:txBody>
+          <a:bodyPr wrap="none" anchor="t" lIns="0" rIns="0" tIns="0" bIns="0">
+            <a:spAutoFit/>
+          </a:bodyPr>
+          <a:lstStyle/>
+          <a:p>
+            <a:pPr algn="l"/>
+            <a:r>
+              <a:rPr sz="1511" b="0" i="0">
+                <a:solidFill>
+                  <a:srgbClr val="5B6570"/>
+                </a:solidFill>
+                <a:latin typeface="IBM Plex Sans"/>
+              </a:rPr>
+              <a:t/>
+            </a:r>
+          </a:p>
+        </p:txBody>
+      </p:sp>
+      <p:sp>
+        <p:nvSpPr>
+          <p:cNvPr id="53" name="TextBox 52"/>
+          <p:cNvSpPr txBox="1"/>
+          <p:nvPr/>
+        </p:nvSpPr>
+        <p:spPr>
+          <a:xfrm>
+            <a:off x="10199010" y="20503134"/>
+            <a:ext cx="180000" cy="249522"/>
+          </a:xfrm>
+          <a:prstGeom prst="rect">
+            <a:avLst/>
+          </a:prstGeom>
+          <a:noFill/>
+        </p:spPr>
+        <p:txBody>
+          <a:bodyPr wrap="none" anchor="t" lIns="0" rIns="0" tIns="0" bIns="0">
+            <a:spAutoFit/>
+          </a:bodyPr>
+          <a:lstStyle/>
+          <a:p>
+            <a:pPr algn="l"/>
+            <a:r>
+              <a:rPr sz="1511" b="0" i="0">
                 <a:solidFill>
                   <a:srgbClr val="5B6570"/>
                 </a:solidFill>
@@ -6104,14 +6279,49 @@
       </p:sp>
       <p:sp>
         <p:nvSpPr>
-          <p:cNvPr id="49" name="Right Arrow 48"/>
+          <p:cNvPr id="54" name="TextBox 53"/>
+          <p:cNvSpPr txBox="1"/>
+          <p:nvPr/>
+        </p:nvSpPr>
+        <p:spPr>
+          <a:xfrm>
+            <a:off x="10199010" y="20791044"/>
+            <a:ext cx="180000" cy="249522"/>
+          </a:xfrm>
+          <a:prstGeom prst="rect">
+            <a:avLst/>
+          </a:prstGeom>
+          <a:noFill/>
+        </p:spPr>
+        <p:txBody>
+          <a:bodyPr wrap="none" anchor="t" lIns="0" rIns="0" tIns="0" bIns="0">
+            <a:spAutoFit/>
+          </a:bodyPr>
+          <a:lstStyle/>
+          <a:p>
+            <a:pPr algn="l"/>
+            <a:r>
+              <a:rPr sz="1511" b="0" i="0">
+                <a:solidFill>
+                  <a:srgbClr val="5B6570"/>
+                </a:solidFill>
+                <a:latin typeface="IBM Plex Sans"/>
+              </a:rPr>
+              <a:t>· xếp hạng CLB</a:t>
+            </a:r>
+          </a:p>
+        </p:txBody>
+      </p:sp>
+      <p:sp>
+        <p:nvSpPr>
+          <p:cNvPr id="55" name="Right Arrow 54"/>
           <p:cNvSpPr/>
           <p:nvPr/>
         </p:nvSpPr>
         <p:spPr>
           <a:xfrm>
-            <a:off x="12653100" y="20456520"/>
-            <a:ext cx="479850" cy="219360"/>
+            <a:off x="12036149" y="19565370"/>
+            <a:ext cx="411300" cy="219360"/>
           </a:xfrm>
           <a:prstGeom prst="rightArrow">
             <a:avLst/>
@@ -6148,18 +6358,18 @@
       </p:sp>
       <p:sp>
         <p:nvSpPr>
-          <p:cNvPr id="50" name="Rounded Rectangle 49"/>
+          <p:cNvPr id="56" name="Rounded Rectangle 55"/>
           <p:cNvSpPr/>
           <p:nvPr/>
         </p:nvSpPr>
         <p:spPr>
           <a:xfrm>
-            <a:off x="13132950" y="19537950"/>
-            <a:ext cx="3290400" cy="2056500"/>
+            <a:off x="12447450" y="17755650"/>
+            <a:ext cx="3975900" cy="3838800"/>
           </a:xfrm>
           <a:prstGeom prst="roundRect">
             <a:avLst>
-              <a:gd name="adj" fmla="val 6000"/>
+              <a:gd name="adj" fmla="val 3214"/>
             </a:avLst>
           </a:prstGeom>
           <a:solidFill>
@@ -6196,14 +6406,14 @@
       </p:sp>
       <p:sp>
         <p:nvSpPr>
-          <p:cNvPr id="51" name="Oval 50"/>
+          <p:cNvPr id="57" name="Oval 56"/>
           <p:cNvSpPr/>
           <p:nvPr/>
         </p:nvSpPr>
         <p:spPr>
           <a:xfrm>
-            <a:off x="13324889" y="19743600"/>
-            <a:ext cx="438720" cy="438720"/>
+            <a:off x="12625680" y="17947590"/>
+            <a:ext cx="411300" cy="411300"/>
           </a:xfrm>
           <a:prstGeom prst="ellipse">
             <a:avLst/>
@@ -6249,14 +6459,14 @@
       </p:sp>
       <p:sp>
         <p:nvSpPr>
-          <p:cNvPr id="52" name="TextBox 51"/>
+          <p:cNvPr id="58" name="TextBox 57"/>
           <p:cNvSpPr txBox="1"/>
           <p:nvPr/>
         </p:nvSpPr>
         <p:spPr>
           <a:xfrm>
-            <a:off x="13900710" y="19801182"/>
-            <a:ext cx="180000" cy="392106"/>
+            <a:off x="13160370" y="17988720"/>
+            <a:ext cx="180000" cy="356460"/>
           </a:xfrm>
           <a:prstGeom prst="rect">
             <a:avLst/>
@@ -6271,27 +6481,27 @@
           <a:p>
             <a:pPr algn="l"/>
             <a:r>
-              <a:rPr sz="2374" b="1" i="0">
+              <a:rPr sz="2159" b="1" i="0">
                 <a:solidFill>
                   <a:srgbClr val="1C2321"/>
                 </a:solidFill>
                 <a:latin typeface="Be Vietnam Pro"/>
               </a:rPr>
-              <a:t>Xếp ưu tiên</a:t>
-            </a:r>
-          </a:p>
-        </p:txBody>
-      </p:sp>
-      <p:sp>
-        <p:nvSpPr>
-          <p:cNvPr id="53" name="TextBox 52"/>
+              <a:t>Xếp ưu tiên ở mỗi CLB</a:t>
+            </a:r>
+          </a:p>
+        </p:txBody>
+      </p:sp>
+      <p:sp>
+        <p:nvSpPr>
+          <p:cNvPr id="59" name="TextBox 58"/>
           <p:cNvSpPr txBox="1"/>
           <p:nvPr/>
         </p:nvSpPr>
         <p:spPr>
           <a:xfrm>
-            <a:off x="13379730" y="20356437"/>
-            <a:ext cx="180000" cy="302991"/>
+            <a:off x="12666810" y="18487764"/>
+            <a:ext cx="180000" cy="249522"/>
           </a:xfrm>
           <a:prstGeom prst="rect">
             <a:avLst/>
@@ -6306,27 +6516,27 @@
           <a:p>
             <a:pPr algn="l"/>
             <a:r>
-              <a:rPr sz="1835" b="0" i="0">
+              <a:rPr sz="1511" b="0" i="0">
                 <a:solidFill>
                   <a:srgbClr val="5B6570"/>
                 </a:solidFill>
                 <a:latin typeface="IBM Plex Sans"/>
               </a:rPr>
-              <a:t>Đã thi → theo điểm</a:t>
-            </a:r>
-          </a:p>
-        </p:txBody>
-      </p:sp>
-      <p:sp>
-        <p:nvSpPr>
-          <p:cNvPr id="54" name="TextBox 53"/>
+              <a:t>Tầng 1 · em đã thi CLB đó</a:t>
+            </a:r>
+          </a:p>
+        </p:txBody>
+      </p:sp>
+      <p:sp>
+        <p:nvSpPr>
+          <p:cNvPr id="60" name="TextBox 59"/>
           <p:cNvSpPr txBox="1"/>
           <p:nvPr/>
         </p:nvSpPr>
         <p:spPr>
           <a:xfrm>
-            <a:off x="13379730" y="20726607"/>
-            <a:ext cx="180000" cy="302991"/>
+            <a:off x="12666810" y="18775674"/>
+            <a:ext cx="180000" cy="249522"/>
           </a:xfrm>
           <a:prstGeom prst="rect">
             <a:avLst/>
@@ -6341,27 +6551,27 @@
           <a:p>
             <a:pPr algn="l"/>
             <a:r>
-              <a:rPr sz="1835" b="0" i="0">
+              <a:rPr sz="1511" b="0" i="0">
                 <a:solidFill>
                   <a:srgbClr val="5B6570"/>
                 </a:solidFill>
                 <a:latin typeface="IBM Plex Sans"/>
               </a:rPr>
-              <a:t>Bằng điểm → bốc thăm</a:t>
-            </a:r>
-          </a:p>
-        </p:txBody>
-      </p:sp>
-      <p:sp>
-        <p:nvSpPr>
-          <p:cNvPr id="55" name="TextBox 54"/>
+              <a:t>· điểm cao xếp trước</a:t>
+            </a:r>
+          </a:p>
+        </p:txBody>
+      </p:sp>
+      <p:sp>
+        <p:nvSpPr>
+          <p:cNvPr id="61" name="TextBox 60"/>
           <p:cNvSpPr txBox="1"/>
           <p:nvPr/>
         </p:nvSpPr>
         <p:spPr>
           <a:xfrm>
-            <a:off x="13379730" y="21096777"/>
-            <a:ext cx="180000" cy="302991"/>
+            <a:off x="12666810" y="19063584"/>
+            <a:ext cx="180000" cy="249522"/>
           </a:xfrm>
           <a:prstGeom prst="rect">
             <a:avLst/>
@@ -6376,27 +6586,237 @@
           <a:p>
             <a:pPr algn="l"/>
             <a:r>
-              <a:rPr sz="1835" b="0" i="0">
+              <a:rPr sz="1511" b="0" i="0">
                 <a:solidFill>
                   <a:srgbClr val="5B6570"/>
                 </a:solidFill>
                 <a:latin typeface="IBM Plex Sans"/>
               </a:rPr>
-              <a:t>Không thi → bốc thăm</a:t>
-            </a:r>
-          </a:p>
-        </p:txBody>
-      </p:sp>
-      <p:sp>
-        <p:nvSpPr>
-          <p:cNvPr id="56" name="Right Arrow 55"/>
+              <a:t>· bằng điểm → số bốc thăm nhỏ trước</a:t>
+            </a:r>
+          </a:p>
+        </p:txBody>
+      </p:sp>
+      <p:sp>
+        <p:nvSpPr>
+          <p:cNvPr id="62" name="TextBox 61"/>
+          <p:cNvSpPr txBox="1"/>
+          <p:nvPr/>
+        </p:nvSpPr>
+        <p:spPr>
+          <a:xfrm>
+            <a:off x="12666810" y="19351494"/>
+            <a:ext cx="180000" cy="249522"/>
+          </a:xfrm>
+          <a:prstGeom prst="rect">
+            <a:avLst/>
+          </a:prstGeom>
+          <a:noFill/>
+        </p:spPr>
+        <p:txBody>
+          <a:bodyPr wrap="none" anchor="t" lIns="0" rIns="0" tIns="0" bIns="0">
+            <a:spAutoFit/>
+          </a:bodyPr>
+          <a:lstStyle/>
+          <a:p>
+            <a:pPr algn="l"/>
+            <a:r>
+              <a:rPr sz="1511" b="0" i="0">
+                <a:solidFill>
+                  <a:srgbClr val="5B6570"/>
+                </a:solidFill>
+                <a:latin typeface="IBM Plex Sans"/>
+              </a:rPr>
+              <a:t>Tầng 2 · em không thi CLB đó</a:t>
+            </a:r>
+          </a:p>
+        </p:txBody>
+      </p:sp>
+      <p:sp>
+        <p:nvSpPr>
+          <p:cNvPr id="63" name="TextBox 62"/>
+          <p:cNvSpPr txBox="1"/>
+          <p:nvPr/>
+        </p:nvSpPr>
+        <p:spPr>
+          <a:xfrm>
+            <a:off x="12666810" y="19639404"/>
+            <a:ext cx="180000" cy="249522"/>
+          </a:xfrm>
+          <a:prstGeom prst="rect">
+            <a:avLst/>
+          </a:prstGeom>
+          <a:noFill/>
+        </p:spPr>
+        <p:txBody>
+          <a:bodyPr wrap="none" anchor="t" lIns="0" rIns="0" tIns="0" bIns="0">
+            <a:spAutoFit/>
+          </a:bodyPr>
+          <a:lstStyle/>
+          <a:p>
+            <a:pPr algn="l"/>
+            <a:r>
+              <a:rPr sz="1511" b="0" i="0">
+                <a:solidFill>
+                  <a:srgbClr val="5B6570"/>
+                </a:solidFill>
+                <a:latin typeface="IBM Plex Sans"/>
+              </a:rPr>
+              <a:t>· xếp theo số bốc thăm</a:t>
+            </a:r>
+          </a:p>
+        </p:txBody>
+      </p:sp>
+      <p:sp>
+        <p:nvSpPr>
+          <p:cNvPr id="64" name="TextBox 63"/>
+          <p:cNvSpPr txBox="1"/>
+          <p:nvPr/>
+        </p:nvSpPr>
+        <p:spPr>
+          <a:xfrm>
+            <a:off x="12666810" y="19927314"/>
+            <a:ext cx="180000" cy="249522"/>
+          </a:xfrm>
+          <a:prstGeom prst="rect">
+            <a:avLst/>
+          </a:prstGeom>
+          <a:noFill/>
+        </p:spPr>
+        <p:txBody>
+          <a:bodyPr wrap="none" anchor="t" lIns="0" rIns="0" tIns="0" bIns="0">
+            <a:spAutoFit/>
+          </a:bodyPr>
+          <a:lstStyle/>
+          <a:p>
+            <a:pPr algn="l"/>
+            <a:r>
+              <a:rPr sz="1511" b="0" i="0">
+                <a:solidFill>
+                  <a:srgbClr val="5B6570"/>
+                </a:solidFill>
+                <a:latin typeface="IBM Plex Sans"/>
+              </a:rPr>
+              <a:t>Tầng 1 luôn đứng trước tầng 2</a:t>
+            </a:r>
+          </a:p>
+        </p:txBody>
+      </p:sp>
+      <p:sp>
+        <p:nvSpPr>
+          <p:cNvPr id="65" name="TextBox 64"/>
+          <p:cNvSpPr txBox="1"/>
+          <p:nvPr/>
+        </p:nvSpPr>
+        <p:spPr>
+          <a:xfrm>
+            <a:off x="12666810" y="20215224"/>
+            <a:ext cx="180000" cy="249522"/>
+          </a:xfrm>
+          <a:prstGeom prst="rect">
+            <a:avLst/>
+          </a:prstGeom>
+          <a:noFill/>
+        </p:spPr>
+        <p:txBody>
+          <a:bodyPr wrap="none" anchor="t" lIns="0" rIns="0" tIns="0" bIns="0">
+            <a:spAutoFit/>
+          </a:bodyPr>
+          <a:lstStyle/>
+          <a:p>
+            <a:pPr algn="l"/>
+            <a:r>
+              <a:rPr sz="1511" b="0" i="0">
+                <a:solidFill>
+                  <a:srgbClr val="5B6570"/>
+                </a:solidFill>
+                <a:latin typeface="IBM Plex Sans"/>
+              </a:rPr>
+              <a:t/>
+            </a:r>
+          </a:p>
+        </p:txBody>
+      </p:sp>
+      <p:sp>
+        <p:nvSpPr>
+          <p:cNvPr id="66" name="TextBox 65"/>
+          <p:cNvSpPr txBox="1"/>
+          <p:nvPr/>
+        </p:nvSpPr>
+        <p:spPr>
+          <a:xfrm>
+            <a:off x="12666810" y="20503134"/>
+            <a:ext cx="180000" cy="249522"/>
+          </a:xfrm>
+          <a:prstGeom prst="rect">
+            <a:avLst/>
+          </a:prstGeom>
+          <a:noFill/>
+        </p:spPr>
+        <p:txBody>
+          <a:bodyPr wrap="none" anchor="t" lIns="0" rIns="0" tIns="0" bIns="0">
+            <a:spAutoFit/>
+          </a:bodyPr>
+          <a:lstStyle/>
+          <a:p>
+            <a:pPr algn="l"/>
+            <a:r>
+              <a:rPr sz="1511" b="0" i="0">
+                <a:solidFill>
+                  <a:srgbClr val="5B6570"/>
+                </a:solidFill>
+                <a:latin typeface="IBM Plex Sans"/>
+              </a:rPr>
+              <a:t>CLB không biết em chọn mình</a:t>
+            </a:r>
+          </a:p>
+        </p:txBody>
+      </p:sp>
+      <p:sp>
+        <p:nvSpPr>
+          <p:cNvPr id="67" name="TextBox 66"/>
+          <p:cNvSpPr txBox="1"/>
+          <p:nvPr/>
+        </p:nvSpPr>
+        <p:spPr>
+          <a:xfrm>
+            <a:off x="12666810" y="20791044"/>
+            <a:ext cx="180000" cy="249522"/>
+          </a:xfrm>
+          <a:prstGeom prst="rect">
+            <a:avLst/>
+          </a:prstGeom>
+          <a:noFill/>
+        </p:spPr>
+        <p:txBody>
+          <a:bodyPr wrap="none" anchor="t" lIns="0" rIns="0" tIns="0" bIns="0">
+            <a:spAutoFit/>
+          </a:bodyPr>
+          <a:lstStyle/>
+          <a:p>
+            <a:pPr algn="l"/>
+            <a:r>
+              <a:rPr sz="1511" b="0" i="0">
+                <a:solidFill>
+                  <a:srgbClr val="5B6570"/>
+                </a:solidFill>
+                <a:latin typeface="IBM Plex Sans"/>
+              </a:rPr>
+              <a:t>là nguyện vọng thứ mấy</a:t>
+            </a:r>
+          </a:p>
+        </p:txBody>
+      </p:sp>
+      <p:sp>
+        <p:nvSpPr>
+          <p:cNvPr id="68" name="Right Arrow 67"/>
           <p:cNvSpPr/>
           <p:nvPr/>
         </p:nvSpPr>
         <p:spPr>
           <a:xfrm>
-            <a:off x="16423350" y="20456520"/>
-            <a:ext cx="479850" cy="219360"/>
+            <a:off x="16423350" y="19565370"/>
+            <a:ext cx="411300" cy="219360"/>
           </a:xfrm>
           <a:prstGeom prst="rightArrow">
             <a:avLst/>
@@ -6433,18 +6853,18 @@
       </p:sp>
       <p:sp>
         <p:nvSpPr>
-          <p:cNvPr id="57" name="Rounded Rectangle 56"/>
+          <p:cNvPr id="69" name="Rounded Rectangle 68"/>
           <p:cNvSpPr/>
           <p:nvPr/>
         </p:nvSpPr>
         <p:spPr>
           <a:xfrm>
-            <a:off x="16903200" y="18372600"/>
-            <a:ext cx="5346900" cy="4387200"/>
+            <a:off x="16834650" y="17755650"/>
+            <a:ext cx="5278350" cy="3838800"/>
           </a:xfrm>
           <a:prstGeom prst="roundRect">
             <a:avLst>
-              <a:gd name="adj" fmla="val 2812"/>
+              <a:gd name="adj" fmla="val 3214"/>
             </a:avLst>
           </a:prstGeom>
           <a:solidFill>
@@ -6481,14 +6901,14 @@
       </p:sp>
       <p:sp>
         <p:nvSpPr>
-          <p:cNvPr id="58" name="Oval 57"/>
+          <p:cNvPr id="70" name="Oval 69"/>
           <p:cNvSpPr/>
           <p:nvPr/>
         </p:nvSpPr>
         <p:spPr>
           <a:xfrm>
-            <a:off x="17095140" y="18578250"/>
-            <a:ext cx="438720" cy="438720"/>
+            <a:off x="17012880" y="17947590"/>
+            <a:ext cx="411300" cy="411300"/>
           </a:xfrm>
           <a:prstGeom prst="ellipse">
             <a:avLst/>
@@ -6534,14 +6954,14 @@
       </p:sp>
       <p:sp>
         <p:nvSpPr>
-          <p:cNvPr id="59" name="TextBox 58"/>
+          <p:cNvPr id="71" name="TextBox 70"/>
           <p:cNvSpPr txBox="1"/>
           <p:nvPr/>
         </p:nvSpPr>
         <p:spPr>
           <a:xfrm>
-            <a:off x="17670960" y="18635832"/>
-            <a:ext cx="180000" cy="392106"/>
+            <a:off x="17547570" y="18002430"/>
+            <a:ext cx="180000" cy="356460"/>
           </a:xfrm>
           <a:prstGeom prst="rect">
             <a:avLst/>
@@ -6556,7 +6976,7 @@
           <a:p>
             <a:pPr algn="l"/>
             <a:r>
-              <a:rPr sz="2374" b="1" i="0">
+              <a:rPr sz="2159" b="1" i="0">
                 <a:solidFill>
                   <a:srgbClr val="1C2321"/>
                 </a:solidFill>
@@ -6569,14 +6989,14 @@
       </p:sp>
       <p:sp>
         <p:nvSpPr>
-          <p:cNvPr id="60" name="TextBox 59"/>
+          <p:cNvPr id="72" name="TextBox 71"/>
           <p:cNvSpPr txBox="1"/>
           <p:nvPr/>
         </p:nvSpPr>
         <p:spPr>
           <a:xfrm>
-            <a:off x="17149980" y="19191087"/>
-            <a:ext cx="180000" cy="302991"/>
+            <a:off x="17054010" y="18501474"/>
+            <a:ext cx="180000" cy="249522"/>
           </a:xfrm>
           <a:prstGeom prst="rect">
             <a:avLst/>
@@ -6591,27 +7011,27 @@
           <a:p>
             <a:pPr algn="l"/>
             <a:r>
-              <a:rPr sz="1835" b="0" i="0">
+              <a:rPr sz="1511" b="0" i="0">
                 <a:solidFill>
                   <a:srgbClr val="5B6570"/>
                 </a:solidFill>
                 <a:latin typeface="IBM Plex Sans"/>
               </a:rPr>
-              <a:t>Học sinh nộp theo nguyện vọng</a:t>
-            </a:r>
-          </a:p>
-        </p:txBody>
-      </p:sp>
-      <p:sp>
-        <p:nvSpPr>
-          <p:cNvPr id="61" name="TextBox 60"/>
+              <a:t>1. Em nộp vào nguyện vọng cao nhất còn mở</a:t>
+            </a:r>
+          </a:p>
+        </p:txBody>
+      </p:sp>
+      <p:sp>
+        <p:nvSpPr>
+          <p:cNvPr id="73" name="TextBox 72"/>
           <p:cNvSpPr txBox="1"/>
           <p:nvPr/>
         </p:nvSpPr>
         <p:spPr>
           <a:xfrm>
-            <a:off x="17149980" y="19561257"/>
-            <a:ext cx="180000" cy="302991"/>
+            <a:off x="17054010" y="18789384"/>
+            <a:ext cx="180000" cy="249522"/>
           </a:xfrm>
           <a:prstGeom prst="rect">
             <a:avLst/>
@@ -6626,27 +7046,27 @@
           <a:p>
             <a:pPr algn="l"/>
             <a:r>
-              <a:rPr sz="1835" b="0" i="0">
+              <a:rPr sz="1511" b="0" i="0">
                 <a:solidFill>
                   <a:srgbClr val="5B6570"/>
                 </a:solidFill>
                 <a:latin typeface="IBM Plex Sans"/>
               </a:rPr>
-              <a:t>CLB giữ tạm các em ưu tiên cao nhất</a:t>
-            </a:r>
-          </a:p>
-        </p:txBody>
-      </p:sp>
-      <p:sp>
-        <p:nvSpPr>
-          <p:cNvPr id="62" name="TextBox 61"/>
+              <a:t>2. CLB giữ tạm các em ưu tiên cao nhất</a:t>
+            </a:r>
+          </a:p>
+        </p:txBody>
+      </p:sp>
+      <p:sp>
+        <p:nvSpPr>
+          <p:cNvPr id="74" name="TextBox 73"/>
           <p:cNvSpPr txBox="1"/>
           <p:nvPr/>
         </p:nvSpPr>
         <p:spPr>
           <a:xfrm>
-            <a:off x="17149980" y="19931427"/>
-            <a:ext cx="180000" cy="302991"/>
+            <a:off x="17054010" y="19077294"/>
+            <a:ext cx="180000" cy="249522"/>
           </a:xfrm>
           <a:prstGeom prst="rect">
             <a:avLst/>
@@ -6661,31 +7081,66 @@
           <a:p>
             <a:pPr algn="l"/>
             <a:r>
-              <a:rPr sz="1835" b="0" i="0">
+              <a:rPr sz="1511" b="0" i="0">
                 <a:solidFill>
                   <a:srgbClr val="5B6570"/>
                 </a:solidFill>
                 <a:latin typeface="IBM Plex Sans"/>
               </a:rPr>
-              <a:t>Em bị trả lại nộp nguyện vọng kế tiếp</a:t>
-            </a:r>
-          </a:p>
-        </p:txBody>
-      </p:sp>
-      <p:sp>
-        <p:nvSpPr>
-          <p:cNvPr id="63" name="Rounded Rectangle 62"/>
+              <a:t>3. Em bị trả lại nộp nguyện vọng kế tiếp</a:t>
+            </a:r>
+          </a:p>
+        </p:txBody>
+      </p:sp>
+      <p:sp>
+        <p:nvSpPr>
+          <p:cNvPr id="75" name="TextBox 74"/>
+          <p:cNvSpPr txBox="1"/>
+          <p:nvPr/>
+        </p:nvSpPr>
+        <p:spPr>
+          <a:xfrm>
+            <a:off x="17054010" y="19365204"/>
+            <a:ext cx="180000" cy="249522"/>
+          </a:xfrm>
+          <a:prstGeom prst="rect">
+            <a:avLst/>
+          </a:prstGeom>
+          <a:noFill/>
+        </p:spPr>
+        <p:txBody>
+          <a:bodyPr wrap="none" anchor="t" lIns="0" rIns="0" tIns="0" bIns="0">
+            <a:spAutoFit/>
+          </a:bodyPr>
+          <a:lstStyle/>
+          <a:p>
+            <a:pPr algn="l"/>
+            <a:r>
+              <a:rPr sz="1511" b="0" i="0">
+                <a:solidFill>
+                  <a:srgbClr val="5B6570"/>
+                </a:solidFill>
+                <a:latin typeface="IBM Plex Sans"/>
+              </a:rPr>
+              <a:t>4. Lặp đến khi không còn ai phải nộp lại</a:t>
+            </a:r>
+          </a:p>
+        </p:txBody>
+      </p:sp>
+      <p:sp>
+        <p:nvSpPr>
+          <p:cNvPr id="76" name="Rounded Rectangle 75"/>
           <p:cNvSpPr/>
           <p:nvPr/>
         </p:nvSpPr>
         <p:spPr>
           <a:xfrm>
-            <a:off x="17149980" y="20771850"/>
-            <a:ext cx="4853340" cy="1713750"/>
+            <a:off x="17054010" y="19949250"/>
+            <a:ext cx="4839630" cy="1466970"/>
           </a:xfrm>
           <a:prstGeom prst="roundRect">
             <a:avLst>
-              <a:gd name="adj" fmla="val 7200"/>
+              <a:gd name="adj" fmla="val 8411"/>
             </a:avLst>
           </a:prstGeom>
           <a:solidFill>
@@ -6722,14 +7177,14 @@
       </p:sp>
       <p:sp>
         <p:nvSpPr>
-          <p:cNvPr id="64" name="TextBox 63"/>
+          <p:cNvPr id="77" name="TextBox 76"/>
           <p:cNvSpPr txBox="1"/>
           <p:nvPr/>
         </p:nvSpPr>
         <p:spPr>
           <a:xfrm>
-            <a:off x="17396760" y="21035082"/>
-            <a:ext cx="180000" cy="392106"/>
+            <a:off x="17273370" y="20176836"/>
+            <a:ext cx="180000" cy="285168"/>
           </a:xfrm>
           <a:prstGeom prst="rect">
             <a:avLst/>
@@ -6744,27 +7199,27 @@
           <a:p>
             <a:pPr algn="l"/>
             <a:r>
-              <a:rPr sz="2374" b="1" i="0">
+              <a:rPr sz="1727" b="1" i="0">
                 <a:solidFill>
                   <a:srgbClr val="1C2321"/>
                 </a:solidFill>
                 <a:latin typeface="Be Vietnam Pro"/>
               </a:rPr>
-              <a:t>Suất dự trữ</a:t>
-            </a:r>
-          </a:p>
-        </p:txBody>
-      </p:sp>
-      <p:sp>
-        <p:nvSpPr>
-          <p:cNvPr id="65" name="TextBox 64"/>
+              <a:t>Suất dự trữ — xét hai lượt</a:t>
+            </a:r>
+          </a:p>
+        </p:txBody>
+      </p:sp>
+      <p:sp>
+        <p:nvSpPr>
+          <p:cNvPr id="78" name="TextBox 77"/>
           <p:cNvSpPr txBox="1"/>
           <p:nvPr/>
         </p:nvSpPr>
         <p:spPr>
           <a:xfrm>
-            <a:off x="17396760" y="21590337"/>
-            <a:ext cx="180000" cy="302991"/>
+            <a:off x="17273370" y="20611443"/>
+            <a:ext cx="180000" cy="231699"/>
           </a:xfrm>
           <a:prstGeom prst="rect">
             <a:avLst/>
@@ -6779,27 +7234,27 @@
           <a:p>
             <a:pPr algn="l"/>
             <a:r>
-              <a:rPr sz="1835" b="0" i="0">
+              <a:rPr sz="1403" b="0" i="0">
                 <a:solidFill>
                   <a:srgbClr val="5B6570"/>
                 </a:solidFill>
                 <a:latin typeface="IBM Plex Sans"/>
               </a:rPr>
-              <a:t>Giữ chỗ cho nhóm ưu tiên</a:t>
-            </a:r>
-          </a:p>
-        </p:txBody>
-      </p:sp>
-      <p:sp>
-        <p:nvSpPr>
-          <p:cNvPr id="66" name="TextBox 65"/>
+              <a:t>Lượt 1 · chỉ xét em thuộc diện dự trữ</a:t>
+            </a:r>
+          </a:p>
+        </p:txBody>
+      </p:sp>
+      <p:sp>
+        <p:nvSpPr>
+          <p:cNvPr id="79" name="TextBox 78"/>
           <p:cNvSpPr txBox="1"/>
           <p:nvPr/>
         </p:nvSpPr>
         <p:spPr>
           <a:xfrm>
-            <a:off x="17396760" y="21960507"/>
-            <a:ext cx="180000" cy="302991"/>
+            <a:off x="17273370" y="20871933"/>
+            <a:ext cx="180000" cy="231699"/>
           </a:xfrm>
           <a:prstGeom prst="rect">
             <a:avLst/>
@@ -6814,27 +7269,62 @@
           <a:p>
             <a:pPr algn="l"/>
             <a:r>
-              <a:rPr sz="1835" b="0" i="0">
+              <a:rPr sz="1403" b="0" i="0">
                 <a:solidFill>
                   <a:srgbClr val="5B6570"/>
                 </a:solidFill>
                 <a:latin typeface="IBM Plex Sans"/>
               </a:rPr>
-              <a:t>Không đủ người → trả về xét chung</a:t>
-            </a:r>
-          </a:p>
-        </p:txBody>
-      </p:sp>
-      <p:sp>
-        <p:nvSpPr>
-          <p:cNvPr id="67" name="Right Arrow 66"/>
+              <a:t>Lượt 2 · xét chung phần chỗ còn lại</a:t>
+            </a:r>
+          </a:p>
+        </p:txBody>
+      </p:sp>
+      <p:sp>
+        <p:nvSpPr>
+          <p:cNvPr id="80" name="TextBox 79"/>
+          <p:cNvSpPr txBox="1"/>
+          <p:nvPr/>
+        </p:nvSpPr>
+        <p:spPr>
+          <a:xfrm>
+            <a:off x="17273370" y="21132423"/>
+            <a:ext cx="180000" cy="231699"/>
+          </a:xfrm>
+          <a:prstGeom prst="rect">
+            <a:avLst/>
+          </a:prstGeom>
+          <a:noFill/>
+        </p:spPr>
+        <p:txBody>
+          <a:bodyPr wrap="none" anchor="t" lIns="0" rIns="0" tIns="0" bIns="0">
+            <a:spAutoFit/>
+          </a:bodyPr>
+          <a:lstStyle/>
+          <a:p>
+            <a:pPr algn="l"/>
+            <a:r>
+              <a:rPr sz="1403" b="0" i="0">
+                <a:solidFill>
+                  <a:srgbClr val="5B6570"/>
+                </a:solidFill>
+                <a:latin typeface="IBM Plex Sans"/>
+              </a:rPr>
+              <a:t>Dư suất dự trữ → tự chuyển sang xét chung</a:t>
+            </a:r>
+          </a:p>
+        </p:txBody>
+      </p:sp>
+      <p:sp>
+        <p:nvSpPr>
+          <p:cNvPr id="81" name="Right Arrow 80"/>
           <p:cNvSpPr/>
           <p:nvPr/>
         </p:nvSpPr>
         <p:spPr>
           <a:xfrm>
-            <a:off x="22250100" y="20456520"/>
-            <a:ext cx="479850" cy="219360"/>
+            <a:off x="22113000" y="19565370"/>
+            <a:ext cx="411300" cy="219360"/>
           </a:xfrm>
           <a:prstGeom prst="rightArrow">
             <a:avLst/>
@@ -6871,18 +7361,18 @@
       </p:sp>
       <p:sp>
         <p:nvSpPr>
-          <p:cNvPr id="68" name="Rounded Rectangle 67"/>
+          <p:cNvPr id="82" name="Rounded Rectangle 81"/>
           <p:cNvSpPr/>
           <p:nvPr/>
         </p:nvSpPr>
         <p:spPr>
           <a:xfrm>
-            <a:off x="22729950" y="18921000"/>
-            <a:ext cx="3290400" cy="1371000"/>
+            <a:off x="22524300" y="17755650"/>
+            <a:ext cx="3496050" cy="2056500"/>
           </a:xfrm>
           <a:prstGeom prst="roundRect">
             <a:avLst>
-              <a:gd name="adj" fmla="val 9000"/>
+              <a:gd name="adj" fmla="val 6000"/>
             </a:avLst>
           </a:prstGeom>
           <a:solidFill>
@@ -6919,14 +7409,14 @@
       </p:sp>
       <p:sp>
         <p:nvSpPr>
-          <p:cNvPr id="69" name="Oval 68"/>
+          <p:cNvPr id="83" name="Oval 82"/>
           <p:cNvSpPr/>
           <p:nvPr/>
         </p:nvSpPr>
         <p:spPr>
           <a:xfrm>
-            <a:off x="22921890" y="19126650"/>
-            <a:ext cx="438720" cy="438720"/>
+            <a:off x="22702530" y="17947590"/>
+            <a:ext cx="411300" cy="411300"/>
           </a:xfrm>
           <a:prstGeom prst="ellipse">
             <a:avLst/>
@@ -6972,14 +7462,14 @@
       </p:sp>
       <p:sp>
         <p:nvSpPr>
-          <p:cNvPr id="70" name="TextBox 69"/>
+          <p:cNvPr id="84" name="TextBox 83"/>
           <p:cNvSpPr txBox="1"/>
           <p:nvPr/>
         </p:nvSpPr>
         <p:spPr>
           <a:xfrm>
-            <a:off x="23497710" y="19184232"/>
-            <a:ext cx="180000" cy="392106"/>
+            <a:off x="23237220" y="17988720"/>
+            <a:ext cx="180000" cy="356460"/>
           </a:xfrm>
           <a:prstGeom prst="rect">
             <a:avLst/>
@@ -6994,7 +7484,7 @@
           <a:p>
             <a:pPr algn="l"/>
             <a:r>
-              <a:rPr sz="2374" b="1" i="0">
+              <a:rPr sz="2159" b="1" i="0">
                 <a:solidFill>
                   <a:srgbClr val="1C2321"/>
                 </a:solidFill>
@@ -7007,14 +7497,14 @@
       </p:sp>
       <p:sp>
         <p:nvSpPr>
-          <p:cNvPr id="71" name="TextBox 70"/>
+          <p:cNvPr id="85" name="TextBox 84"/>
           <p:cNvSpPr txBox="1"/>
           <p:nvPr/>
         </p:nvSpPr>
         <p:spPr>
           <a:xfrm>
-            <a:off x="22976730" y="19739487"/>
-            <a:ext cx="180000" cy="302991"/>
+            <a:off x="22743660" y="18487764"/>
+            <a:ext cx="180000" cy="249522"/>
           </a:xfrm>
           <a:prstGeom prst="rect">
             <a:avLst/>
@@ -7029,27 +7519,97 @@
           <a:p>
             <a:pPr algn="l"/>
             <a:r>
-              <a:rPr sz="1835" b="0" i="0">
+              <a:rPr sz="1511" b="0" i="0">
                 <a:solidFill>
                   <a:srgbClr val="5B6570"/>
                 </a:solidFill>
                 <a:latin typeface="IBM Plex Sans"/>
               </a:rPr>
-              <a:t>Không còn cặp phá vỡ</a:t>
-            </a:r>
-          </a:p>
-        </p:txBody>
-      </p:sp>
-      <p:sp>
-        <p:nvSpPr>
-          <p:cNvPr id="72" name="Down Arrow 71"/>
+              <a:t>Tìm cặp phá vỡ: em thích CLB</a:t>
+            </a:r>
+          </a:p>
+        </p:txBody>
+      </p:sp>
+      <p:sp>
+        <p:nvSpPr>
+          <p:cNvPr id="86" name="TextBox 85"/>
+          <p:cNvSpPr txBox="1"/>
+          <p:nvPr/>
+        </p:nvSpPr>
+        <p:spPr>
+          <a:xfrm>
+            <a:off x="22743660" y="18775674"/>
+            <a:ext cx="180000" cy="249522"/>
+          </a:xfrm>
+          <a:prstGeom prst="rect">
+            <a:avLst/>
+          </a:prstGeom>
+          <a:noFill/>
+        </p:spPr>
+        <p:txBody>
+          <a:bodyPr wrap="none" anchor="t" lIns="0" rIns="0" tIns="0" bIns="0">
+            <a:spAutoFit/>
+          </a:bodyPr>
+          <a:lstStyle/>
+          <a:p>
+            <a:pPr algn="l"/>
+            <a:r>
+              <a:rPr sz="1511" b="0" i="0">
+                <a:solidFill>
+                  <a:srgbClr val="5B6570"/>
+                </a:solidFill>
+                <a:latin typeface="IBM Plex Sans"/>
+              </a:rPr>
+              <a:t>khác hơn và CLB đó cũng nhận em</a:t>
+            </a:r>
+          </a:p>
+        </p:txBody>
+      </p:sp>
+      <p:sp>
+        <p:nvSpPr>
+          <p:cNvPr id="87" name="TextBox 86"/>
+          <p:cNvSpPr txBox="1"/>
+          <p:nvPr/>
+        </p:nvSpPr>
+        <p:spPr>
+          <a:xfrm>
+            <a:off x="22743660" y="19063584"/>
+            <a:ext cx="180000" cy="249522"/>
+          </a:xfrm>
+          <a:prstGeom prst="rect">
+            <a:avLst/>
+          </a:prstGeom>
+          <a:noFill/>
+        </p:spPr>
+        <p:txBody>
+          <a:bodyPr wrap="none" anchor="t" lIns="0" rIns="0" tIns="0" bIns="0">
+            <a:spAutoFit/>
+          </a:bodyPr>
+          <a:lstStyle/>
+          <a:p>
+            <a:pPr algn="l"/>
+            <a:r>
+              <a:rPr sz="1511" b="0" i="0">
+                <a:solidFill>
+                  <a:srgbClr val="5B6570"/>
+                </a:solidFill>
+                <a:latin typeface="IBM Plex Sans"/>
+              </a:rPr>
+              <a:t>Yêu cầu: 0 cặp</a:t>
+            </a:r>
+          </a:p>
+        </p:txBody>
+      </p:sp>
+      <p:sp>
+        <p:nvSpPr>
+          <p:cNvPr id="88" name="Down Arrow 87"/>
           <p:cNvSpPr/>
           <p:nvPr/>
         </p:nvSpPr>
         <p:spPr>
           <a:xfrm>
-            <a:off x="24265470" y="20292000"/>
-            <a:ext cx="219360" cy="479850"/>
+            <a:off x="24162645" y="19812150"/>
+            <a:ext cx="219360" cy="342750"/>
           </a:xfrm>
           <a:prstGeom prst="downArrow">
             <a:avLst/>
@@ -7086,18 +7646,18 @@
       </p:sp>
       <p:sp>
         <p:nvSpPr>
-          <p:cNvPr id="73" name="Rounded Rectangle 72"/>
+          <p:cNvPr id="89" name="Rounded Rectangle 88"/>
           <p:cNvSpPr/>
           <p:nvPr/>
         </p:nvSpPr>
         <p:spPr>
           <a:xfrm>
-            <a:off x="22729950" y="20771850"/>
-            <a:ext cx="3290400" cy="1713750"/>
+            <a:off x="22524300" y="20154900"/>
+            <a:ext cx="3496050" cy="1439550"/>
           </a:xfrm>
           <a:prstGeom prst="roundRect">
             <a:avLst>
-              <a:gd name="adj" fmla="val 7200"/>
+              <a:gd name="adj" fmla="val 8571"/>
             </a:avLst>
           </a:prstGeom>
           <a:solidFill>
@@ -7134,14 +7694,14 @@
       </p:sp>
       <p:sp>
         <p:nvSpPr>
-          <p:cNvPr id="74" name="TextBox 73"/>
+          <p:cNvPr id="90" name="TextBox 89"/>
           <p:cNvSpPr txBox="1"/>
           <p:nvPr/>
         </p:nvSpPr>
         <p:spPr>
           <a:xfrm>
-            <a:off x="22976730" y="21035082"/>
-            <a:ext cx="180000" cy="392106"/>
+            <a:off x="22743660" y="20387970"/>
+            <a:ext cx="180000" cy="356460"/>
           </a:xfrm>
           <a:prstGeom prst="rect">
             <a:avLst/>
@@ -7156,7 +7716,7 @@
           <a:p>
             <a:pPr algn="l"/>
             <a:r>
-              <a:rPr sz="2374" b="1" i="0">
+              <a:rPr sz="2159" b="1" i="0">
                 <a:solidFill>
                   <a:srgbClr val="1C2321"/>
                 </a:solidFill>
@@ -7169,14 +7729,14 @@
       </p:sp>
       <p:sp>
         <p:nvSpPr>
-          <p:cNvPr id="75" name="TextBox 74"/>
+          <p:cNvPr id="91" name="TextBox 90"/>
           <p:cNvSpPr txBox="1"/>
           <p:nvPr/>
         </p:nvSpPr>
         <p:spPr>
           <a:xfrm>
-            <a:off x="22976730" y="21590337"/>
-            <a:ext cx="180000" cy="302991"/>
+            <a:off x="22743660" y="20887014"/>
+            <a:ext cx="180000" cy="249522"/>
           </a:xfrm>
           <a:prstGeom prst="rect">
             <a:avLst/>
@@ -7191,7 +7751,7 @@
           <a:p>
             <a:pPr algn="l"/>
             <a:r>
-              <a:rPr sz="1835" b="0" i="0">
+              <a:rPr sz="1511" b="0" i="0">
                 <a:solidFill>
                   <a:srgbClr val="5B6570"/>
                 </a:solidFill>
@@ -7204,14 +7764,14 @@
       </p:sp>
       <p:sp>
         <p:nvSpPr>
-          <p:cNvPr id="76" name="TextBox 75"/>
+          <p:cNvPr id="92" name="TextBox 91"/>
           <p:cNvSpPr txBox="1"/>
           <p:nvPr/>
         </p:nvSpPr>
         <p:spPr>
           <a:xfrm>
-            <a:off x="22976730" y="21960507"/>
-            <a:ext cx="180000" cy="302991"/>
+            <a:off x="22743660" y="21174924"/>
+            <a:ext cx="180000" cy="249522"/>
           </a:xfrm>
           <a:prstGeom prst="rect">
             <a:avLst/>
@@ -7226,27 +7786,119 @@
           <a:p>
             <a:pPr algn="l"/>
             <a:r>
-              <a:rPr sz="1835" b="0" i="0">
+              <a:rPr sz="1511" b="0" i="0">
                 <a:solidFill>
                   <a:srgbClr val="5B6570"/>
                 </a:solidFill>
                 <a:latin typeface="IBM Plex Sans"/>
               </a:rPr>
-              <a:t>Danh sách từng CLB</a:t>
-            </a:r>
-          </a:p>
-        </p:txBody>
-      </p:sp>
-      <p:sp>
-        <p:nvSpPr>
-          <p:cNvPr id="77" name="TextBox 76"/>
+              <a:t>Xuất danh sách từng CLB</a:t>
+            </a:r>
+          </a:p>
+        </p:txBody>
+      </p:sp>
+      <p:sp>
+        <p:nvSpPr>
+          <p:cNvPr id="93" name="Down Arrow 92"/>
+          <p:cNvSpPr/>
+          <p:nvPr/>
+        </p:nvSpPr>
+        <p:spPr>
+          <a:xfrm>
+            <a:off x="14325720" y="21594450"/>
+            <a:ext cx="219360" cy="411300"/>
+          </a:xfrm>
+          <a:prstGeom prst="downArrow">
+            <a:avLst/>
+          </a:prstGeom>
+          <a:solidFill>
+            <a:srgbClr val="5B6570"/>
+          </a:solidFill>
+          <a:ln>
+            <a:noFill/>
+          </a:ln>
+          <a:effectLst/>
+        </p:spPr>
+        <p:style>
+          <a:lnRef idx="1">
+            <a:schemeClr val="accent1"/>
+          </a:lnRef>
+          <a:fillRef idx="3">
+            <a:schemeClr val="accent1"/>
+          </a:fillRef>
+          <a:effectRef idx="2">
+            <a:schemeClr val="accent1"/>
+          </a:effectRef>
+          <a:fontRef idx="minor">
+            <a:schemeClr val="lt1"/>
+          </a:fontRef>
+        </p:style>
+        <p:txBody>
+          <a:bodyPr rtlCol="0" anchor="ctr"/>
+          <a:lstStyle/>
+          <a:p>
+            <a:pPr algn="ctr"/>
+          </a:p>
+        </p:txBody>
+      </p:sp>
+      <p:sp>
+        <p:nvSpPr>
+          <p:cNvPr id="94" name="Rounded Rectangle 93"/>
+          <p:cNvSpPr/>
+          <p:nvPr/>
+        </p:nvSpPr>
+        <p:spPr>
+          <a:xfrm>
+            <a:off x="9979650" y="22005750"/>
+            <a:ext cx="16040700" cy="2193600"/>
+          </a:xfrm>
+          <a:prstGeom prst="roundRect">
+            <a:avLst>
+              <a:gd name="adj" fmla="val 5625"/>
+            </a:avLst>
+          </a:prstGeom>
+          <a:solidFill>
+            <a:srgbClr val="F1DFB8"/>
+          </a:solidFill>
+          <a:ln w="20565">
+            <a:solidFill>
+              <a:srgbClr val="B8781A"/>
+            </a:solidFill>
+          </a:ln>
+          <a:effectLst/>
+        </p:spPr>
+        <p:style>
+          <a:lnRef idx="1">
+            <a:schemeClr val="accent1"/>
+          </a:lnRef>
+          <a:fillRef idx="3">
+            <a:schemeClr val="accent1"/>
+          </a:fillRef>
+          <a:effectRef idx="2">
+            <a:schemeClr val="accent1"/>
+          </a:effectRef>
+          <a:fontRef idx="minor">
+            <a:schemeClr val="lt1"/>
+          </a:fontRef>
+        </p:style>
+        <p:txBody>
+          <a:bodyPr rtlCol="0" anchor="ctr"/>
+          <a:lstStyle/>
+          <a:p>
+            <a:pPr algn="ctr"/>
+          </a:p>
+        </p:txBody>
+      </p:sp>
+      <p:sp>
+        <p:nvSpPr>
+          <p:cNvPr id="95" name="TextBox 94"/>
           <p:cNvSpPr txBox="1"/>
           <p:nvPr/>
         </p:nvSpPr>
         <p:spPr>
           <a:xfrm>
-            <a:off x="10048200" y="23216343"/>
-            <a:ext cx="180000" cy="231699"/>
+            <a:off x="10199010" y="22208658"/>
+            <a:ext cx="180000" cy="320814"/>
           </a:xfrm>
           <a:prstGeom prst="rect">
             <a:avLst/>
@@ -7261,7 +7913,794 @@
           <a:p>
             <a:pPr algn="l"/>
             <a:r>
-              <a:rPr sz="1403" b="0" i="0">
+              <a:rPr sz="1943" b="1" i="0">
+                <a:solidFill>
+                  <a:srgbClr val="1C2321"/>
+                </a:solidFill>
+                <a:latin typeface="Be Vietnam Pro"/>
+              </a:rPr>
+              <a:t>Bốc thăm hoạt động thế nào</a:t>
+            </a:r>
+          </a:p>
+        </p:txBody>
+      </p:sp>
+      <p:sp>
+        <p:nvSpPr>
+          <p:cNvPr id="96" name="Rounded Rectangle 95"/>
+          <p:cNvSpPr/>
+          <p:nvPr/>
+        </p:nvSpPr>
+        <p:spPr>
+          <a:xfrm>
+            <a:off x="10199010" y="22622700"/>
+            <a:ext cx="3756540" cy="1371000"/>
+          </a:xfrm>
+          <a:prstGeom prst="roundRect">
+            <a:avLst>
+              <a:gd name="adj" fmla="val 9000"/>
+            </a:avLst>
+          </a:prstGeom>
+          <a:solidFill>
+            <a:srgbClr val="FFFFFF"/>
+          </a:solidFill>
+          <a:ln w="13710">
+            <a:solidFill>
+              <a:srgbClr val="B8781A"/>
+            </a:solidFill>
+          </a:ln>
+          <a:effectLst/>
+        </p:spPr>
+        <p:style>
+          <a:lnRef idx="1">
+            <a:schemeClr val="accent1"/>
+          </a:lnRef>
+          <a:fillRef idx="3">
+            <a:schemeClr val="accent1"/>
+          </a:fillRef>
+          <a:effectRef idx="2">
+            <a:schemeClr val="accent1"/>
+          </a:effectRef>
+          <a:fontRef idx="minor">
+            <a:schemeClr val="lt1"/>
+          </a:fontRef>
+        </p:style>
+        <p:txBody>
+          <a:bodyPr rtlCol="0" anchor="ctr"/>
+          <a:lstStyle/>
+          <a:p>
+            <a:pPr algn="ctr"/>
+          </a:p>
+        </p:txBody>
+      </p:sp>
+      <p:sp>
+        <p:nvSpPr>
+          <p:cNvPr id="97" name="TextBox 96"/>
+          <p:cNvSpPr txBox="1"/>
+          <p:nvPr/>
+        </p:nvSpPr>
+        <p:spPr>
+          <a:xfrm>
+            <a:off x="10418370" y="22848915"/>
+            <a:ext cx="180000" cy="267345"/>
+          </a:xfrm>
+          <a:prstGeom prst="rect">
+            <a:avLst/>
+          </a:prstGeom>
+          <a:noFill/>
+        </p:spPr>
+        <p:txBody>
+          <a:bodyPr wrap="none" anchor="t" lIns="0" rIns="0" tIns="0" bIns="0">
+            <a:spAutoFit/>
+          </a:bodyPr>
+          <a:lstStyle/>
+          <a:p>
+            <a:pPr algn="l"/>
+            <a:r>
+              <a:rPr sz="1619" b="1" i="0">
+                <a:solidFill>
+                  <a:srgbClr val="1C2321"/>
+                </a:solidFill>
+                <a:latin typeface="Be Vietnam Pro"/>
+              </a:rPr>
+              <a:t>Một em · một số</a:t>
+            </a:r>
+          </a:p>
+        </p:txBody>
+      </p:sp>
+      <p:sp>
+        <p:nvSpPr>
+          <p:cNvPr id="98" name="TextBox 97"/>
+          <p:cNvSpPr txBox="1"/>
+          <p:nvPr/>
+        </p:nvSpPr>
+        <p:spPr>
+          <a:xfrm>
+            <a:off x="10418370" y="23263642"/>
+            <a:ext cx="180000" cy="222787"/>
+          </a:xfrm>
+          <a:prstGeom prst="rect">
+            <a:avLst/>
+          </a:prstGeom>
+          <a:noFill/>
+        </p:spPr>
+        <p:txBody>
+          <a:bodyPr wrap="none" anchor="t" lIns="0" rIns="0" tIns="0" bIns="0">
+            <a:spAutoFit/>
+          </a:bodyPr>
+          <a:lstStyle/>
+          <a:p>
+            <a:pPr algn="l"/>
+            <a:r>
+              <a:rPr sz="1349" b="0" i="0">
+                <a:solidFill>
+                  <a:srgbClr val="5B6570"/>
+                </a:solidFill>
+                <a:latin typeface="IBM Plex Sans"/>
+              </a:rPr>
+              <a:t>Bốc một lần cho mỗi học sinh</a:t>
+            </a:r>
+          </a:p>
+        </p:txBody>
+      </p:sp>
+      <p:sp>
+        <p:nvSpPr>
+          <p:cNvPr id="99" name="TextBox 98"/>
+          <p:cNvSpPr txBox="1"/>
+          <p:nvPr/>
+        </p:nvSpPr>
+        <p:spPr>
+          <a:xfrm>
+            <a:off x="10418370" y="23510422"/>
+            <a:ext cx="180000" cy="222787"/>
+          </a:xfrm>
+          <a:prstGeom prst="rect">
+            <a:avLst/>
+          </a:prstGeom>
+          <a:noFill/>
+        </p:spPr>
+        <p:txBody>
+          <a:bodyPr wrap="none" anchor="t" lIns="0" rIns="0" tIns="0" bIns="0">
+            <a:spAutoFit/>
+          </a:bodyPr>
+          <a:lstStyle/>
+          <a:p>
+            <a:pPr algn="l"/>
+            <a:r>
+              <a:rPr sz="1349" b="0" i="0">
+                <a:solidFill>
+                  <a:srgbClr val="5B6570"/>
+                </a:solidFill>
+                <a:latin typeface="IBM Plex Sans"/>
+              </a:rPr>
+              <a:t>Dùng chung cho mọi CLB</a:t>
+            </a:r>
+          </a:p>
+        </p:txBody>
+      </p:sp>
+      <p:sp>
+        <p:nvSpPr>
+          <p:cNvPr id="100" name="TextBox 99"/>
+          <p:cNvSpPr txBox="1"/>
+          <p:nvPr/>
+        </p:nvSpPr>
+        <p:spPr>
+          <a:xfrm>
+            <a:off x="10418370" y="23757202"/>
+            <a:ext cx="180000" cy="222787"/>
+          </a:xfrm>
+          <a:prstGeom prst="rect">
+            <a:avLst/>
+          </a:prstGeom>
+          <a:noFill/>
+        </p:spPr>
+        <p:txBody>
+          <a:bodyPr wrap="none" anchor="t" lIns="0" rIns="0" tIns="0" bIns="0">
+            <a:spAutoFit/>
+          </a:bodyPr>
+          <a:lstStyle/>
+          <a:p>
+            <a:pPr algn="l"/>
+            <a:r>
+              <a:rPr sz="1349" b="0" i="0">
+                <a:solidFill>
+                  <a:srgbClr val="5B6570"/>
+                </a:solidFill>
+                <a:latin typeface="IBM Plex Sans"/>
+              </a:rPr>
+              <a:t>Số nhỏ hơn → ưu tiên hơn</a:t>
+            </a:r>
+          </a:p>
+        </p:txBody>
+      </p:sp>
+      <p:sp>
+        <p:nvSpPr>
+          <p:cNvPr id="101" name="Rounded Rectangle 100"/>
+          <p:cNvSpPr/>
+          <p:nvPr/>
+        </p:nvSpPr>
+        <p:spPr>
+          <a:xfrm>
+            <a:off x="14147490" y="22622700"/>
+            <a:ext cx="3756540" cy="1371000"/>
+          </a:xfrm>
+          <a:prstGeom prst="roundRect">
+            <a:avLst>
+              <a:gd name="adj" fmla="val 9000"/>
+            </a:avLst>
+          </a:prstGeom>
+          <a:solidFill>
+            <a:srgbClr val="FFFFFF"/>
+          </a:solidFill>
+          <a:ln w="13710">
+            <a:solidFill>
+              <a:srgbClr val="B8781A"/>
+            </a:solidFill>
+          </a:ln>
+          <a:effectLst/>
+        </p:spPr>
+        <p:style>
+          <a:lnRef idx="1">
+            <a:schemeClr val="accent1"/>
+          </a:lnRef>
+          <a:fillRef idx="3">
+            <a:schemeClr val="accent1"/>
+          </a:fillRef>
+          <a:effectRef idx="2">
+            <a:schemeClr val="accent1"/>
+          </a:effectRef>
+          <a:fontRef idx="minor">
+            <a:schemeClr val="lt1"/>
+          </a:fontRef>
+        </p:style>
+        <p:txBody>
+          <a:bodyPr rtlCol="0" anchor="ctr"/>
+          <a:lstStyle/>
+          <a:p>
+            <a:pPr algn="ctr"/>
+          </a:p>
+        </p:txBody>
+      </p:sp>
+      <p:sp>
+        <p:nvSpPr>
+          <p:cNvPr id="102" name="TextBox 101"/>
+          <p:cNvSpPr txBox="1"/>
+          <p:nvPr/>
+        </p:nvSpPr>
+        <p:spPr>
+          <a:xfrm>
+            <a:off x="14366850" y="22848915"/>
+            <a:ext cx="180000" cy="267345"/>
+          </a:xfrm>
+          <a:prstGeom prst="rect">
+            <a:avLst/>
+          </a:prstGeom>
+          <a:noFill/>
+        </p:spPr>
+        <p:txBody>
+          <a:bodyPr wrap="none" anchor="t" lIns="0" rIns="0" tIns="0" bIns="0">
+            <a:spAutoFit/>
+          </a:bodyPr>
+          <a:lstStyle/>
+          <a:p>
+            <a:pPr algn="l"/>
+            <a:r>
+              <a:rPr sz="1619" b="1" i="0">
+                <a:solidFill>
+                  <a:srgbClr val="1C2321"/>
+                </a:solidFill>
+                <a:latin typeface="Be Vietnam Pro"/>
+              </a:rPr>
+              <a:t>Chỉ dùng khi hoà</a:t>
+            </a:r>
+          </a:p>
+        </p:txBody>
+      </p:sp>
+      <p:sp>
+        <p:nvSpPr>
+          <p:cNvPr id="103" name="TextBox 102"/>
+          <p:cNvSpPr txBox="1"/>
+          <p:nvPr/>
+        </p:nvSpPr>
+        <p:spPr>
+          <a:xfrm>
+            <a:off x="14366850" y="23263642"/>
+            <a:ext cx="180000" cy="222787"/>
+          </a:xfrm>
+          <a:prstGeom prst="rect">
+            <a:avLst/>
+          </a:prstGeom>
+          <a:noFill/>
+        </p:spPr>
+        <p:txBody>
+          <a:bodyPr wrap="none" anchor="t" lIns="0" rIns="0" tIns="0" bIns="0">
+            <a:spAutoFit/>
+          </a:bodyPr>
+          <a:lstStyle/>
+          <a:p>
+            <a:pPr algn="l"/>
+            <a:r>
+              <a:rPr sz="1349" b="0" i="0">
+                <a:solidFill>
+                  <a:srgbClr val="5B6570"/>
+                </a:solidFill>
+                <a:latin typeface="IBM Plex Sans"/>
+              </a:rPr>
+              <a:t>Hai em bằng điểm ở cùng CLB</a:t>
+            </a:r>
+          </a:p>
+        </p:txBody>
+      </p:sp>
+      <p:sp>
+        <p:nvSpPr>
+          <p:cNvPr id="104" name="TextBox 103"/>
+          <p:cNvSpPr txBox="1"/>
+          <p:nvPr/>
+        </p:nvSpPr>
+        <p:spPr>
+          <a:xfrm>
+            <a:off x="14366850" y="23510422"/>
+            <a:ext cx="180000" cy="222787"/>
+          </a:xfrm>
+          <a:prstGeom prst="rect">
+            <a:avLst/>
+          </a:prstGeom>
+          <a:noFill/>
+        </p:spPr>
+        <p:txBody>
+          <a:bodyPr wrap="none" anchor="t" lIns="0" rIns="0" tIns="0" bIns="0">
+            <a:spAutoFit/>
+          </a:bodyPr>
+          <a:lstStyle/>
+          <a:p>
+            <a:pPr algn="l"/>
+            <a:r>
+              <a:rPr sz="1349" b="0" i="0">
+                <a:solidFill>
+                  <a:srgbClr val="5B6570"/>
+                </a:solidFill>
+                <a:latin typeface="IBM Plex Sans"/>
+              </a:rPr>
+              <a:t>hoặc em không thi CLB đó</a:t>
+            </a:r>
+          </a:p>
+        </p:txBody>
+      </p:sp>
+      <p:sp>
+        <p:nvSpPr>
+          <p:cNvPr id="105" name="TextBox 104"/>
+          <p:cNvSpPr txBox="1"/>
+          <p:nvPr/>
+        </p:nvSpPr>
+        <p:spPr>
+          <a:xfrm>
+            <a:off x="14366850" y="23757202"/>
+            <a:ext cx="180000" cy="222787"/>
+          </a:xfrm>
+          <a:prstGeom prst="rect">
+            <a:avLst/>
+          </a:prstGeom>
+          <a:noFill/>
+        </p:spPr>
+        <p:txBody>
+          <a:bodyPr wrap="none" anchor="t" lIns="0" rIns="0" tIns="0" bIns="0">
+            <a:spAutoFit/>
+          </a:bodyPr>
+          <a:lstStyle/>
+          <a:p>
+            <a:pPr algn="l"/>
+            <a:r>
+              <a:rPr sz="1349" b="0" i="0">
+                <a:solidFill>
+                  <a:srgbClr val="5B6570"/>
+                </a:solidFill>
+                <a:latin typeface="IBM Plex Sans"/>
+              </a:rPr>
+              <a:t>Điểm luôn quyết định trước</a:t>
+            </a:r>
+          </a:p>
+        </p:txBody>
+      </p:sp>
+      <p:sp>
+        <p:nvSpPr>
+          <p:cNvPr id="106" name="Rounded Rectangle 105"/>
+          <p:cNvSpPr/>
+          <p:nvPr/>
+        </p:nvSpPr>
+        <p:spPr>
+          <a:xfrm>
+            <a:off x="18095970" y="22622700"/>
+            <a:ext cx="3756540" cy="1371000"/>
+          </a:xfrm>
+          <a:prstGeom prst="roundRect">
+            <a:avLst>
+              <a:gd name="adj" fmla="val 9000"/>
+            </a:avLst>
+          </a:prstGeom>
+          <a:solidFill>
+            <a:srgbClr val="FFFFFF"/>
+          </a:solidFill>
+          <a:ln w="13710">
+            <a:solidFill>
+              <a:srgbClr val="B8781A"/>
+            </a:solidFill>
+          </a:ln>
+          <a:effectLst/>
+        </p:spPr>
+        <p:style>
+          <a:lnRef idx="1">
+            <a:schemeClr val="accent1"/>
+          </a:lnRef>
+          <a:fillRef idx="3">
+            <a:schemeClr val="accent1"/>
+          </a:fillRef>
+          <a:effectRef idx="2">
+            <a:schemeClr val="accent1"/>
+          </a:effectRef>
+          <a:fontRef idx="minor">
+            <a:schemeClr val="lt1"/>
+          </a:fontRef>
+        </p:style>
+        <p:txBody>
+          <a:bodyPr rtlCol="0" anchor="ctr"/>
+          <a:lstStyle/>
+          <a:p>
+            <a:pPr algn="ctr"/>
+          </a:p>
+        </p:txBody>
+      </p:sp>
+      <p:sp>
+        <p:nvSpPr>
+          <p:cNvPr id="107" name="TextBox 106"/>
+          <p:cNvSpPr txBox="1"/>
+          <p:nvPr/>
+        </p:nvSpPr>
+        <p:spPr>
+          <a:xfrm>
+            <a:off x="18315330" y="22848915"/>
+            <a:ext cx="180000" cy="267345"/>
+          </a:xfrm>
+          <a:prstGeom prst="rect">
+            <a:avLst/>
+          </a:prstGeom>
+          <a:noFill/>
+        </p:spPr>
+        <p:txBody>
+          <a:bodyPr wrap="none" anchor="t" lIns="0" rIns="0" tIns="0" bIns="0">
+            <a:spAutoFit/>
+          </a:bodyPr>
+          <a:lstStyle/>
+          <a:p>
+            <a:pPr algn="l"/>
+            <a:r>
+              <a:rPr sz="1619" b="1" i="0">
+                <a:solidFill>
+                  <a:srgbClr val="1C2321"/>
+                </a:solidFill>
+                <a:latin typeface="Be Vietnam Pro"/>
+              </a:rPr>
+              <a:t>Kiểm tra lại được</a:t>
+            </a:r>
+          </a:p>
+        </p:txBody>
+      </p:sp>
+      <p:sp>
+        <p:nvSpPr>
+          <p:cNvPr id="108" name="TextBox 107"/>
+          <p:cNvSpPr txBox="1"/>
+          <p:nvPr/>
+        </p:nvSpPr>
+        <p:spPr>
+          <a:xfrm>
+            <a:off x="18315330" y="23263642"/>
+            <a:ext cx="180000" cy="222787"/>
+          </a:xfrm>
+          <a:prstGeom prst="rect">
+            <a:avLst/>
+          </a:prstGeom>
+          <a:noFill/>
+        </p:spPr>
+        <p:txBody>
+          <a:bodyPr wrap="none" anchor="t" lIns="0" rIns="0" tIns="0" bIns="0">
+            <a:spAutoFit/>
+          </a:bodyPr>
+          <a:lstStyle/>
+          <a:p>
+            <a:pPr algn="l"/>
+            <a:r>
+              <a:rPr sz="1349" b="0" i="0">
+                <a:solidFill>
+                  <a:srgbClr val="5B6570"/>
+                </a:solidFill>
+                <a:latin typeface="IBM Plex Sans"/>
+              </a:rPr>
+              <a:t>Không phụ thuộc thứ tự nhập tên</a:t>
+            </a:r>
+          </a:p>
+        </p:txBody>
+      </p:sp>
+      <p:sp>
+        <p:nvSpPr>
+          <p:cNvPr id="109" name="TextBox 108"/>
+          <p:cNvSpPr txBox="1"/>
+          <p:nvPr/>
+        </p:nvSpPr>
+        <p:spPr>
+          <a:xfrm>
+            <a:off x="18315330" y="23510422"/>
+            <a:ext cx="180000" cy="222787"/>
+          </a:xfrm>
+          <a:prstGeom prst="rect">
+            <a:avLst/>
+          </a:prstGeom>
+          <a:noFill/>
+        </p:spPr>
+        <p:txBody>
+          <a:bodyPr wrap="none" anchor="t" lIns="0" rIns="0" tIns="0" bIns="0">
+            <a:spAutoFit/>
+          </a:bodyPr>
+          <a:lstStyle/>
+          <a:p>
+            <a:pPr algn="l"/>
+            <a:r>
+              <a:rPr sz="1349" b="0" i="0">
+                <a:solidFill>
+                  <a:srgbClr val="5B6570"/>
+                </a:solidFill>
+                <a:latin typeface="IBM Plex Sans"/>
+              </a:rPr>
+              <a:t>Cùng dữ liệu + cùng hạt giống</a:t>
+            </a:r>
+          </a:p>
+        </p:txBody>
+      </p:sp>
+      <p:sp>
+        <p:nvSpPr>
+          <p:cNvPr id="110" name="TextBox 109"/>
+          <p:cNvSpPr txBox="1"/>
+          <p:nvPr/>
+        </p:nvSpPr>
+        <p:spPr>
+          <a:xfrm>
+            <a:off x="18315330" y="23757202"/>
+            <a:ext cx="180000" cy="222787"/>
+          </a:xfrm>
+          <a:prstGeom prst="rect">
+            <a:avLst/>
+          </a:prstGeom>
+          <a:noFill/>
+        </p:spPr>
+        <p:txBody>
+          <a:bodyPr wrap="none" anchor="t" lIns="0" rIns="0" tIns="0" bIns="0">
+            <a:spAutoFit/>
+          </a:bodyPr>
+          <a:lstStyle/>
+          <a:p>
+            <a:pPr algn="l"/>
+            <a:r>
+              <a:rPr sz="1349" b="0" i="0">
+                <a:solidFill>
+                  <a:srgbClr val="5B6570"/>
+                </a:solidFill>
+                <a:latin typeface="IBM Plex Sans"/>
+              </a:rPr>
+              <a:t>→ ra đúng một kết quả</a:t>
+            </a:r>
+          </a:p>
+        </p:txBody>
+      </p:sp>
+      <p:sp>
+        <p:nvSpPr>
+          <p:cNvPr id="111" name="Rounded Rectangle 110"/>
+          <p:cNvSpPr/>
+          <p:nvPr/>
+        </p:nvSpPr>
+        <p:spPr>
+          <a:xfrm>
+            <a:off x="22044450" y="22622700"/>
+            <a:ext cx="3756540" cy="1371000"/>
+          </a:xfrm>
+          <a:prstGeom prst="roundRect">
+            <a:avLst>
+              <a:gd name="adj" fmla="val 9000"/>
+            </a:avLst>
+          </a:prstGeom>
+          <a:solidFill>
+            <a:srgbClr val="FFFFFF"/>
+          </a:solidFill>
+          <a:ln w="13710">
+            <a:solidFill>
+              <a:srgbClr val="B8781A"/>
+            </a:solidFill>
+          </a:ln>
+          <a:effectLst/>
+        </p:spPr>
+        <p:style>
+          <a:lnRef idx="1">
+            <a:schemeClr val="accent1"/>
+          </a:lnRef>
+          <a:fillRef idx="3">
+            <a:schemeClr val="accent1"/>
+          </a:fillRef>
+          <a:effectRef idx="2">
+            <a:schemeClr val="accent1"/>
+          </a:effectRef>
+          <a:fontRef idx="minor">
+            <a:schemeClr val="lt1"/>
+          </a:fontRef>
+        </p:style>
+        <p:txBody>
+          <a:bodyPr rtlCol="0" anchor="ctr"/>
+          <a:lstStyle/>
+          <a:p>
+            <a:pPr algn="ctr"/>
+          </a:p>
+        </p:txBody>
+      </p:sp>
+      <p:sp>
+        <p:nvSpPr>
+          <p:cNvPr id="112" name="TextBox 111"/>
+          <p:cNvSpPr txBox="1"/>
+          <p:nvPr/>
+        </p:nvSpPr>
+        <p:spPr>
+          <a:xfrm>
+            <a:off x="22263810" y="22848915"/>
+            <a:ext cx="180000" cy="267345"/>
+          </a:xfrm>
+          <a:prstGeom prst="rect">
+            <a:avLst/>
+          </a:prstGeom>
+          <a:noFill/>
+        </p:spPr>
+        <p:txBody>
+          <a:bodyPr wrap="none" anchor="t" lIns="0" rIns="0" tIns="0" bIns="0">
+            <a:spAutoFit/>
+          </a:bodyPr>
+          <a:lstStyle/>
+          <a:p>
+            <a:pPr algn="l"/>
+            <a:r>
+              <a:rPr sz="1619" b="1" i="0">
+                <a:solidFill>
+                  <a:srgbClr val="1C2321"/>
+                </a:solidFill>
+                <a:latin typeface="Be Vietnam Pro"/>
+              </a:rPr>
+              <a:t>Khoá sau khi bốc</a:t>
+            </a:r>
+          </a:p>
+        </p:txBody>
+      </p:sp>
+      <p:sp>
+        <p:nvSpPr>
+          <p:cNvPr id="113" name="TextBox 112"/>
+          <p:cNvSpPr txBox="1"/>
+          <p:nvPr/>
+        </p:nvSpPr>
+        <p:spPr>
+          <a:xfrm>
+            <a:off x="22263810" y="23263642"/>
+            <a:ext cx="180000" cy="222787"/>
+          </a:xfrm>
+          <a:prstGeom prst="rect">
+            <a:avLst/>
+          </a:prstGeom>
+          <a:noFill/>
+        </p:spPr>
+        <p:txBody>
+          <a:bodyPr wrap="none" anchor="t" lIns="0" rIns="0" tIns="0" bIns="0">
+            <a:spAutoFit/>
+          </a:bodyPr>
+          <a:lstStyle/>
+          <a:p>
+            <a:pPr algn="l"/>
+            <a:r>
+              <a:rPr sz="1349" b="0" i="0">
+                <a:solidFill>
+                  <a:srgbClr val="5B6570"/>
+                </a:solidFill>
+                <a:latin typeface="IBM Plex Sans"/>
+              </a:rPr>
+              <a:t>Em thêm muộn chèn vào vị trí ngẫu nhiên</a:t>
+            </a:r>
+          </a:p>
+        </p:txBody>
+      </p:sp>
+      <p:sp>
+        <p:nvSpPr>
+          <p:cNvPr id="114" name="TextBox 113"/>
+          <p:cNvSpPr txBox="1"/>
+          <p:nvPr/>
+        </p:nvSpPr>
+        <p:spPr>
+          <a:xfrm>
+            <a:off x="22263810" y="23510422"/>
+            <a:ext cx="180000" cy="222787"/>
+          </a:xfrm>
+          <a:prstGeom prst="rect">
+            <a:avLst/>
+          </a:prstGeom>
+          <a:noFill/>
+        </p:spPr>
+        <p:txBody>
+          <a:bodyPr wrap="none" anchor="t" lIns="0" rIns="0" tIns="0" bIns="0">
+            <a:spAutoFit/>
+          </a:bodyPr>
+          <a:lstStyle/>
+          <a:p>
+            <a:pPr algn="l"/>
+            <a:r>
+              <a:rPr sz="1349" b="0" i="0">
+                <a:solidFill>
+                  <a:srgbClr val="5B6570"/>
+                </a:solidFill>
+                <a:latin typeface="IBM Plex Sans"/>
+              </a:rPr>
+              <a:t>Thứ tự các em cũ giữ nguyên</a:t>
+            </a:r>
+          </a:p>
+        </p:txBody>
+      </p:sp>
+      <p:sp>
+        <p:nvSpPr>
+          <p:cNvPr id="115" name="TextBox 114"/>
+          <p:cNvSpPr txBox="1"/>
+          <p:nvPr/>
+        </p:nvSpPr>
+        <p:spPr>
+          <a:xfrm>
+            <a:off x="22263810" y="23757202"/>
+            <a:ext cx="180000" cy="222787"/>
+          </a:xfrm>
+          <a:prstGeom prst="rect">
+            <a:avLst/>
+          </a:prstGeom>
+          <a:noFill/>
+        </p:spPr>
+        <p:txBody>
+          <a:bodyPr wrap="none" anchor="t" lIns="0" rIns="0" tIns="0" bIns="0">
+            <a:spAutoFit/>
+          </a:bodyPr>
+          <a:lstStyle/>
+          <a:p>
+            <a:pPr algn="l"/>
+            <a:r>
+              <a:rPr sz="1349" b="0" i="0">
+                <a:solidFill>
+                  <a:srgbClr val="5B6570"/>
+                </a:solidFill>
+                <a:latin typeface="IBM Plex Sans"/>
+              </a:rPr>
+              <a:t>Muốn bốc lại phải bấm "Vẽ lại"</a:t>
+            </a:r>
+          </a:p>
+        </p:txBody>
+      </p:sp>
+      <p:sp>
+        <p:nvSpPr>
+          <p:cNvPr id="116" name="TextBox 115"/>
+          <p:cNvSpPr txBox="1"/>
+          <p:nvPr/>
+        </p:nvSpPr>
+        <p:spPr>
+          <a:xfrm>
+            <a:off x="9979650" y="24291207"/>
+            <a:ext cx="180000" cy="213876"/>
+          </a:xfrm>
+          <a:prstGeom prst="rect">
+            <a:avLst/>
+          </a:prstGeom>
+          <a:noFill/>
+        </p:spPr>
+        <p:txBody>
+          <a:bodyPr wrap="none" anchor="t" lIns="0" rIns="0" tIns="0" bIns="0">
+            <a:spAutoFit/>
+          </a:bodyPr>
+          <a:lstStyle/>
+          <a:p>
+            <a:pPr algn="l"/>
+            <a:r>
+              <a:rPr sz="1295" b="0" i="0">
                 <a:solidFill>
                   <a:srgbClr val="8A929A"/>
                 </a:solidFill>
@@ -7274,18 +8713,18 @@
       </p:sp>
       <p:sp>
         <p:nvSpPr>
-          <p:cNvPr id="78" name="Rounded Rectangle 77"/>
+          <p:cNvPr id="117" name="Rounded Rectangle 116"/>
           <p:cNvSpPr/>
           <p:nvPr/>
         </p:nvSpPr>
         <p:spPr>
           <a:xfrm>
-            <a:off x="9774000" y="23863500"/>
-            <a:ext cx="16452000" cy="2092499"/>
+            <a:off x="9774000" y="24686100"/>
+            <a:ext cx="16452000" cy="1269899"/>
           </a:xfrm>
           <a:prstGeom prst="roundRect">
             <a:avLst>
-              <a:gd name="adj" fmla="val 5161"/>
+              <a:gd name="adj" fmla="val 8504"/>
             </a:avLst>
           </a:prstGeom>
           <a:noFill/>
@@ -7321,14 +8760,14 @@
       </p:sp>
       <p:sp>
         <p:nvSpPr>
-          <p:cNvPr id="79" name="TextBox 78"/>
+          <p:cNvPr id="118" name="TextBox 117"/>
           <p:cNvSpPr txBox="1"/>
           <p:nvPr/>
         </p:nvSpPr>
         <p:spPr>
           <a:xfrm>
-            <a:off x="9954000" y="24007500"/>
-            <a:ext cx="16092000" cy="1804499"/>
+            <a:off x="9954000" y="24830100"/>
+            <a:ext cx="16092000" cy="981899"/>
           </a:xfrm>
           <a:prstGeom prst="rect">
             <a:avLst/>
@@ -7356,7 +8795,7 @@
       </p:sp>
       <p:sp>
         <p:nvSpPr>
-          <p:cNvPr id="80" name="Rounded Rectangle 79"/>
+          <p:cNvPr id="119" name="Rounded Rectangle 118"/>
           <p:cNvSpPr/>
           <p:nvPr/>
         </p:nvSpPr>
@@ -7404,7 +8843,7 @@
       </p:sp>
       <p:sp>
         <p:nvSpPr>
-          <p:cNvPr id="81" name="Oval 80"/>
+          <p:cNvPr id="120" name="Oval 119"/>
           <p:cNvSpPr/>
           <p:nvPr/>
         </p:nvSpPr>
@@ -7457,7 +8896,7 @@
       </p:sp>
       <p:sp>
         <p:nvSpPr>
-          <p:cNvPr id="82" name="TextBox 81"/>
+          <p:cNvPr id="121" name="TextBox 120"/>
           <p:cNvSpPr txBox="1"/>
           <p:nvPr/>
         </p:nvSpPr>
@@ -7492,7 +8931,7 @@
       </p:sp>
       <p:sp>
         <p:nvSpPr>
-          <p:cNvPr id="83" name="Oval 82"/>
+          <p:cNvPr id="122" name="Oval 121"/>
           <p:cNvSpPr/>
           <p:nvPr/>
         </p:nvSpPr>
@@ -7545,7 +8984,7 @@
       </p:sp>
       <p:sp>
         <p:nvSpPr>
-          <p:cNvPr id="84" name="Rounded Rectangle 83"/>
+          <p:cNvPr id="123" name="Rounded Rectangle 122"/>
           <p:cNvSpPr/>
           <p:nvPr/>
         </p:nvSpPr>
@@ -7592,7 +9031,7 @@
       </p:sp>
       <p:sp>
         <p:nvSpPr>
-          <p:cNvPr id="85" name="TextBox 84"/>
+          <p:cNvPr id="124" name="TextBox 123"/>
           <p:cNvSpPr txBox="1"/>
           <p:nvPr/>
         </p:nvSpPr>
@@ -7627,7 +9066,7 @@
       </p:sp>
       <p:sp>
         <p:nvSpPr>
-          <p:cNvPr id="86" name="Oval 85"/>
+          <p:cNvPr id="125" name="Oval 124"/>
           <p:cNvSpPr/>
           <p:nvPr/>
         </p:nvSpPr>
@@ -7680,7 +9119,7 @@
       </p:sp>
       <p:sp>
         <p:nvSpPr>
-          <p:cNvPr id="87" name="Rounded Rectangle 86"/>
+          <p:cNvPr id="126" name="Rounded Rectangle 125"/>
           <p:cNvSpPr/>
           <p:nvPr/>
         </p:nvSpPr>
@@ -7727,7 +9166,7 @@
       </p:sp>
       <p:sp>
         <p:nvSpPr>
-          <p:cNvPr id="88" name="TextBox 87"/>
+          <p:cNvPr id="127" name="TextBox 126"/>
           <p:cNvSpPr txBox="1"/>
           <p:nvPr/>
         </p:nvSpPr>
@@ -7762,7 +9201,7 @@
       </p:sp>
       <p:sp>
         <p:nvSpPr>
-          <p:cNvPr id="89" name="Oval 88"/>
+          <p:cNvPr id="128" name="Oval 127"/>
           <p:cNvSpPr/>
           <p:nvPr/>
         </p:nvSpPr>
@@ -7815,7 +9254,7 @@
       </p:sp>
       <p:sp>
         <p:nvSpPr>
-          <p:cNvPr id="90" name="Rounded Rectangle 89"/>
+          <p:cNvPr id="129" name="Rounded Rectangle 128"/>
           <p:cNvSpPr/>
           <p:nvPr/>
         </p:nvSpPr>
@@ -7862,7 +9301,7 @@
       </p:sp>
       <p:sp>
         <p:nvSpPr>
-          <p:cNvPr id="91" name="TextBox 90"/>
+          <p:cNvPr id="130" name="TextBox 129"/>
           <p:cNvSpPr txBox="1"/>
           <p:nvPr/>
         </p:nvSpPr>
@@ -7897,7 +9336,7 @@
       </p:sp>
       <p:sp>
         <p:nvSpPr>
-          <p:cNvPr id="92" name="Oval 91"/>
+          <p:cNvPr id="131" name="Oval 130"/>
           <p:cNvSpPr/>
           <p:nvPr/>
         </p:nvSpPr>
@@ -7950,7 +9389,7 @@
       </p:sp>
       <p:sp>
         <p:nvSpPr>
-          <p:cNvPr id="93" name="Rounded Rectangle 92"/>
+          <p:cNvPr id="132" name="Rounded Rectangle 131"/>
           <p:cNvSpPr/>
           <p:nvPr/>
         </p:nvSpPr>
@@ -7997,7 +9436,7 @@
       </p:sp>
       <p:sp>
         <p:nvSpPr>
-          <p:cNvPr id="94" name="TextBox 93"/>
+          <p:cNvPr id="133" name="TextBox 132"/>
           <p:cNvSpPr txBox="1"/>
           <p:nvPr/>
         </p:nvSpPr>
@@ -8032,7 +9471,7 @@
       </p:sp>
       <p:sp>
         <p:nvSpPr>
-          <p:cNvPr id="95" name="Rounded Rectangle 94"/>
+          <p:cNvPr id="134" name="Rounded Rectangle 133"/>
           <p:cNvSpPr/>
           <p:nvPr/>
         </p:nvSpPr>
@@ -8080,7 +9519,7 @@
       </p:sp>
       <p:sp>
         <p:nvSpPr>
-          <p:cNvPr id="96" name="Oval 95"/>
+          <p:cNvPr id="135" name="Oval 134"/>
           <p:cNvSpPr/>
           <p:nvPr/>
         </p:nvSpPr>
@@ -8133,7 +9572,7 @@
       </p:sp>
       <p:sp>
         <p:nvSpPr>
-          <p:cNvPr id="97" name="TextBox 96"/>
+          <p:cNvPr id="136" name="TextBox 135"/>
           <p:cNvSpPr txBox="1"/>
           <p:nvPr/>
         </p:nvSpPr>
@@ -8168,7 +9607,7 @@
       </p:sp>
       <p:grpSp>
         <p:nvGrpSpPr>
-          <p:cNvPr id="98" name="Bieu do khai gian"/>
+          <p:cNvPr id="137" name="Bieu do khai gian"/>
           <p:cNvGrpSpPr/>
           <p:nvPr/>
         </p:nvGrpSpPr>
@@ -8182,7 +9621,7 @@
         </p:grpSpPr>
         <p:graphicFrame>
           <p:nvGraphicFramePr>
-            <p:cNvPr id="102" name="Chart 101"/>
+            <p:cNvPr id="141" name="Chart 140"/>
             <p:cNvGraphicFramePr>
               <a:graphicFrameLocks noGrp="1"/>
             </p:cNvGraphicFramePr>
@@ -8201,7 +9640,7 @@
       </p:grpSp>
       <p:sp>
         <p:nvSpPr>
-          <p:cNvPr id="99" name="TextBox 98"/>
+          <p:cNvPr id="138" name="TextBox 137"/>
           <p:cNvSpPr txBox="1"/>
           <p:nvPr/>
         </p:nvSpPr>
@@ -8236,7 +9675,7 @@
       </p:sp>
       <p:sp>
         <p:nvSpPr>
-          <p:cNvPr id="100" name="TextBox 99"/>
+          <p:cNvPr id="139" name="TextBox 138"/>
           <p:cNvSpPr txBox="1"/>
           <p:nvPr/>
         </p:nvSpPr>
@@ -8271,7 +9710,7 @@
       </p:sp>
       <p:sp>
         <p:nvSpPr>
-          <p:cNvPr id="101" name="TextBox 100"/>
+          <p:cNvPr id="140" name="TextBox 139"/>
           <p:cNvSpPr txBox="1"/>
           <p:nvPr/>
         </p:nvSpPr>
@@ -8306,7 +9745,7 @@
       </p:sp>
       <p:grpSp>
         <p:nvGrpSpPr>
-          <p:cNvPr id="103" name="Bieu do nguyen vong"/>
+          <p:cNvPr id="142" name="Bieu do nguyen vong"/>
           <p:cNvGrpSpPr/>
           <p:nvPr/>
         </p:nvGrpSpPr>
@@ -8320,7 +9759,7 @@
         </p:grpSpPr>
         <p:graphicFrame>
           <p:nvGraphicFramePr>
-            <p:cNvPr id="107" name="Chart 106"/>
+            <p:cNvPr id="146" name="Chart 145"/>
             <p:cNvGraphicFramePr>
               <a:graphicFrameLocks noGrp="1"/>
             </p:cNvGraphicFramePr>
@@ -8339,7 +9778,7 @@
       </p:grpSp>
       <p:sp>
         <p:nvSpPr>
-          <p:cNvPr id="104" name="TextBox 103"/>
+          <p:cNvPr id="143" name="TextBox 142"/>
           <p:cNvSpPr txBox="1"/>
           <p:nvPr/>
         </p:nvSpPr>
@@ -8374,7 +9813,7 @@
       </p:sp>
       <p:sp>
         <p:nvSpPr>
-          <p:cNvPr id="105" name="TextBox 104"/>
+          <p:cNvPr id="144" name="TextBox 143"/>
           <p:cNvSpPr txBox="1"/>
           <p:nvPr/>
         </p:nvSpPr>
@@ -8409,7 +9848,7 @@
       </p:sp>
       <p:sp>
         <p:nvSpPr>
-          <p:cNvPr id="106" name="TextBox 105"/>
+          <p:cNvPr id="145" name="TextBox 144"/>
           <p:cNvSpPr txBox="1"/>
           <p:nvPr/>
         </p:nvSpPr>
@@ -8444,7 +9883,7 @@
       </p:sp>
       <p:sp>
         <p:nvSpPr>
-          <p:cNvPr id="108" name="Rounded Rectangle 107"/>
+          <p:cNvPr id="147" name="Rounded Rectangle 146"/>
           <p:cNvSpPr/>
           <p:nvPr/>
         </p:nvSpPr>
@@ -8491,7 +9930,7 @@
       </p:sp>
       <p:sp>
         <p:nvSpPr>
-          <p:cNvPr id="109" name="TextBox 108"/>
+          <p:cNvPr id="148" name="TextBox 147"/>
           <p:cNvSpPr txBox="1"/>
           <p:nvPr/>
         </p:nvSpPr>
@@ -8526,7 +9965,7 @@
       </p:sp>
       <p:sp>
         <p:nvSpPr>
-          <p:cNvPr id="110" name="Rounded Rectangle 109"/>
+          <p:cNvPr id="149" name="Rounded Rectangle 148"/>
           <p:cNvSpPr/>
           <p:nvPr/>
         </p:nvSpPr>
@@ -8574,7 +10013,7 @@
       </p:sp>
       <p:sp>
         <p:nvSpPr>
-          <p:cNvPr id="111" name="TextBox 110"/>
+          <p:cNvPr id="150" name="TextBox 149"/>
           <p:cNvSpPr txBox="1"/>
           <p:nvPr/>
         </p:nvSpPr>
@@ -8609,7 +10048,7 @@
       </p:sp>
       <p:sp>
         <p:nvSpPr>
-          <p:cNvPr id="112" name="Rounded Rectangle 111"/>
+          <p:cNvPr id="151" name="Rounded Rectangle 150"/>
           <p:cNvSpPr/>
           <p:nvPr/>
         </p:nvSpPr>
@@ -8656,7 +10095,7 @@
       </p:sp>
       <p:sp>
         <p:nvSpPr>
-          <p:cNvPr id="113" name="TextBox 112"/>
+          <p:cNvPr id="152" name="TextBox 151"/>
           <p:cNvSpPr txBox="1"/>
           <p:nvPr/>
         </p:nvSpPr>

</xml_diff>

<commit_message>
Drop the late-student example from the lottery card
Co-Authored-By: Claude Opus 5.5 <noreply@anthropic.com>
Claude-Session: https://claude.ai/code/session_01NkYGd36L1Tpym32yxKyitD
</commit_message>
<xml_diff>
--- a/poster/poster_khung_1-2.pptx
+++ b/poster/poster_khung_1-2.pptx
@@ -8601,7 +8601,7 @@
                 </a:solidFill>
                 <a:latin typeface="IBM Plex Sans"/>
               </a:rPr>
-              <a:t>Em thêm muộn chèn vào vị trí ngẫu nhiên</a:t>
+              <a:t>Số đã bốc giữ nguyên ở các lần chạy sau</a:t>
             </a:r>
           </a:p>
         </p:txBody>
@@ -8636,7 +8636,7 @@
                 </a:solidFill>
                 <a:latin typeface="IBM Plex Sans"/>
               </a:rPr>
-              <a:t>Thứ tự các em cũ giữ nguyên</a:t>
+              <a:t>Muốn bốc lại phải bấm "Vẽ lại"</a:t>
             </a:r>
           </a:p>
         </p:txBody>
@@ -8649,8 +8649,8 @@
         </p:nvSpPr>
         <p:spPr>
           <a:xfrm>
-            <a:off x="22263810" y="23757202"/>
-            <a:ext cx="180000" cy="222787"/>
+            <a:off x="9979650" y="24291207"/>
+            <a:ext cx="180000" cy="213876"/>
           </a:xfrm>
           <a:prstGeom prst="rect">
             <a:avLst/>
@@ -8665,41 +8665,6 @@
           <a:p>
             <a:pPr algn="l"/>
             <a:r>
-              <a:rPr sz="1349" b="0" i="0">
-                <a:solidFill>
-                  <a:srgbClr val="5B6570"/>
-                </a:solidFill>
-                <a:latin typeface="IBM Plex Sans"/>
-              </a:rPr>
-              <a:t>Muốn bốc lại phải bấm "Vẽ lại"</a:t>
-            </a:r>
-          </a:p>
-        </p:txBody>
-      </p:sp>
-      <p:sp>
-        <p:nvSpPr>
-          <p:cNvPr id="116" name="TextBox 115"/>
-          <p:cNvSpPr txBox="1"/>
-          <p:nvPr/>
-        </p:nvSpPr>
-        <p:spPr>
-          <a:xfrm>
-            <a:off x="9979650" y="24291207"/>
-            <a:ext cx="180000" cy="213876"/>
-          </a:xfrm>
-          <a:prstGeom prst="rect">
-            <a:avLst/>
-          </a:prstGeom>
-          <a:noFill/>
-        </p:spPr>
-        <p:txBody>
-          <a:bodyPr wrap="none" anchor="t" lIns="0" rIns="0" tIns="0" bIns="0">
-            <a:spAutoFit/>
-          </a:bodyPr>
-          <a:lstStyle/>
-          <a:p>
-            <a:pPr algn="l"/>
-            <a:r>
               <a:rPr sz="1295" b="0" i="0">
                 <a:solidFill>
                   <a:srgbClr val="8A929A"/>
@@ -8713,7 +8678,7 @@
       </p:sp>
       <p:sp>
         <p:nvSpPr>
-          <p:cNvPr id="117" name="Rounded Rectangle 116"/>
+          <p:cNvPr id="116" name="Rounded Rectangle 115"/>
           <p:cNvSpPr/>
           <p:nvPr/>
         </p:nvSpPr>
@@ -8760,7 +8725,7 @@
       </p:sp>
       <p:sp>
         <p:nvSpPr>
-          <p:cNvPr id="118" name="TextBox 117"/>
+          <p:cNvPr id="117" name="TextBox 116"/>
           <p:cNvSpPr txBox="1"/>
           <p:nvPr/>
         </p:nvSpPr>
@@ -8795,7 +8760,7 @@
       </p:sp>
       <p:sp>
         <p:nvSpPr>
-          <p:cNvPr id="119" name="Rounded Rectangle 118"/>
+          <p:cNvPr id="118" name="Rounded Rectangle 117"/>
           <p:cNvSpPr/>
           <p:nvPr/>
         </p:nvSpPr>
@@ -8843,7 +8808,7 @@
       </p:sp>
       <p:sp>
         <p:nvSpPr>
-          <p:cNvPr id="120" name="Oval 119"/>
+          <p:cNvPr id="119" name="Oval 118"/>
           <p:cNvSpPr/>
           <p:nvPr/>
         </p:nvSpPr>
@@ -8896,7 +8861,7 @@
       </p:sp>
       <p:sp>
         <p:nvSpPr>
-          <p:cNvPr id="121" name="TextBox 120"/>
+          <p:cNvPr id="120" name="TextBox 119"/>
           <p:cNvSpPr txBox="1"/>
           <p:nvPr/>
         </p:nvSpPr>
@@ -8931,7 +8896,7 @@
       </p:sp>
       <p:sp>
         <p:nvSpPr>
-          <p:cNvPr id="122" name="Oval 121"/>
+          <p:cNvPr id="121" name="Oval 120"/>
           <p:cNvSpPr/>
           <p:nvPr/>
         </p:nvSpPr>
@@ -8984,7 +8949,7 @@
       </p:sp>
       <p:sp>
         <p:nvSpPr>
-          <p:cNvPr id="123" name="Rounded Rectangle 122"/>
+          <p:cNvPr id="122" name="Rounded Rectangle 121"/>
           <p:cNvSpPr/>
           <p:nvPr/>
         </p:nvSpPr>
@@ -9031,7 +8996,7 @@
       </p:sp>
       <p:sp>
         <p:nvSpPr>
-          <p:cNvPr id="124" name="TextBox 123"/>
+          <p:cNvPr id="123" name="TextBox 122"/>
           <p:cNvSpPr txBox="1"/>
           <p:nvPr/>
         </p:nvSpPr>
@@ -9066,7 +9031,7 @@
       </p:sp>
       <p:sp>
         <p:nvSpPr>
-          <p:cNvPr id="125" name="Oval 124"/>
+          <p:cNvPr id="124" name="Oval 123"/>
           <p:cNvSpPr/>
           <p:nvPr/>
         </p:nvSpPr>
@@ -9119,7 +9084,7 @@
       </p:sp>
       <p:sp>
         <p:nvSpPr>
-          <p:cNvPr id="126" name="Rounded Rectangle 125"/>
+          <p:cNvPr id="125" name="Rounded Rectangle 124"/>
           <p:cNvSpPr/>
           <p:nvPr/>
         </p:nvSpPr>
@@ -9166,7 +9131,7 @@
       </p:sp>
       <p:sp>
         <p:nvSpPr>
-          <p:cNvPr id="127" name="TextBox 126"/>
+          <p:cNvPr id="126" name="TextBox 125"/>
           <p:cNvSpPr txBox="1"/>
           <p:nvPr/>
         </p:nvSpPr>
@@ -9201,7 +9166,7 @@
       </p:sp>
       <p:sp>
         <p:nvSpPr>
-          <p:cNvPr id="128" name="Oval 127"/>
+          <p:cNvPr id="127" name="Oval 126"/>
           <p:cNvSpPr/>
           <p:nvPr/>
         </p:nvSpPr>
@@ -9254,7 +9219,7 @@
       </p:sp>
       <p:sp>
         <p:nvSpPr>
-          <p:cNvPr id="129" name="Rounded Rectangle 128"/>
+          <p:cNvPr id="128" name="Rounded Rectangle 127"/>
           <p:cNvSpPr/>
           <p:nvPr/>
         </p:nvSpPr>
@@ -9301,7 +9266,7 @@
       </p:sp>
       <p:sp>
         <p:nvSpPr>
-          <p:cNvPr id="130" name="TextBox 129"/>
+          <p:cNvPr id="129" name="TextBox 128"/>
           <p:cNvSpPr txBox="1"/>
           <p:nvPr/>
         </p:nvSpPr>
@@ -9336,7 +9301,7 @@
       </p:sp>
       <p:sp>
         <p:nvSpPr>
-          <p:cNvPr id="131" name="Oval 130"/>
+          <p:cNvPr id="130" name="Oval 129"/>
           <p:cNvSpPr/>
           <p:nvPr/>
         </p:nvSpPr>
@@ -9389,7 +9354,7 @@
       </p:sp>
       <p:sp>
         <p:nvSpPr>
-          <p:cNvPr id="132" name="Rounded Rectangle 131"/>
+          <p:cNvPr id="131" name="Rounded Rectangle 130"/>
           <p:cNvSpPr/>
           <p:nvPr/>
         </p:nvSpPr>
@@ -9436,7 +9401,7 @@
       </p:sp>
       <p:sp>
         <p:nvSpPr>
-          <p:cNvPr id="133" name="TextBox 132"/>
+          <p:cNvPr id="132" name="TextBox 131"/>
           <p:cNvSpPr txBox="1"/>
           <p:nvPr/>
         </p:nvSpPr>
@@ -9471,7 +9436,7 @@
       </p:sp>
       <p:sp>
         <p:nvSpPr>
-          <p:cNvPr id="134" name="Rounded Rectangle 133"/>
+          <p:cNvPr id="133" name="Rounded Rectangle 132"/>
           <p:cNvSpPr/>
           <p:nvPr/>
         </p:nvSpPr>
@@ -9519,7 +9484,7 @@
       </p:sp>
       <p:sp>
         <p:nvSpPr>
-          <p:cNvPr id="135" name="Oval 134"/>
+          <p:cNvPr id="134" name="Oval 133"/>
           <p:cNvSpPr/>
           <p:nvPr/>
         </p:nvSpPr>
@@ -9572,7 +9537,7 @@
       </p:sp>
       <p:sp>
         <p:nvSpPr>
-          <p:cNvPr id="136" name="TextBox 135"/>
+          <p:cNvPr id="135" name="TextBox 134"/>
           <p:cNvSpPr txBox="1"/>
           <p:nvPr/>
         </p:nvSpPr>
@@ -9607,7 +9572,7 @@
       </p:sp>
       <p:grpSp>
         <p:nvGrpSpPr>
-          <p:cNvPr id="137" name="Bieu do khai gian"/>
+          <p:cNvPr id="136" name="Bieu do khai gian"/>
           <p:cNvGrpSpPr/>
           <p:nvPr/>
         </p:nvGrpSpPr>
@@ -9621,7 +9586,7 @@
         </p:grpSpPr>
         <p:graphicFrame>
           <p:nvGraphicFramePr>
-            <p:cNvPr id="141" name="Chart 140"/>
+            <p:cNvPr id="140" name="Chart 139"/>
             <p:cNvGraphicFramePr>
               <a:graphicFrameLocks noGrp="1"/>
             </p:cNvGraphicFramePr>
@@ -9640,7 +9605,7 @@
       </p:grpSp>
       <p:sp>
         <p:nvSpPr>
-          <p:cNvPr id="138" name="TextBox 137"/>
+          <p:cNvPr id="137" name="TextBox 136"/>
           <p:cNvSpPr txBox="1"/>
           <p:nvPr/>
         </p:nvSpPr>
@@ -9675,7 +9640,7 @@
       </p:sp>
       <p:sp>
         <p:nvSpPr>
-          <p:cNvPr id="139" name="TextBox 138"/>
+          <p:cNvPr id="138" name="TextBox 137"/>
           <p:cNvSpPr txBox="1"/>
           <p:nvPr/>
         </p:nvSpPr>
@@ -9710,7 +9675,7 @@
       </p:sp>
       <p:sp>
         <p:nvSpPr>
-          <p:cNvPr id="140" name="TextBox 139"/>
+          <p:cNvPr id="139" name="TextBox 138"/>
           <p:cNvSpPr txBox="1"/>
           <p:nvPr/>
         </p:nvSpPr>
@@ -9745,7 +9710,7 @@
       </p:sp>
       <p:grpSp>
         <p:nvGrpSpPr>
-          <p:cNvPr id="142" name="Bieu do nguyen vong"/>
+          <p:cNvPr id="141" name="Bieu do nguyen vong"/>
           <p:cNvGrpSpPr/>
           <p:nvPr/>
         </p:nvGrpSpPr>
@@ -9759,7 +9724,7 @@
         </p:grpSpPr>
         <p:graphicFrame>
           <p:nvGraphicFramePr>
-            <p:cNvPr id="146" name="Chart 145"/>
+            <p:cNvPr id="145" name="Chart 144"/>
             <p:cNvGraphicFramePr>
               <a:graphicFrameLocks noGrp="1"/>
             </p:cNvGraphicFramePr>
@@ -9778,7 +9743,7 @@
       </p:grpSp>
       <p:sp>
         <p:nvSpPr>
-          <p:cNvPr id="143" name="TextBox 142"/>
+          <p:cNvPr id="142" name="TextBox 141"/>
           <p:cNvSpPr txBox="1"/>
           <p:nvPr/>
         </p:nvSpPr>
@@ -9813,7 +9778,7 @@
       </p:sp>
       <p:sp>
         <p:nvSpPr>
-          <p:cNvPr id="144" name="TextBox 143"/>
+          <p:cNvPr id="143" name="TextBox 142"/>
           <p:cNvSpPr txBox="1"/>
           <p:nvPr/>
         </p:nvSpPr>
@@ -9848,7 +9813,7 @@
       </p:sp>
       <p:sp>
         <p:nvSpPr>
-          <p:cNvPr id="145" name="TextBox 144"/>
+          <p:cNvPr id="144" name="TextBox 143"/>
           <p:cNvSpPr txBox="1"/>
           <p:nvPr/>
         </p:nvSpPr>
@@ -9883,7 +9848,7 @@
       </p:sp>
       <p:sp>
         <p:nvSpPr>
-          <p:cNvPr id="147" name="Rounded Rectangle 146"/>
+          <p:cNvPr id="146" name="Rounded Rectangle 145"/>
           <p:cNvSpPr/>
           <p:nvPr/>
         </p:nvSpPr>
@@ -9930,7 +9895,7 @@
       </p:sp>
       <p:sp>
         <p:nvSpPr>
-          <p:cNvPr id="148" name="TextBox 147"/>
+          <p:cNvPr id="147" name="TextBox 146"/>
           <p:cNvSpPr txBox="1"/>
           <p:nvPr/>
         </p:nvSpPr>
@@ -9965,7 +9930,7 @@
       </p:sp>
       <p:sp>
         <p:nvSpPr>
-          <p:cNvPr id="149" name="Rounded Rectangle 148"/>
+          <p:cNvPr id="148" name="Rounded Rectangle 147"/>
           <p:cNvSpPr/>
           <p:nvPr/>
         </p:nvSpPr>
@@ -10013,7 +9978,7 @@
       </p:sp>
       <p:sp>
         <p:nvSpPr>
-          <p:cNvPr id="150" name="TextBox 149"/>
+          <p:cNvPr id="149" name="TextBox 148"/>
           <p:cNvSpPr txBox="1"/>
           <p:nvPr/>
         </p:nvSpPr>
@@ -10048,7 +10013,7 @@
       </p:sp>
       <p:sp>
         <p:nvSpPr>
-          <p:cNvPr id="151" name="Rounded Rectangle 150"/>
+          <p:cNvPr id="150" name="Rounded Rectangle 149"/>
           <p:cNvSpPr/>
           <p:nvPr/>
         </p:nvSpPr>
@@ -10095,7 +10060,7 @@
       </p:sp>
       <p:sp>
         <p:nvSpPr>
-          <p:cNvPr id="152" name="TextBox 151"/>
+          <p:cNvPr id="151" name="TextBox 150"/>
           <p:cNvSpPr txBox="1"/>
           <p:nvPr/>
         </p:nvSpPr>

</xml_diff>

<commit_message>
Fill the diagram boxes and drop '=' and '+' from its labels
Larger text in every box, rebalanced column widths so nothing
overflows, and the lock card now reads in words: changing the seed
and confirming once more to draw again.

Co-Authored-By: Claude Opus 5.5 <noreply@anthropic.com>
Claude-Session: https://claude.ai/code/session_01NkYGd36L1Tpym32yxKyitD
</commit_message>
<xml_diff>
--- a/poster/poster_khung_1-2.pptx
+++ b/poster/poster_khung_1-2.pptx
@@ -5923,11 +5923,11 @@
         <p:spPr>
           <a:xfrm>
             <a:off x="9979650" y="17755650"/>
-            <a:ext cx="2056500" cy="3838800"/>
+            <a:ext cx="1850850" cy="3838800"/>
           </a:xfrm>
           <a:prstGeom prst="roundRect">
             <a:avLst>
-              <a:gd name="adj" fmla="val 6000"/>
+              <a:gd name="adj" fmla="val 6666"/>
             </a:avLst>
           </a:prstGeom>
           <a:solidFill>
@@ -5970,8 +5970,8 @@
         </p:nvSpPr>
         <p:spPr>
           <a:xfrm>
-            <a:off x="10199010" y="17988720"/>
-            <a:ext cx="180000" cy="356460"/>
+            <a:off x="10199010" y="17991462"/>
+            <a:ext cx="180000" cy="392106"/>
           </a:xfrm>
           <a:prstGeom prst="rect">
             <a:avLst/>
@@ -5986,7 +5986,7 @@
           <a:p>
             <a:pPr algn="l"/>
             <a:r>
-              <a:rPr sz="2159" b="1" i="0">
+              <a:rPr sz="2374" b="1" i="0">
                 <a:solidFill>
                   <a:srgbClr val="1C2321"/>
                 </a:solidFill>
@@ -6005,8 +6005,8 @@
         </p:nvSpPr>
         <p:spPr>
           <a:xfrm>
-            <a:off x="10199010" y="18487764"/>
-            <a:ext cx="180000" cy="249522"/>
+            <a:off x="10199010" y="18531636"/>
+            <a:ext cx="180000" cy="285168"/>
           </a:xfrm>
           <a:prstGeom prst="rect">
             <a:avLst/>
@@ -6021,7 +6021,7 @@
           <a:p>
             <a:pPr algn="l"/>
             <a:r>
-              <a:rPr sz="1511" b="0" i="0">
+              <a:rPr sz="1727" b="0" i="0">
                 <a:solidFill>
                   <a:srgbClr val="5B6570"/>
                 </a:solidFill>
@@ -6040,8 +6040,8 @@
         </p:nvSpPr>
         <p:spPr>
           <a:xfrm>
-            <a:off x="10199010" y="18775674"/>
-            <a:ext cx="180000" cy="249522"/>
+            <a:off x="10199010" y="18860676"/>
+            <a:ext cx="180000" cy="285168"/>
           </a:xfrm>
           <a:prstGeom prst="rect">
             <a:avLst/>
@@ -6056,7 +6056,7 @@
           <a:p>
             <a:pPr algn="l"/>
             <a:r>
-              <a:rPr sz="1511" b="0" i="0">
+              <a:rPr sz="1727" b="0" i="0">
                 <a:solidFill>
                   <a:srgbClr val="5B6570"/>
                 </a:solidFill>
@@ -6075,8 +6075,8 @@
         </p:nvSpPr>
         <p:spPr>
           <a:xfrm>
-            <a:off x="10199010" y="19063584"/>
-            <a:ext cx="180000" cy="249522"/>
+            <a:off x="10199010" y="19189716"/>
+            <a:ext cx="180000" cy="285168"/>
           </a:xfrm>
           <a:prstGeom prst="rect">
             <a:avLst/>
@@ -6091,7 +6091,7 @@
           <a:p>
             <a:pPr algn="l"/>
             <a:r>
-              <a:rPr sz="1511" b="0" i="0">
+              <a:rPr sz="1727" b="0" i="0">
                 <a:solidFill>
                   <a:srgbClr val="5B6570"/>
                 </a:solidFill>
@@ -6110,8 +6110,8 @@
         </p:nvSpPr>
         <p:spPr>
           <a:xfrm>
-            <a:off x="10199010" y="19351494"/>
-            <a:ext cx="180000" cy="249522"/>
+            <a:off x="10199010" y="19518756"/>
+            <a:ext cx="180000" cy="285168"/>
           </a:xfrm>
           <a:prstGeom prst="rect">
             <a:avLst/>
@@ -6126,7 +6126,7 @@
           <a:p>
             <a:pPr algn="l"/>
             <a:r>
-              <a:rPr sz="1511" b="0" i="0">
+              <a:rPr sz="1727" b="0" i="0">
                 <a:solidFill>
                   <a:srgbClr val="5B6570"/>
                 </a:solidFill>
@@ -6145,8 +6145,8 @@
         </p:nvSpPr>
         <p:spPr>
           <a:xfrm>
-            <a:off x="10199010" y="19639404"/>
-            <a:ext cx="180000" cy="249522"/>
+            <a:off x="10199010" y="19847796"/>
+            <a:ext cx="180000" cy="285168"/>
           </a:xfrm>
           <a:prstGeom prst="rect">
             <a:avLst/>
@@ -6161,7 +6161,7 @@
           <a:p>
             <a:pPr algn="l"/>
             <a:r>
-              <a:rPr sz="1511" b="0" i="0">
+              <a:rPr sz="1727" b="0" i="0">
                 <a:solidFill>
                   <a:srgbClr val="5B6570"/>
                 </a:solidFill>
@@ -6180,8 +6180,8 @@
         </p:nvSpPr>
         <p:spPr>
           <a:xfrm>
-            <a:off x="10199010" y="19927314"/>
-            <a:ext cx="180000" cy="249522"/>
+            <a:off x="10199010" y="20176836"/>
+            <a:ext cx="180000" cy="285168"/>
           </a:xfrm>
           <a:prstGeom prst="rect">
             <a:avLst/>
@@ -6196,7 +6196,7 @@
           <a:p>
             <a:pPr algn="l"/>
             <a:r>
-              <a:rPr sz="1511" b="0" i="0">
+              <a:rPr sz="1727" b="0" i="0">
                 <a:solidFill>
                   <a:srgbClr val="5B6570"/>
                 </a:solidFill>
@@ -6215,8 +6215,8 @@
         </p:nvSpPr>
         <p:spPr>
           <a:xfrm>
-            <a:off x="10199010" y="20215224"/>
-            <a:ext cx="180000" cy="249522"/>
+            <a:off x="10199010" y="20505876"/>
+            <a:ext cx="180000" cy="285168"/>
           </a:xfrm>
           <a:prstGeom prst="rect">
             <a:avLst/>
@@ -6231,7 +6231,7 @@
           <a:p>
             <a:pPr algn="l"/>
             <a:r>
-              <a:rPr sz="1511" b="0" i="0">
+              <a:rPr sz="1727" b="0" i="0">
                 <a:solidFill>
                   <a:srgbClr val="5B6570"/>
                 </a:solidFill>
@@ -6250,8 +6250,8 @@
         </p:nvSpPr>
         <p:spPr>
           <a:xfrm>
-            <a:off x="10199010" y="20503134"/>
-            <a:ext cx="180000" cy="249522"/>
+            <a:off x="10199010" y="20834916"/>
+            <a:ext cx="180000" cy="285168"/>
           </a:xfrm>
           <a:prstGeom prst="rect">
             <a:avLst/>
@@ -6266,7 +6266,7 @@
           <a:p>
             <a:pPr algn="l"/>
             <a:r>
-              <a:rPr sz="1511" b="0" i="0">
+              <a:rPr sz="1727" b="0" i="0">
                 <a:solidFill>
                   <a:srgbClr val="5B6570"/>
                 </a:solidFill>
@@ -6285,8 +6285,8 @@
         </p:nvSpPr>
         <p:spPr>
           <a:xfrm>
-            <a:off x="10199010" y="20791044"/>
-            <a:ext cx="180000" cy="249522"/>
+            <a:off x="10199010" y="21163956"/>
+            <a:ext cx="180000" cy="285168"/>
           </a:xfrm>
           <a:prstGeom prst="rect">
             <a:avLst/>
@@ -6301,7 +6301,7 @@
           <a:p>
             <a:pPr algn="l"/>
             <a:r>
-              <a:rPr sz="1511" b="0" i="0">
+              <a:rPr sz="1727" b="0" i="0">
                 <a:solidFill>
                   <a:srgbClr val="5B6570"/>
                 </a:solidFill>
@@ -6320,8 +6320,8 @@
         </p:nvSpPr>
         <p:spPr>
           <a:xfrm>
-            <a:off x="12036149" y="19565370"/>
-            <a:ext cx="411300" cy="219360"/>
+            <a:off x="11830499" y="19565370"/>
+            <a:ext cx="342750" cy="219360"/>
           </a:xfrm>
           <a:prstGeom prst="rightArrow">
             <a:avLst/>
@@ -6364,8 +6364,8 @@
         </p:nvSpPr>
         <p:spPr>
           <a:xfrm>
-            <a:off x="12447450" y="17755650"/>
-            <a:ext cx="3975900" cy="3838800"/>
+            <a:off x="12173250" y="17755650"/>
+            <a:ext cx="4250100" cy="3838800"/>
           </a:xfrm>
           <a:prstGeom prst="roundRect">
             <a:avLst>
@@ -6412,7 +6412,7 @@
         </p:nvSpPr>
         <p:spPr>
           <a:xfrm>
-            <a:off x="12625680" y="17947590"/>
+            <a:off x="12351480" y="17947590"/>
             <a:ext cx="411300" cy="411300"/>
           </a:xfrm>
           <a:prstGeom prst="ellipse">
@@ -6465,8 +6465,8 @@
         </p:nvSpPr>
         <p:spPr>
           <a:xfrm>
-            <a:off x="13160370" y="17988720"/>
-            <a:ext cx="180000" cy="356460"/>
+            <a:off x="12886170" y="17990091"/>
+            <a:ext cx="180000" cy="374283"/>
           </a:xfrm>
           <a:prstGeom prst="rect">
             <a:avLst/>
@@ -6481,7 +6481,7 @@
           <a:p>
             <a:pPr algn="l"/>
             <a:r>
-              <a:rPr sz="2159" b="1" i="0">
+              <a:rPr sz="2267" b="1" i="0">
                 <a:solidFill>
                   <a:srgbClr val="1C2321"/>
                 </a:solidFill>
@@ -6500,8 +6500,8 @@
         </p:nvSpPr>
         <p:spPr>
           <a:xfrm>
-            <a:off x="12666810" y="18487764"/>
-            <a:ext cx="180000" cy="249522"/>
+            <a:off x="12392609" y="18517926"/>
+            <a:ext cx="180000" cy="285168"/>
           </a:xfrm>
           <a:prstGeom prst="rect">
             <a:avLst/>
@@ -6516,7 +6516,7 @@
           <a:p>
             <a:pPr algn="l"/>
             <a:r>
-              <a:rPr sz="1511" b="0" i="0">
+              <a:rPr sz="1727" b="0" i="0">
                 <a:solidFill>
                   <a:srgbClr val="5B6570"/>
                 </a:solidFill>
@@ -6535,8 +6535,8 @@
         </p:nvSpPr>
         <p:spPr>
           <a:xfrm>
-            <a:off x="12666810" y="18775674"/>
-            <a:ext cx="180000" cy="249522"/>
+            <a:off x="12392609" y="18846966"/>
+            <a:ext cx="180000" cy="285168"/>
           </a:xfrm>
           <a:prstGeom prst="rect">
             <a:avLst/>
@@ -6551,7 +6551,7 @@
           <a:p>
             <a:pPr algn="l"/>
             <a:r>
-              <a:rPr sz="1511" b="0" i="0">
+              <a:rPr sz="1727" b="0" i="0">
                 <a:solidFill>
                   <a:srgbClr val="5B6570"/>
                 </a:solidFill>
@@ -6570,8 +6570,8 @@
         </p:nvSpPr>
         <p:spPr>
           <a:xfrm>
-            <a:off x="12666810" y="19063584"/>
-            <a:ext cx="180000" cy="249522"/>
+            <a:off x="12392609" y="19176006"/>
+            <a:ext cx="180000" cy="285168"/>
           </a:xfrm>
           <a:prstGeom prst="rect">
             <a:avLst/>
@@ -6586,7 +6586,7 @@
           <a:p>
             <a:pPr algn="l"/>
             <a:r>
-              <a:rPr sz="1511" b="0" i="0">
+              <a:rPr sz="1727" b="0" i="0">
                 <a:solidFill>
                   <a:srgbClr val="5B6570"/>
                 </a:solidFill>
@@ -6605,8 +6605,8 @@
         </p:nvSpPr>
         <p:spPr>
           <a:xfrm>
-            <a:off x="12666810" y="19351494"/>
-            <a:ext cx="180000" cy="249522"/>
+            <a:off x="12392609" y="19505046"/>
+            <a:ext cx="180000" cy="285168"/>
           </a:xfrm>
           <a:prstGeom prst="rect">
             <a:avLst/>
@@ -6621,7 +6621,7 @@
           <a:p>
             <a:pPr algn="l"/>
             <a:r>
-              <a:rPr sz="1511" b="0" i="0">
+              <a:rPr sz="1727" b="0" i="0">
                 <a:solidFill>
                   <a:srgbClr val="5B6570"/>
                 </a:solidFill>
@@ -6640,8 +6640,8 @@
         </p:nvSpPr>
         <p:spPr>
           <a:xfrm>
-            <a:off x="12666810" y="19639404"/>
-            <a:ext cx="180000" cy="249522"/>
+            <a:off x="12392609" y="19834086"/>
+            <a:ext cx="180000" cy="285168"/>
           </a:xfrm>
           <a:prstGeom prst="rect">
             <a:avLst/>
@@ -6656,7 +6656,7 @@
           <a:p>
             <a:pPr algn="l"/>
             <a:r>
-              <a:rPr sz="1511" b="0" i="0">
+              <a:rPr sz="1727" b="0" i="0">
                 <a:solidFill>
                   <a:srgbClr val="5B6570"/>
                 </a:solidFill>
@@ -6675,8 +6675,8 @@
         </p:nvSpPr>
         <p:spPr>
           <a:xfrm>
-            <a:off x="12666810" y="19927314"/>
-            <a:ext cx="180000" cy="249522"/>
+            <a:off x="12392609" y="20163126"/>
+            <a:ext cx="180000" cy="285168"/>
           </a:xfrm>
           <a:prstGeom prst="rect">
             <a:avLst/>
@@ -6691,7 +6691,7 @@
           <a:p>
             <a:pPr algn="l"/>
             <a:r>
-              <a:rPr sz="1511" b="0" i="0">
+              <a:rPr sz="1727" b="0" i="0">
                 <a:solidFill>
                   <a:srgbClr val="5B6570"/>
                 </a:solidFill>
@@ -6710,8 +6710,8 @@
         </p:nvSpPr>
         <p:spPr>
           <a:xfrm>
-            <a:off x="12666810" y="20215224"/>
-            <a:ext cx="180000" cy="249522"/>
+            <a:off x="12392609" y="20492166"/>
+            <a:ext cx="180000" cy="285168"/>
           </a:xfrm>
           <a:prstGeom prst="rect">
             <a:avLst/>
@@ -6726,13 +6726,13 @@
           <a:p>
             <a:pPr algn="l"/>
             <a:r>
-              <a:rPr sz="1511" b="0" i="0">
+              <a:rPr sz="1727" b="0" i="0">
                 <a:solidFill>
                   <a:srgbClr val="5B6570"/>
                 </a:solidFill>
                 <a:latin typeface="IBM Plex Sans"/>
               </a:rPr>
-              <a:t/>
+              <a:t>CLB không biết em chọn mình</a:t>
             </a:r>
           </a:p>
         </p:txBody>
@@ -6745,8 +6745,8 @@
         </p:nvSpPr>
         <p:spPr>
           <a:xfrm>
-            <a:off x="12666810" y="20503134"/>
-            <a:ext cx="180000" cy="249522"/>
+            <a:off x="12392609" y="20821206"/>
+            <a:ext cx="180000" cy="285168"/>
           </a:xfrm>
           <a:prstGeom prst="rect">
             <a:avLst/>
@@ -6761,42 +6761,7 @@
           <a:p>
             <a:pPr algn="l"/>
             <a:r>
-              <a:rPr sz="1511" b="0" i="0">
-                <a:solidFill>
-                  <a:srgbClr val="5B6570"/>
-                </a:solidFill>
-                <a:latin typeface="IBM Plex Sans"/>
-              </a:rPr>
-              <a:t>CLB không biết em chọn mình</a:t>
-            </a:r>
-          </a:p>
-        </p:txBody>
-      </p:sp>
-      <p:sp>
-        <p:nvSpPr>
-          <p:cNvPr id="67" name="TextBox 66"/>
-          <p:cNvSpPr txBox="1"/>
-          <p:nvPr/>
-        </p:nvSpPr>
-        <p:spPr>
-          <a:xfrm>
-            <a:off x="12666810" y="20791044"/>
-            <a:ext cx="180000" cy="249522"/>
-          </a:xfrm>
-          <a:prstGeom prst="rect">
-            <a:avLst/>
-          </a:prstGeom>
-          <a:noFill/>
-        </p:spPr>
-        <p:txBody>
-          <a:bodyPr wrap="none" anchor="t" lIns="0" rIns="0" tIns="0" bIns="0">
-            <a:spAutoFit/>
-          </a:bodyPr>
-          <a:lstStyle/>
-          <a:p>
-            <a:pPr algn="l"/>
-            <a:r>
-              <a:rPr sz="1511" b="0" i="0">
+              <a:rPr sz="1727" b="0" i="0">
                 <a:solidFill>
                   <a:srgbClr val="5B6570"/>
                 </a:solidFill>
@@ -6809,14 +6774,14 @@
       </p:sp>
       <p:sp>
         <p:nvSpPr>
-          <p:cNvPr id="68" name="Right Arrow 67"/>
+          <p:cNvPr id="67" name="Right Arrow 66"/>
           <p:cNvSpPr/>
           <p:nvPr/>
         </p:nvSpPr>
         <p:spPr>
           <a:xfrm>
             <a:off x="16423350" y="19565370"/>
-            <a:ext cx="411300" cy="219360"/>
+            <a:ext cx="342750" cy="219360"/>
           </a:xfrm>
           <a:prstGeom prst="rightArrow">
             <a:avLst/>
@@ -6853,14 +6818,14 @@
       </p:sp>
       <p:sp>
         <p:nvSpPr>
-          <p:cNvPr id="69" name="Rounded Rectangle 68"/>
+          <p:cNvPr id="68" name="Rounded Rectangle 67"/>
           <p:cNvSpPr/>
           <p:nvPr/>
         </p:nvSpPr>
         <p:spPr>
           <a:xfrm>
-            <a:off x="16834650" y="17755650"/>
-            <a:ext cx="5278350" cy="3838800"/>
+            <a:off x="16766100" y="17755650"/>
+            <a:ext cx="5209800" cy="3838800"/>
           </a:xfrm>
           <a:prstGeom prst="roundRect">
             <a:avLst>
@@ -6901,13 +6866,13 @@
       </p:sp>
       <p:sp>
         <p:nvSpPr>
-          <p:cNvPr id="70" name="Oval 69"/>
+          <p:cNvPr id="69" name="Oval 68"/>
           <p:cNvSpPr/>
           <p:nvPr/>
         </p:nvSpPr>
         <p:spPr>
           <a:xfrm>
-            <a:off x="17012880" y="17947590"/>
+            <a:off x="16944330" y="17947590"/>
             <a:ext cx="411300" cy="411300"/>
           </a:xfrm>
           <a:prstGeom prst="ellipse">
@@ -6954,14 +6919,14 @@
       </p:sp>
       <p:sp>
         <p:nvSpPr>
-          <p:cNvPr id="71" name="TextBox 70"/>
+          <p:cNvPr id="70" name="TextBox 69"/>
           <p:cNvSpPr txBox="1"/>
           <p:nvPr/>
         </p:nvSpPr>
         <p:spPr>
           <a:xfrm>
-            <a:off x="17547570" y="18002430"/>
-            <a:ext cx="180000" cy="356460"/>
+            <a:off x="17479020" y="17991462"/>
+            <a:ext cx="180000" cy="392106"/>
           </a:xfrm>
           <a:prstGeom prst="rect">
             <a:avLst/>
@@ -6976,7 +6941,7 @@
           <a:p>
             <a:pPr algn="l"/>
             <a:r>
-              <a:rPr sz="2159" b="1" i="0">
+              <a:rPr sz="2374" b="1" i="0">
                 <a:solidFill>
                   <a:srgbClr val="1C2321"/>
                 </a:solidFill>
@@ -6989,14 +6954,14 @@
       </p:sp>
       <p:sp>
         <p:nvSpPr>
-          <p:cNvPr id="72" name="TextBox 71"/>
+          <p:cNvPr id="71" name="TextBox 70"/>
           <p:cNvSpPr txBox="1"/>
           <p:nvPr/>
         </p:nvSpPr>
         <p:spPr>
           <a:xfrm>
-            <a:off x="17054010" y="18501474"/>
-            <a:ext cx="180000" cy="249522"/>
+            <a:off x="16985460" y="18531636"/>
+            <a:ext cx="180000" cy="285168"/>
           </a:xfrm>
           <a:prstGeom prst="rect">
             <a:avLst/>
@@ -7011,7 +6976,7 @@
           <a:p>
             <a:pPr algn="l"/>
             <a:r>
-              <a:rPr sz="1511" b="0" i="0">
+              <a:rPr sz="1727" b="0" i="0">
                 <a:solidFill>
                   <a:srgbClr val="5B6570"/>
                 </a:solidFill>
@@ -7024,14 +6989,14 @@
       </p:sp>
       <p:sp>
         <p:nvSpPr>
-          <p:cNvPr id="73" name="TextBox 72"/>
+          <p:cNvPr id="72" name="TextBox 71"/>
           <p:cNvSpPr txBox="1"/>
           <p:nvPr/>
         </p:nvSpPr>
         <p:spPr>
           <a:xfrm>
-            <a:off x="17054010" y="18789384"/>
-            <a:ext cx="180000" cy="249522"/>
+            <a:off x="16985460" y="18860676"/>
+            <a:ext cx="180000" cy="285168"/>
           </a:xfrm>
           <a:prstGeom prst="rect">
             <a:avLst/>
@@ -7046,7 +7011,7 @@
           <a:p>
             <a:pPr algn="l"/>
             <a:r>
-              <a:rPr sz="1511" b="0" i="0">
+              <a:rPr sz="1727" b="0" i="0">
                 <a:solidFill>
                   <a:srgbClr val="5B6570"/>
                 </a:solidFill>
@@ -7059,14 +7024,14 @@
       </p:sp>
       <p:sp>
         <p:nvSpPr>
-          <p:cNvPr id="74" name="TextBox 73"/>
+          <p:cNvPr id="73" name="TextBox 72"/>
           <p:cNvSpPr txBox="1"/>
           <p:nvPr/>
         </p:nvSpPr>
         <p:spPr>
           <a:xfrm>
-            <a:off x="17054010" y="19077294"/>
-            <a:ext cx="180000" cy="249522"/>
+            <a:off x="16985460" y="19189716"/>
+            <a:ext cx="180000" cy="285168"/>
           </a:xfrm>
           <a:prstGeom prst="rect">
             <a:avLst/>
@@ -7081,7 +7046,7 @@
           <a:p>
             <a:pPr algn="l"/>
             <a:r>
-              <a:rPr sz="1511" b="0" i="0">
+              <a:rPr sz="1727" b="0" i="0">
                 <a:solidFill>
                   <a:srgbClr val="5B6570"/>
                 </a:solidFill>
@@ -7094,14 +7059,14 @@
       </p:sp>
       <p:sp>
         <p:nvSpPr>
-          <p:cNvPr id="75" name="TextBox 74"/>
+          <p:cNvPr id="74" name="TextBox 73"/>
           <p:cNvSpPr txBox="1"/>
           <p:nvPr/>
         </p:nvSpPr>
         <p:spPr>
           <a:xfrm>
-            <a:off x="17054010" y="19365204"/>
-            <a:ext cx="180000" cy="249522"/>
+            <a:off x="16985460" y="19518756"/>
+            <a:ext cx="180000" cy="285168"/>
           </a:xfrm>
           <a:prstGeom prst="rect">
             <a:avLst/>
@@ -7116,7 +7081,7 @@
           <a:p>
             <a:pPr algn="l"/>
             <a:r>
-              <a:rPr sz="1511" b="0" i="0">
+              <a:rPr sz="1727" b="0" i="0">
                 <a:solidFill>
                   <a:srgbClr val="5B6570"/>
                 </a:solidFill>
@@ -7129,18 +7094,18 @@
       </p:sp>
       <p:sp>
         <p:nvSpPr>
-          <p:cNvPr id="76" name="Rounded Rectangle 75"/>
+          <p:cNvPr id="75" name="Rounded Rectangle 74"/>
           <p:cNvSpPr/>
           <p:nvPr/>
         </p:nvSpPr>
         <p:spPr>
           <a:xfrm>
-            <a:off x="17054010" y="19949250"/>
-            <a:ext cx="4839630" cy="1466970"/>
+            <a:off x="16985460" y="19880700"/>
+            <a:ext cx="4771080" cy="1617780"/>
           </a:xfrm>
           <a:prstGeom prst="roundRect">
             <a:avLst>
-              <a:gd name="adj" fmla="val 8411"/>
+              <a:gd name="adj" fmla="val 7627"/>
             </a:avLst>
           </a:prstGeom>
           <a:solidFill>
@@ -7177,14 +7142,14 @@
       </p:sp>
       <p:sp>
         <p:nvSpPr>
-          <p:cNvPr id="77" name="TextBox 76"/>
+          <p:cNvPr id="76" name="TextBox 75"/>
           <p:cNvSpPr txBox="1"/>
           <p:nvPr/>
         </p:nvSpPr>
         <p:spPr>
           <a:xfrm>
-            <a:off x="17273370" y="20176836"/>
-            <a:ext cx="180000" cy="285168"/>
+            <a:off x="17204820" y="20111028"/>
+            <a:ext cx="180000" cy="320814"/>
           </a:xfrm>
           <a:prstGeom prst="rect">
             <a:avLst/>
@@ -7199,7 +7164,7 @@
           <a:p>
             <a:pPr algn="l"/>
             <a:r>
-              <a:rPr sz="1727" b="1" i="0">
+              <a:rPr sz="1943" b="1" i="0">
                 <a:solidFill>
                   <a:srgbClr val="1C2321"/>
                 </a:solidFill>
@@ -7212,14 +7177,14 @@
       </p:sp>
       <p:sp>
         <p:nvSpPr>
-          <p:cNvPr id="78" name="TextBox 77"/>
+          <p:cNvPr id="77" name="TextBox 76"/>
           <p:cNvSpPr txBox="1"/>
           <p:nvPr/>
         </p:nvSpPr>
         <p:spPr>
           <a:xfrm>
-            <a:off x="17273370" y="20611443"/>
-            <a:ext cx="180000" cy="231699"/>
+            <a:off x="17204820" y="20573055"/>
+            <a:ext cx="180000" cy="267345"/>
           </a:xfrm>
           <a:prstGeom prst="rect">
             <a:avLst/>
@@ -7234,7 +7199,7 @@
           <a:p>
             <a:pPr algn="l"/>
             <a:r>
-              <a:rPr sz="1403" b="0" i="0">
+              <a:rPr sz="1619" b="0" i="0">
                 <a:solidFill>
                   <a:srgbClr val="5B6570"/>
                 </a:solidFill>
@@ -7247,14 +7212,14 @@
       </p:sp>
       <p:sp>
         <p:nvSpPr>
-          <p:cNvPr id="79" name="TextBox 78"/>
+          <p:cNvPr id="78" name="TextBox 77"/>
           <p:cNvSpPr txBox="1"/>
           <p:nvPr/>
         </p:nvSpPr>
         <p:spPr>
           <a:xfrm>
-            <a:off x="17273370" y="20871933"/>
-            <a:ext cx="180000" cy="231699"/>
+            <a:off x="17204820" y="20860965"/>
+            <a:ext cx="180000" cy="267345"/>
           </a:xfrm>
           <a:prstGeom prst="rect">
             <a:avLst/>
@@ -7269,7 +7234,7 @@
           <a:p>
             <a:pPr algn="l"/>
             <a:r>
-              <a:rPr sz="1403" b="0" i="0">
+              <a:rPr sz="1619" b="0" i="0">
                 <a:solidFill>
                   <a:srgbClr val="5B6570"/>
                 </a:solidFill>
@@ -7282,14 +7247,14 @@
       </p:sp>
       <p:sp>
         <p:nvSpPr>
-          <p:cNvPr id="80" name="TextBox 79"/>
+          <p:cNvPr id="79" name="TextBox 78"/>
           <p:cNvSpPr txBox="1"/>
           <p:nvPr/>
         </p:nvSpPr>
         <p:spPr>
           <a:xfrm>
-            <a:off x="17273370" y="21132423"/>
-            <a:ext cx="180000" cy="231699"/>
+            <a:off x="17204820" y="21148875"/>
+            <a:ext cx="180000" cy="267345"/>
           </a:xfrm>
           <a:prstGeom prst="rect">
             <a:avLst/>
@@ -7304,7 +7269,7 @@
           <a:p>
             <a:pPr algn="l"/>
             <a:r>
-              <a:rPr sz="1403" b="0" i="0">
+              <a:rPr sz="1619" b="0" i="0">
                 <a:solidFill>
                   <a:srgbClr val="5B6570"/>
                 </a:solidFill>
@@ -7317,14 +7282,14 @@
       </p:sp>
       <p:sp>
         <p:nvSpPr>
-          <p:cNvPr id="81" name="Right Arrow 80"/>
+          <p:cNvPr id="80" name="Right Arrow 79"/>
           <p:cNvSpPr/>
           <p:nvPr/>
         </p:nvSpPr>
         <p:spPr>
           <a:xfrm>
-            <a:off x="22113000" y="19565370"/>
-            <a:ext cx="411300" cy="219360"/>
+            <a:off x="21975900" y="19565370"/>
+            <a:ext cx="342750" cy="219360"/>
           </a:xfrm>
           <a:prstGeom prst="rightArrow">
             <a:avLst/>
@@ -7361,18 +7326,18 @@
       </p:sp>
       <p:sp>
         <p:nvSpPr>
-          <p:cNvPr id="82" name="Rounded Rectangle 81"/>
+          <p:cNvPr id="81" name="Rounded Rectangle 80"/>
           <p:cNvSpPr/>
           <p:nvPr/>
         </p:nvSpPr>
         <p:spPr>
           <a:xfrm>
-            <a:off x="22524300" y="17755650"/>
-            <a:ext cx="3496050" cy="2056500"/>
+            <a:off x="22318650" y="17755650"/>
+            <a:ext cx="3701700" cy="2125050"/>
           </a:xfrm>
           <a:prstGeom prst="roundRect">
             <a:avLst>
-              <a:gd name="adj" fmla="val 6000"/>
+              <a:gd name="adj" fmla="val 5806"/>
             </a:avLst>
           </a:prstGeom>
           <a:solidFill>
@@ -7409,13 +7374,13 @@
       </p:sp>
       <p:sp>
         <p:nvSpPr>
-          <p:cNvPr id="83" name="Oval 82"/>
+          <p:cNvPr id="82" name="Oval 81"/>
           <p:cNvSpPr/>
           <p:nvPr/>
         </p:nvSpPr>
         <p:spPr>
           <a:xfrm>
-            <a:off x="22702530" y="17947590"/>
+            <a:off x="22496880" y="17947590"/>
             <a:ext cx="411300" cy="411300"/>
           </a:xfrm>
           <a:prstGeom prst="ellipse">
@@ -7462,14 +7427,14 @@
       </p:sp>
       <p:sp>
         <p:nvSpPr>
-          <p:cNvPr id="84" name="TextBox 83"/>
+          <p:cNvPr id="83" name="TextBox 82"/>
           <p:cNvSpPr txBox="1"/>
           <p:nvPr/>
         </p:nvSpPr>
         <p:spPr>
           <a:xfrm>
-            <a:off x="23237220" y="17988720"/>
-            <a:ext cx="180000" cy="356460"/>
+            <a:off x="23031570" y="17991462"/>
+            <a:ext cx="180000" cy="392106"/>
           </a:xfrm>
           <a:prstGeom prst="rect">
             <a:avLst/>
@@ -7484,7 +7449,7 @@
           <a:p>
             <a:pPr algn="l"/>
             <a:r>
-              <a:rPr sz="2159" b="1" i="0">
+              <a:rPr sz="2374" b="1" i="0">
                 <a:solidFill>
                   <a:srgbClr val="1C2321"/>
                 </a:solidFill>
@@ -7497,14 +7462,14 @@
       </p:sp>
       <p:sp>
         <p:nvSpPr>
-          <p:cNvPr id="85" name="TextBox 84"/>
+          <p:cNvPr id="84" name="TextBox 83"/>
           <p:cNvSpPr txBox="1"/>
           <p:nvPr/>
         </p:nvSpPr>
         <p:spPr>
           <a:xfrm>
-            <a:off x="22743660" y="18487764"/>
-            <a:ext cx="180000" cy="249522"/>
+            <a:off x="22538010" y="18531636"/>
+            <a:ext cx="180000" cy="285168"/>
           </a:xfrm>
           <a:prstGeom prst="rect">
             <a:avLst/>
@@ -7519,27 +7484,27 @@
           <a:p>
             <a:pPr algn="l"/>
             <a:r>
-              <a:rPr sz="1511" b="0" i="0">
+              <a:rPr sz="1727" b="0" i="0">
                 <a:solidFill>
                   <a:srgbClr val="5B6570"/>
                 </a:solidFill>
                 <a:latin typeface="IBM Plex Sans"/>
               </a:rPr>
-              <a:t>Tìm cặp phá vỡ: em thích CLB</a:t>
-            </a:r>
-          </a:p>
-        </p:txBody>
-      </p:sp>
-      <p:sp>
-        <p:nvSpPr>
-          <p:cNvPr id="86" name="TextBox 85"/>
+              <a:t>Tìm cặp phá vỡ: em thích</a:t>
+            </a:r>
+          </a:p>
+        </p:txBody>
+      </p:sp>
+      <p:sp>
+        <p:nvSpPr>
+          <p:cNvPr id="85" name="TextBox 84"/>
           <p:cNvSpPr txBox="1"/>
           <p:nvPr/>
         </p:nvSpPr>
         <p:spPr>
           <a:xfrm>
-            <a:off x="22743660" y="18775674"/>
-            <a:ext cx="180000" cy="249522"/>
+            <a:off x="22538010" y="18860676"/>
+            <a:ext cx="180000" cy="285168"/>
           </a:xfrm>
           <a:prstGeom prst="rect">
             <a:avLst/>
@@ -7554,27 +7519,27 @@
           <a:p>
             <a:pPr algn="l"/>
             <a:r>
-              <a:rPr sz="1511" b="0" i="0">
+              <a:rPr sz="1727" b="0" i="0">
                 <a:solidFill>
                   <a:srgbClr val="5B6570"/>
                 </a:solidFill>
                 <a:latin typeface="IBM Plex Sans"/>
               </a:rPr>
-              <a:t>khác hơn và CLB đó cũng nhận em</a:t>
-            </a:r>
-          </a:p>
-        </p:txBody>
-      </p:sp>
-      <p:sp>
-        <p:nvSpPr>
-          <p:cNvPr id="87" name="TextBox 86"/>
+              <a:t>CLB khác hơn và CLB đó</a:t>
+            </a:r>
+          </a:p>
+        </p:txBody>
+      </p:sp>
+      <p:sp>
+        <p:nvSpPr>
+          <p:cNvPr id="86" name="TextBox 85"/>
           <p:cNvSpPr txBox="1"/>
           <p:nvPr/>
         </p:nvSpPr>
         <p:spPr>
           <a:xfrm>
-            <a:off x="22743660" y="19063584"/>
-            <a:ext cx="180000" cy="249522"/>
+            <a:off x="22538010" y="19189716"/>
+            <a:ext cx="180000" cy="285168"/>
           </a:xfrm>
           <a:prstGeom prst="rect">
             <a:avLst/>
@@ -7589,7 +7554,42 @@
           <a:p>
             <a:pPr algn="l"/>
             <a:r>
-              <a:rPr sz="1511" b="0" i="0">
+              <a:rPr sz="1727" b="0" i="0">
+                <a:solidFill>
+                  <a:srgbClr val="5B6570"/>
+                </a:solidFill>
+                <a:latin typeface="IBM Plex Sans"/>
+              </a:rPr>
+              <a:t>cũng nhận em</a:t>
+            </a:r>
+          </a:p>
+        </p:txBody>
+      </p:sp>
+      <p:sp>
+        <p:nvSpPr>
+          <p:cNvPr id="87" name="TextBox 86"/>
+          <p:cNvSpPr txBox="1"/>
+          <p:nvPr/>
+        </p:nvSpPr>
+        <p:spPr>
+          <a:xfrm>
+            <a:off x="22538010" y="19518756"/>
+            <a:ext cx="180000" cy="285168"/>
+          </a:xfrm>
+          <a:prstGeom prst="rect">
+            <a:avLst/>
+          </a:prstGeom>
+          <a:noFill/>
+        </p:spPr>
+        <p:txBody>
+          <a:bodyPr wrap="none" anchor="t" lIns="0" rIns="0" tIns="0" bIns="0">
+            <a:spAutoFit/>
+          </a:bodyPr>
+          <a:lstStyle/>
+          <a:p>
+            <a:pPr algn="l"/>
+            <a:r>
+              <a:rPr sz="1727" b="0" i="0">
                 <a:solidFill>
                   <a:srgbClr val="5B6570"/>
                 </a:solidFill>
@@ -7608,8 +7608,8 @@
         </p:nvSpPr>
         <p:spPr>
           <a:xfrm>
-            <a:off x="24162645" y="19812150"/>
-            <a:ext cx="219360" cy="342750"/>
+            <a:off x="24059819" y="19880700"/>
+            <a:ext cx="219360" cy="205650"/>
           </a:xfrm>
           <a:prstGeom prst="downArrow">
             <a:avLst/>
@@ -7652,12 +7652,12 @@
         </p:nvSpPr>
         <p:spPr>
           <a:xfrm>
-            <a:off x="22524300" y="20154900"/>
-            <a:ext cx="3496050" cy="1439550"/>
+            <a:off x="22318650" y="20086350"/>
+            <a:ext cx="3701700" cy="1508100"/>
           </a:xfrm>
           <a:prstGeom prst="roundRect">
             <a:avLst>
-              <a:gd name="adj" fmla="val 8571"/>
+              <a:gd name="adj" fmla="val 8181"/>
             </a:avLst>
           </a:prstGeom>
           <a:solidFill>
@@ -7700,8 +7700,8 @@
         </p:nvSpPr>
         <p:spPr>
           <a:xfrm>
-            <a:off x="22743660" y="20387970"/>
-            <a:ext cx="180000" cy="356460"/>
+            <a:off x="22538010" y="20322162"/>
+            <a:ext cx="180000" cy="392106"/>
           </a:xfrm>
           <a:prstGeom prst="rect">
             <a:avLst/>
@@ -7716,7 +7716,7 @@
           <a:p>
             <a:pPr algn="l"/>
             <a:r>
-              <a:rPr sz="2159" b="1" i="0">
+              <a:rPr sz="2374" b="1" i="0">
                 <a:solidFill>
                   <a:srgbClr val="1C2321"/>
                 </a:solidFill>
@@ -7735,8 +7735,8 @@
         </p:nvSpPr>
         <p:spPr>
           <a:xfrm>
-            <a:off x="22743660" y="20887014"/>
-            <a:ext cx="180000" cy="249522"/>
+            <a:off x="22538010" y="20862336"/>
+            <a:ext cx="180000" cy="285168"/>
           </a:xfrm>
           <a:prstGeom prst="rect">
             <a:avLst/>
@@ -7751,7 +7751,7 @@
           <a:p>
             <a:pPr algn="l"/>
             <a:r>
-              <a:rPr sz="1511" b="0" i="0">
+              <a:rPr sz="1727" b="0" i="0">
                 <a:solidFill>
                   <a:srgbClr val="5B6570"/>
                 </a:solidFill>
@@ -7770,8 +7770,8 @@
         </p:nvSpPr>
         <p:spPr>
           <a:xfrm>
-            <a:off x="22743660" y="21174924"/>
-            <a:ext cx="180000" cy="249522"/>
+            <a:off x="22538010" y="21191376"/>
+            <a:ext cx="180000" cy="285168"/>
           </a:xfrm>
           <a:prstGeom prst="rect">
             <a:avLst/>
@@ -7786,7 +7786,7 @@
           <a:p>
             <a:pPr algn="l"/>
             <a:r>
-              <a:rPr sz="1511" b="0" i="0">
+              <a:rPr sz="1727" b="0" i="0">
                 <a:solidFill>
                   <a:srgbClr val="5B6570"/>
                 </a:solidFill>
@@ -7805,7 +7805,7 @@
         </p:nvSpPr>
         <p:spPr>
           <a:xfrm>
-            <a:off x="14325720" y="21594450"/>
+            <a:off x="14188620" y="21594450"/>
             <a:ext cx="219360" cy="411300"/>
           </a:xfrm>
           <a:prstGeom prst="downArrow">
@@ -7897,8 +7897,8 @@
         </p:nvSpPr>
         <p:spPr>
           <a:xfrm>
-            <a:off x="10199010" y="22208658"/>
-            <a:ext cx="180000" cy="320814"/>
+            <a:off x="10199010" y="22197690"/>
+            <a:ext cx="180000" cy="356460"/>
           </a:xfrm>
           <a:prstGeom prst="rect">
             <a:avLst/>
@@ -7913,7 +7913,7 @@
           <a:p>
             <a:pPr algn="l"/>
             <a:r>
-              <a:rPr sz="1943" b="1" i="0">
+              <a:rPr sz="2159" b="1" i="0">
                 <a:solidFill>
                   <a:srgbClr val="1C2321"/>
                 </a:solidFill>
@@ -7932,12 +7932,12 @@
         </p:nvSpPr>
         <p:spPr>
           <a:xfrm>
-            <a:off x="10199010" y="22622700"/>
-            <a:ext cx="3756540" cy="1371000"/>
+            <a:off x="10199010" y="22608990"/>
+            <a:ext cx="3756540" cy="1453260"/>
           </a:xfrm>
           <a:prstGeom prst="roundRect">
             <a:avLst>
-              <a:gd name="adj" fmla="val 9000"/>
+              <a:gd name="adj" fmla="val 8490"/>
             </a:avLst>
           </a:prstGeom>
           <a:solidFill>
@@ -7980,8 +7980,8 @@
         </p:nvSpPr>
         <p:spPr>
           <a:xfrm>
-            <a:off x="10418370" y="22848915"/>
-            <a:ext cx="180000" cy="267345"/>
+            <a:off x="10418370" y="22837947"/>
+            <a:ext cx="180000" cy="302991"/>
           </a:xfrm>
           <a:prstGeom prst="rect">
             <a:avLst/>
@@ -7996,7 +7996,7 @@
           <a:p>
             <a:pPr algn="l"/>
             <a:r>
-              <a:rPr sz="1619" b="1" i="0">
+              <a:rPr sz="1835" b="1" i="0">
                 <a:solidFill>
                   <a:srgbClr val="1C2321"/>
                 </a:solidFill>
@@ -8015,8 +8015,8 @@
         </p:nvSpPr>
         <p:spPr>
           <a:xfrm>
-            <a:off x="10418370" y="23263642"/>
-            <a:ext cx="180000" cy="222787"/>
+            <a:off x="10418370" y="23272554"/>
+            <a:ext cx="180000" cy="249522"/>
           </a:xfrm>
           <a:prstGeom prst="rect">
             <a:avLst/>
@@ -8031,7 +8031,7 @@
           <a:p>
             <a:pPr algn="l"/>
             <a:r>
-              <a:rPr sz="1349" b="0" i="0">
+              <a:rPr sz="1511" b="0" i="0">
                 <a:solidFill>
                   <a:srgbClr val="5B6570"/>
                 </a:solidFill>
@@ -8050,8 +8050,8 @@
         </p:nvSpPr>
         <p:spPr>
           <a:xfrm>
-            <a:off x="10418370" y="23510422"/>
-            <a:ext cx="180000" cy="222787"/>
+            <a:off x="10418370" y="23533044"/>
+            <a:ext cx="180000" cy="249522"/>
           </a:xfrm>
           <a:prstGeom prst="rect">
             <a:avLst/>
@@ -8066,7 +8066,7 @@
           <a:p>
             <a:pPr algn="l"/>
             <a:r>
-              <a:rPr sz="1349" b="0" i="0">
+              <a:rPr sz="1511" b="0" i="0">
                 <a:solidFill>
                   <a:srgbClr val="5B6570"/>
                 </a:solidFill>
@@ -8085,8 +8085,8 @@
         </p:nvSpPr>
         <p:spPr>
           <a:xfrm>
-            <a:off x="10418370" y="23757202"/>
-            <a:ext cx="180000" cy="222787"/>
+            <a:off x="10418370" y="23793534"/>
+            <a:ext cx="180000" cy="249522"/>
           </a:xfrm>
           <a:prstGeom prst="rect">
             <a:avLst/>
@@ -8101,7 +8101,7 @@
           <a:p>
             <a:pPr algn="l"/>
             <a:r>
-              <a:rPr sz="1349" b="0" i="0">
+              <a:rPr sz="1511" b="0" i="0">
                 <a:solidFill>
                   <a:srgbClr val="5B6570"/>
                 </a:solidFill>
@@ -8120,12 +8120,12 @@
         </p:nvSpPr>
         <p:spPr>
           <a:xfrm>
-            <a:off x="14147490" y="22622700"/>
-            <a:ext cx="3756540" cy="1371000"/>
+            <a:off x="14147490" y="22608990"/>
+            <a:ext cx="3756540" cy="1453260"/>
           </a:xfrm>
           <a:prstGeom prst="roundRect">
             <a:avLst>
-              <a:gd name="adj" fmla="val 9000"/>
+              <a:gd name="adj" fmla="val 8490"/>
             </a:avLst>
           </a:prstGeom>
           <a:solidFill>
@@ -8168,8 +8168,8 @@
         </p:nvSpPr>
         <p:spPr>
           <a:xfrm>
-            <a:off x="14366850" y="22848915"/>
-            <a:ext cx="180000" cy="267345"/>
+            <a:off x="14366850" y="22837947"/>
+            <a:ext cx="180000" cy="302991"/>
           </a:xfrm>
           <a:prstGeom prst="rect">
             <a:avLst/>
@@ -8184,7 +8184,7 @@
           <a:p>
             <a:pPr algn="l"/>
             <a:r>
-              <a:rPr sz="1619" b="1" i="0">
+              <a:rPr sz="1835" b="1" i="0">
                 <a:solidFill>
                   <a:srgbClr val="1C2321"/>
                 </a:solidFill>
@@ -8203,8 +8203,8 @@
         </p:nvSpPr>
         <p:spPr>
           <a:xfrm>
-            <a:off x="14366850" y="23263642"/>
-            <a:ext cx="180000" cy="222787"/>
+            <a:off x="14366850" y="23272554"/>
+            <a:ext cx="180000" cy="249522"/>
           </a:xfrm>
           <a:prstGeom prst="rect">
             <a:avLst/>
@@ -8219,7 +8219,7 @@
           <a:p>
             <a:pPr algn="l"/>
             <a:r>
-              <a:rPr sz="1349" b="0" i="0">
+              <a:rPr sz="1511" b="0" i="0">
                 <a:solidFill>
                   <a:srgbClr val="5B6570"/>
                 </a:solidFill>
@@ -8238,8 +8238,8 @@
         </p:nvSpPr>
         <p:spPr>
           <a:xfrm>
-            <a:off x="14366850" y="23510422"/>
-            <a:ext cx="180000" cy="222787"/>
+            <a:off x="14366850" y="23533044"/>
+            <a:ext cx="180000" cy="249522"/>
           </a:xfrm>
           <a:prstGeom prst="rect">
             <a:avLst/>
@@ -8254,7 +8254,7 @@
           <a:p>
             <a:pPr algn="l"/>
             <a:r>
-              <a:rPr sz="1349" b="0" i="0">
+              <a:rPr sz="1511" b="0" i="0">
                 <a:solidFill>
                   <a:srgbClr val="5B6570"/>
                 </a:solidFill>
@@ -8273,8 +8273,8 @@
         </p:nvSpPr>
         <p:spPr>
           <a:xfrm>
-            <a:off x="14366850" y="23757202"/>
-            <a:ext cx="180000" cy="222787"/>
+            <a:off x="14366850" y="23793534"/>
+            <a:ext cx="180000" cy="249522"/>
           </a:xfrm>
           <a:prstGeom prst="rect">
             <a:avLst/>
@@ -8289,7 +8289,7 @@
           <a:p>
             <a:pPr algn="l"/>
             <a:r>
-              <a:rPr sz="1349" b="0" i="0">
+              <a:rPr sz="1511" b="0" i="0">
                 <a:solidFill>
                   <a:srgbClr val="5B6570"/>
                 </a:solidFill>
@@ -8308,12 +8308,12 @@
         </p:nvSpPr>
         <p:spPr>
           <a:xfrm>
-            <a:off x="18095970" y="22622700"/>
-            <a:ext cx="3756540" cy="1371000"/>
+            <a:off x="18095970" y="22608990"/>
+            <a:ext cx="3756540" cy="1453260"/>
           </a:xfrm>
           <a:prstGeom prst="roundRect">
             <a:avLst>
-              <a:gd name="adj" fmla="val 9000"/>
+              <a:gd name="adj" fmla="val 8490"/>
             </a:avLst>
           </a:prstGeom>
           <a:solidFill>
@@ -8356,8 +8356,8 @@
         </p:nvSpPr>
         <p:spPr>
           <a:xfrm>
-            <a:off x="18315330" y="22848915"/>
-            <a:ext cx="180000" cy="267345"/>
+            <a:off x="18315330" y="22837947"/>
+            <a:ext cx="180000" cy="302991"/>
           </a:xfrm>
           <a:prstGeom prst="rect">
             <a:avLst/>
@@ -8372,7 +8372,7 @@
           <a:p>
             <a:pPr algn="l"/>
             <a:r>
-              <a:rPr sz="1619" b="1" i="0">
+              <a:rPr sz="1835" b="1" i="0">
                 <a:solidFill>
                   <a:srgbClr val="1C2321"/>
                 </a:solidFill>
@@ -8391,8 +8391,8 @@
         </p:nvSpPr>
         <p:spPr>
           <a:xfrm>
-            <a:off x="18315330" y="23263642"/>
-            <a:ext cx="180000" cy="222787"/>
+            <a:off x="18315330" y="23272554"/>
+            <a:ext cx="180000" cy="249522"/>
           </a:xfrm>
           <a:prstGeom prst="rect">
             <a:avLst/>
@@ -8407,7 +8407,7 @@
           <a:p>
             <a:pPr algn="l"/>
             <a:r>
-              <a:rPr sz="1349" b="0" i="0">
+              <a:rPr sz="1511" b="0" i="0">
                 <a:solidFill>
                   <a:srgbClr val="5B6570"/>
                 </a:solidFill>
@@ -8426,8 +8426,8 @@
         </p:nvSpPr>
         <p:spPr>
           <a:xfrm>
-            <a:off x="18315330" y="23510422"/>
-            <a:ext cx="180000" cy="222787"/>
+            <a:off x="18315330" y="23533044"/>
+            <a:ext cx="180000" cy="249522"/>
           </a:xfrm>
           <a:prstGeom prst="rect">
             <a:avLst/>
@@ -8442,13 +8442,13 @@
           <a:p>
             <a:pPr algn="l"/>
             <a:r>
-              <a:rPr sz="1349" b="0" i="0">
+              <a:rPr sz="1511" b="0" i="0">
                 <a:solidFill>
                   <a:srgbClr val="5B6570"/>
                 </a:solidFill>
                 <a:latin typeface="IBM Plex Sans"/>
               </a:rPr>
-              <a:t>Cùng dữ liệu + cùng hạt giống</a:t>
+              <a:t>Cùng dữ liệu và cùng hạt giống</a:t>
             </a:r>
           </a:p>
         </p:txBody>
@@ -8461,8 +8461,8 @@
         </p:nvSpPr>
         <p:spPr>
           <a:xfrm>
-            <a:off x="18315330" y="23757202"/>
-            <a:ext cx="180000" cy="222787"/>
+            <a:off x="18315330" y="23793534"/>
+            <a:ext cx="180000" cy="249522"/>
           </a:xfrm>
           <a:prstGeom prst="rect">
             <a:avLst/>
@@ -8477,7 +8477,7 @@
           <a:p>
             <a:pPr algn="l"/>
             <a:r>
-              <a:rPr sz="1349" b="0" i="0">
+              <a:rPr sz="1511" b="0" i="0">
                 <a:solidFill>
                   <a:srgbClr val="5B6570"/>
                 </a:solidFill>
@@ -8496,12 +8496,12 @@
         </p:nvSpPr>
         <p:spPr>
           <a:xfrm>
-            <a:off x="22044450" y="22622700"/>
-            <a:ext cx="3756540" cy="1371000"/>
+            <a:off x="22044450" y="22608990"/>
+            <a:ext cx="3756540" cy="1453260"/>
           </a:xfrm>
           <a:prstGeom prst="roundRect">
             <a:avLst>
-              <a:gd name="adj" fmla="val 9000"/>
+              <a:gd name="adj" fmla="val 8490"/>
             </a:avLst>
           </a:prstGeom>
           <a:solidFill>
@@ -8544,8 +8544,8 @@
         </p:nvSpPr>
         <p:spPr>
           <a:xfrm>
-            <a:off x="22263810" y="22848915"/>
-            <a:ext cx="180000" cy="267345"/>
+            <a:off x="22263810" y="22837947"/>
+            <a:ext cx="180000" cy="302991"/>
           </a:xfrm>
           <a:prstGeom prst="rect">
             <a:avLst/>
@@ -8560,7 +8560,7 @@
           <a:p>
             <a:pPr algn="l"/>
             <a:r>
-              <a:rPr sz="1619" b="1" i="0">
+              <a:rPr sz="1835" b="1" i="0">
                 <a:solidFill>
                   <a:srgbClr val="1C2321"/>
                 </a:solidFill>
@@ -8579,8 +8579,8 @@
         </p:nvSpPr>
         <p:spPr>
           <a:xfrm>
-            <a:off x="22263810" y="23263642"/>
-            <a:ext cx="180000" cy="222787"/>
+            <a:off x="22263810" y="23272554"/>
+            <a:ext cx="180000" cy="249522"/>
           </a:xfrm>
           <a:prstGeom prst="rect">
             <a:avLst/>
@@ -8595,13 +8595,13 @@
           <a:p>
             <a:pPr algn="l"/>
             <a:r>
-              <a:rPr sz="1349" b="0" i="0">
+              <a:rPr sz="1511" b="0" i="0">
                 <a:solidFill>
                   <a:srgbClr val="5B6570"/>
                 </a:solidFill>
                 <a:latin typeface="IBM Plex Sans"/>
               </a:rPr>
-              <a:t>Số đã bốc giữ nguyên ở các lần chạy sau</a:t>
+              <a:t>Số đã bốc giữ nguyên ở lần chạy sau</a:t>
             </a:r>
           </a:p>
         </p:txBody>
@@ -8614,8 +8614,8 @@
         </p:nvSpPr>
         <p:spPr>
           <a:xfrm>
-            <a:off x="22263810" y="23510422"/>
-            <a:ext cx="180000" cy="222787"/>
+            <a:off x="22263810" y="23533044"/>
+            <a:ext cx="180000" cy="249522"/>
           </a:xfrm>
           <a:prstGeom prst="rect">
             <a:avLst/>
@@ -8630,13 +8630,13 @@
           <a:p>
             <a:pPr algn="l"/>
             <a:r>
-              <a:rPr sz="1349" b="0" i="0">
+              <a:rPr sz="1511" b="0" i="0">
                 <a:solidFill>
                   <a:srgbClr val="5B6570"/>
                 </a:solidFill>
                 <a:latin typeface="IBM Plex Sans"/>
               </a:rPr>
-              <a:t>Bốc lại = đổi hạt giống, xác nhận 2 lần</a:t>
+              <a:t>Muốn bốc lại thì đổi hạt giống</a:t>
             </a:r>
           </a:p>
         </p:txBody>
@@ -8649,8 +8649,8 @@
         </p:nvSpPr>
         <p:spPr>
           <a:xfrm>
-            <a:off x="9979650" y="24291207"/>
-            <a:ext cx="180000" cy="213876"/>
+            <a:off x="22263810" y="23793534"/>
+            <a:ext cx="180000" cy="249522"/>
           </a:xfrm>
           <a:prstGeom prst="rect">
             <a:avLst/>
@@ -8665,6 +8665,41 @@
           <a:p>
             <a:pPr algn="l"/>
             <a:r>
+              <a:rPr sz="1511" b="0" i="0">
+                <a:solidFill>
+                  <a:srgbClr val="5B6570"/>
+                </a:solidFill>
+                <a:latin typeface="IBM Plex Sans"/>
+              </a:rPr>
+              <a:t>và xác nhận thêm một lần</a:t>
+            </a:r>
+          </a:p>
+        </p:txBody>
+      </p:sp>
+      <p:sp>
+        <p:nvSpPr>
+          <p:cNvPr id="116" name="TextBox 115"/>
+          <p:cNvSpPr txBox="1"/>
+          <p:nvPr/>
+        </p:nvSpPr>
+        <p:spPr>
+          <a:xfrm>
+            <a:off x="9979650" y="24291207"/>
+            <a:ext cx="180000" cy="213876"/>
+          </a:xfrm>
+          <a:prstGeom prst="rect">
+            <a:avLst/>
+          </a:prstGeom>
+          <a:noFill/>
+        </p:spPr>
+        <p:txBody>
+          <a:bodyPr wrap="none" anchor="t" lIns="0" rIns="0" tIns="0" bIns="0">
+            <a:spAutoFit/>
+          </a:bodyPr>
+          <a:lstStyle/>
+          <a:p>
+            <a:pPr algn="l"/>
+            <a:r>
               <a:rPr sz="1295" b="0" i="0">
                 <a:solidFill>
                   <a:srgbClr val="8A929A"/>
@@ -8678,7 +8713,7 @@
       </p:sp>
       <p:sp>
         <p:nvSpPr>
-          <p:cNvPr id="116" name="Rounded Rectangle 115"/>
+          <p:cNvPr id="117" name="Rounded Rectangle 116"/>
           <p:cNvSpPr/>
           <p:nvPr/>
         </p:nvSpPr>
@@ -8725,7 +8760,7 @@
       </p:sp>
       <p:sp>
         <p:nvSpPr>
-          <p:cNvPr id="117" name="TextBox 116"/>
+          <p:cNvPr id="118" name="TextBox 117"/>
           <p:cNvSpPr txBox="1"/>
           <p:nvPr/>
         </p:nvSpPr>
@@ -8760,7 +8795,7 @@
       </p:sp>
       <p:sp>
         <p:nvSpPr>
-          <p:cNvPr id="118" name="Rounded Rectangle 117"/>
+          <p:cNvPr id="119" name="Rounded Rectangle 118"/>
           <p:cNvSpPr/>
           <p:nvPr/>
         </p:nvSpPr>
@@ -8808,7 +8843,7 @@
       </p:sp>
       <p:sp>
         <p:nvSpPr>
-          <p:cNvPr id="119" name="Oval 118"/>
+          <p:cNvPr id="120" name="Oval 119"/>
           <p:cNvSpPr/>
           <p:nvPr/>
         </p:nvSpPr>
@@ -8861,7 +8896,7 @@
       </p:sp>
       <p:sp>
         <p:nvSpPr>
-          <p:cNvPr id="120" name="TextBox 119"/>
+          <p:cNvPr id="121" name="TextBox 120"/>
           <p:cNvSpPr txBox="1"/>
           <p:nvPr/>
         </p:nvSpPr>
@@ -8896,7 +8931,7 @@
       </p:sp>
       <p:sp>
         <p:nvSpPr>
-          <p:cNvPr id="121" name="Oval 120"/>
+          <p:cNvPr id="122" name="Oval 121"/>
           <p:cNvSpPr/>
           <p:nvPr/>
         </p:nvSpPr>
@@ -8949,7 +8984,7 @@
       </p:sp>
       <p:sp>
         <p:nvSpPr>
-          <p:cNvPr id="122" name="Rounded Rectangle 121"/>
+          <p:cNvPr id="123" name="Rounded Rectangle 122"/>
           <p:cNvSpPr/>
           <p:nvPr/>
         </p:nvSpPr>
@@ -8996,7 +9031,7 @@
       </p:sp>
       <p:sp>
         <p:nvSpPr>
-          <p:cNvPr id="123" name="TextBox 122"/>
+          <p:cNvPr id="124" name="TextBox 123"/>
           <p:cNvSpPr txBox="1"/>
           <p:nvPr/>
         </p:nvSpPr>
@@ -9031,7 +9066,7 @@
       </p:sp>
       <p:sp>
         <p:nvSpPr>
-          <p:cNvPr id="124" name="Oval 123"/>
+          <p:cNvPr id="125" name="Oval 124"/>
           <p:cNvSpPr/>
           <p:nvPr/>
         </p:nvSpPr>
@@ -9084,7 +9119,7 @@
       </p:sp>
       <p:sp>
         <p:nvSpPr>
-          <p:cNvPr id="125" name="Rounded Rectangle 124"/>
+          <p:cNvPr id="126" name="Rounded Rectangle 125"/>
           <p:cNvSpPr/>
           <p:nvPr/>
         </p:nvSpPr>
@@ -9131,7 +9166,7 @@
       </p:sp>
       <p:sp>
         <p:nvSpPr>
-          <p:cNvPr id="126" name="TextBox 125"/>
+          <p:cNvPr id="127" name="TextBox 126"/>
           <p:cNvSpPr txBox="1"/>
           <p:nvPr/>
         </p:nvSpPr>
@@ -9166,7 +9201,7 @@
       </p:sp>
       <p:sp>
         <p:nvSpPr>
-          <p:cNvPr id="127" name="Oval 126"/>
+          <p:cNvPr id="128" name="Oval 127"/>
           <p:cNvSpPr/>
           <p:nvPr/>
         </p:nvSpPr>
@@ -9219,7 +9254,7 @@
       </p:sp>
       <p:sp>
         <p:nvSpPr>
-          <p:cNvPr id="128" name="Rounded Rectangle 127"/>
+          <p:cNvPr id="129" name="Rounded Rectangle 128"/>
           <p:cNvSpPr/>
           <p:nvPr/>
         </p:nvSpPr>
@@ -9266,7 +9301,7 @@
       </p:sp>
       <p:sp>
         <p:nvSpPr>
-          <p:cNvPr id="129" name="TextBox 128"/>
+          <p:cNvPr id="130" name="TextBox 129"/>
           <p:cNvSpPr txBox="1"/>
           <p:nvPr/>
         </p:nvSpPr>
@@ -9301,7 +9336,7 @@
       </p:sp>
       <p:sp>
         <p:nvSpPr>
-          <p:cNvPr id="130" name="Oval 129"/>
+          <p:cNvPr id="131" name="Oval 130"/>
           <p:cNvSpPr/>
           <p:nvPr/>
         </p:nvSpPr>
@@ -9354,7 +9389,7 @@
       </p:sp>
       <p:sp>
         <p:nvSpPr>
-          <p:cNvPr id="131" name="Rounded Rectangle 130"/>
+          <p:cNvPr id="132" name="Rounded Rectangle 131"/>
           <p:cNvSpPr/>
           <p:nvPr/>
         </p:nvSpPr>
@@ -9401,7 +9436,7 @@
       </p:sp>
       <p:sp>
         <p:nvSpPr>
-          <p:cNvPr id="132" name="TextBox 131"/>
+          <p:cNvPr id="133" name="TextBox 132"/>
           <p:cNvSpPr txBox="1"/>
           <p:nvPr/>
         </p:nvSpPr>
@@ -9436,7 +9471,7 @@
       </p:sp>
       <p:sp>
         <p:nvSpPr>
-          <p:cNvPr id="133" name="Rounded Rectangle 132"/>
+          <p:cNvPr id="134" name="Rounded Rectangle 133"/>
           <p:cNvSpPr/>
           <p:nvPr/>
         </p:nvSpPr>
@@ -9484,7 +9519,7 @@
       </p:sp>
       <p:sp>
         <p:nvSpPr>
-          <p:cNvPr id="134" name="Oval 133"/>
+          <p:cNvPr id="135" name="Oval 134"/>
           <p:cNvSpPr/>
           <p:nvPr/>
         </p:nvSpPr>
@@ -9537,7 +9572,7 @@
       </p:sp>
       <p:sp>
         <p:nvSpPr>
-          <p:cNvPr id="135" name="TextBox 134"/>
+          <p:cNvPr id="136" name="TextBox 135"/>
           <p:cNvSpPr txBox="1"/>
           <p:nvPr/>
         </p:nvSpPr>
@@ -9572,7 +9607,7 @@
       </p:sp>
       <p:grpSp>
         <p:nvGrpSpPr>
-          <p:cNvPr id="136" name="Bieu do khai gian"/>
+          <p:cNvPr id="137" name="Bieu do khai gian"/>
           <p:cNvGrpSpPr/>
           <p:nvPr/>
         </p:nvGrpSpPr>
@@ -9586,7 +9621,7 @@
         </p:grpSpPr>
         <p:graphicFrame>
           <p:nvGraphicFramePr>
-            <p:cNvPr id="140" name="Chart 139"/>
+            <p:cNvPr id="141" name="Chart 140"/>
             <p:cNvGraphicFramePr>
               <a:graphicFrameLocks noGrp="1"/>
             </p:cNvGraphicFramePr>
@@ -9605,7 +9640,7 @@
       </p:grpSp>
       <p:sp>
         <p:nvSpPr>
-          <p:cNvPr id="137" name="TextBox 136"/>
+          <p:cNvPr id="138" name="TextBox 137"/>
           <p:cNvSpPr txBox="1"/>
           <p:nvPr/>
         </p:nvSpPr>
@@ -9640,7 +9675,7 @@
       </p:sp>
       <p:sp>
         <p:nvSpPr>
-          <p:cNvPr id="138" name="TextBox 137"/>
+          <p:cNvPr id="139" name="TextBox 138"/>
           <p:cNvSpPr txBox="1"/>
           <p:nvPr/>
         </p:nvSpPr>
@@ -9675,7 +9710,7 @@
       </p:sp>
       <p:sp>
         <p:nvSpPr>
-          <p:cNvPr id="139" name="TextBox 138"/>
+          <p:cNvPr id="140" name="TextBox 139"/>
           <p:cNvSpPr txBox="1"/>
           <p:nvPr/>
         </p:nvSpPr>
@@ -9710,7 +9745,7 @@
       </p:sp>
       <p:grpSp>
         <p:nvGrpSpPr>
-          <p:cNvPr id="141" name="Bieu do nguyen vong"/>
+          <p:cNvPr id="142" name="Bieu do nguyen vong"/>
           <p:cNvGrpSpPr/>
           <p:nvPr/>
         </p:nvGrpSpPr>
@@ -9724,7 +9759,7 @@
         </p:grpSpPr>
         <p:graphicFrame>
           <p:nvGraphicFramePr>
-            <p:cNvPr id="145" name="Chart 144"/>
+            <p:cNvPr id="146" name="Chart 145"/>
             <p:cNvGraphicFramePr>
               <a:graphicFrameLocks noGrp="1"/>
             </p:cNvGraphicFramePr>
@@ -9743,7 +9778,7 @@
       </p:grpSp>
       <p:sp>
         <p:nvSpPr>
-          <p:cNvPr id="142" name="TextBox 141"/>
+          <p:cNvPr id="143" name="TextBox 142"/>
           <p:cNvSpPr txBox="1"/>
           <p:nvPr/>
         </p:nvSpPr>
@@ -9778,7 +9813,7 @@
       </p:sp>
       <p:sp>
         <p:nvSpPr>
-          <p:cNvPr id="143" name="TextBox 142"/>
+          <p:cNvPr id="144" name="TextBox 143"/>
           <p:cNvSpPr txBox="1"/>
           <p:nvPr/>
         </p:nvSpPr>
@@ -9813,7 +9848,7 @@
       </p:sp>
       <p:sp>
         <p:nvSpPr>
-          <p:cNvPr id="144" name="TextBox 143"/>
+          <p:cNvPr id="145" name="TextBox 144"/>
           <p:cNvSpPr txBox="1"/>
           <p:nvPr/>
         </p:nvSpPr>
@@ -9848,7 +9883,7 @@
       </p:sp>
       <p:sp>
         <p:nvSpPr>
-          <p:cNvPr id="146" name="Rounded Rectangle 145"/>
+          <p:cNvPr id="147" name="Rounded Rectangle 146"/>
           <p:cNvSpPr/>
           <p:nvPr/>
         </p:nvSpPr>
@@ -9895,7 +9930,7 @@
       </p:sp>
       <p:sp>
         <p:nvSpPr>
-          <p:cNvPr id="147" name="TextBox 146"/>
+          <p:cNvPr id="148" name="TextBox 147"/>
           <p:cNvSpPr txBox="1"/>
           <p:nvPr/>
         </p:nvSpPr>
@@ -9930,7 +9965,7 @@
       </p:sp>
       <p:sp>
         <p:nvSpPr>
-          <p:cNvPr id="148" name="Rounded Rectangle 147"/>
+          <p:cNvPr id="149" name="Rounded Rectangle 148"/>
           <p:cNvSpPr/>
           <p:nvPr/>
         </p:nvSpPr>
@@ -9978,7 +10013,7 @@
       </p:sp>
       <p:sp>
         <p:nvSpPr>
-          <p:cNvPr id="149" name="TextBox 148"/>
+          <p:cNvPr id="150" name="TextBox 149"/>
           <p:cNvSpPr txBox="1"/>
           <p:nvPr/>
         </p:nvSpPr>
@@ -10013,7 +10048,7 @@
       </p:sp>
       <p:sp>
         <p:nvSpPr>
-          <p:cNvPr id="150" name="Rounded Rectangle 149"/>
+          <p:cNvPr id="151" name="Rounded Rectangle 150"/>
           <p:cNvSpPr/>
           <p:nvPr/>
         </p:nvSpPr>
@@ -10060,7 +10095,7 @@
       </p:sp>
       <p:sp>
         <p:nvSpPr>
-          <p:cNvPr id="151" name="TextBox 150"/>
+          <p:cNvPr id="152" name="TextBox 151"/>
           <p:cNvSpPr txBox="1"/>
           <p:nvPr/>
         </p:nvSpPr>

</xml_diff>

<commit_message>
Replace the verified-results charts with lottery sensitivity data
Chart one shows how many students keep the same club across 200 lottery
seeds on the three simulated sets (100%, 96.7%, 90.7%; only 3 of 270 ever
lose a place). Chart two ranks what moves results most on the 140-student
set, with the lottery at 4.36% against 15.14% for a half-point scoring
error. Numbers come from SO_LIEU_DA_KIEM_CHUNG.md 3c and TN6. The PPTX
carries both as native charts, and the fact sheet's P5 guidance follows.

Co-Authored-By: Claude Opus 5.5 <noreply@anthropic.com>
Claude-Session: https://claude.ai/code/session_01NkYGd36L1Tpym32yxKyitD
</commit_message>
<xml_diff>
--- a/poster/poster_khung_1-2.pptx
+++ b/poster/poster_khung_1-2.pptx
@@ -115,6 +115,287 @@
     <c:plotArea>
       <c:barChart>
         <c:barDir val="bar"/>
+        <c:grouping val="percentStacked"/>
+        <c:ser>
+          <c:idx val="0"/>
+          <c:order val="0"/>
+          <c:tx>
+            <c:strRef>
+              <c:f>Sheet1!$B$1</c:f>
+              <c:strCache>
+                <c:ptCount val="1"/>
+                <c:pt idx="0">
+                  <c:v>Luôn giữ nguyên CLB</c:v>
+                </c:pt>
+              </c:strCache>
+            </c:strRef>
+          </c:tx>
+          <c:spPr>
+            <a:solidFill>
+              <a:srgbClr val="27805A"/>
+            </a:solidFill>
+          </c:spPr>
+          <c:dLbls>
+            <c:dLbl>
+              <c:idx val="0"/>
+              <c:tx>
+                <c:rich>
+                  <a:bodyPr/>
+                  <a:lstStyle/>
+                  <a:p>
+                    <a:r>
+                      <a:rPr sz="1231" b="1">
+                        <a:solidFill>
+                          <a:srgbClr val="FFFFFF"/>
+                        </a:solidFill>
+                      </a:rPr>
+                      <a:t>100%</a:t>
+                    </a:r>
+                  </a:p>
+                </c:rich>
+              </c:tx>
+              <c:dLblPos val="inBase"/>
+              <c:showLegendKey val="0"/>
+              <c:showVal val="1"/>
+              <c:showCatName val="0"/>
+              <c:showSerName val="0"/>
+              <c:showPercent val="0"/>
+              <c:showBubbleSize val="0"/>
+            </c:dLbl>
+            <c:dLbl>
+              <c:idx val="1"/>
+              <c:tx>
+                <c:rich>
+                  <a:bodyPr/>
+                  <a:lstStyle/>
+                  <a:p>
+                    <a:r>
+                      <a:rPr sz="1231" b="1">
+                        <a:solidFill>
+                          <a:srgbClr val="FFFFFF"/>
+                        </a:solidFill>
+                      </a:rPr>
+                      <a:t>96,7% · 116 em</a:t>
+                    </a:r>
+                  </a:p>
+                </c:rich>
+              </c:tx>
+              <c:dLblPos val="inBase"/>
+              <c:showLegendKey val="0"/>
+              <c:showVal val="1"/>
+              <c:showCatName val="0"/>
+              <c:showSerName val="0"/>
+              <c:showPercent val="0"/>
+              <c:showBubbleSize val="0"/>
+            </c:dLbl>
+            <c:dLbl>
+              <c:idx val="2"/>
+              <c:tx>
+                <c:rich>
+                  <a:bodyPr/>
+                  <a:lstStyle/>
+                  <a:p>
+                    <a:r>
+                      <a:rPr sz="1231" b="1">
+                        <a:solidFill>
+                          <a:srgbClr val="FFFFFF"/>
+                        </a:solidFill>
+                      </a:rPr>
+                      <a:t>90,7% · 127 em</a:t>
+                    </a:r>
+                  </a:p>
+                </c:rich>
+              </c:tx>
+              <c:dLblPos val="inBase"/>
+              <c:showLegendKey val="0"/>
+              <c:showVal val="1"/>
+              <c:showCatName val="0"/>
+              <c:showSerName val="0"/>
+              <c:showPercent val="0"/>
+              <c:showBubbleSize val="0"/>
+            </c:dLbl>
+            <c:showLegendKey val="0"/>
+            <c:showVal val="0"/>
+            <c:showCatName val="0"/>
+            <c:showSerName val="0"/>
+            <c:showPercent val="0"/>
+            <c:showBubbleSize val="0"/>
+            <c:showLeaderLines val="1"/>
+          </c:dLbls>
+          <c:cat>
+            <c:strRef>
+              <c:f>Sheet1!$A$2:$A$4</c:f>
+              <c:strCache>
+                <c:ptCount val="3"/>
+                <c:pt idx="0">
+                  <c:v>Bộ 10 em · 0 em có lúc đổi</c:v>
+                </c:pt>
+                <c:pt idx="1">
+                  <c:v>Bộ 120 em · 4 em có lúc đổi</c:v>
+                </c:pt>
+                <c:pt idx="2">
+                  <c:v>Bộ 140 em · 13 em có lúc đổi</c:v>
+                </c:pt>
+              </c:strCache>
+            </c:strRef>
+          </c:cat>
+          <c:val>
+            <c:numRef>
+              <c:f>Sheet1!$B$2:$B$4</c:f>
+              <c:numCache>
+                <c:formatCode>General</c:formatCode>
+                <c:ptCount val="3"/>
+                <c:pt idx="0">
+                  <c:v>10</c:v>
+                </c:pt>
+                <c:pt idx="1">
+                  <c:v>116</c:v>
+                </c:pt>
+                <c:pt idx="2">
+                  <c:v>127</c:v>
+                </c:pt>
+              </c:numCache>
+            </c:numRef>
+          </c:val>
+        </c:ser>
+        <c:ser>
+          <c:idx val="1"/>
+          <c:order val="1"/>
+          <c:tx>
+            <c:strRef>
+              <c:f>Sheet1!$C$1</c:f>
+              <c:strCache>
+                <c:ptCount val="1"/>
+                <c:pt idx="0">
+                  <c:v>Có lúc đổi CLB</c:v>
+                </c:pt>
+              </c:strCache>
+            </c:strRef>
+          </c:tx>
+          <c:spPr>
+            <a:solidFill>
+              <a:srgbClr val="B8781A"/>
+            </a:solidFill>
+          </c:spPr>
+          <c:cat>
+            <c:strRef>
+              <c:f>Sheet1!$A$2:$A$4</c:f>
+              <c:strCache>
+                <c:ptCount val="3"/>
+                <c:pt idx="0">
+                  <c:v>Bộ 10 em · 0 em có lúc đổi</c:v>
+                </c:pt>
+                <c:pt idx="1">
+                  <c:v>Bộ 120 em · 4 em có lúc đổi</c:v>
+                </c:pt>
+                <c:pt idx="2">
+                  <c:v>Bộ 140 em · 13 em có lúc đổi</c:v>
+                </c:pt>
+              </c:strCache>
+            </c:strRef>
+          </c:cat>
+          <c:val>
+            <c:numRef>
+              <c:f>Sheet1!$C$2:$C$4</c:f>
+              <c:numCache>
+                <c:formatCode>General</c:formatCode>
+                <c:ptCount val="3"/>
+                <c:pt idx="0">
+                  <c:v>0</c:v>
+                </c:pt>
+                <c:pt idx="1">
+                  <c:v>4</c:v>
+                </c:pt>
+                <c:pt idx="2">
+                  <c:v>13</c:v>
+                </c:pt>
+              </c:numCache>
+            </c:numRef>
+          </c:val>
+        </c:ser>
+        <c:gapWidth val="40"/>
+        <c:overlap val="100"/>
+        <c:axId val="-2068027336"/>
+        <c:axId val="-2113994440"/>
+      </c:barChart>
+      <c:catAx>
+        <c:axId val="-2068027336"/>
+        <c:scaling>
+          <c:orientation val="maxMin"/>
+        </c:scaling>
+        <c:delete val="0"/>
+        <c:axPos val="l"/>
+        <c:majorTickMark val="out"/>
+        <c:minorTickMark val="none"/>
+        <c:tickLblPos val="nextTo"/>
+        <c:spPr>
+          <a:ln>
+            <a:noFill/>
+          </a:ln>
+        </c:spPr>
+        <c:txPr>
+          <a:bodyPr/>
+          <a:lstStyle/>
+          <a:p>
+            <a:pPr>
+              <a:defRPr sz="869"/>
+            </a:pPr>
+          </a:p>
+        </c:txPr>
+        <c:crossAx val="-2113994440"/>
+        <c:crosses val="autoZero"/>
+        <c:auto val="1"/>
+        <c:lblAlgn val="ctr"/>
+        <c:lblOffset val="100"/>
+        <c:noMultiLvlLbl val="0"/>
+      </c:catAx>
+      <c:valAx>
+        <c:axId val="-2113994440"/>
+        <c:scaling/>
+        <c:delete/>
+        <c:axPos val="b"/>
+        <c:majorTickMark val="out"/>
+        <c:minorTickMark val="none"/>
+        <c:tickLblPos val="nextTo"/>
+        <c:crossAx val="-2068027336"/>
+        <c:crosses val="autoZero"/>
+      </c:valAx>
+    </c:plotArea>
+    <c:legend>
+      <c:legendPos val="t"/>
+      <c:overlay val="0"/>
+    </c:legend>
+    <c:dispBlanksAs val="gap"/>
+  </c:chart>
+  <c:txPr>
+    <a:bodyPr/>
+    <a:lstStyle/>
+    <a:p>
+      <a:pPr>
+        <a:defRPr sz="869">
+          <a:solidFill>
+            <a:srgbClr val="1C2321"/>
+          </a:solidFill>
+          <a:latin typeface="IBM Plex Sans"/>
+        </a:defRPr>
+      </a:pPr>
+      <a:endParaRPr lang="en-US"/>
+    </a:p>
+  </c:txPr>
+  <c:externalData r:id="rId1">
+    <c:autoUpdate val="0"/>
+  </c:externalData>
+</c:chartSpace>
+</file>
+
+<file path=ppt/charts/chart2.xml><?xml version="1.0" encoding="utf-8"?>
+<c:chartSpace xmlns:c="http://schemas.openxmlformats.org/drawingml/2006/chart" xmlns:a="http://schemas.openxmlformats.org/drawingml/2006/main" xmlns:r="http://schemas.openxmlformats.org/officeDocument/2006/relationships">
+  <c:date1904 val="0"/>
+  <c:chart>
+    <c:autoTitleDeleted val="1"/>
+    <c:plotArea>
+      <c:barChart>
+        <c:barDir val="bar"/>
         <c:grouping val="clustered"/>
         <c:ser>
           <c:idx val="0"/>
@@ -134,12 +415,44 @@
             <c:idx val="0"/>
             <c:spPr>
               <a:solidFill>
-                <a:srgbClr val="27805A"/>
+                <a:srgbClr val="B9BEC3"/>
               </a:solidFill>
             </c:spPr>
           </c:dPt>
           <c:dPt>
             <c:idx val="1"/>
+            <c:spPr>
+              <a:solidFill>
+                <a:srgbClr val="B9BEC3"/>
+              </a:solidFill>
+            </c:spPr>
+          </c:dPt>
+          <c:dPt>
+            <c:idx val="2"/>
+            <c:spPr>
+              <a:solidFill>
+                <a:srgbClr val="B8781A"/>
+              </a:solidFill>
+            </c:spPr>
+          </c:dPt>
+          <c:dPt>
+            <c:idx val="3"/>
+            <c:spPr>
+              <a:solidFill>
+                <a:srgbClr val="B9BEC3"/>
+              </a:solidFill>
+            </c:spPr>
+          </c:dPt>
+          <c:dPt>
+            <c:idx val="4"/>
+            <c:spPr>
+              <a:solidFill>
+                <a:srgbClr val="B9BEC3"/>
+              </a:solidFill>
+            </c:spPr>
+          </c:dPt>
+          <c:dPt>
+            <c:idx val="5"/>
             <c:spPr>
               <a:solidFill>
                 <a:srgbClr val="B9BEC3"/>
@@ -160,7 +473,7 @@
                           <a:srgbClr val="1C2321"/>
                         </a:solidFill>
                       </a:rPr>
-                      <a:t>0 / 1 400 em</a:t>
+                      <a:t>15,14%</a:t>
                     </a:r>
                   </a:p>
                 </c:rich>
@@ -186,7 +499,111 @@
                           <a:srgbClr val="1C2321"/>
                         </a:solidFill>
                       </a:rPr>
-                      <a:t>258 / 1 400 em (18,43%)</a:t>
+                      <a:t>4,75%</a:t>
+                    </a:r>
+                  </a:p>
+                </c:rich>
+              </c:tx>
+              <c:dLblPos val="outEnd"/>
+              <c:showLegendKey val="0"/>
+              <c:showVal val="1"/>
+              <c:showCatName val="0"/>
+              <c:showSerName val="0"/>
+              <c:showPercent val="0"/>
+              <c:showBubbleSize val="0"/>
+            </c:dLbl>
+            <c:dLbl>
+              <c:idx val="2"/>
+              <c:tx>
+                <c:rich>
+                  <a:bodyPr/>
+                  <a:lstStyle/>
+                  <a:p>
+                    <a:r>
+                      <a:rPr sz="1231" b="1">
+                        <a:solidFill>
+                          <a:srgbClr val="1C2321"/>
+                        </a:solidFill>
+                      </a:rPr>
+                      <a:t>4,36%</a:t>
+                    </a:r>
+                  </a:p>
+                </c:rich>
+              </c:tx>
+              <c:dLblPos val="outEnd"/>
+              <c:showLegendKey val="0"/>
+              <c:showVal val="1"/>
+              <c:showCatName val="0"/>
+              <c:showSerName val="0"/>
+              <c:showPercent val="0"/>
+              <c:showBubbleSize val="0"/>
+            </c:dLbl>
+            <c:dLbl>
+              <c:idx val="3"/>
+              <c:tx>
+                <c:rich>
+                  <a:bodyPr/>
+                  <a:lstStyle/>
+                  <a:p>
+                    <a:r>
+                      <a:rPr sz="1231" b="1">
+                        <a:solidFill>
+                          <a:srgbClr val="1C2321"/>
+                        </a:solidFill>
+                      </a:rPr>
+                      <a:t>1,27%</a:t>
+                    </a:r>
+                  </a:p>
+                </c:rich>
+              </c:tx>
+              <c:dLblPos val="outEnd"/>
+              <c:showLegendKey val="0"/>
+              <c:showVal val="1"/>
+              <c:showCatName val="0"/>
+              <c:showSerName val="0"/>
+              <c:showPercent val="0"/>
+              <c:showBubbleSize val="0"/>
+            </c:dLbl>
+            <c:dLbl>
+              <c:idx val="4"/>
+              <c:tx>
+                <c:rich>
+                  <a:bodyPr/>
+                  <a:lstStyle/>
+                  <a:p>
+                    <a:r>
+                      <a:rPr sz="1231" b="1">
+                        <a:solidFill>
+                          <a:srgbClr val="1C2321"/>
+                        </a:solidFill>
+                      </a:rPr>
+                      <a:t>0,83%</a:t>
+                    </a:r>
+                  </a:p>
+                </c:rich>
+              </c:tx>
+              <c:dLblPos val="outEnd"/>
+              <c:showLegendKey val="0"/>
+              <c:showVal val="1"/>
+              <c:showCatName val="0"/>
+              <c:showSerName val="0"/>
+              <c:showPercent val="0"/>
+              <c:showBubbleSize val="0"/>
+            </c:dLbl>
+            <c:dLbl>
+              <c:idx val="5"/>
+              <c:tx>
+                <c:rich>
+                  <a:bodyPr/>
+                  <a:lstStyle/>
+                  <a:p>
+                    <a:r>
+                      <a:rPr sz="1231" b="1">
+                        <a:solidFill>
+                          <a:srgbClr val="1C2321"/>
+                        </a:solidFill>
+                      </a:rPr>
+                      <a:t>0,50%</a:t>
                     </a:r>
                   </a:p>
                 </c:rich>
@@ -209,29 +626,53 @@
           </c:dLbls>
           <c:cat>
             <c:strRef>
-              <c:f>Sheet1!$A$2:$A$3</c:f>
+              <c:f>Sheet1!$A$2:$A$7</c:f>
               <c:strCache>
-                <c:ptCount val="2"/>
+                <c:ptCount val="6"/>
                 <c:pt idx="0">
-                  <c:v>Phần mềm (RB-DA)</c:v>
+                  <c:v>Điểm chấm lệch ±0,5</c:v>
                 </c:pt>
                 <c:pt idx="1">
-                  <c:v>Cơ chế Boston</c:v>
+                  <c:v>Điểm chấm lệch ±0,1</c:v>
+                </c:pt>
+                <c:pt idx="2">
+                  <c:v>Đổi hạt giống bốc thăm</c:v>
+                </c:pt>
+                <c:pt idx="3">
+                  <c:v>Bớt 1 học sinh</c:v>
+                </c:pt>
+                <c:pt idx="4">
+                  <c:v>Chỉ tiêu mỗi CLB ±1</c:v>
+                </c:pt>
+                <c:pt idx="5">
+                  <c:v>Thêm 1 học sinh</c:v>
                 </c:pt>
               </c:strCache>
             </c:strRef>
           </c:cat>
           <c:val>
             <c:numRef>
-              <c:f>Sheet1!$B$2:$B$3</c:f>
+              <c:f>Sheet1!$B$2:$B$7</c:f>
               <c:numCache>
                 <c:formatCode>General</c:formatCode>
-                <c:ptCount val="2"/>
+                <c:ptCount val="6"/>
                 <c:pt idx="0">
-                  <c:v>0</c:v>
+                  <c:v>15.14</c:v>
                 </c:pt>
                 <c:pt idx="1">
-                  <c:v>258</c:v>
+                  <c:v>4.75</c:v>
+                </c:pt>
+                <c:pt idx="2">
+                  <c:v>4.36</c:v>
+                </c:pt>
+                <c:pt idx="3">
+                  <c:v>1.27</c:v>
+                </c:pt>
+                <c:pt idx="4">
+                  <c:v>0.83</c:v>
+                </c:pt>
+                <c:pt idx="5">
+                  <c:v>0.5</c:v>
                 </c:pt>
               </c:numCache>
             </c:numRef>
@@ -263,7 +704,7 @@
           <a:lstStyle/>
           <a:p>
             <a:pPr>
-              <a:defRPr b="1" sz="1159"/>
+              <a:defRPr b="0" sz="1159"/>
             </a:pPr>
           </a:p>
         </c:txPr>
@@ -277,7 +718,7 @@
       <c:valAx>
         <c:axId val="-2113994440"/>
         <c:scaling>
-          <c:max val="400.0"/>
+          <c:max val="16.0"/>
           <c:min val="0.0"/>
         </c:scaling>
         <c:delete val="0"/>
@@ -291,6 +732,7 @@
             </a:ln>
           </c:spPr>
         </c:majorGridlines>
+        <c:numFmt formatCode="0&quot;%&quot;" sourceLinked="0"/>
         <c:majorTickMark val="out"/>
         <c:minorTickMark val="none"/>
         <c:tickLblPos val="nextTo"/>
@@ -314,320 +756,7 @@
         </c:txPr>
         <c:crossAx val="-2068027336"/>
         <c:crosses val="autoZero"/>
-        <c:majorUnit val="100.0"/>
-      </c:valAx>
-    </c:plotArea>
-    <c:dispBlanksAs val="gap"/>
-  </c:chart>
-  <c:txPr>
-    <a:bodyPr/>
-    <a:lstStyle/>
-    <a:p>
-      <a:pPr>
-        <a:defRPr sz="941">
-          <a:solidFill>
-            <a:srgbClr val="1C2321"/>
-          </a:solidFill>
-          <a:latin typeface="IBM Plex Sans"/>
-        </a:defRPr>
-      </a:pPr>
-      <a:endParaRPr lang="en-US"/>
-    </a:p>
-  </c:txPr>
-  <c:externalData r:id="rId1">
-    <c:autoUpdate val="0"/>
-  </c:externalData>
-</c:chartSpace>
-</file>
-
-<file path=ppt/charts/chart2.xml><?xml version="1.0" encoding="utf-8"?>
-<c:chartSpace xmlns:c="http://schemas.openxmlformats.org/drawingml/2006/chart" xmlns:a="http://schemas.openxmlformats.org/drawingml/2006/main" xmlns:r="http://schemas.openxmlformats.org/officeDocument/2006/relationships">
-  <c:date1904 val="0"/>
-  <c:chart>
-    <c:autoTitleDeleted val="1"/>
-    <c:plotArea>
-      <c:barChart>
-        <c:barDir val="col"/>
-        <c:grouping val="clustered"/>
-        <c:ser>
-          <c:idx val="0"/>
-          <c:order val="0"/>
-          <c:tx>
-            <c:strRef>
-              <c:f>Sheet1!$B$1</c:f>
-              <c:strCache>
-                <c:ptCount val="1"/>
-                <c:pt idx="0">
-                  <c:v>Số em</c:v>
-                </c:pt>
-              </c:strCache>
-            </c:strRef>
-          </c:tx>
-          <c:dPt>
-            <c:idx val="0"/>
-            <c:spPr>
-              <a:solidFill>
-                <a:srgbClr val="27805A"/>
-              </a:solidFill>
-            </c:spPr>
-          </c:dPt>
-          <c:dPt>
-            <c:idx val="1"/>
-            <c:spPr>
-              <a:solidFill>
-                <a:srgbClr val="7FAE95"/>
-              </a:solidFill>
-            </c:spPr>
-          </c:dPt>
-          <c:dPt>
-            <c:idx val="2"/>
-            <c:spPr>
-              <a:solidFill>
-                <a:srgbClr val="7FAE95"/>
-              </a:solidFill>
-            </c:spPr>
-          </c:dPt>
-          <c:dPt>
-            <c:idx val="3"/>
-            <c:spPr>
-              <a:solidFill>
-                <a:srgbClr val="7FAE95"/>
-              </a:solidFill>
-            </c:spPr>
-          </c:dPt>
-          <c:dLbls>
-            <c:dLbl>
-              <c:idx val="0"/>
-              <c:tx>
-                <c:rich>
-                  <a:bodyPr/>
-                  <a:lstStyle/>
-                  <a:p>
-                    <a:r>
-                      <a:rPr sz="1231" b="1">
-                        <a:solidFill>
-                          <a:srgbClr val="1C2321"/>
-                        </a:solidFill>
-                      </a:rPr>
-                      <a:t>64 em · 59%</a:t>
-                    </a:r>
-                  </a:p>
-                </c:rich>
-              </c:tx>
-              <c:dLblPos val="outEnd"/>
-              <c:showLegendKey val="0"/>
-              <c:showVal val="1"/>
-              <c:showCatName val="0"/>
-              <c:showSerName val="0"/>
-              <c:showPercent val="0"/>
-              <c:showBubbleSize val="0"/>
-            </c:dLbl>
-            <c:dLbl>
-              <c:idx val="1"/>
-              <c:tx>
-                <c:rich>
-                  <a:bodyPr/>
-                  <a:lstStyle/>
-                  <a:p>
-                    <a:r>
-                      <a:rPr sz="1231" b="1">
-                        <a:solidFill>
-                          <a:srgbClr val="1C2321"/>
-                        </a:solidFill>
-                      </a:rPr>
-                      <a:t>28 em · 26%</a:t>
-                    </a:r>
-                  </a:p>
-                </c:rich>
-              </c:tx>
-              <c:dLblPos val="outEnd"/>
-              <c:showLegendKey val="0"/>
-              <c:showVal val="1"/>
-              <c:showCatName val="0"/>
-              <c:showSerName val="0"/>
-              <c:showPercent val="0"/>
-              <c:showBubbleSize val="0"/>
-            </c:dLbl>
-            <c:dLbl>
-              <c:idx val="2"/>
-              <c:tx>
-                <c:rich>
-                  <a:bodyPr/>
-                  <a:lstStyle/>
-                  <a:p>
-                    <a:r>
-                      <a:rPr sz="1231" b="1">
-                        <a:solidFill>
-                          <a:srgbClr val="1C2321"/>
-                        </a:solidFill>
-                      </a:rPr>
-                      <a:t>10 em · 9%</a:t>
-                    </a:r>
-                  </a:p>
-                </c:rich>
-              </c:tx>
-              <c:dLblPos val="outEnd"/>
-              <c:showLegendKey val="0"/>
-              <c:showVal val="1"/>
-              <c:showCatName val="0"/>
-              <c:showSerName val="0"/>
-              <c:showPercent val="0"/>
-              <c:showBubbleSize val="0"/>
-            </c:dLbl>
-            <c:dLbl>
-              <c:idx val="3"/>
-              <c:tx>
-                <c:rich>
-                  <a:bodyPr/>
-                  <a:lstStyle/>
-                  <a:p>
-                    <a:r>
-                      <a:rPr sz="1231" b="1">
-                        <a:solidFill>
-                          <a:srgbClr val="1C2321"/>
-                        </a:solidFill>
-                      </a:rPr>
-                      <a:t>6 em · 6%</a:t>
-                    </a:r>
-                  </a:p>
-                </c:rich>
-              </c:tx>
-              <c:dLblPos val="outEnd"/>
-              <c:showLegendKey val="0"/>
-              <c:showVal val="1"/>
-              <c:showCatName val="0"/>
-              <c:showSerName val="0"/>
-              <c:showPercent val="0"/>
-              <c:showBubbleSize val="0"/>
-            </c:dLbl>
-            <c:showLegendKey val="0"/>
-            <c:showVal val="0"/>
-            <c:showCatName val="0"/>
-            <c:showSerName val="0"/>
-            <c:showPercent val="0"/>
-            <c:showBubbleSize val="0"/>
-            <c:showLeaderLines val="1"/>
-          </c:dLbls>
-          <c:cat>
-            <c:strRef>
-              <c:f>Sheet1!$A$2:$A$5</c:f>
-              <c:strCache>
-                <c:ptCount val="4"/>
-                <c:pt idx="0">
-                  <c:v>NV 1</c:v>
-                </c:pt>
-                <c:pt idx="1">
-                  <c:v>NV 2</c:v>
-                </c:pt>
-                <c:pt idx="2">
-                  <c:v>NV 3</c:v>
-                </c:pt>
-                <c:pt idx="3">
-                  <c:v>NV 4</c:v>
-                </c:pt>
-              </c:strCache>
-            </c:strRef>
-          </c:cat>
-          <c:val>
-            <c:numRef>
-              <c:f>Sheet1!$B$2:$B$5</c:f>
-              <c:numCache>
-                <c:formatCode>General</c:formatCode>
-                <c:ptCount val="4"/>
-                <c:pt idx="0">
-                  <c:v>64</c:v>
-                </c:pt>
-                <c:pt idx="1">
-                  <c:v>28</c:v>
-                </c:pt>
-                <c:pt idx="2">
-                  <c:v>10</c:v>
-                </c:pt>
-                <c:pt idx="3">
-                  <c:v>6</c:v>
-                </c:pt>
-              </c:numCache>
-            </c:numRef>
-          </c:val>
-        </c:ser>
-        <c:gapWidth val="70"/>
-        <c:axId val="-2068027336"/>
-        <c:axId val="-2113994440"/>
-      </c:barChart>
-      <c:catAx>
-        <c:axId val="-2068027336"/>
-        <c:scaling>
-          <c:orientation val="minMax"/>
-        </c:scaling>
-        <c:delete val="0"/>
-        <c:axPos val="b"/>
-        <c:majorTickMark val="out"/>
-        <c:minorTickMark val="none"/>
-        <c:tickLblPos val="nextTo"/>
-        <c:spPr>
-          <a:ln>
-            <a:solidFill>
-              <a:srgbClr val="5B6570"/>
-            </a:solidFill>
-          </a:ln>
-        </c:spPr>
-        <c:txPr>
-          <a:bodyPr/>
-          <a:lstStyle/>
-          <a:p>
-            <a:pPr>
-              <a:defRPr b="1" sz="1159"/>
-            </a:pPr>
-          </a:p>
-        </c:txPr>
-        <c:crossAx val="-2113994440"/>
-        <c:crosses val="autoZero"/>
-        <c:auto val="1"/>
-        <c:lblAlgn val="ctr"/>
-        <c:lblOffset val="100"/>
-        <c:noMultiLvlLbl val="0"/>
-      </c:catAx>
-      <c:valAx>
-        <c:axId val="-2113994440"/>
-        <c:scaling>
-          <c:max val="70.0"/>
-          <c:min val="0.0"/>
-        </c:scaling>
-        <c:delete val="0"/>
-        <c:axPos val="l"/>
-        <c:majorGridlines>
-          <c:spPr>
-            <a:ln>
-              <a:solidFill>
-                <a:srgbClr val="DBDCD5"/>
-              </a:solidFill>
-            </a:ln>
-          </c:spPr>
-        </c:majorGridlines>
-        <c:majorTickMark val="out"/>
-        <c:minorTickMark val="none"/>
-        <c:tickLblPos val="nextTo"/>
-        <c:spPr>
-          <a:ln>
-            <a:noFill/>
-          </a:ln>
-        </c:spPr>
-        <c:txPr>
-          <a:bodyPr/>
-          <a:lstStyle/>
-          <a:p>
-            <a:pPr>
-              <a:defRPr>
-                <a:solidFill>
-                  <a:srgbClr val="8A929A"/>
-                </a:solidFill>
-              </a:defRPr>
-            </a:pPr>
-          </a:p>
-        </c:txPr>
-        <c:crossAx val="-2068027336"/>
-        <c:crosses val="autoZero"/>
-        <c:majorUnit val="20.0"/>
+        <c:majorUnit val="5.0"/>
       </c:valAx>
     </c:plotArea>
     <c:dispBlanksAs val="gap"/>
@@ -9607,28 +9736,28 @@
       </p:sp>
       <p:grpSp>
         <p:nvGrpSpPr>
-          <p:cNvPr id="137" name="Bieu do khai gian"/>
+          <p:cNvPr id="137" name="Bieu do giu nguyen"/>
           <p:cNvGrpSpPr/>
           <p:nvPr/>
         </p:nvGrpSpPr>
         <p:grpSpPr>
           <a:xfrm>
-            <a:off x="27958050" y="13202212"/>
+            <a:off x="27958050" y="13110187"/>
             <a:ext cx="6993899" cy="2208600"/>
-            <a:chOff x="27958050" y="13202212"/>
+            <a:chOff x="27958050" y="13110187"/>
             <a:chExt cx="6993899" cy="2208600"/>
           </a:xfrm>
         </p:grpSpPr>
         <p:graphicFrame>
           <p:nvGraphicFramePr>
-            <p:cNvPr id="141" name="Chart 140"/>
+            <p:cNvPr id="142" name="Chart 141"/>
             <p:cNvGraphicFramePr>
               <a:graphicFrameLocks noGrp="1"/>
             </p:cNvGraphicFramePr>
             <p:nvPr/>
           </p:nvGraphicFramePr>
           <p:xfrm>
-            <a:off x="27958050" y="13202212"/>
+            <a:off x="27958050" y="13110187"/>
             <a:ext cx="6993899" cy="2208600"/>
           </p:xfrm>
           <a:graphic>
@@ -9668,7 +9797,7 @@
                 </a:solidFill>
                 <a:latin typeface="Be Vietnam Pro"/>
               </a:rPr>
-              <a:t>Số em khai sai nguyện vọng mà được lợi</a:t>
+              <a:t>Đổi hạt giống bốc thăm 200 lần</a:t>
             </a:r>
           </a:p>
         </p:txBody>
@@ -9703,7 +9832,7 @@
                 </a:solidFill>
                 <a:latin typeface="IBM Plex Sans"/>
               </a:rPr>
-              <a:t>Vét cạn mọi cách khai của từng em · 200 thể hiện, 1 400 lượt học sinh</a:t>
+              <a:t>Bao nhiêu em luôn giữ nguyên CLB? · 3 bộ dữ liệu mô phỏng</a:t>
             </a:r>
           </a:p>
         </p:txBody>
@@ -9716,7 +9845,7 @@
         </p:nvSpPr>
         <p:spPr>
           <a:xfrm>
-            <a:off x="28050075" y="15541488"/>
+            <a:off x="28050075" y="15656519"/>
             <a:ext cx="180000" cy="143559"/>
           </a:xfrm>
           <a:prstGeom prst="rect">
@@ -9738,36 +9867,71 @@
                 </a:solidFill>
                 <a:latin typeface="IBM Plex Sans"/>
               </a:rPr>
-              <a:t>Dữ liệu mô phỏng — nguồn: NGHIEN_CUU_TOI_UU.md, TN3</a:t>
+              <a:t>Dữ liệu mô phỏng — nguồn: du_lieu_test/SO_LIEU_DA_KIEM_CHUNG.md, mục 3c</a:t>
+            </a:r>
+          </a:p>
+        </p:txBody>
+      </p:sp>
+      <p:sp>
+        <p:nvSpPr>
+          <p:cNvPr id="141" name="TextBox 140"/>
+          <p:cNvSpPr txBox="1"/>
+          <p:nvPr/>
+        </p:nvSpPr>
+        <p:spPr>
+          <a:xfrm>
+            <a:off x="28050075" y="15386885"/>
+            <a:ext cx="180000" cy="167485"/>
+          </a:xfrm>
+          <a:prstGeom prst="rect">
+            <a:avLst/>
+          </a:prstGeom>
+          <a:noFill/>
+        </p:spPr>
+        <p:txBody>
+          <a:bodyPr wrap="none" anchor="t" lIns="0" rIns="0" tIns="0" bIns="0">
+            <a:spAutoFit/>
+          </a:bodyPr>
+          <a:lstStyle/>
+          <a:p>
+            <a:pPr algn="l"/>
+            <a:r>
+              <a:rPr sz="1014" b="1" i="0">
+                <a:solidFill>
+                  <a:srgbClr val="1C2321"/>
+                </a:solidFill>
+                <a:latin typeface="IBM Plex Sans"/>
+              </a:rPr>
+              <a:t>Chỉ 3/270 em (1,1%) có lúc mất suất vì bốc thăm · 0 cặp phá vỡ ở mọi hạt giống</a:t>
             </a:r>
           </a:p>
         </p:txBody>
       </p:sp>
       <p:grpSp>
         <p:nvGrpSpPr>
-          <p:cNvPr id="142" name="Bieu do nguyen vong"/>
+          <p:cNvPr id="143" name="Bieu do nhieu"/>
           <p:cNvGrpSpPr/>
           <p:nvPr/>
         </p:nvGrpSpPr>
         <p:grpSpPr>
           <a:xfrm>
-            <a:off x="27958050" y="16797150"/>
-            <a:ext cx="6993899" cy="3404924"/>
-            <a:chOff x="27958050" y="16797150"/>
-            <a:chExt cx="6993899" cy="3404924"/>
+            <a:off x="27958050" y="16843162"/>
+            <a:ext cx="6993899" cy="3174862"/>
+            <a:chOff x="27958050" y="16843162"/>
+            <a:chExt cx="6993899" cy="3174862"/>
           </a:xfrm>
         </p:grpSpPr>
         <p:graphicFrame>
           <p:nvGraphicFramePr>
-            <p:cNvPr id="146" name="Chart 145"/>
+            <p:cNvPr id="148" name="Chart 147"/>
             <p:cNvGraphicFramePr>
               <a:graphicFrameLocks noGrp="1"/>
             </p:cNvGraphicFramePr>
             <p:nvPr/>
           </p:nvGraphicFramePr>
           <p:xfrm>
-            <a:off x="27958050" y="16797150"/>
-            <a:ext cx="6993899" cy="3404924"/>
+            <a:off x="27958050" y="16843162"/>
+            <a:ext cx="6993899" cy="3174862"/>
           </p:xfrm>
           <a:graphic>
             <a:graphicData uri="http://schemas.openxmlformats.org/drawingml/2006/chart">
@@ -9778,7 +9942,7 @@
       </p:grpSp>
       <p:sp>
         <p:nvSpPr>
-          <p:cNvPr id="143" name="TextBox 142"/>
+          <p:cNvPr id="144" name="TextBox 143"/>
           <p:cNvSpPr txBox="1"/>
           <p:nvPr/>
         </p:nvSpPr>
@@ -9806,14 +9970,14 @@
                 </a:solidFill>
                 <a:latin typeface="Be Vietnam Pro"/>
               </a:rPr>
-              <a:t>Được xếp vào nguyện vọng thứ mấy</a:t>
-            </a:r>
-          </a:p>
-        </p:txBody>
-      </p:sp>
-      <p:sp>
-        <p:nvSpPr>
-          <p:cNvPr id="144" name="TextBox 143"/>
+              <a:t>Điều gì làm kết quả thay đổi nhiều nhất?</a:t>
+            </a:r>
+          </a:p>
+        </p:txBody>
+      </p:sp>
+      <p:sp>
+        <p:nvSpPr>
+          <p:cNvPr id="145" name="TextBox 144"/>
           <p:cNvSpPr txBox="1"/>
           <p:nvPr/>
         </p:nvSpPr>
@@ -9841,14 +10005,14 @@
                 </a:solidFill>
                 <a:latin typeface="IBM Plex Sans"/>
               </a:rPr>
-              <a:t>108 em được xếp · bộ 120 học sinh, 10 CLB · hạt giống bốc thăm 42</a:t>
-            </a:r>
-          </a:p>
-        </p:txBody>
-      </p:sp>
-      <p:sp>
-        <p:nvSpPr>
-          <p:cNvPr id="145" name="TextBox 144"/>
+              <a:t>% học sinh đổi CLB, trung bình · bộ 140 em mô phỏng</a:t>
+            </a:r>
+          </a:p>
+        </p:txBody>
+      </p:sp>
+      <p:sp>
+        <p:nvSpPr>
+          <p:cNvPr id="146" name="TextBox 145"/>
           <p:cNvSpPr txBox="1"/>
           <p:nvPr/>
         </p:nvSpPr>
@@ -9876,14 +10040,49 @@
                 </a:solidFill>
                 <a:latin typeface="IBM Plex Sans"/>
               </a:rPr>
-              <a:t>Dữ liệu mô phỏng — nguồn: du_lieu_test/SO_LIEU_DA_KIEM_CHUNG.md, mục 2</a:t>
-            </a:r>
-          </a:p>
-        </p:txBody>
-      </p:sp>
-      <p:sp>
-        <p:nvSpPr>
-          <p:cNvPr id="147" name="Rounded Rectangle 146"/>
+              <a:t>Dữ liệu mô phỏng — nguồn: NGHIEN_CUU_TOI_UU.md, TN6</a:t>
+            </a:r>
+          </a:p>
+        </p:txBody>
+      </p:sp>
+      <p:sp>
+        <p:nvSpPr>
+          <p:cNvPr id="147" name="TextBox 146"/>
+          <p:cNvSpPr txBox="1"/>
+          <p:nvPr/>
+        </p:nvSpPr>
+        <p:spPr>
+          <a:xfrm>
+            <a:off x="28050075" y="20109129"/>
+            <a:ext cx="180000" cy="167485"/>
+          </a:xfrm>
+          <a:prstGeom prst="rect">
+            <a:avLst/>
+          </a:prstGeom>
+          <a:noFill/>
+        </p:spPr>
+        <p:txBody>
+          <a:bodyPr wrap="none" anchor="t" lIns="0" rIns="0" tIns="0" bIns="0">
+            <a:spAutoFit/>
+          </a:bodyPr>
+          <a:lstStyle/>
+          <a:p>
+            <a:pPr algn="l"/>
+            <a:r>
+              <a:rPr sz="1014" b="1" i="0">
+                <a:solidFill>
+                  <a:srgbClr val="1C2321"/>
+                </a:solidFill>
+                <a:latin typeface="IBM Plex Sans"/>
+              </a:rPr>
+              <a:t>392 phép thử trên 3 bộ dữ liệu · 0 cặp phá vỡ</a:t>
+            </a:r>
+          </a:p>
+        </p:txBody>
+      </p:sp>
+      <p:sp>
+        <p:nvSpPr>
+          <p:cNvPr id="149" name="Rounded Rectangle 148"/>
           <p:cNvSpPr/>
           <p:nvPr/>
         </p:nvSpPr>
@@ -9930,7 +10129,7 @@
       </p:sp>
       <p:sp>
         <p:nvSpPr>
-          <p:cNvPr id="148" name="TextBox 147"/>
+          <p:cNvPr id="150" name="TextBox 149"/>
           <p:cNvSpPr txBox="1"/>
           <p:nvPr/>
         </p:nvSpPr>
@@ -9958,14 +10157,14 @@
                 </a:solidFill>
                 <a:latin typeface="IBM Plex Sans"/>
               </a:rPr>
-              <a:t>[ P5 — em viết 1–2 câu: hai biểu đồ này nói gì với học sinh? ]</a:t>
-            </a:r>
-          </a:p>
-        </p:txBody>
-      </p:sp>
-      <p:sp>
-        <p:nvSpPr>
-          <p:cNvPr id="149" name="Rounded Rectangle 148"/>
+              <a:t>[ P5 — em viết 1–2 câu: hai biểu đồ này nói gì về bốc thăm? ]</a:t>
+            </a:r>
+          </a:p>
+        </p:txBody>
+      </p:sp>
+      <p:sp>
+        <p:nvSpPr>
+          <p:cNvPr id="151" name="Rounded Rectangle 150"/>
           <p:cNvSpPr/>
           <p:nvPr/>
         </p:nvSpPr>
@@ -10013,7 +10212,7 @@
       </p:sp>
       <p:sp>
         <p:nvSpPr>
-          <p:cNvPr id="150" name="TextBox 149"/>
+          <p:cNvPr id="152" name="TextBox 151"/>
           <p:cNvSpPr txBox="1"/>
           <p:nvPr/>
         </p:nvSpPr>
@@ -10048,7 +10247,7 @@
       </p:sp>
       <p:sp>
         <p:nvSpPr>
-          <p:cNvPr id="151" name="Rounded Rectangle 150"/>
+          <p:cNvPr id="153" name="Rounded Rectangle 152"/>
           <p:cNvSpPr/>
           <p:nvPr/>
         </p:nvSpPr>
@@ -10095,7 +10294,7 @@
       </p:sp>
       <p:sp>
         <p:nvSpPr>
-          <p:cNvPr id="152" name="TextBox 151"/>
+          <p:cNvPr id="154" name="TextBox 153"/>
           <p:cNvSpPr txBox="1"/>
           <p:nvPr/>
         </p:nvSpPr>

</xml_diff>

<commit_message>
Show the lottery sensitivity chart for all three simulated sets
Grouped bars per kind of change, one bar per dataset, read straight from
so_lieu_ben_vung.json instead of copied by hand. The lottery ranges from
0% to 4.36% depending on how tight the data is, and a half-point scoring
error is the largest effect on every set. Native PPTX chart and fact
sheet follow.

Co-Authored-By: Claude Opus 5.5 <noreply@anthropic.com>
Claude-Session: https://claude.ai/code/session_01NkYGd36L1Tpym32yxKyitD
</commit_message>
<xml_diff>
--- a/poster/poster_khung_1-2.pptx
+++ b/poster/poster_khung_1-2.pptx
@@ -406,59 +406,16 @@
               <c:strCache>
                 <c:ptCount val="1"/>
                 <c:pt idx="0">
-                  <c:v>Số em</c:v>
+                  <c:v>Bộ 10 em</c:v>
                 </c:pt>
               </c:strCache>
             </c:strRef>
           </c:tx>
-          <c:dPt>
-            <c:idx val="0"/>
-            <c:spPr>
-              <a:solidFill>
-                <a:srgbClr val="B9BEC3"/>
-              </a:solidFill>
-            </c:spPr>
-          </c:dPt>
-          <c:dPt>
-            <c:idx val="1"/>
-            <c:spPr>
-              <a:solidFill>
-                <a:srgbClr val="B9BEC3"/>
-              </a:solidFill>
-            </c:spPr>
-          </c:dPt>
-          <c:dPt>
-            <c:idx val="2"/>
-            <c:spPr>
-              <a:solidFill>
-                <a:srgbClr val="B8781A"/>
-              </a:solidFill>
-            </c:spPr>
-          </c:dPt>
-          <c:dPt>
-            <c:idx val="3"/>
-            <c:spPr>
-              <a:solidFill>
-                <a:srgbClr val="B9BEC3"/>
-              </a:solidFill>
-            </c:spPr>
-          </c:dPt>
-          <c:dPt>
-            <c:idx val="4"/>
-            <c:spPr>
-              <a:solidFill>
-                <a:srgbClr val="B9BEC3"/>
-              </a:solidFill>
-            </c:spPr>
-          </c:dPt>
-          <c:dPt>
-            <c:idx val="5"/>
-            <c:spPr>
-              <a:solidFill>
-                <a:srgbClr val="B9BEC3"/>
-              </a:solidFill>
-            </c:spPr>
-          </c:dPt>
+          <c:spPr>
+            <a:solidFill>
+              <a:srgbClr val="A9CDB9"/>
+            </a:solidFill>
+          </c:spPr>
           <c:dLbls>
             <c:dLbl>
               <c:idx val="0"/>
@@ -468,7 +425,483 @@
                   <a:lstStyle/>
                   <a:p>
                     <a:r>
-                      <a:rPr sz="1231" b="1">
+                      <a:rPr sz="797" b="0">
+                        <a:solidFill>
+                          <a:srgbClr val="1C2321"/>
+                        </a:solidFill>
+                      </a:rPr>
+                      <a:t>4,50%</a:t>
+                    </a:r>
+                  </a:p>
+                </c:rich>
+              </c:tx>
+              <c:dLblPos val="outEnd"/>
+              <c:showLegendKey val="0"/>
+              <c:showVal val="1"/>
+              <c:showCatName val="0"/>
+              <c:showSerName val="0"/>
+              <c:showPercent val="0"/>
+              <c:showBubbleSize val="0"/>
+            </c:dLbl>
+            <c:dLbl>
+              <c:idx val="1"/>
+              <c:tx>
+                <c:rich>
+                  <a:bodyPr/>
+                  <a:lstStyle/>
+                  <a:p>
+                    <a:r>
+                      <a:rPr sz="797" b="0">
+                        <a:solidFill>
+                          <a:srgbClr val="1C2321"/>
+                        </a:solidFill>
+                      </a:rPr>
+                      <a:t>0%</a:t>
+                    </a:r>
+                  </a:p>
+                </c:rich>
+              </c:tx>
+              <c:dLblPos val="outEnd"/>
+              <c:showLegendKey val="0"/>
+              <c:showVal val="1"/>
+              <c:showCatName val="0"/>
+              <c:showSerName val="0"/>
+              <c:showPercent val="0"/>
+              <c:showBubbleSize val="0"/>
+            </c:dLbl>
+            <c:dLbl>
+              <c:idx val="2"/>
+              <c:tx>
+                <c:rich>
+                  <a:bodyPr/>
+                  <a:lstStyle/>
+                  <a:p>
+                    <a:r>
+                      <a:rPr sz="797" b="1">
+                        <a:solidFill>
+                          <a:srgbClr val="1C2321"/>
+                        </a:solidFill>
+                      </a:rPr>
+                      <a:t>0%</a:t>
+                    </a:r>
+                  </a:p>
+                </c:rich>
+              </c:tx>
+              <c:dLblPos val="outEnd"/>
+              <c:showLegendKey val="0"/>
+              <c:showVal val="1"/>
+              <c:showCatName val="0"/>
+              <c:showSerName val="0"/>
+              <c:showPercent val="0"/>
+              <c:showBubbleSize val="0"/>
+            </c:dLbl>
+            <c:dLbl>
+              <c:idx val="3"/>
+              <c:tx>
+                <c:rich>
+                  <a:bodyPr/>
+                  <a:lstStyle/>
+                  <a:p>
+                    <a:r>
+                      <a:rPr sz="797" b="0">
+                        <a:solidFill>
+                          <a:srgbClr val="1C2321"/>
+                        </a:solidFill>
+                      </a:rPr>
+                      <a:t>3,33%</a:t>
+                    </a:r>
+                  </a:p>
+                </c:rich>
+              </c:tx>
+              <c:dLblPos val="outEnd"/>
+              <c:showLegendKey val="0"/>
+              <c:showVal val="1"/>
+              <c:showCatName val="0"/>
+              <c:showSerName val="0"/>
+              <c:showPercent val="0"/>
+              <c:showBubbleSize val="0"/>
+            </c:dLbl>
+            <c:dLbl>
+              <c:idx val="4"/>
+              <c:tx>
+                <c:rich>
+                  <a:bodyPr/>
+                  <a:lstStyle/>
+                  <a:p>
+                    <a:r>
+                      <a:rPr sz="797" b="0">
+                        <a:solidFill>
+                          <a:srgbClr val="1C2321"/>
+                        </a:solidFill>
+                      </a:rPr>
+                      <a:t>6,25%</a:t>
+                    </a:r>
+                  </a:p>
+                </c:rich>
+              </c:tx>
+              <c:dLblPos val="outEnd"/>
+              <c:showLegendKey val="0"/>
+              <c:showVal val="1"/>
+              <c:showCatName val="0"/>
+              <c:showSerName val="0"/>
+              <c:showPercent val="0"/>
+              <c:showBubbleSize val="0"/>
+            </c:dLbl>
+            <c:dLbl>
+              <c:idx val="5"/>
+              <c:tx>
+                <c:rich>
+                  <a:bodyPr/>
+                  <a:lstStyle/>
+                  <a:p>
+                    <a:r>
+                      <a:rPr sz="797" b="0">
+                        <a:solidFill>
+                          <a:srgbClr val="1C2321"/>
+                        </a:solidFill>
+                      </a:rPr>
+                      <a:t>2,00%</a:t>
+                    </a:r>
+                  </a:p>
+                </c:rich>
+              </c:tx>
+              <c:dLblPos val="outEnd"/>
+              <c:showLegendKey val="0"/>
+              <c:showVal val="1"/>
+              <c:showCatName val="0"/>
+              <c:showSerName val="0"/>
+              <c:showPercent val="0"/>
+              <c:showBubbleSize val="0"/>
+            </c:dLbl>
+            <c:showLegendKey val="0"/>
+            <c:showVal val="0"/>
+            <c:showCatName val="0"/>
+            <c:showSerName val="0"/>
+            <c:showPercent val="0"/>
+            <c:showBubbleSize val="0"/>
+            <c:showLeaderLines val="1"/>
+          </c:dLbls>
+          <c:cat>
+            <c:strRef>
+              <c:f>Sheet1!$A$2:$A$7</c:f>
+              <c:strCache>
+                <c:ptCount val="6"/>
+                <c:pt idx="0">
+                  <c:v>Điểm chấm lệch ±0,5</c:v>
+                </c:pt>
+                <c:pt idx="1">
+                  <c:v>Điểm chấm lệch ±0,1</c:v>
+                </c:pt>
+                <c:pt idx="2">
+                  <c:v>Đổi hạt giống bốc thăm</c:v>
+                </c:pt>
+                <c:pt idx="3">
+                  <c:v>Bớt 1 học sinh</c:v>
+                </c:pt>
+                <c:pt idx="4">
+                  <c:v>Chỉ tiêu mỗi CLB ±1</c:v>
+                </c:pt>
+                <c:pt idx="5">
+                  <c:v>Thêm 1 học sinh</c:v>
+                </c:pt>
+              </c:strCache>
+            </c:strRef>
+          </c:cat>
+          <c:val>
+            <c:numRef>
+              <c:f>Sheet1!$B$2:$B$7</c:f>
+              <c:numCache>
+                <c:formatCode>General</c:formatCode>
+                <c:ptCount val="6"/>
+                <c:pt idx="0">
+                  <c:v>4.5</c:v>
+                </c:pt>
+                <c:pt idx="1">
+                  <c:v>0.0</c:v>
+                </c:pt>
+                <c:pt idx="2">
+                  <c:v>0.0</c:v>
+                </c:pt>
+                <c:pt idx="3">
+                  <c:v>3.33</c:v>
+                </c:pt>
+                <c:pt idx="4">
+                  <c:v>6.25</c:v>
+                </c:pt>
+                <c:pt idx="5">
+                  <c:v>2.0</c:v>
+                </c:pt>
+              </c:numCache>
+            </c:numRef>
+          </c:val>
+        </c:ser>
+        <c:ser>
+          <c:idx val="1"/>
+          <c:order val="1"/>
+          <c:tx>
+            <c:strRef>
+              <c:f>Sheet1!$C$1</c:f>
+              <c:strCache>
+                <c:ptCount val="1"/>
+                <c:pt idx="0">
+                  <c:v>Bộ 120 em</c:v>
+                </c:pt>
+              </c:strCache>
+            </c:strRef>
+          </c:tx>
+          <c:spPr>
+            <a:solidFill>
+              <a:srgbClr val="5FA07E"/>
+            </a:solidFill>
+          </c:spPr>
+          <c:dLbls>
+            <c:dLbl>
+              <c:idx val="0"/>
+              <c:tx>
+                <c:rich>
+                  <a:bodyPr/>
+                  <a:lstStyle/>
+                  <a:p>
+                    <a:r>
+                      <a:rPr sz="797" b="0">
+                        <a:solidFill>
+                          <a:srgbClr val="1C2321"/>
+                        </a:solidFill>
+                      </a:rPr>
+                      <a:t>9,92%</a:t>
+                    </a:r>
+                  </a:p>
+                </c:rich>
+              </c:tx>
+              <c:dLblPos val="outEnd"/>
+              <c:showLegendKey val="0"/>
+              <c:showVal val="1"/>
+              <c:showCatName val="0"/>
+              <c:showSerName val="0"/>
+              <c:showPercent val="0"/>
+              <c:showBubbleSize val="0"/>
+            </c:dLbl>
+            <c:dLbl>
+              <c:idx val="1"/>
+              <c:tx>
+                <c:rich>
+                  <a:bodyPr/>
+                  <a:lstStyle/>
+                  <a:p>
+                    <a:r>
+                      <a:rPr sz="797" b="0">
+                        <a:solidFill>
+                          <a:srgbClr val="1C2321"/>
+                        </a:solidFill>
+                      </a:rPr>
+                      <a:t>1,54%</a:t>
+                    </a:r>
+                  </a:p>
+                </c:rich>
+              </c:tx>
+              <c:dLblPos val="outEnd"/>
+              <c:showLegendKey val="0"/>
+              <c:showVal val="1"/>
+              <c:showCatName val="0"/>
+              <c:showSerName val="0"/>
+              <c:showPercent val="0"/>
+              <c:showBubbleSize val="0"/>
+            </c:dLbl>
+            <c:dLbl>
+              <c:idx val="2"/>
+              <c:tx>
+                <c:rich>
+                  <a:bodyPr/>
+                  <a:lstStyle/>
+                  <a:p>
+                    <a:r>
+                      <a:rPr sz="797" b="1">
+                        <a:solidFill>
+                          <a:srgbClr val="1C2321"/>
+                        </a:solidFill>
+                      </a:rPr>
+                      <a:t>1,83%</a:t>
+                    </a:r>
+                  </a:p>
+                </c:rich>
+              </c:tx>
+              <c:dLblPos val="outEnd"/>
+              <c:showLegendKey val="0"/>
+              <c:showVal val="1"/>
+              <c:showCatName val="0"/>
+              <c:showSerName val="0"/>
+              <c:showPercent val="0"/>
+              <c:showBubbleSize val="0"/>
+            </c:dLbl>
+            <c:dLbl>
+              <c:idx val="3"/>
+              <c:tx>
+                <c:rich>
+                  <a:bodyPr/>
+                  <a:lstStyle/>
+                  <a:p>
+                    <a:r>
+                      <a:rPr sz="797" b="0">
+                        <a:solidFill>
+                          <a:srgbClr val="1C2321"/>
+                        </a:solidFill>
+                      </a:rPr>
+                      <a:t>1,68%</a:t>
+                    </a:r>
+                  </a:p>
+                </c:rich>
+              </c:tx>
+              <c:dLblPos val="outEnd"/>
+              <c:showLegendKey val="0"/>
+              <c:showVal val="1"/>
+              <c:showCatName val="0"/>
+              <c:showSerName val="0"/>
+              <c:showPercent val="0"/>
+              <c:showBubbleSize val="0"/>
+            </c:dLbl>
+            <c:dLbl>
+              <c:idx val="4"/>
+              <c:tx>
+                <c:rich>
+                  <a:bodyPr/>
+                  <a:lstStyle/>
+                  <a:p>
+                    <a:r>
+                      <a:rPr sz="797" b="0">
+                        <a:solidFill>
+                          <a:srgbClr val="1C2321"/>
+                        </a:solidFill>
+                      </a:rPr>
+                      <a:t>0,38%</a:t>
+                    </a:r>
+                  </a:p>
+                </c:rich>
+              </c:tx>
+              <c:dLblPos val="outEnd"/>
+              <c:showLegendKey val="0"/>
+              <c:showVal val="1"/>
+              <c:showCatName val="0"/>
+              <c:showSerName val="0"/>
+              <c:showPercent val="0"/>
+              <c:showBubbleSize val="0"/>
+            </c:dLbl>
+            <c:dLbl>
+              <c:idx val="5"/>
+              <c:tx>
+                <c:rich>
+                  <a:bodyPr/>
+                  <a:lstStyle/>
+                  <a:p>
+                    <a:r>
+                      <a:rPr sz="797" b="0">
+                        <a:solidFill>
+                          <a:srgbClr val="1C2321"/>
+                        </a:solidFill>
+                      </a:rPr>
+                      <a:t>0,08%</a:t>
+                    </a:r>
+                  </a:p>
+                </c:rich>
+              </c:tx>
+              <c:dLblPos val="outEnd"/>
+              <c:showLegendKey val="0"/>
+              <c:showVal val="1"/>
+              <c:showCatName val="0"/>
+              <c:showSerName val="0"/>
+              <c:showPercent val="0"/>
+              <c:showBubbleSize val="0"/>
+            </c:dLbl>
+            <c:showLegendKey val="0"/>
+            <c:showVal val="0"/>
+            <c:showCatName val="0"/>
+            <c:showSerName val="0"/>
+            <c:showPercent val="0"/>
+            <c:showBubbleSize val="0"/>
+            <c:showLeaderLines val="1"/>
+          </c:dLbls>
+          <c:cat>
+            <c:strRef>
+              <c:f>Sheet1!$A$2:$A$7</c:f>
+              <c:strCache>
+                <c:ptCount val="6"/>
+                <c:pt idx="0">
+                  <c:v>Điểm chấm lệch ±0,5</c:v>
+                </c:pt>
+                <c:pt idx="1">
+                  <c:v>Điểm chấm lệch ±0,1</c:v>
+                </c:pt>
+                <c:pt idx="2">
+                  <c:v>Đổi hạt giống bốc thăm</c:v>
+                </c:pt>
+                <c:pt idx="3">
+                  <c:v>Bớt 1 học sinh</c:v>
+                </c:pt>
+                <c:pt idx="4">
+                  <c:v>Chỉ tiêu mỗi CLB ±1</c:v>
+                </c:pt>
+                <c:pt idx="5">
+                  <c:v>Thêm 1 học sinh</c:v>
+                </c:pt>
+              </c:strCache>
+            </c:strRef>
+          </c:cat>
+          <c:val>
+            <c:numRef>
+              <c:f>Sheet1!$C$2:$C$7</c:f>
+              <c:numCache>
+                <c:formatCode>General</c:formatCode>
+                <c:ptCount val="6"/>
+                <c:pt idx="0">
+                  <c:v>9.92</c:v>
+                </c:pt>
+                <c:pt idx="1">
+                  <c:v>1.54</c:v>
+                </c:pt>
+                <c:pt idx="2">
+                  <c:v>1.83</c:v>
+                </c:pt>
+                <c:pt idx="3">
+                  <c:v>1.68</c:v>
+                </c:pt>
+                <c:pt idx="4">
+                  <c:v>0.38</c:v>
+                </c:pt>
+                <c:pt idx="5">
+                  <c:v>0.08</c:v>
+                </c:pt>
+              </c:numCache>
+            </c:numRef>
+          </c:val>
+        </c:ser>
+        <c:ser>
+          <c:idx val="2"/>
+          <c:order val="2"/>
+          <c:tx>
+            <c:strRef>
+              <c:f>Sheet1!$D$1</c:f>
+              <c:strCache>
+                <c:ptCount val="1"/>
+                <c:pt idx="0">
+                  <c:v>Bộ 140 em</c:v>
+                </c:pt>
+              </c:strCache>
+            </c:strRef>
+          </c:tx>
+          <c:spPr>
+            <a:solidFill>
+              <a:srgbClr val="27805A"/>
+            </a:solidFill>
+          </c:spPr>
+          <c:dLbls>
+            <c:dLbl>
+              <c:idx val="0"/>
+              <c:tx>
+                <c:rich>
+                  <a:bodyPr/>
+                  <a:lstStyle/>
+                  <a:p>
+                    <a:r>
+                      <a:rPr sz="797" b="0">
                         <a:solidFill>
                           <a:srgbClr val="1C2321"/>
                         </a:solidFill>
@@ -494,7 +927,7 @@
                   <a:lstStyle/>
                   <a:p>
                     <a:r>
-                      <a:rPr sz="1231" b="1">
+                      <a:rPr sz="797" b="0">
                         <a:solidFill>
                           <a:srgbClr val="1C2321"/>
                         </a:solidFill>
@@ -520,7 +953,7 @@
                   <a:lstStyle/>
                   <a:p>
                     <a:r>
-                      <a:rPr sz="1231" b="1">
+                      <a:rPr sz="797" b="1">
                         <a:solidFill>
                           <a:srgbClr val="1C2321"/>
                         </a:solidFill>
@@ -546,7 +979,7 @@
                   <a:lstStyle/>
                   <a:p>
                     <a:r>
-                      <a:rPr sz="1231" b="1">
+                      <a:rPr sz="797" b="0">
                         <a:solidFill>
                           <a:srgbClr val="1C2321"/>
                         </a:solidFill>
@@ -572,7 +1005,7 @@
                   <a:lstStyle/>
                   <a:p>
                     <a:r>
-                      <a:rPr sz="1231" b="1">
+                      <a:rPr sz="797" b="0">
                         <a:solidFill>
                           <a:srgbClr val="1C2321"/>
                         </a:solidFill>
@@ -598,7 +1031,7 @@
                   <a:lstStyle/>
                   <a:p>
                     <a:r>
-                      <a:rPr sz="1231" b="1">
+                      <a:rPr sz="797" b="0">
                         <a:solidFill>
                           <a:srgbClr val="1C2321"/>
                         </a:solidFill>
@@ -652,7 +1085,7 @@
           </c:cat>
           <c:val>
             <c:numRef>
-              <c:f>Sheet1!$B$2:$B$7</c:f>
+              <c:f>Sheet1!$D$2:$D$7</c:f>
               <c:numCache>
                 <c:formatCode>General</c:formatCode>
                 <c:ptCount val="6"/>
@@ -678,7 +1111,8 @@
             </c:numRef>
           </c:val>
         </c:ser>
-        <c:gapWidth val="70"/>
+        <c:gapWidth val="50"/>
+        <c:overlap val="-10"/>
         <c:axId val="-2068027336"/>
         <c:axId val="-2113994440"/>
       </c:barChart>
@@ -704,7 +1138,7 @@
           <a:lstStyle/>
           <a:p>
             <a:pPr>
-              <a:defRPr b="0" sz="1159"/>
+              <a:defRPr sz="1014"/>
             </a:pPr>
           </a:p>
         </c:txPr>
@@ -759,6 +1193,10 @@
         <c:majorUnit val="5.0"/>
       </c:valAx>
     </c:plotArea>
+    <c:legend>
+      <c:legendPos val="t"/>
+      <c:overlay val="0"/>
+    </c:legend>
     <c:dispBlanksAs val="gap"/>
   </c:chart>
   <c:txPr>
@@ -766,7 +1204,7 @@
     <a:lstStyle/>
     <a:p>
       <a:pPr>
-        <a:defRPr sz="941">
+        <a:defRPr sz="797">
           <a:solidFill>
             <a:srgbClr val="1C2321"/>
           </a:solidFill>
@@ -9915,10 +10353,10 @@
         </p:nvGrpSpPr>
         <p:grpSpPr>
           <a:xfrm>
-            <a:off x="27958050" y="16843162"/>
-            <a:ext cx="6993899" cy="3174862"/>
-            <a:chOff x="27958050" y="16843162"/>
-            <a:chExt cx="6993899" cy="3174862"/>
+            <a:off x="27958050" y="16751137"/>
+            <a:ext cx="6993899" cy="3358912"/>
+            <a:chOff x="27958050" y="16751137"/>
+            <a:chExt cx="6993899" cy="3358912"/>
           </a:xfrm>
         </p:grpSpPr>
         <p:graphicFrame>
@@ -9930,8 +10368,8 @@
             <p:nvPr/>
           </p:nvGraphicFramePr>
           <p:xfrm>
-            <a:off x="27958050" y="16843162"/>
-            <a:ext cx="6993899" cy="3174862"/>
+            <a:off x="27958050" y="16751137"/>
+            <a:ext cx="6993899" cy="3358912"/>
           </p:xfrm>
           <a:graphic>
             <a:graphicData uri="http://schemas.openxmlformats.org/drawingml/2006/chart">
@@ -10005,7 +10443,7 @@
                 </a:solidFill>
                 <a:latin typeface="IBM Plex Sans"/>
               </a:rPr>
-              <a:t>% học sinh đổi CLB, trung bình · bộ 140 em mô phỏng</a:t>
+              <a:t>% học sinh đổi CLB, trung bình · 3 bộ dữ liệu mô phỏng</a:t>
             </a:r>
           </a:p>
         </p:txBody>
@@ -10018,7 +10456,7 @@
         </p:nvSpPr>
         <p:spPr>
           <a:xfrm>
-            <a:off x="28050075" y="20378762"/>
+            <a:off x="28050075" y="20415573"/>
             <a:ext cx="180000" cy="143559"/>
           </a:xfrm>
           <a:prstGeom prst="rect">
@@ -10040,7 +10478,7 @@
                 </a:solidFill>
                 <a:latin typeface="IBM Plex Sans"/>
               </a:rPr>
-              <a:t>Dữ liệu mô phỏng — nguồn: NGHIEN_CUU_TOI_UU.md, TN6</a:t>
+              <a:t>Dữ liệu mô phỏng — nguồn: NGHIEN_CUU_TOI_UU.md, TN6 (du_lieu_test/so_lieu_ben_vung.json)</a:t>
             </a:r>
           </a:p>
         </p:txBody>
@@ -10053,7 +10491,7 @@
         </p:nvSpPr>
         <p:spPr>
           <a:xfrm>
-            <a:off x="28050075" y="20109129"/>
+            <a:off x="28050075" y="20168945"/>
             <a:ext cx="180000" cy="167485"/>
           </a:xfrm>
           <a:prstGeom prst="rect">
@@ -10075,7 +10513,7 @@
                 </a:solidFill>
                 <a:latin typeface="IBM Plex Sans"/>
               </a:rPr>
-              <a:t>392 phép thử trên 3 bộ dữ liệu · 0 cặp phá vỡ</a:t>
+              <a:t>Bốc thăm: 0% – 4,36% tuỳ độ chật của dữ liệu · 392 phép thử · 0 cặp phá vỡ</a:t>
             </a:r>
           </a:p>
         </p:txBody>

</xml_diff>